<commit_message>
docs: presentation and notes updates, worklog entries 64-67
Co-Authored-By: Claude Sonnet 5.5 <noreply@anthropic.com>
Claude-Session: https://claude.ai/code/session_01V1631aLqopE3GM2inWjbQ8
</commit_message>
<xml_diff>
--- a/docs/prezentacja_postepy.pptx
+++ b/docs/prezentacja_postepy.pptx
@@ -120,7 +120,7 @@
   <p:extLst>
     <p:ext uri="{521415D9-36F7-43E2-AB2F-B90AF26B5E84}">
       <p14:sectionLst xmlns:p14="http://schemas.microsoft.com/office/powerpoint/2010/main">
-        <p14:section name="Wprowadzenie" id="{18693348-bd2a-070b-ec3f-965240777d6e}">
+        <p14:section name="Wprowadzenie" id="{c61bd391-4038-c0b9-b2e1-7a27b48827db}">
           <p14:sldIdLst>
             <p14:sldId id="256"/>
             <p14:sldId id="257"/>
@@ -128,27 +128,27 @@
             <p14:sldId id="259"/>
           </p14:sldIdLst>
         </p14:section>
-        <p14:section name="Dane i etykiety" id="{30247978-da4c-43fd-a6a4-a8839b3579a7}">
+        <p14:section name="Dane i etykiety" id="{68e35cf1-0de9-01a5-4c3a-015d8d8c0f95}">
           <p14:sldIdLst>
             <p14:sldId id="260"/>
             <p14:sldId id="261"/>
             <p14:sldId id="262"/>
           </p14:sldIdLst>
         </p14:section>
-        <p14:section name="Router" id="{491fe4a7-0e6b-1a94-7551-7a67e8681837}">
+        <p14:section name="Router" id="{1496c409-2850-0bc5-7511-1ac0ae7c494c}">
           <p14:sldIdLst>
             <p14:sldId id="263"/>
             <p14:sldId id="264"/>
           </p14:sldIdLst>
         </p14:section>
-        <p14:section name="Wyniki" id="{4c6c06ac-e3b7-9780-5b3c-229acc1499aa}">
+        <p14:section name="Wyniki" id="{3d3590a9-6be4-df01-0021-659ab980249c}">
           <p14:sldIdLst>
             <p14:sldId id="265"/>
             <p14:sldId id="266"/>
             <p14:sldId id="267"/>
           </p14:sldIdLst>
         </p14:section>
-        <p14:section name="Dalej" id="{db2449bc-7e23-25b6-0259-ed86a0f24923}">
+        <p14:section name="Dalej" id="{74747c1c-f02d-c008-bee6-8d1546cc7b8b}">
           <p14:sldIdLst>
             <p14:sldId id="268"/>
             <p14:sldId id="269"/>
@@ -575,7 +575,21 @@
           <a:p>
             <a:r>
               <a:rPr lang="pl-PL" sz="1400"/>
-              <a:t>Mały model to qwen3:8b, duży to Qwen3.8-27B. Liczby 8 i 27 to miliardy parametrów, czyli rozmiar modelu. Całość zajmie ok. 18–20 minut.</a:t>
+              <a:t>Mały model to qwen3:8b, duży to Qwen3.8-27B. Liczby 8 i 27 to miliardy parametrów, czyli rozmiar modelu.
+</a:t>
+            </a:r>
+          </a:p>
+          <a:p>
+            <a:r>
+              <a:rPr lang="pl-PL" sz="1400"/>
+              <a:t>W całej prezentacji „pytanie trudne” znaczy: duży model odpowiada na nie wyraźnie lepiej niż mały. „Pytanie łatwe” znaczy: mały wystarcza.
+</a:t>
+            </a:r>
+          </a:p>
+          <a:p>
+            <a:r>
+              <a:rPr lang="pl-PL" sz="1400"/>
+              <a:t>Całość zajmie ok. 18–20 minut.</a:t>
             </a:r>
           </a:p>
         </p:txBody>
@@ -669,7 +683,7 @@
           <a:p>
             <a:r>
               <a:rPr lang="pl-PL" sz="1400"/>
-              <a:t>Najpierw, jak mierzę jakość routera. Weź dwa losowe pytania: jedno naprawdę trudne, drugie łatwe. Czy router dał trudnemu wyższy wynik? Miara AUROC to odsetek takich par, w których tak. 0,5 oznacza zgadywanie, a 1,0 bezbłędny router. Mój router ma 0,682: w 68 parach na 100 ustawia je dobrze. To ta sama miara, której użyłem przy Arenie, tylko tam porównywałem dwie etykiety.
+              <a:t>Teraz wyniki routera. Używam dwóch miar.
 </a:t>
             </a:r>
           </a:p>
@@ -679,7 +693,14 @@
           <a:p>
             <a:r>
               <a:rPr lang="pl-PL" sz="1400"/>
-              <a:t>Druga miara to APGR: jaką część możliwego zysku jakości odzyskuję w porównaniu z wysyłaniem wszystkiego do małego modelu. 0,5 odpowiada losowemu wysyłaniu, a 0,91 idealnemu routerowi. Mój ma 0,605.
+              <a:t>Pierwsza to AUROC, znany już ze slajdu 4: dla losowej pary pytań, jedno trudne i jedno łatwe, odsetek par, w których router dał trudnemu wyższy wynik. Wynik routera to ta liczba od 0 do 1 ze slajdu 9: im wyższa, tym bardziej router uważa pytanie za trudne (np. 0,7, gdy 14 z 20 podobnych pytań było trudnych). 0,5 to zgadywanie, 1,0 to bezbłędny router. Mój router ma 0,682, czyli w 68 parach na 100 ustawia je dobrze. AUROC nie zależy od progu: ocenia sam wynik routera.
+</a:t>
+            </a:r>
+          </a:p>
+          <a:p>
+            <a:r>
+              <a:rPr lang="pl-PL" sz="1400"/>
+              <a:t>Jak liczy się jedną parę: jeśli trudne pytanie dostało wyższy wynik niż łatwe, para daje 1. Jeśli niższy, 0. Jeśli wyniki są równe, 0,5. Np. trudne dostało 0,70, a łatwe 0,40: wynik pary to 1. AUROC to średnia z wyników wszystkich takich par. U nas jest ok. 1130 trudnych i 1880 łatwych pytań, czyli ponad 2 miliony par.
 </a:t>
             </a:r>
           </a:p>
@@ -689,7 +710,7 @@
           <a:p>
             <a:r>
               <a:rPr lang="pl-PL" sz="1400"/>
-              <a:t>Wszystkie wyniki są policzone na pytaniach, których router wcześniej nie widział (3010 pytań, walidacja krzyżowa).
+              <a:t>Druga to APGR. Najpierw „jakość”: to średnia ocena odpowiedzi w skali od 0 do 1. Gdy wszystko idzie do małego, jakość to 0,625, a gdy wszystko do dużego, 0,846. Cały możliwy zysk to więc 0,221. Router, który przy pewnym progu daje jakość 0,777, odzyskuje 0,152 z 0,221, czyli 0,69. To odzyskana część zysku dla jednego progu. Takich punktów jest wiele, po jednym dla każdego progu. APGR to średnia z nich wszystkich, czyli jedna liczba opisująca cały router. Zobaczysz te punkty jako wykres na następnym slajdzie. Losowe wysyłanie daje APGR 0,5, a idealny router 0,91. Mój ma 0,605.
 </a:t>
             </a:r>
           </a:p>
@@ -699,7 +720,14 @@
           <a:p>
             <a:r>
               <a:rPr lang="pl-PL" sz="1400"/>
-              <a:t>Słupki. Losowy ma 0,5. Sama długość pytania 0,525, czyli prawie nic nie mówi. „Samo źródło” 0,631: to router, który nie czyta pytania, tylko wie, z jakiego zbioru pochodzi (matematyka zwykle łatwa, rozmowy trudniejsze). To poprzeczka: czy router wie coś więcej niż rodzaj pytania. Wie, ale niewiele więcej: różnica to 0,05 w AUROC, istotna statystycznie.
+              <a:t>Uwaga, co dokładnie mierzą te liczby: to wynik warstwy 2 (kNN), bo tylko ona daje liczbę od 0 do 1 dla każdego pytania. Warstwę 1 sprawdziłem osobno (ok. 0,55) oraz razem z kNN: kaskada nie zmienia jakości. Warstwy 3 jeszcze nie ma, więc nie ma czego mierzyć. Cały router, ze wszystkimi warstwami, ocenię na zbiorze testowym.
+</a:t>
+            </a:r>
+          </a:p>
+          <a:p>
+            <a:r>
+              <a:rPr lang="pl-PL" sz="1400"/>
+              <a:t>Słupki na wykresie to AUROC. Losowy: 0,5. Sama długość pytania: 0,525, czyli prawie nic nie mówi. „Samo źródło”: 0,631. To router, który w ogóle nie czyta pytania, tylko wie, z jakiego zbioru pochodzi, i daje każdemu pytaniu wynik równy odsetkowi trudnych pytań w tym zbiorze (4% dla zadań matematycznych, 48% dla WildChat). W praktyce źródła nie znamy, więc to tylko poprzeczka. Pytam: czy router wie coś więcej niż rodzaj pytania? Wie, ale niewiele więcej: różnica to 0,05 w AUROC i 0,023 w APGR (0,605 wobec 0,582), istotna statystycznie.
 </a:t>
             </a:r>
           </a:p>
@@ -709,7 +737,7 @@
           <a:p>
             <a:r>
               <a:rPr lang="pl-PL" sz="1400"/>
-              <a:t>Uczciwie: dużą część skuteczności daje samo rozpoznanie rodzaju pytania. Wewnątrz jednego źródła wynik jest słabszy: dla Areny 0,60, a dla pytań o wiedzę (TriviaQA) ok. 0,50, czyli nic.
+              <a:t>Uczciwie: dużą część skuteczności daje samo rozpoznanie rodzaju pytania. Wewnątrz jednego źródła wynik jest słabszy: dla Areny 0,60, a dla pytań o wiedzę (TriviaQA) ok. 0,50, czyli nic. Heurystyki z warstwy 1 dają same ok. 0,55, więc nie poprawiają kNN.
 </a:t>
             </a:r>
           </a:p>
@@ -820,7 +848,7 @@
           <a:p>
             <a:r>
               <a:rPr lang="pl-PL" sz="1400"/>
-              <a:t>Jak czytać wykres. Oś pozioma to odsetek pytań wysyłanych do dużego modelu. Oś pionowa to średnia jakość odpowiedzi od 0 do 1. Wszystko do małego daje 0,625, wszystko do dużego 0,846. Szara linia to losowe wysyłanie, a pomarańczowa to router. Router jest wyżej: przy tym samym udziale dużego daje lepszą jakość. Przewaga jest umiarkowana, ok. 0,03.
+              <a:t>Ten slajd pokazuje dwie różne rzeczy: po lewej wykres, po prawej tabelę. Wyjaśniam je po kolei, a na końcu, jak się do siebie mają.
 </a:t>
             </a:r>
           </a:p>
@@ -829,8 +857,40 @@
           </a:p>
           <a:p>
             <a:r>
-              <a:rPr lang="pl-PL" sz="1400"/>
-              <a:t>Przykład: przy progu 0,3 do dużego idzie 54% pytań, a jakość to 0,777. To ok. 46% mniej wywołań dużego modelu za ok. 8% niższą jakość.
+              <a:rPr lang="pl-PL" sz="1400" b="1"/>
+              <a:t>LEWA STRONA: </a:t>
+            </a:r>
+            <a:r>
+              <a:rPr lang="pl-PL" sz="1400"/>
+              <a:t>WYKRES (to jest obraz APGR)
+</a:t>
+            </a:r>
+          </a:p>
+          <a:p>
+            <a:r>
+              <a:rPr lang="pl-PL" sz="1400"/>
+              <a:t>Oś pozioma to odsetek pytań, które wysyłam do dużego modelu, od 0% do 100%. Oś pionowa to jakość, czyli średnia ocena odpowiedzi w skali 0–1. Liczę ją tak: dla każdego pytania biorę ocenę modelu, do którego poszło, i uśredniam po wszystkich pytaniach.
+</a:t>
+            </a:r>
+          </a:p>
+          <a:p>
+            <a:r>
+              <a:rPr lang="pl-PL" sz="1400"/>
+              <a:t>Wszystko do małego daje 0,625, a wszystko do dużego 0,846. Szara linia to wysyłanie losowe: jakość rośnie po prostu proporcjonalnie do udziału dużego. Pomarańczowa linia to router. Jest wyżej, czyli przy tym samym udziale dużego modelu daje lepszą jakość.
+</a:t>
+            </a:r>
+          </a:p>
+          <a:p>
+            <a:r>
+              <a:rPr lang="pl-PL" sz="1400"/>
+              <a:t>Ten wykres to właśnie te punkty, z których APGR jest średnią. Przy 54% do dużego jakość routera to 0,777, czyli odzyskuję 0,69 luki między 0,625 a 0,846, a przy wysyłaniu losowym byłoby to 0,54. APGR (0,605 wobec 0,5 losowo) mierzy odstęp między liniami.
+</a:t>
+            </a:r>
+          </a:p>
+          <a:p>
+            <a:r>
+              <a:rPr lang="pl-PL" sz="1400"/>
+              <a:t>Jeden punkt jako przykład, próg 0,3: do dużego idzie 54% pytań, jakość to 0,777. To ok. 46% mniej wywołań dużego modelu (100% minus 54%) za ok. 8% niższą jakość (0,846 spada do 0,777). Uwaga: te dwie liczby, 46% i 8%, to odczyt z jednego punktu wykresu, a nie APGR. APGR jest jedną liczbą opisującą całą linię.
 </a:t>
             </a:r>
           </a:p>
@@ -839,8 +899,26 @@
           </a:p>
           <a:p>
             <a:r>
-              <a:rPr lang="pl-PL" sz="1400"/>
-              <a:t>Tabela po prawej pokazuje, ile poważnych błędów akceptujemy. Poważny błąd to pytanie, na które duży model odpowiedziałby wyraźnie lepiej (o ponad 2 punkty), a które poszło do małego. Takich pytań jest 15,9% wszystkich.
+              <a:rPr lang="pl-PL" sz="1400" b="1"/>
+              <a:t>PRAWA STRONA: </a:t>
+            </a:r>
+            <a:r>
+              <a:rPr lang="pl-PL" sz="1400"/>
+              <a:t>TABELA (to jest inna miara, nie APGR)
+</a:t>
+            </a:r>
+          </a:p>
+          <a:p>
+            <a:r>
+              <a:rPr lang="pl-PL" sz="1400"/>
+              <a:t>Średnia jakość nie pokazuje najgorszych przypadków. Pytanie poważnie błędne to takie, na które duży model odpowiedziałby wyraźnie lepiej (o ponad 2 punkty w skali 1–5), a które poszło do małego. Takich pytań jest 15,9% wszystkich.
+</a:t>
+            </a:r>
+          </a:p>
+          <a:p>
+            <a:r>
+              <a:rPr lang="pl-PL" sz="1400"/>
+              <a:t>Tabela mówi: jeśli akceptuję do 12% poważnych błędów wśród pytań wysłanych do małego, to do małego idzie 47% pytań. Przy 10% idzie 22%, przy 15% aż 90%. Poniżej ok. 8% żaden próg nie daje gwarancji z 95% pewnością.
 </a:t>
             </a:r>
           </a:p>
@@ -849,18 +927,22 @@
           </a:p>
           <a:p>
             <a:r>
-              <a:rPr lang="pl-PL" sz="1400"/>
-              <a:t>Czytam tak. Jeśli akceptuję do 12% poważnych błędów wśród pytań wysłanych do małego, do małego idzie 47% pytań. Przy 10% idzie 22%, przy 15% aż 90%. Poniżej ok. 8% żaden próg nie daje gwarancji z 95% pewnością. Router zmniejsza ryzyko, ale go nie usuwa.
-</a:t>
-            </a:r>
-          </a:p>
-          <a:p>
-            <a:endParaRPr lang="pl-PL" sz="1400"/>
-          </a:p>
-          <a:p>
-            <a:r>
-              <a:rPr lang="pl-PL" sz="1400"/>
-              <a:t>Dlaczego tak? Administratorowi łatwiej wybrać „akceptuję do 12% pomyłek” niż liczbę 0,3.
+              <a:rPr lang="pl-PL" sz="1400" b="1"/>
+              <a:t>JAK SIĘ TE DWA OBRAZY DO SIEBIE MAJĄ
+</a:t>
+            </a:r>
+          </a:p>
+          <a:p>
+            <a:r>
+              <a:rPr lang="pl-PL" sz="1400"/>
+              <a:t>To ten sam router i te same progi, oglądane z dwóch stron. Wykres odpowiada na pytanie „ile średnio stracę na jakości”, tabela na pytanie „jak często popełnię poważny błąd”. Np. próg 0,3: z wykresu 54% do dużego i jakość 0,777, z tabeli do małego idzie ok. 47% pytań, a wśród nich ok. 11% to poważne błędy.
+</a:t>
+            </a:r>
+          </a:p>
+          <a:p>
+            <a:r>
+              <a:rPr lang="pl-PL" sz="1400"/>
+              <a:t>Do oceny routera służą AUROC i APGR (nie zależą od progu). Wykres i tabela pomagają administratorowi wybrać jeden próg: albo patrząc na koszt (wykres), albo na ryzyko (tabela).
 </a:t>
             </a:r>
           </a:p>
@@ -877,7 +959,7 @@
           <a:p>
             <a:r>
               <a:rPr lang="pl-PL" sz="1400"/>
-              <a:t>Jak liczone? Próg wyznaczam na jednej części danych, a sprawdzam na drugiej. Pewność 95% liczę metodą Clopper–Pearsona.
+              <a:t>Jak liczona jest tabela? Próg wyznaczam na jednej części danych, a sprawdzam na drugiej. Pewność 95% liczę metodą Clopper–Pearsona.
 </a:t>
             </a:r>
           </a:p>
@@ -978,7 +1060,7 @@
           <a:p>
             <a:r>
               <a:rPr lang="pl-PL" sz="1400"/>
-              <a:t>Poważny błąd to pytanie, na które duży model byłby wyraźnie lepszy, a router wysłał je do małego. Przy progu 0,3 router pomija 30% takich pytań. Losowo byłoby 46%.
+              <a:t>Na poprzednim slajdzie pokazałem, że router czasem popełnia poważny błąd: wysyła do małego modelu pytanie, na które duży odpowiedziałby wyraźnie lepiej (o ponad 2 punkty w skali 1–5). Takich pytań jest 15,9% wszystkich.
 </a:t>
             </a:r>
           </a:p>
@@ -988,7 +1070,7 @@
           <a:p>
             <a:r>
               <a:rPr lang="pl-PL" sz="1400"/>
-              <a:t>Wykres pokazuje, gdzie myli się najbardziej. Dla pytań otwartych, Areny i WildChat, pomija 25% i 17% takich pytań. Dla pytań o fakty (TriviaQA) aż 81%, a dla zadań programistycznych (HumanEval) 84%.
+              <a:t>Wyobraź sobie 100 takich pytań. Przy progu 0,3 router wysyła do dużego modelu 70 z nich i to jest dobrze. Pozostałe 30 trafia do małego, więc użytkownik dostaje gorszą odpowiedź, niż mógł dostać. Stąd 30%. Gdyby router niczego nie umiał i losowo kierował do małego tyle samo pytań co teraz (ok. 46% wszystkich), do małego trafiłoby 46 z tych 100. Router jest więc lepszy od losowania, ale nie bezbłędny.
 </a:t>
             </a:r>
           </a:p>
@@ -998,12 +1080,54 @@
           <a:p>
             <a:r>
               <a:rPr lang="pl-PL" sz="1400"/>
-              <a:t>Dlaczego? Router widzi tylko tekst pytania, a nie to, co wie mały model. Dwa pytania o fakty wyglądają podobnie, ale mały model może znać odpowiedź na jedno i nie znać drugiej. W tekście tego nie widać.
+              <a:t>Wykres pokazuje to osobno dla każdego źródła. Biorę 100 pytań trudnych z danego źródła i liczę, ile z nich router wysłał do małego, czyli w ilu przypadkach się pomylił:
+</a:t>
+            </a:r>
+          </a:p>
+          <a:p>
+            <a:r>
+              <a:rPr lang="pl-PL" sz="1400"/>
+              <a:t>• Arena: 25 ze 100.
+</a:t>
+            </a:r>
+          </a:p>
+          <a:p>
+            <a:r>
+              <a:rPr lang="pl-PL" sz="1400"/>
+              <a:t>• WildChat: 17 ze 100.
+</a:t>
+            </a:r>
+          </a:p>
+          <a:p>
+            <a:r>
+              <a:rPr lang="pl-PL" sz="1400"/>
+              <a:t>• TriviaQA, pytania o fakty: 81 ze 100.
+</a:t>
+            </a:r>
+          </a:p>
+          <a:p>
+            <a:r>
+              <a:rPr lang="pl-PL" sz="1400"/>
+              <a:t>• HumanEval, zadania programistyczne: 84 ze 100.
+</a:t>
+            </a:r>
+          </a:p>
+          <a:p>
+            <a:r>
+              <a:rPr lang="pl-PL" sz="1400"/>
+              <a:t>Przy pytaniach otwartych router myli się więc rzadziej, a przy faktach i programowaniu myli się prawie za każdym razem, gdy pytanie jest trudne.
 </a:t>
             </a:r>
           </a:p>
           <a:p>
             <a:endParaRPr lang="pl-PL" sz="1400"/>
+          </a:p>
+          <a:p>
+            <a:r>
+              <a:rPr lang="pl-PL" sz="1400"/>
+              <a:t>Dlaczego tak jest? Router widzi tylko tekst pytania, a nie to, co wie mały model. Dwa pytania o fakty wyglądają podobnie, ale mały model może znać odpowiedź na jedno i nie znać drugiej. W tekście tego nie widać.
+</a:t>
+            </a:r>
           </a:p>
           <a:p>
             <a:r>
@@ -1035,7 +1159,7 @@
           <a:p>
             <a:r>
               <a:rPr lang="pl-PL" sz="1400"/>
-              <a:t>Próbki są małe: 42 pytania z TriviaQA i 19 z HumanEval. Wnioski ostrożnie.
+              <a:t>Próbki są małe: 42 pytania trudne z TriviaQA i 19 z HumanEval. Wnioski ostrożnie.
 </a:t>
             </a:r>
           </a:p>
@@ -1146,7 +1270,7 @@
           <a:p>
             <a:r>
               <a:rPr lang="pl-PL" sz="1400"/>
-              <a:t>Implementacja. Usługa RouterService działa w DeepFellow. Napisałem 57 nowych testów, a cały zestaw testów przechodzi. Sprawdziłem ją od początku do końca na osobnej instancji z modelami Gemini: wybór modelu, nagłówki z decyzją, strumieniowanie i przełączenie na duży model przy błędzie. Test wykrył błąd: wycofany model zwracał 404 jako zwykłą odpowiedź i omijał to przełączenie. Naprawiłem. Z modelami Qwen jeszcze nie uruchamiałem. Zrobię to na komputerze służbowym.
+              <a:t>Implementacja. Usługa RouterService działa w DeepFellow Infra w wersji 0.34. Napisałem 57 nowych testów, a cały zestaw testów (5157) przechodzi. Sprawdziłem ją od początku do końca na osobnej instancji z modelami Gemini: wybór modelu, nagłówki z decyzją, strumieniowanie i przełączenie na duży model przy błędzie (po angielsku fallback). Test wykrył błąd: wycofany model zwracał 404 jako zwykłą odpowiedź i omijał to przełączenie. Naprawiłem. Z modelami Qwen 8B i 27B jeszcze nie uruchamiałem. Zrobię to na komputerze służbowym.
 </a:t>
             </a:r>
           </a:p>
@@ -1156,7 +1280,7 @@
           <a:p>
             <a:r>
               <a:rPr lang="pl-PL" sz="1400"/>
-              <a:t>Sprawdziłem też dwie rzeczy. Czas: mediana ok. 20 ms, a 90% zapytań w mniej niż 65 ms (cel poniżej 50 ms spełniony dla mediany). Odporność: po literówkach, parafrazach i zamianie na synonimy decyzja zmienia się tylko w 6–10% pytań. Losowo byłoby 42–48%. Router nie jest więc wrażliwy na drobne zmiany sformułowania.
+              <a:t>Sprawdziłem też dwie rzeczy. Czas: mediana 20,6 ms, a 90% zapytań w mniej niż 65 ms (cel poniżej 50 ms spełniony dla mediany). Odporność: po literówkach, parafrazach i zamianie na synonimy decyzja zmienia się tylko w 6–10% pytań. Losowo byłoby 42–48%. Router nie jest więc wrażliwy na drobne zmiany sformułowania.
 </a:t>
             </a:r>
           </a:p>
@@ -1277,7 +1401,7 @@
           <a:p>
             <a:r>
               <a:rPr lang="pl-PL" sz="1400"/>
-              <a:t>Co dalej. Po pierwsze, uruchomić system z modelami Qwen na komputerze służbowym i zmierzyć opóźnienie przez DeepFellow. Po drugie, sprawdzić warstwę 3 (test go/no-go): czy mały model oceniający pytanie poprawia wynik routera. Po trzecie, dodać dane bliższe wdrożeniu, np. własne zapytania, zadania SQL, polecenia biurowe. To wymaga ponownego pomiaru, ale pozwoli też sprawdzić, czy heurystyki warstwy 1 działają lepiej na takich danych. Po czwarte, otworzyć zbiór testowy raz i zrobić ocenę końcową.
+              <a:t>Co dalej. Po pierwsze, uruchomić system z modelami Qwen 8B i 27B na komputerze służbowym i zmierzyć opóźnienie przez DeepFellow. Po drugie, sprawdzić warstwę 3 (test go/no-go): czy mały model oceniający pytanie poprawia wynik routera. Po trzecie, dodać dane bliższe wdrożeniu, np. własne zapytania, zadania SQL, polecenia biurowe. To wymaga ponownego pomiaru, ale pozwoli też sprawdzić, czy heurystyki warstwy 1 działają lepiej na takich danych. Po czwarte, otworzyć zbiór testowy raz i zrobić ocenę końcową.
 </a:t>
             </a:r>
           </a:p>
@@ -1463,7 +1587,7 @@
           <a:p>
             <a:r>
               <a:rPr lang="pl-PL" sz="1400"/>
-              <a:t>Router ma wybierać osobno dla każdego pytania: proste do małego, trudne do dużego. Na rysunku pytanie wchodzi do routera i idzie w jedną z dwóch stron. Dla użytkownika nic się nie zmienia: w DeepFellow to po prostu model o nazwie router.
+              <a:t>Router ma wybierać osobno dla każdego pytania: proste do małego (qwen3:8b), trudne do dużego (Qwen 27B). Na rysunku pytanie wchodzi do routera i idzie w jedną z dwóch stron. Dla użytkownika nic się nie zmienia: w DeepFellow to po prostu model o nazwie router.
 </a:t>
             </a:r>
           </a:p>
@@ -1614,7 +1738,7 @@
           <a:p>
             <a:r>
               <a:rPr lang="pl-PL" sz="1400"/>
-              <a:t>Plan miał też trzy warstwy rozpoznawania trudności, konfigurację w pliku YAML, kategorie tematyczne i podział złożonych zadań na części (Map-Reduce). Odpowiedzi miałem oceniać między innymi miarą ROUGE.
+              <a:t>Plan miał też trzy warstwy rozpoznawania trudności: proste heurystyki, porównanie z podobnymi pytaniami i mały model. Do tego konfigurację w pliku YAML, kategorie tematyczne i podział złożonych zadań na części (Map-Reduce). Odpowiedzi miałem oceniać między innymi miarą ROUGE.
 </a:t>
             </a:r>
           </a:p>
@@ -1748,7 +1872,7 @@
           <a:p>
             <a:r>
               <a:rPr lang="pl-PL" sz="1400"/>
-              <a:t>Porównałem jedno z drugim dla 1723 pytań. Wynik to 0,55. Znaczy to: biorę losowo dwa pytania, jedno trudne według Areny, drugie nie. W 55 przypadkach na 100 to pierwsze jest też trudniejsze dla moich modeli. Przy zwykłym rzucie monetą byłoby 50 na 100. Czyli zgodności prawie nie ma. Ta miara nazywa się AUROC i użyję jej później do oceny routera.
+              <a:t>Porównałem jedno z drugim dla 1723 pytań. Wynik to 0,55. Mierzę to miarą o nazwie AUROC. Wyobraź sobie losowo wybraną parę pytań: jedno trudne według Areny, drugie nie. Para liczy się jako 1, gdy to pierwsze ma większą zmierzoną przewagę dużego modelu, jako 0, gdy mniejszą, i jako 0,5 przy remisie. AUROC to średnia z takich wyników po wszystkich parach, czyli w praktyce odsetek par ustawionych dobrze. Wynik 0,55 znaczy: w 55 parach na 100. Przy zwykłym rzucie monetą byłoby 50 na 100, a przy pełnej zgodności 100 na 100. Czyli zgodności prawie nie ma. Tej samej miary użyję później do oceny routera.
 </a:t>
             </a:r>
           </a:p>
@@ -1906,7 +2030,7 @@
           <a:p>
             <a:r>
               <a:rPr lang="pl-PL" sz="1400"/>
-              <a:t>Krok 1. Wysyłam je do obu modeli: do małego trzy razy, do dużego raz. Odpowiedzi modeli są losowe, więc jedna próbka małego modelu byłaby za mało pewna.
+              <a:t>Mam 4313 pytań z ośmiu źródeł. Krok 1. Wysyłam każde do obu modeli: do małego trzy razy, do dużego raz. Odpowiedzi modeli są losowe, więc jedna próbka małego modelu byłaby za mało pewna.
 </a:t>
             </a:r>
           </a:p>
@@ -1926,7 +2050,7 @@
           <a:p>
             <a:r>
               <a:rPr lang="pl-PL" sz="1400"/>
-              <a:t>Krok 3. Liczę różnicę: ocena dużego minus średnia ocena małego.
+              <a:t>Krok 3. Liczę różnicę, oznaczoną Δ (delta): ocena dużego minus średnia ocena małego.
 </a:t>
             </a:r>
           </a:p>
@@ -1946,7 +2070,7 @@
           <a:p>
             <a:r>
               <a:rPr lang="pl-PL" sz="1400"/>
-              <a:t>Przykład z rysunku. Duży dostał 5, mały 3, 3 i 4, średnio 3,3. Różnica to 1,7 punktu, więcej niż 1, więc pytanie jest trudne. Na slajdzie te oceny są przeliczone na skalę 0–1, stąd próg 0,25.
+              <a:t>Przykład z rysunku. Duży dostał 5, mały 3, 3 i 4, średnio 3,3. Różnica to 1,7 punktu, więcej niż 1, więc pytanie jest trudne. Na slajdzie te oceny są przeliczone na skalę 0–1 (wzorem (ocena − 1) / 4): duży dostał 1,00, mały średnio 0,58, więc Δ = 0,42. Granica Δ &gt; 0,25 odpowiada więc jednemu punktowi. Nazywam ją progiem trudności, żeby nie mylić jej z progiem routera, o którym będzie mowa dalej.
 </a:t>
             </a:r>
           </a:p>
@@ -2074,7 +2198,7 @@
           <a:p>
             <a:r>
               <a:rPr lang="pl-PL" sz="1400"/>
-              <a:t>Mam 4313 pytań z ośmiu źródeł. Dwa to zbiory prawdziwych rozmów z chatbotami: Arena i WildChat. Dalej pytania wygenerowane przez Gemini i zbiory z matematyki, wiedzy i programowania. Dzięki temu są i pytania otwarte, i takie ze znaną poprawną odpowiedzią.
+              <a:t>Mam 4313 pytań z ośmiu źródeł i 17 252 odpowiedzi obu modeli. Dwa źródła to zbiory prawdziwych rozmów z chatbotami: Arena i WildChat. Dalej pytania wygenerowane przez Gemini i zbiory z matematyki, wiedzy i programowania. Dzięki temu są i pytania otwarte, i takie ze znaną poprawną odpowiedzią.
 </a:t>
             </a:r>
           </a:p>
@@ -2232,7 +2356,7 @@
           <a:p>
             <a:r>
               <a:rPr lang="pl-PL" sz="1400"/>
-              <a:t>Pierwsza liczba: 90%. Gdy zmienię kolejność odpowiedzi, ten sam sędzia daje tę samą klasę w 90% pytań. Jest więc w miarę stabilny.
+              <a:t>Pierwsza liczba: 90%. Gdy zmienię kolejność odpowiedzi, ten sam sędzia daje tę samą klasę (trudne albo łatwe) w 90% pytań. Jest więc w miarę stabilny.
 </a:t>
             </a:r>
           </a:p>
@@ -2252,7 +2376,7 @@
           <a:p>
             <a:r>
               <a:rPr lang="pl-PL" sz="1400"/>
-              <a:t>Trzecia: sam oceniłem 100 odpowiedzi, nie wiedząc, który model je napisał. Z sędzią zgadzam się umiarkowanie: korelacja 0,59, identyczna ocena w 43% przypadków, a różnica nie większa niż jeden punkt w 77%.
+              <a:t>Trzecia: sam oceniłem 100 odpowiedzi, nie wiedząc, który model je napisał. Z sędzią zgadzam się umiarkowanie. Korelacja wynosi 0,59 (1 oznaczałaby identyczne uporządkowanie ocen, a 0 brak związku). Dodatkowo identyczną ocenę dałem w 43% przypadków, a różnicę nie większą niż jeden punkt w 77%.
 </a:t>
             </a:r>
           </a:p>
@@ -2262,7 +2386,7 @@
           <a:p>
             <a:r>
               <a:rPr lang="pl-PL" sz="1400"/>
-              <a:t>Czwarta: sędzia jest surowszy ode mnie średnio o 0,4 punktu.
+              <a:t>Czwarta: sędzia jest surowszy ode mnie średnio o 0,4 punktu (jego średnia ocena to 3,00, a moja 3,40).
 </a:t>
             </a:r>
           </a:p>
@@ -2400,7 +2524,21 @@
           <a:p>
             <a:r>
               <a:rPr lang="pl-PL" sz="1400"/>
-              <a:t>Warstwa 1: heurystyki, czyli punkty za proste cechy tekstu pytania. Pytanie dostaje plus jeden punkt za każdą frazę z listy zadań trudnych i minus jeden za każdą frazę z listy łatwych. Do tego plus jeden punkt, gdy jest dłuższe niż 400 znaków, kolejny plus jeden powyżej 1500, minus jeden, gdy ponad 10% znaków to cyfry, i plus jeden za adres internetowy. Wszystkie te punkty administrator może zmienić.
+              <a:t>Warstwa 1: heurystyki, czyli punkty za proste cechy tekstu pytania. Pytanie dostaje plus jeden punkt za każdą frazę z listy zadań trudnych i minus jeden za każdą frazę z listy łatwych. Do tego plus jeden punkt, gdy jest dłuższe niż 400 znaków, kolejny plus jeden powyżej 1500, minus jeden, gdy ponad 10% znaków to cyfry, i plus jeden za adres internetowy. Administrator może zmienić wszystkie te punkty.
+</a:t>
+            </a:r>
+          </a:p>
+          <a:p>
+            <a:r>
+              <a:rPr lang="pl-PL" sz="1400"/>
+              <a:t>Słowa pochodzą z literatury, a nie z moich danych, żeby ich nie dopasować do wyników. Pierwsze źródło to taksonomia Blooma (Anderson i Krathwohl, 2001), czyli hierarchia poziomów myślenia od zapamiętywania do tworzenia: słowa jak „analyze”, „compare”, „design” wskazują zadania trudniejsze, a „what is”, „define” łatwiejsze. Drugie źródło to lista fraz z AgentBus, praktycznego systemu routingu modeli: np. „debug”, „refactor”, „step by step”.
+</a:t>
+            </a:r>
+          </a:p>
+          <a:p>
+            <a:r>
+              <a:rPr lang="pl-PL" sz="1400"/>
+              <a:t>Gdy suma punktów dojdzie do progu (domyślnie 2), pytanie idzie od razu do dużego modelu, bez dalszych warstw. Ta warstwa kieruje tylko do dużego, bo pomyłka w tę stronę kosztuje tylko pieniądze, a nie jakość. Jest opcjonalna: bez pliku z parametrami jest wyłączona. U nas próg 2 punkty obejmuje 6% pytań, z których 52% jest naprawdę trudnych (wśród wszystkich pytań 37%), więc heurystyki są lepsze od zgadywania o kilkanaście punktów procentowych i obejmują niewiele ruchu. W pomiarze nie zmieniają jakości całego routera.
 </a:t>
             </a:r>
           </a:p>
@@ -2410,7 +2548,7 @@
           <a:p>
             <a:r>
               <a:rPr lang="pl-PL" sz="1400"/>
-              <a:t>Skąd słowa kluczowe? Z literatury, a nie z moich danych, żeby ich nie dopasować do wyników. Pierwsze źródło to taksonomia Blooma (Anderson i Krathwohl, 2001): hierarchia poziomów myślenia, od zapamiętywania do tworzenia. Słowa z wyższych poziomów, jak „analyze”, „compare”, „evaluate”, „design”, „implement”, wskazują zadania trudniejsze. Słowa z niższych, jak „what is”, „define”, „name”, wskazują łatwiejsze. Drugie źródło to lista fraz z AgentBus, praktycznego systemu routingu modeli językowych: np. „debug”, „refactor”, „step by step”, „trade-offs”.
+              <a:t>Warstwa 2: porównanie z podobnymi pytaniami (metoda kNN) na embeddingach, czyli na liczbowym opisie pytania. To główna część rozwiązania i wyjaśniam ją na następnym slajdzie.
 </a:t>
             </a:r>
           </a:p>
@@ -2420,7 +2558,7 @@
           <a:p>
             <a:r>
               <a:rPr lang="pl-PL" sz="1400"/>
-              <a:t>Jeśli suma punktów dojdzie do progu (domyślnie 2 punkty), pytanie idzie od razu do dużego modelu, bez liczenia embeddingu i bez warstwy 2. Poniżej progu decyduje warstwa 2. Ta warstwa kieruje tylko do dużego modelu, bo pomyłka w tę stronę kosztuje tylko pieniądze, a nie jakość. Próg można kalibrować: wyższy oznacza mniej pytań kierowanych od razu, ale większą pewność. U nas próg 2 punkty obejmuje 6% pytań, z których 52% jest naprawdę trudnych (wśród wszystkich pytań 37%). Próg 3 obejmuje 2% pytań, z czego 55% trudnych. W pomiarze takie kierowanie nie zmienia jakości całego routera (różnice do 0,003, bez wyraźnego wpływu). Warstwa jest opcjonalna: bez pliku z parametrami jest wyłączona.
+              <a:t>Warstwa 3: mały model sam ocenia, czy pytanie jest trudne. Jeszcze jej nie ma. Wejdzie, jeśli krótki test pokaże zysk. Ten test nazywa się go/no-go: jeśli pomaga, budujemy, jeśli nie, rezygnujemy.
 </a:t>
             </a:r>
           </a:p>
@@ -2430,27 +2568,7 @@
           <a:p>
             <a:r>
               <a:rPr lang="pl-PL" sz="1400"/>
-              <a:t>Warstwa 2: porównanie z podobnymi pytaniami (metoda kNN). To główna część rozwiązania i wyjaśniam ją na następnym slajdzie.
-</a:t>
-            </a:r>
-          </a:p>
-          <a:p>
-            <a:endParaRPr lang="pl-PL" sz="1400"/>
-          </a:p>
-          <a:p>
-            <a:r>
-              <a:rPr lang="pl-PL" sz="1400"/>
-              <a:t>Warstwa 3: mały model sam ocenia, czy pytanie jest trudne. Jeszcze jej nie ma. Wejdzie, jeśli krótki test pokaże zysk. Ten test nazywa się go/no-go: jeśli pomaga, budujemy, jeśli nie, rezygnujemy.
-</a:t>
-            </a:r>
-          </a:p>
-          <a:p>
-            <a:endParaRPr lang="pl-PL" sz="1400"/>
-          </a:p>
-          <a:p>
-            <a:r>
-              <a:rPr lang="pl-PL" sz="1400"/>
-              <a:t>Na końcu router zwraca liczbę od 0 do 1. Administrator ustawia próg: wynik powyżej idzie do dużego modelu, poniżej do małego. Gdy cokolwiek zawiedzie, pytanie idzie do dużego, bo to bezpieczniejsze.
+              <a:t>Na końcu router zwraca liczbę od 0 do 1. To jego wynik dla pytania: im wyższy, tym bardziej router uważa pytanie za trudne, czyli tym większa szansa, że duży model odpowie wyraźnie lepiej. Administrator ustawia próg: wynik powyżej idzie do dużego modelu, poniżej do małego. Gdy cokolwiek zawiedzie, pytanie idzie do dużego, bo to bezpieczniejsze.
 </a:t>
             </a:r>
           </a:p>
@@ -2467,7 +2585,7 @@
           <a:p>
             <a:r>
               <a:rPr lang="pl-PL" sz="1400"/>
-              <a:t>Ile to trwa? Reguły ok. 0,3 ms, a warstwa 2 ok. 20 ms. Warstwa 3 byłaby wywołaniem małego modelu, czyli sekundami, dlatego jest ostatnia.</a:t>
+              <a:t>Ile to trwa? Heurystyki ok. 0,3 ms, a warstwa 2 ok. 20 ms. Warstwa 3 byłaby wywołaniem małego modelu, czyli sekundami, dlatego jest ostatnia.</a:t>
             </a:r>
           </a:p>
         </p:txBody>
@@ -2611,7 +2729,34 @@
           <a:p>
             <a:r>
               <a:rPr lang="pl-PL" sz="1400"/>
-              <a:t>Dlaczego tak, a nie bardziej skomplikowanie? Po pierwsze, nie trzeba niczego trenować: baza to zapisane pytania, a nowe dane to dopisanie wierszy. Po drugie, wynik ma zrozumiałe znaczenie i można pokazać, które pytania były sąsiadami. Po trzecie, liczy się lokalnie w ok. 20 ms, więc pytania nie opuszczają serwera. Po czwarte, sprawdziłem alternatywy: cztery inne modele zamieniające tekst na liczby i dziewięć klasyfikatorów. Żaden nie był istotnie lepszy. Najlepszy z nich jest trzy razy wolniejszy i bez wyraźnej poprawy.
+              <a:t>Dlaczego tak, a nie bardziej skomplikowanie? Po pierwsze, nie trzeba niczego trenować: baza to zapisane pytania, a nowe dane to dopisanie wierszy. Po drugie, wynik ma zrozumiałe znaczenie i można pokazać, które pytania były sąsiadami. Po trzecie, liczy się lokalnie w ok. 20 ms, więc pytania nie opuszczają serwera.
+</a:t>
+            </a:r>
+          </a:p>
+          <a:p>
+            <a:endParaRPr lang="pl-PL" sz="1400"/>
+          </a:p>
+          <a:p>
+            <a:r>
+              <a:rPr lang="pl-PL" sz="1400"/>
+              <a:t>A dlaczego kNN, a nie same embeddingi? Embedding to tylko lista liczb opisująca pytanie. Sama nie mówi, czy pytanie jest trudne. Potrzebna jest metoda, która z tych liczb zrobi wynik. Najprostsza to porównanie z pytaniami, których trudność już znam, czyli właśnie kNN.
+</a:t>
+            </a:r>
+          </a:p>
+          <a:p>
+            <a:r>
+              <a:rPr lang="pl-PL" sz="1400"/>
+              <a:t>To nie jest mój wymysł. Wzorowałem się na metodzie „Similarity-Weighted Ranking” z artykułu RouteLLM (Ong i in., 2024). Tam nowe zapytanie też zamienia się na embedding, porównuje z 80 tysiącami pytań z Chatbot Arena przez podobieństwo i liczy ważoną sumę głosów ludzi. Ta metoda nie wymaga trenowania. Inne metody z tego artykułu (faktoryzacja macierzy, BERT, duży model językowy) wymagają trenowania albo fine-tuningu, którego mój plan nie przewiduje. Różnię się tym, że uśredniam etykiety zmierzone na własnych modelach, a nie głosy z Areny, i biorę tylko 20 najbliższych pytań, a nie całą historię. Wadą oryginału jest czas i koszt: przeszukuje całą bazę przy każdym zapytaniu (w ich zestawieniu ok. 39 USD za milion zapytań). U mnie baza ma ok. 3 tysięcy wektorów, a wyszukiwanie trwa ok. 1 ms.
+</a:t>
+            </a:r>
+          </a:p>
+          <a:p>
+            <a:endParaRPr lang="pl-PL" sz="1400"/>
+          </a:p>
+          <a:p>
+            <a:r>
+              <a:rPr lang="pl-PL" sz="1400"/>
+              <a:t>Co sprawdziłem. Wyniki routera liczę na pytaniach, których router nie widział w nauce (walidacja krzyżowa: dzielę dane na części, uczę na jednych, oceniam na pozostałych). Miara to AUROC, taka jak na slajdzie 4, tylko teraz pytam, czy router daje wyższy wynik pytaniom trudnym niż łatwym. Cztery modele zamieniające tekst na liczby dały AUROC od 0,679 do 0,709. Najlepszy, qwen3, jest trzy razy wolniejszy (52 ms wobec 17,6 ms) i ma niewielką przewagę, więc zostaje nomic. Dziewięć klasyfikatorów (regresja logistyczna, SVM, sieć MLP, boosting drzew i inne) dało od 0,662 do 0,691. Żaden nie jest istotnie lepszy od kNN. Wniosek: ok. 0,68–0,69 to sufit informacji, który mają w sobie embeddingi dla tych etykiet.
 </a:t>
             </a:r>
           </a:p>
@@ -2628,7 +2773,14 @@
           <a:p>
             <a:r>
               <a:rPr lang="pl-PL" sz="1400"/>
-              <a:t>Dlaczego 20 sąsiadów? Przy jednym wynik jest zaszumiony, od ok. 20 jest stabilny, a więcej nie poprawia.
+              <a:t>Dlaczego 20 sąsiadów? Przy jednym AUROC to 0,590, bo wynik jest zaszumiony, a od ok. 20 jest stabilny (0,682 przy 20, 0,689 przy 40). Więcej nie poprawia.
+</a:t>
+            </a:r>
+          </a:p>
+          <a:p>
+            <a:r>
+              <a:rPr lang="pl-PL" sz="1400"/>
+              <a:t>Czy ważenie pomaga? Tak, trochę: równe wagi dają 0,677, a ważenie podobieństwem 0,682. Ostrzejsze ważenie daje do 0,702, ale wybrałem je spośród 30 wariantów na tych samych danych, więc nie przyjmuję tego bez potwierdzenia.
 </a:t>
             </a:r>
           </a:p>
@@ -3524,7 +3676,7 @@
                   <a:schemeClr val="tx1"/>
                 </a:solidFill>
               </a:rPr>
-              <a:t>Reguły nie dodają nic do kNN, a wybór k i embeddera nie zmienia wyniku</a:t>
+              <a:t>Heurystyki (warstwa 1) nie dodają nic do kNN, a wybór k i embeddera nie zmienia wyniku</a:t>
             </a:r>
             <a:endParaRPr lang="en-US" sz="1600" dirty="0"/>
           </a:p>
@@ -3670,8 +3822,8 @@
         </p:nvSpPr>
         <p:spPr>
           <a:xfrm>
-            <a:off x="5486400" y="1188720"/>
-            <a:ext cx="3200400" cy="822960"/>
+            <a:off x="5486400" y="1143000"/>
+            <a:ext cx="3200400" cy="1097280"/>
           </a:xfrm>
           <a:prstGeom prst="rect">
             <a:avLst/>
@@ -3684,17 +3836,34 @@
           <a:lstStyle/>
           <a:p>
             <a:pPr indent="0" marL="0">
-              <a:buNone/>
-            </a:pPr>
-            <a:r>
-              <a:rPr lang="en-US" sz="1600" b="1" dirty="0">
+              <a:spcAft>
+                <a:spcPts val="400"/>
+              </a:spcAft>
+              <a:buNone/>
+            </a:pPr>
+            <a:r>
+              <a:rPr lang="en-US" sz="1400" dirty="0">
                 <a:solidFill>
                   <a:schemeClr val="tx1"/>
                 </a:solidFill>
               </a:rPr>
-              <a:t>Próg 0,3: 54% do dużego, jakość 0,777 (zawsze duży: 0,846)</a:t>
-            </a:r>
-            <a:endParaRPr lang="en-US" sz="1600" dirty="0"/>
+              <a:t>To obraz APGR: pomarańczowa nad szarą (0,605 wobec 0,5).</a:t>
+            </a:r>
+            <a:endParaRPr lang="en-US" sz="1400" dirty="0"/>
+          </a:p>
+          <a:p>
+            <a:pPr indent="0" marL="0">
+              <a:buNone/>
+            </a:pPr>
+            <a:r>
+              <a:rPr lang="en-US" sz="1400" dirty="0">
+                <a:solidFill>
+                  <a:schemeClr val="tx1"/>
+                </a:solidFill>
+              </a:rPr>
+              <a:t>Próg 0,3: 54% do dużego, jakość 0,777.</a:t>
+            </a:r>
+            <a:endParaRPr lang="en-US" sz="1400" dirty="0"/>
           </a:p>
         </p:txBody>
       </p:sp>
@@ -3706,8 +3875,8 @@
         </p:nvSpPr>
         <p:spPr>
           <a:xfrm>
-            <a:off x="5486400" y="2148840"/>
-            <a:ext cx="3200400" cy="2423160"/>
+            <a:off x="5486400" y="2331720"/>
+            <a:ext cx="3200400" cy="2331720"/>
           </a:xfrm>
           <a:prstGeom prst="rect">
             <a:avLst/>
@@ -3731,7 +3900,7 @@
         </p:nvSpPr>
         <p:spPr>
           <a:xfrm>
-            <a:off x="5623560" y="2240280"/>
+            <a:off x="5623560" y="2395728"/>
             <a:ext cx="2926080" cy="320040"/>
           </a:xfrm>
           <a:prstGeom prst="rect">
@@ -3753,7 +3922,7 @@
                   <a:schemeClr val="tx1"/>
                 </a:solidFill>
               </a:rPr>
-              <a:t>Akceptowany błąd krytyczny</a:t>
+              <a:t>Ryzyko: poważne błędy</a:t>
             </a:r>
             <a:endParaRPr lang="en-US" sz="1400" dirty="0"/>
           </a:p>
@@ -3774,7 +3943,7 @@
           </p:nvPr>
         </p:nvGraphicFramePr>
         <p:xfrm>
-          <a:off x="5623560" y="2606040"/>
+          <a:off x="5623560" y="2743200"/>
           <a:ext cx="2926080" cy="914400"/>
         </p:xfrm>
         <a:graphic>
@@ -3800,7 +3969,7 @@
                             <a:srgbClr val="1B1F2A"/>
                           </a:solidFill>
                         </a:rPr>
-                        <a:t>Do</a:t>
+                        <a:t>Błędów do</a:t>
                       </a:r>
                       <a:endParaRPr lang="en-US" sz="1400" dirty="0"/>
                     </a:p>
@@ -6299,7 +6468,7 @@
                   <a:schemeClr val="tx2"/>
                 </a:solidFill>
               </a:rPr>
-              <a:t>heurystyki, potem embeddingi, potem mały model</a:t>
+              <a:t>heurystyki, porównanie z podobnymi pytaniami, mały model</a:t>
             </a:r>
             <a:endParaRPr lang="en-US" sz="1400" dirty="0"/>
           </a:p>
@@ -6787,7 +6956,7 @@
                   <a:schemeClr val="tx2"/>
                 </a:solidFill>
               </a:rPr>
-              <a:t>0,55 znaczy: w 55 z 100 losowych par (trudne i łatwe wg Areny) trudne ma też większą przewagę dużego modelu. Rzut monetą to 50.</a:t>
+              <a:t>AUROC 0,55 znaczy: w 55 z 100 losowych par (trudne i łatwe wg Areny) trudne ma też większą przewagę dużego modelu. Rzut monetą to 50.</a:t>
             </a:r>
             <a:endParaRPr lang="en-US" sz="1400" dirty="0"/>
           </a:p>
@@ -7678,7 +7847,7 @@
         <p:spPr>
           <a:xfrm>
             <a:off x="5760720" y="1170432"/>
-            <a:ext cx="2743200" cy="594360"/>
+            <a:ext cx="2743200" cy="640080"/>
           </a:xfrm>
           <a:prstGeom prst="rect">
             <a:avLst/>
@@ -7713,8 +7882,8 @@
         </p:nvSpPr>
         <p:spPr>
           <a:xfrm>
-            <a:off x="5760720" y="1783080"/>
-            <a:ext cx="2743200" cy="320040"/>
+            <a:off x="5760720" y="1828800"/>
+            <a:ext cx="2743200" cy="274320"/>
           </a:xfrm>
           <a:prstGeom prst="rect">
             <a:avLst/>
@@ -7775,7 +7944,7 @@
         <p:spPr>
           <a:xfrm>
             <a:off x="5760720" y="2450592"/>
-            <a:ext cx="2743200" cy="594360"/>
+            <a:ext cx="2743200" cy="640080"/>
           </a:xfrm>
           <a:prstGeom prst="rect">
             <a:avLst/>
@@ -7810,8 +7979,8 @@
         </p:nvSpPr>
         <p:spPr>
           <a:xfrm>
-            <a:off x="5760720" y="3063240"/>
-            <a:ext cx="2743200" cy="320040"/>
+            <a:off x="5760720" y="3108960"/>
+            <a:ext cx="2743200" cy="274320"/>
           </a:xfrm>
           <a:prstGeom prst="rect">
             <a:avLst/>
@@ -7872,7 +8041,7 @@
         <p:spPr>
           <a:xfrm>
             <a:off x="5760720" y="3730752"/>
-            <a:ext cx="2743200" cy="594360"/>
+            <a:ext cx="2743200" cy="640080"/>
           </a:xfrm>
           <a:prstGeom prst="rect">
             <a:avLst/>
@@ -7907,8 +8076,8 @@
         </p:nvSpPr>
         <p:spPr>
           <a:xfrm>
-            <a:off x="5760720" y="4343400"/>
-            <a:ext cx="2743200" cy="320040"/>
+            <a:off x="5760720" y="4389120"/>
+            <a:ext cx="2743200" cy="274320"/>
           </a:xfrm>
           <a:prstGeom prst="rect">
             <a:avLst/>
@@ -8052,7 +8221,7 @@
         <p:spPr>
           <a:xfrm>
             <a:off x="457200" y="1188720"/>
-            <a:ext cx="3977640" cy="1325880"/>
+            <a:ext cx="3977640" cy="1417320"/>
           </a:xfrm>
           <a:prstGeom prst="rect">
             <a:avLst/>
@@ -8113,7 +8282,7 @@
         <p:spPr>
           <a:xfrm>
             <a:off x="640080" y="1965960"/>
-            <a:ext cx="3611880" cy="457200"/>
+            <a:ext cx="3611880" cy="548640"/>
           </a:xfrm>
           <a:prstGeom prst="rect">
             <a:avLst/>
@@ -8149,7 +8318,7 @@
         <p:spPr>
           <a:xfrm>
             <a:off x="4709160" y="1188720"/>
-            <a:ext cx="3977640" cy="1325880"/>
+            <a:ext cx="3977640" cy="1417320"/>
           </a:xfrm>
           <a:prstGeom prst="rect">
             <a:avLst/>
@@ -8210,7 +8379,7 @@
         <p:spPr>
           <a:xfrm>
             <a:off x="4892040" y="1965960"/>
-            <a:ext cx="3611880" cy="457200"/>
+            <a:ext cx="3611880" cy="548640"/>
           </a:xfrm>
           <a:prstGeom prst="rect">
             <a:avLst/>
@@ -8246,7 +8415,7 @@
         <p:spPr>
           <a:xfrm>
             <a:off x="457200" y="2697480"/>
-            <a:ext cx="3977640" cy="1325880"/>
+            <a:ext cx="3977640" cy="1417320"/>
           </a:xfrm>
           <a:prstGeom prst="rect">
             <a:avLst/>
@@ -8307,7 +8476,7 @@
         <p:spPr>
           <a:xfrm>
             <a:off x="640080" y="3474720"/>
-            <a:ext cx="3611880" cy="457200"/>
+            <a:ext cx="3611880" cy="548640"/>
           </a:xfrm>
           <a:prstGeom prst="rect">
             <a:avLst/>
@@ -8343,7 +8512,7 @@
         <p:spPr>
           <a:xfrm>
             <a:off x="4709160" y="2697480"/>
-            <a:ext cx="3977640" cy="1325880"/>
+            <a:ext cx="3977640" cy="1417320"/>
           </a:xfrm>
           <a:prstGeom prst="rect">
             <a:avLst/>
@@ -8404,7 +8573,7 @@
         <p:spPr>
           <a:xfrm>
             <a:off x="4892040" y="3474720"/>
-            <a:ext cx="3611880" cy="457200"/>
+            <a:ext cx="3611880" cy="548640"/>
           </a:xfrm>
           <a:prstGeom prst="rect">
             <a:avLst/>
@@ -8439,8 +8608,8 @@
         </p:nvSpPr>
         <p:spPr>
           <a:xfrm>
-            <a:off x="457200" y="4206240"/>
-            <a:ext cx="8229600" cy="457200"/>
+            <a:off x="457200" y="4297680"/>
+            <a:ext cx="8229600" cy="411480"/>
           </a:xfrm>
           <a:prstGeom prst="rect">
             <a:avLst/>
@@ -9468,7 +9637,7 @@
                   <a:schemeClr val="tx1"/>
                 </a:solidFill>
               </a:rPr>
-              <a:t>Bez uczenia i bez fine-tuningu</a:t>
+              <a:t>Bez uczenia (jak SW Ranking, RouteLLM)</a:t>
             </a:r>
             <a:endParaRPr lang="en-US" sz="1400" dirty="0"/>
           </a:p>
@@ -9567,7 +9736,7 @@
                   <a:schemeClr val="tx1"/>
                 </a:solidFill>
               </a:rPr>
-              <a:t>Embeddery: 4 sprawdzone (AUROC 0,679–0,709). Najlepszy, qwen3, jest 3× wolniejszy (52 ms wobec 17,6 ms), bez istotnego zysku w APGR.</a:t>
+              <a:t>Embeddery: 4 sprawdzone (AUROC 0,679–0,709). Najlepszy, qwen3, jest 3× wolniejszy (52 ms wobec 17,6 ms), a jego przewaga niewielka.</a:t>
             </a:r>
             <a:endParaRPr lang="en-US" sz="1400" dirty="0"/>
           </a:p>

</xml_diff>

<commit_message>
docs: test z Qwenem, zestaw curli, prezentacja 15 slajdów, dziennik 70
Co-Authored-By: Claude Sonnet 5.5 <noreply@anthropic.com>
Claude-Session: https://claude.ai/code/session_01V1631aLqopE3GM2inWjbQ8
</commit_message>
<xml_diff>
--- a/docs/prezentacja_postepy.pptx
+++ b/docs/prezentacja_postepy.pptx
@@ -19,9 +19,10 @@
     <p:sldId id="267" r:id="rId13"/>
     <p:sldId id="268" r:id="rId14"/>
     <p:sldId id="269" r:id="rId15"/>
+    <p:sldId id="270" r:id="rId16"/>
   </p:sldIdLst>
   <p:notesMasterIdLst>
-    <p:notesMasterId r:id="rId16"/>
+    <p:notesMasterId r:id="rId17"/>
   </p:notesMasterIdLst>
   <p:sldSz cx="9144000" cy="5143500"/>
   <p:notesSz cx="5143500" cy="9144000"/>
@@ -120,7 +121,7 @@
   <p:extLst>
     <p:ext uri="{521415D9-36F7-43E2-AB2F-B90AF26B5E84}">
       <p14:sectionLst xmlns:p14="http://schemas.microsoft.com/office/powerpoint/2010/main">
-        <p14:section name="Wprowadzenie" id="{c61bd391-4038-c0b9-b2e1-7a27b48827db}">
+        <p14:section name="Wprowadzenie" id="{9f792a53-830f-8634-4c6b-eb0cd7be41d9}">
           <p14:sldIdLst>
             <p14:sldId id="256"/>
             <p14:sldId id="257"/>
@@ -128,30 +129,31 @@
             <p14:sldId id="259"/>
           </p14:sldIdLst>
         </p14:section>
-        <p14:section name="Dane i etykiety" id="{68e35cf1-0de9-01a5-4c3a-015d8d8c0f95}">
+        <p14:section name="Dane i etykiety" id="{c3531a53-bccc-b061-5d30-1e0ffb342f79}">
           <p14:sldIdLst>
             <p14:sldId id="260"/>
             <p14:sldId id="261"/>
             <p14:sldId id="262"/>
           </p14:sldIdLst>
         </p14:section>
-        <p14:section name="Router" id="{1496c409-2850-0bc5-7511-1ac0ae7c494c}">
+        <p14:section name="Router" id="{6d8d1785-5f62-84ca-7ac3-1ea253b93b1d}">
           <p14:sldIdLst>
             <p14:sldId id="263"/>
             <p14:sldId id="264"/>
           </p14:sldIdLst>
         </p14:section>
-        <p14:section name="Wyniki" id="{3d3590a9-6be4-df01-0021-659ab980249c}">
+        <p14:section name="Wyniki" id="{186936ac-1291-99a7-c4b4-8d6c00aaad95}">
           <p14:sldIdLst>
             <p14:sldId id="265"/>
             <p14:sldId id="266"/>
             <p14:sldId id="267"/>
+            <p14:sldId id="268"/>
           </p14:sldIdLst>
         </p14:section>
-        <p14:section name="Dalej" id="{74747c1c-f02d-c008-bee6-8d1546cc7b8b}">
+        <p14:section name="Dalej" id="{c7214c98-ff16-45ce-0887-2f39a54d43d4}">
           <p14:sldIdLst>
-            <p14:sldId id="268"/>
             <p14:sldId id="269"/>
+            <p14:sldId id="270"/>
           </p14:sldIdLst>
         </p14:section>
       </p14:sectionLst>
@@ -589,7 +591,7 @@
           <a:p>
             <a:r>
               <a:rPr lang="pl-PL" sz="1400"/>
-              <a:t>Całość zajmie ok. 18–20 minut.</a:t>
+              <a:t>Całość zajmie ok. 20 minut.</a:t>
             </a:r>
           </a:p>
         </p:txBody>
@@ -1270,7 +1272,7 @@
           <a:p>
             <a:r>
               <a:rPr lang="pl-PL" sz="1400"/>
-              <a:t>Implementacja. Usługa RouterService działa w DeepFellow Infra w wersji 0.34. Napisałem 57 nowych testów, a cały zestaw testów (5157) przechodzi. Sprawdziłem ją od początku do końca na osobnej instancji z modelami Gemini: wybór modelu, nagłówki z decyzją, strumieniowanie i przełączenie na duży model przy błędzie (po angielsku fallback). Test wykrył błąd: wycofany model zwracał 404 jako zwykłą odpowiedź i omijał to przełączenie. Naprawiłem. Z modelami Qwen 8B i 27B jeszcze nie uruchamiałem. Zrobię to na komputerze służbowym.
+              <a:t>Do tej pory wszystkie wyniki liczyłem na zapisanych danych. Teraz pokazuję pierwsze uruchomienie całego systemu na prawdziwych modelach: małym qwen3:8b, uruchomionym w programie Ollama, i dużym Qwen 27B, uruchomionym przez vLLM. Oba podłączone przez DeepFellow. Zrobiłem to 20 października na komputerze służbowym i wysłałem do modelu o nazwie router cztery pytania.
 </a:t>
             </a:r>
           </a:p>
@@ -1280,7 +1282,7 @@
           <a:p>
             <a:r>
               <a:rPr lang="pl-PL" sz="1400"/>
-              <a:t>Sprawdziłem też dwie rzeczy. Czas: mediana 20,6 ms, a 90% zapytań w mniej niż 65 ms (cel poniżej 50 ms spełniony dla mediany). Odporność: po literówkach, parafrazach i zamianie na synonimy decyzja zmienia się tylko w 6–10% pytań. Losowo byłoby 42–48%. Router nie jest więc wrażliwy na drobne zmiany sformułowania.
+              <a:t>Router dopisuje do każdej odpowiedzi trzy nagłówki: który model odpowiedział, która warstwa podjęła decyzję i jaki był wynik kNN, czyli ta liczba od 0 do 1 ze slajdu 9. Dzięki temu decyzję widać bez zaglądania do logów.
 </a:t>
             </a:r>
           </a:p>
@@ -1290,7 +1292,51 @@
           <a:p>
             <a:r>
               <a:rPr lang="pl-PL" sz="1400"/>
-              <a:t>Ograniczenia, które nazywam wprost. Jedna para modeli. Jeden sędzia, a zgodność z człowiekiem jest umiarkowana. Duży model ma jedną próbkę na pytanie. Dane są mało „firmowe”: 63% to publiczne czaty. Wiedza i kod są słabo wykrywane. Warstwa 1 (heurystyki) jest na naszych danych słaba (AUROC ok. 0,55), dlatego jest opcjonalna. Możliwe, że na danych firmowych wypadnie lepiej, ale to hipoteza do sprawdzenia.
+              <a:t>Pierwsze pytanie, o stolicę Francji: wynik 0,19, poniżej progu 0,3, więc odpowiada mały model. Drugie, prośba o opowiadanie o smoku i rycerzu: wynik 0,70, powyżej progu, więc odpowiada duży i pisze całe opowiadanie. Trzecie to polecenie „przeanalizuj i porównaj dwa projekty, oceń kompromisy krok po kroku”. Zawiera pięć fraz z listy zadań trudnych, czyli pięć punktów heurystyk przy progu dwóch. Decyduje więc warstwa 1: pytanie idzie od razu do dużego i nawet nie liczę embeddingu, dlatego nie ma wyniku kNN. Przy opowiadaniu heurystyki dały tylko jeden punkt, więc decyzja przeszła do warstwy 2. Czwarte to mnożenie 17 razy 23 wysłane w trybie strumieniowym, czyli odpowiedź przychodzi kawałkami: wynik 0,10, odpowiada mały, a nagłówki z decyzją dochodzą przed pierwszym kawałkiem odpowiedzi.
+</a:t>
+            </a:r>
+          </a:p>
+          <a:p>
+            <a:endParaRPr lang="pl-PL" sz="1400"/>
+          </a:p>
+          <a:p>
+            <a:r>
+              <a:rPr lang="pl-PL" sz="1400"/>
+              <a:t>Potem zmierzyłem, ile czasu dokłada sam router. To samo proste pytanie wysłałem pięć razy przez router i pięć razy bezpośrednio do małego modelu. Średni czas to 0,376 s wobec 0,363 s, czyli router dodaje ok. 13 ms. Cel z planu to mniej niż 50 ms.
+</a:t>
+            </a:r>
+          </a:p>
+          <a:p>
+            <a:endParaRPr lang="pl-PL" sz="1400"/>
+          </a:p>
+          <a:p>
+            <a:r>
+              <a:rPr lang="pl-PL" sz="1400"/>
+              <a:t>Czego jeszcze nie sprawdziłem: przełączenia na duży model, gdy router ulegnie awarii, oraz tego, że po restarcie DeepFellow usługa wraca sama. To zrobię w następnej kolejności.
+</a:t>
+            </a:r>
+          </a:p>
+          <a:p>
+            <a:endParaRPr lang="pl-PL" sz="1400"/>
+          </a:p>
+          <a:p>
+            <a:r>
+              <a:rPr lang="pl-PL" sz="1400" b="1"/>
+              <a:t>UWAGA
+</a:t>
+            </a:r>
+          </a:p>
+          <a:p>
+            <a:r>
+              <a:rPr lang="pl-PL" sz="1400"/>
+              <a:t>Pięć pomiarów to mało, a czasy bezpośrednie wahają się o ok. 27 ms, czyli więcej niż sama różnica. Wniosek brzmi więc: narzut to kilka do kilkunastu milisekund i na pewno poniżej 50, a nie dokładnie 13.
+</a:t>
+            </a:r>
+          </a:p>
+          <a:p>
+            <a:r>
+              <a:rPr lang="pl-PL" sz="1400"/>
+              <a:t>Cztery pytania pokazują, że mechanizm działa. Nie mówią, jak dobrze router wybiera. Jakość wyboru pokazują wyniki na zbiorze danych z wcześniejszych slajdów.
 </a:t>
             </a:r>
           </a:p>
@@ -1307,7 +1353,14 @@
           <a:p>
             <a:r>
               <a:rPr lang="pl-PL" sz="1400"/>
-              <a:t>Czy zadziała na innych modelach? Router tak, ale etykiety trzeba zmierzyć od nowa: ok. 1,5 doby generowania i ok. 8 USD za sędziego.</a:t>
+              <a:t>Czemu to nie jest to samo co 20,6 ms z następnego slajdu? To dwa różne pomiary: tamten dotyczył samej decyzji routera na moim komputerze, bez DeepFellow, a ten całej drogi przez DeepFellow na komputerze służbowym, jako różnica czasów. Obie liczby są poniżej 50 ms.
+</a:t>
+            </a:r>
+          </a:p>
+          <a:p>
+            <a:r>
+              <a:rPr lang="pl-PL" sz="1400"/>
+              <a:t>Jak rozumieć wynik 0,19? Jako w przybliżeniu odsetek trudnych pytań wśród 20 podobnych z bazy, z większą wagą dla bardziej podobnych.</a:t>
             </a:r>
           </a:p>
         </p:txBody>
@@ -1401,7 +1454,7 @@
           <a:p>
             <a:r>
               <a:rPr lang="pl-PL" sz="1400"/>
-              <a:t>Co dalej. Po pierwsze, uruchomić system z modelami Qwen 8B i 27B na komputerze służbowym i zmierzyć opóźnienie przez DeepFellow. Po drugie, sprawdzić warstwę 3 (test go/no-go): czy mały model oceniający pytanie poprawia wynik routera. Po trzecie, dodać dane bliższe wdrożeniu, np. własne zapytania, zadania SQL, polecenia biurowe. To wymaga ponownego pomiaru, ale pozwoli też sprawdzić, czy heurystyki warstwy 1 działają lepiej na takich danych. Po czwarte, otworzyć zbiór testowy raz i zrobić ocenę końcową.
+              <a:t>Implementacja. Usługa RouterService działa w DeepFellow Infra w wersji 0.34. Napisałem 57 nowych testów, a cały zestaw testów (5157) przechodzi. Sprawdziłem ją od początku do końca na osobnej instancji z modelami Gemini: wybór modelu, nagłówki z decyzją, strumieniowanie i przełączenie na duży model przy błędzie (po angielsku fallback). Test wykrył błąd: wycofany model zwracał 404 jako zwykłą odpowiedź i omijał to przełączenie. Naprawiłem. Z modelami Qwen 8B i 27B uruchomiłem ją już na komputerze służbowym i pokazałem to na poprzednim slajdzie. Zostały dwa sprawdzenia: przełączenie na duży model przy awarii i restart usługi.
 </a:t>
             </a:r>
           </a:p>
@@ -1411,7 +1464,7 @@
           <a:p>
             <a:r>
               <a:rPr lang="pl-PL" sz="1400"/>
-              <a:t>Prośba. Proszę o zatwierdzenie celów liczbowych przed otwarciem testu. Po otwarciu nie będę ich zmieniał, a wyniki podam niezależnie od tego, czy cele są spełnione. To zabezpiecza przed dopasowaniem wymagań do wyniku.
+              <a:t>Sprawdziłem też dwie rzeczy. Czas: mediana 20,6 ms, a 90% zapytań w mniej niż 65 ms (cel poniżej 50 ms spełniony dla mediany). Odporność: po literówkach, parafrazach i zamianie na synonimy decyzja zmienia się tylko w 6–10% pytań. Losowo byłoby 42–48%. Router nie jest więc wrażliwy na drobne zmiany sformułowania.
 </a:t>
             </a:r>
           </a:p>
@@ -1421,49 +1474,7 @@
           <a:p>
             <a:r>
               <a:rPr lang="pl-PL" sz="1400"/>
-              <a:t>Moja propozycja celów:
-</a:t>
-            </a:r>
-          </a:p>
-          <a:p>
-            <a:r>
-              <a:rPr lang="pl-PL" sz="1400"/>
-              <a:t>• router lepszy od „samego źródła” w sposób istotny statystycznie,
-</a:t>
-            </a:r>
-          </a:p>
-          <a:p>
-            <a:r>
-              <a:rPr lang="pl-PL" sz="1400"/>
-              <a:t>• AUROC co najmniej 0,64 (w badaniach 0,68),
-</a:t>
-            </a:r>
-          </a:p>
-          <a:p>
-            <a:r>
-              <a:rPr lang="pl-PL" sz="1400"/>
-              <a:t>• żeby odzyskać 80% możliwego zysku jakości, wysyłam do dużego nie więcej niż 72% pytań (losowo byłoby 80%),
-</a:t>
-            </a:r>
-          </a:p>
-          <a:p>
-            <a:r>
-              <a:rPr lang="pl-PL" sz="1400"/>
-              <a:t>• po literówkach i parafrazach decyzja zmienia się w najwyżej 15% pytań,
-</a:t>
-            </a:r>
-          </a:p>
-          <a:p>
-            <a:r>
-              <a:rPr lang="pl-PL" sz="1400"/>
-              <a:t>• mediana czasu decyzji poniżej 50 ms,
-</a:t>
-            </a:r>
-          </a:p>
-          <a:p>
-            <a:r>
-              <a:rPr lang="pl-PL" sz="1400"/>
-              <a:t>• pytania spoza dziedziny (MMLU, MT-Bench) tylko raportuję, bez progu.
+              <a:t>Ograniczenia, które nazywam wprost. Jedna para modeli. Jeden sędzia, a zgodność z człowiekiem jest umiarkowana. Duży model ma jedną próbkę na pytanie. Dane są mało „firmowe”: 63% to publiczne czaty. Wiedza i kod są słabo wykrywane. Warstwa 1 (heurystyki) jest na naszych danych słaba (AUROC ok. 0,55), dlatego jest opcjonalna. Możliwe, że na danych firmowych wypadnie lepiej, ale to hipoteza do sprawdzenia.
 </a:t>
             </a:r>
           </a:p>
@@ -1472,8 +1483,15 @@
           </a:p>
           <a:p>
             <a:r>
-              <a:rPr lang="pl-PL" sz="1400"/>
-              <a:t>Podsumowanie. Etykiety mierzę z prawdziwych odpowiedzi modeli. Router oparty na podobieństwie pytań daje realny, ale umiarkowany zysk, jest szybki i stabilny. Nie przewidzi tylko tego, czy mały model zna konkretny fakt.</a:t>
+              <a:rPr lang="pl-PL" sz="1400" b="1"/>
+              <a:t>JEŚLI ZAPYTAJĄ
+</a:t>
+            </a:r>
+          </a:p>
+          <a:p>
+            <a:r>
+              <a:rPr lang="pl-PL" sz="1400"/>
+              <a:t>Czy zadziała na innych modelach? Router tak, ale etykiety trzeba zmierzyć od nowa: ok. 1,5 doby generowania i ok. 8 USD za sędziego.</a:t>
             </a:r>
           </a:p>
         </p:txBody>
@@ -1496,6 +1514,172 @@
             <a:fld id="{F7021451-1387-4CA6-816F-3879F97B5CBC}" type="slidenum">
               <a:rPr lang="en-US"/>
               <a:t>14</a:t>
+            </a:fld>
+            <a:endParaRPr lang="en-US"/>
+          </a:p>
+        </p:txBody>
+      </p:sp>
+    </p:spTree>
+    <p:extLst>
+      <p:ext uri="{BB962C8B-B14F-4D97-AF65-F5344CB8AC3E}">
+        <p14:creationId xmlns:p14="http://schemas.microsoft.com/office/powerpoint/2010/main" val="1024086991"/>
+      </p:ext>
+    </p:extLst>
+  </p:cSld>
+  <p:clrMapOvr>
+    <a:masterClrMapping/>
+  </p:clrMapOvr>
+</p:notes>
+</file>
+
+<file path=ppt/notesSlides/notesSlide15.xml><?xml version="1.0" encoding="utf-8"?>
+<p:notes xmlns:a="http://schemas.openxmlformats.org/drawingml/2006/main" xmlns:r="http://schemas.openxmlformats.org/officeDocument/2006/relationships" xmlns:p="http://schemas.openxmlformats.org/presentationml/2006/main">
+  <p:cSld>
+    <p:spTree>
+      <p:nvGrpSpPr>
+        <p:cNvPr id="1" name=""/>
+        <p:cNvGrpSpPr/>
+        <p:nvPr/>
+      </p:nvGrpSpPr>
+      <p:grpSpPr>
+        <a:xfrm>
+          <a:off x="0" y="0"/>
+          <a:ext cx="0" cy="0"/>
+          <a:chOff x="0" y="0"/>
+          <a:chExt cx="0" cy="0"/>
+        </a:xfrm>
+      </p:grpSpPr>
+      <p:sp>
+        <p:nvSpPr>
+          <p:cNvPr id="2" name="Slide Image Placeholder 1"/>
+          <p:cNvSpPr>
+            <a:spLocks noGrp="1" noRot="1" noChangeAspect="1"/>
+          </p:cNvSpPr>
+          <p:nvPr>
+            <p:ph type="sldImg"/>
+          </p:nvPr>
+        </p:nvSpPr>
+        <p:spPr/>
+      </p:sp>
+      <p:sp>
+        <p:nvSpPr>
+          <p:cNvPr id="3" name="Notes Placeholder 2"/>
+          <p:cNvSpPr>
+            <a:spLocks noGrp="1"/>
+          </p:cNvSpPr>
+          <p:nvPr>
+            <p:ph type="body" idx="1"/>
+          </p:nvPr>
+        </p:nvSpPr>
+        <p:spPr/>
+        <p:txBody>
+          <a:bodyPr/>
+          <a:lstStyle/>
+          <a:p>
+            <a:r>
+              <a:rPr lang="pl-PL" sz="1400" b="1"/>
+              <a:t>MÓW
+</a:t>
+            </a:r>
+          </a:p>
+          <a:p>
+            <a:r>
+              <a:rPr lang="pl-PL" sz="1400"/>
+              <a:t>Co dalej. Po pierwsze, dokończyć test z modelami Qwen 8B i 27B na komputerze służbowym: awaria i restart usługi, a opóźnienie zmierzyć dokładniej, na większej liczbie pomiarów. Po drugie, sprawdzić warstwę 3 (test go/no-go): czy mały model oceniający pytanie poprawia wynik routera, i to tylko w strefie niepewności, czyli tam, gdzie warstwa 2 nie jest pewna. Granice strefy dobiorę tak, żeby jakość nie spadła poniżej ustalonego poziomu, który jeszcze trzeba ustalić. Po trzecie, dodać dane bliższe wdrożeniu, np. własne zapytania, zadania SQL, polecenia biurowe. To wymaga ponownego pomiaru, ale pozwoli też sprawdzić, czy heurystyki warstwy 1 działają lepiej na takich danych. Po czwarte, otworzyć zbiór testowy raz i zrobić ocenę końcową.
+</a:t>
+            </a:r>
+          </a:p>
+          <a:p>
+            <a:endParaRPr lang="pl-PL" sz="1400"/>
+          </a:p>
+          <a:p>
+            <a:r>
+              <a:rPr lang="pl-PL" sz="1400"/>
+              <a:t>Prośba. Proszę o zatwierdzenie celów liczbowych przed otwarciem testu. Po otwarciu nie będę ich zmieniał, a wyniki podam niezależnie od tego, czy cele są spełnione. To zabezpiecza przed dopasowaniem wymagań do wyniku.
+</a:t>
+            </a:r>
+          </a:p>
+          <a:p>
+            <a:endParaRPr lang="pl-PL" sz="1400"/>
+          </a:p>
+          <a:p>
+            <a:r>
+              <a:rPr lang="pl-PL" sz="1400"/>
+              <a:t>Moja propozycja celów:
+</a:t>
+            </a:r>
+          </a:p>
+          <a:p>
+            <a:r>
+              <a:rPr lang="pl-PL" sz="1400"/>
+              <a:t>• router lepszy od „samego źródła” w sposób istotny statystycznie,
+</a:t>
+            </a:r>
+          </a:p>
+          <a:p>
+            <a:r>
+              <a:rPr lang="pl-PL" sz="1400"/>
+              <a:t>• AUROC co najmniej 0,64 (w badaniach 0,68),
+</a:t>
+            </a:r>
+          </a:p>
+          <a:p>
+            <a:r>
+              <a:rPr lang="pl-PL" sz="1400"/>
+              <a:t>• żeby odzyskać 80% możliwego zysku jakości, wysyłam do dużego nie więcej niż 72% pytań (losowo byłoby 80%),
+</a:t>
+            </a:r>
+          </a:p>
+          <a:p>
+            <a:r>
+              <a:rPr lang="pl-PL" sz="1400"/>
+              <a:t>• po literówkach i parafrazach decyzja zmienia się w najwyżej 15% pytań,
+</a:t>
+            </a:r>
+          </a:p>
+          <a:p>
+            <a:r>
+              <a:rPr lang="pl-PL" sz="1400"/>
+              <a:t>• mediana czasu decyzji poniżej 50 ms,
+</a:t>
+            </a:r>
+          </a:p>
+          <a:p>
+            <a:r>
+              <a:rPr lang="pl-PL" sz="1400"/>
+              <a:t>• pytania spoza dziedziny (MMLU, MT-Bench) tylko raportuję, bez progu.
+</a:t>
+            </a:r>
+          </a:p>
+          <a:p>
+            <a:endParaRPr lang="pl-PL" sz="1400"/>
+          </a:p>
+          <a:p>
+            <a:r>
+              <a:rPr lang="pl-PL" sz="1400"/>
+              <a:t>Podsumowanie. Etykiety mierzę z prawdziwych odpowiedzi modeli. Router oparty na podobieństwie pytań daje realny, ale umiarkowany zysk, jest szybki i stabilny. Nie przewidzi tylko tego, czy mały model zna konkretny fakt.</a:t>
+            </a:r>
+          </a:p>
+        </p:txBody>
+      </p:sp>
+      <p:sp>
+        <p:nvSpPr>
+          <p:cNvPr id="4" name="Slide Number Placeholder 3"/>
+          <p:cNvSpPr>
+            <a:spLocks noGrp="1"/>
+          </p:cNvSpPr>
+          <p:nvPr>
+            <p:ph type="sldNum" sz="quarter" idx="10"/>
+          </p:nvPr>
+        </p:nvSpPr>
+        <p:spPr/>
+        <p:txBody>
+          <a:bodyPr/>
+          <a:lstStyle/>
+          <a:p>
+            <a:fld id="{F7021451-1387-4CA6-816F-3879F97B5CBC}" type="slidenum">
+              <a:rPr lang="en-US"/>
+              <a:t>15</a:t>
             </a:fld>
             <a:endParaRPr lang="en-US"/>
           </a:p>
@@ -2558,7 +2742,7 @@
           <a:p>
             <a:r>
               <a:rPr lang="pl-PL" sz="1400"/>
-              <a:t>Warstwa 3: mały model sam ocenia, czy pytanie jest trudne. Jeszcze jej nie ma. Wejdzie, jeśli krótki test pokaże zysk. Ten test nazywa się go/no-go: jeśli pomaga, budujemy, jeśli nie, rezygnujemy.
+              <a:t>Warstwa 3: mały model sam ocenia, czy pytanie jest trudne. Jeszcze jej nie ma. Wejdzie, jeśli krótki test pokaże zysk. Ten test nazywa się go/no-go: jeśli pomaga, budujemy, jeśli nie, rezygnujemy. Nie chcę jej wywoływać dla każdego pytania, bo to wywołanie małego modelu i trwa sekundy. Będzie dotyczyć tylko pytań, przy których warstwa 2 jest niepewna. Wyjaśniam to niżej, po omówieniu wyniku routera.
 </a:t>
             </a:r>
           </a:p>
@@ -2569,6 +2753,16 @@
             <a:r>
               <a:rPr lang="pl-PL" sz="1400"/>
               <a:t>Na końcu router zwraca liczbę od 0 do 1. To jego wynik dla pytania: im wyższy, tym bardziej router uważa pytanie za trudne, czyli tym większa szansa, że duży model odpowie wyraźnie lepiej. Administrator ustawia próg: wynik powyżej idzie do dużego modelu, poniżej do małego. Gdy cokolwiek zawiedzie, pytanie idzie do dużego, bo to bezpieczniejsze.
+</a:t>
+            </a:r>
+          </a:p>
+          <a:p>
+            <a:endParaRPr lang="pl-PL" sz="1400"/>
+          </a:p>
+          <a:p>
+            <a:r>
+              <a:rPr lang="pl-PL" sz="1400"/>
+              <a:t>Teraz warstwa 3. Niepewna znaczy: wynik warstwy 2 jest w środku skali, między dwoma progami, a nie przy jej końcach. Przykład: poniżej 0,2 pytanie idzie do małego, powyżej 0,45 do dużego, a pomiędzy decyduje warstwa 3. W naszych danych to mniej więcej połowa pytań. Pozostałe, tak czy inaczej rozstrzyga sama warstwa 2. Granice dobiorę na danych do dostrajania tak, żeby jakość nie spadła poniżej ustalonego poziomu. Tego poziomu jeszcze nie ustaliłem.
 </a:t>
             </a:r>
           </a:p>
@@ -2585,7 +2779,7 @@
           <a:p>
             <a:r>
               <a:rPr lang="pl-PL" sz="1400"/>
-              <a:t>Ile to trwa? Heurystyki ok. 0,3 ms, a warstwa 2 ok. 20 ms. Warstwa 3 byłaby wywołaniem małego modelu, czyli sekundami, dlatego jest ostatnia.</a:t>
+              <a:t>Ile to trwa? Heurystyki ok. 0,3 ms, a warstwa 2 ok. 20 ms. Warstwa 3 byłaby wywołaniem małego modelu, czyli sekundami, dlatego jest ostatnia i tylko dla pytań w strefie niepewności.</a:t>
             </a:r>
           </a:p>
         </p:txBody>
@@ -4631,22 +4825,1272 @@
                   <a:srgbClr val="1B1F2A"/>
                 </a:solidFill>
               </a:rPr>
-              <a:t>Implementacja i ograniczenia</a:t>
+              <a:t>Test na prawdziwych modelach</a:t>
             </a:r>
             <a:endParaRPr lang="en-US" sz="3200" dirty="0"/>
           </a:p>
         </p:txBody>
       </p:sp>
-      <p:sp>
-        <p:nvSpPr>
-          <p:cNvPr id="3" name="Implementacja karta"/>
+      <p:graphicFrame>
+        <p:nvGraphicFramePr>
+          <p:cNvPr id="14" name="Tabela testów"/>
+          <p:cNvGraphicFramePr>
+            <a:graphicFrameLocks noGrp="1"/>
+          </p:cNvGraphicFramePr>
+          <p:nvPr>
+            <p:extLst>
+              <p:ext uri="{D42A27DB-BD31-4B8C-83A1-F6EECF244321}">
+                <p14:modId xmlns:p14="http://schemas.microsoft.com/office/powerpoint/2010/main" val="1579011935"/>
+              </p:ext>
+            </p:extLst>
+          </p:nvPr>
+        </p:nvGraphicFramePr>
+        <p:xfrm>
+          <a:off x="457200" y="1188720"/>
+          <a:ext cx="5577840" cy="914400"/>
+        </p:xfrm>
+        <a:graphic>
+          <a:graphicData uri="http://schemas.openxmlformats.org/drawingml/2006/table">
+            <a:tbl>
+              <a:tblPr/>
+              <a:tblGrid>
+                <a:gridCol w="2286000"/>
+                <a:gridCol w="1097280"/>
+                <a:gridCol w="914400"/>
+                <a:gridCol w="1280160"/>
+              </a:tblGrid>
+              <a:tr h="502920">
+                <a:tc>
+                  <a:txBody>
+                    <a:bodyPr/>
+                    <a:lstStyle/>
+                    <a:p>
+                      <a:pPr indent="0" marL="0">
+                        <a:buNone/>
+                      </a:pPr>
+                      <a:r>
+                        <a:rPr lang="en-US" sz="1300" b="1" dirty="0">
+                          <a:solidFill>
+                            <a:srgbClr val="1B1F2A"/>
+                          </a:solidFill>
+                        </a:rPr>
+                        <a:t>Zapytanie</a:t>
+                      </a:r>
+                      <a:endParaRPr lang="en-US" sz="1300" dirty="0"/>
+                    </a:p>
+                  </a:txBody>
+                  <a:tcPr marL="91440" marR="91440" marT="45720" marB="45720" anchor="ctr">
+                    <a:lnL w="6350" cap="flat" cmpd="sng" algn="ctr">
+                      <a:solidFill>
+                        <a:srgbClr val="C7CEDB"/>
+                      </a:solidFill>
+                      <a:prstDash val="solid"/>
+                      <a:round/>
+                      <a:headEnd type="none" w="med" len="med"/>
+                      <a:tailEnd type="none" w="med" len="med"/>
+                    </a:lnL>
+                    <a:lnR w="6350" cap="flat" cmpd="sng" algn="ctr">
+                      <a:solidFill>
+                        <a:srgbClr val="C7CEDB"/>
+                      </a:solidFill>
+                      <a:prstDash val="solid"/>
+                      <a:round/>
+                      <a:headEnd type="none" w="med" len="med"/>
+                      <a:tailEnd type="none" w="med" len="med"/>
+                    </a:lnR>
+                    <a:lnT w="6350" cap="flat" cmpd="sng" algn="ctr">
+                      <a:solidFill>
+                        <a:srgbClr val="C7CEDB"/>
+                      </a:solidFill>
+                      <a:prstDash val="solid"/>
+                      <a:round/>
+                      <a:headEnd type="none" w="med" len="med"/>
+                      <a:tailEnd type="none" w="med" len="med"/>
+                    </a:lnT>
+                    <a:lnB w="6350" cap="flat" cmpd="sng" algn="ctr">
+                      <a:solidFill>
+                        <a:srgbClr val="C7CEDB"/>
+                      </a:solidFill>
+                      <a:prstDash val="solid"/>
+                      <a:round/>
+                      <a:headEnd type="none" w="med" len="med"/>
+                      <a:tailEnd type="none" w="med" len="med"/>
+                    </a:lnB>
+                    <a:solidFill>
+                      <a:srgbClr val="F1F3F6"/>
+                    </a:solidFill>
+                  </a:tcPr>
+                </a:tc>
+                <a:tc>
+                  <a:txBody>
+                    <a:bodyPr/>
+                    <a:lstStyle/>
+                    <a:p>
+                      <a:pPr indent="0" marL="0">
+                        <a:buNone/>
+                      </a:pPr>
+                      <a:r>
+                        <a:rPr lang="en-US" sz="1300" b="1" dirty="0">
+                          <a:solidFill>
+                            <a:srgbClr val="1B1F2A"/>
+                          </a:solidFill>
+                        </a:rPr>
+                        <a:t>Warstwa</a:t>
+                      </a:r>
+                      <a:endParaRPr lang="en-US" sz="1300" dirty="0"/>
+                    </a:p>
+                  </a:txBody>
+                  <a:tcPr marL="91440" marR="91440" marT="45720" marB="45720" anchor="ctr">
+                    <a:lnL w="6350" cap="flat" cmpd="sng" algn="ctr">
+                      <a:solidFill>
+                        <a:srgbClr val="C7CEDB"/>
+                      </a:solidFill>
+                      <a:prstDash val="solid"/>
+                      <a:round/>
+                      <a:headEnd type="none" w="med" len="med"/>
+                      <a:tailEnd type="none" w="med" len="med"/>
+                    </a:lnL>
+                    <a:lnR w="6350" cap="flat" cmpd="sng" algn="ctr">
+                      <a:solidFill>
+                        <a:srgbClr val="C7CEDB"/>
+                      </a:solidFill>
+                      <a:prstDash val="solid"/>
+                      <a:round/>
+                      <a:headEnd type="none" w="med" len="med"/>
+                      <a:tailEnd type="none" w="med" len="med"/>
+                    </a:lnR>
+                    <a:lnT w="6350" cap="flat" cmpd="sng" algn="ctr">
+                      <a:solidFill>
+                        <a:srgbClr val="C7CEDB"/>
+                      </a:solidFill>
+                      <a:prstDash val="solid"/>
+                      <a:round/>
+                      <a:headEnd type="none" w="med" len="med"/>
+                      <a:tailEnd type="none" w="med" len="med"/>
+                    </a:lnT>
+                    <a:lnB w="6350" cap="flat" cmpd="sng" algn="ctr">
+                      <a:solidFill>
+                        <a:srgbClr val="C7CEDB"/>
+                      </a:solidFill>
+                      <a:prstDash val="solid"/>
+                      <a:round/>
+                      <a:headEnd type="none" w="med" len="med"/>
+                      <a:tailEnd type="none" w="med" len="med"/>
+                    </a:lnB>
+                    <a:solidFill>
+                      <a:srgbClr val="F1F3F6"/>
+                    </a:solidFill>
+                  </a:tcPr>
+                </a:tc>
+                <a:tc>
+                  <a:txBody>
+                    <a:bodyPr/>
+                    <a:lstStyle/>
+                    <a:p>
+                      <a:pPr indent="0" marL="0">
+                        <a:buNone/>
+                      </a:pPr>
+                      <a:r>
+                        <a:rPr lang="en-US" sz="1300" b="1" dirty="0">
+                          <a:solidFill>
+                            <a:srgbClr val="1B1F2A"/>
+                          </a:solidFill>
+                        </a:rPr>
+                        <a:t>Model</a:t>
+                      </a:r>
+                      <a:endParaRPr lang="en-US" sz="1300" dirty="0"/>
+                    </a:p>
+                  </a:txBody>
+                  <a:tcPr marL="91440" marR="91440" marT="45720" marB="45720" anchor="ctr">
+                    <a:lnL w="6350" cap="flat" cmpd="sng" algn="ctr">
+                      <a:solidFill>
+                        <a:srgbClr val="C7CEDB"/>
+                      </a:solidFill>
+                      <a:prstDash val="solid"/>
+                      <a:round/>
+                      <a:headEnd type="none" w="med" len="med"/>
+                      <a:tailEnd type="none" w="med" len="med"/>
+                    </a:lnL>
+                    <a:lnR w="6350" cap="flat" cmpd="sng" algn="ctr">
+                      <a:solidFill>
+                        <a:srgbClr val="C7CEDB"/>
+                      </a:solidFill>
+                      <a:prstDash val="solid"/>
+                      <a:round/>
+                      <a:headEnd type="none" w="med" len="med"/>
+                      <a:tailEnd type="none" w="med" len="med"/>
+                    </a:lnR>
+                    <a:lnT w="6350" cap="flat" cmpd="sng" algn="ctr">
+                      <a:solidFill>
+                        <a:srgbClr val="C7CEDB"/>
+                      </a:solidFill>
+                      <a:prstDash val="solid"/>
+                      <a:round/>
+                      <a:headEnd type="none" w="med" len="med"/>
+                      <a:tailEnd type="none" w="med" len="med"/>
+                    </a:lnT>
+                    <a:lnB w="6350" cap="flat" cmpd="sng" algn="ctr">
+                      <a:solidFill>
+                        <a:srgbClr val="C7CEDB"/>
+                      </a:solidFill>
+                      <a:prstDash val="solid"/>
+                      <a:round/>
+                      <a:headEnd type="none" w="med" len="med"/>
+                      <a:tailEnd type="none" w="med" len="med"/>
+                    </a:lnB>
+                    <a:solidFill>
+                      <a:srgbClr val="F1F3F6"/>
+                    </a:solidFill>
+                  </a:tcPr>
+                </a:tc>
+                <a:tc>
+                  <a:txBody>
+                    <a:bodyPr/>
+                    <a:lstStyle/>
+                    <a:p>
+                      <a:pPr indent="0" marL="0">
+                        <a:buNone/>
+                      </a:pPr>
+                      <a:r>
+                        <a:rPr lang="en-US" sz="1300" b="1" dirty="0">
+                          <a:solidFill>
+                            <a:srgbClr val="1B1F2A"/>
+                          </a:solidFill>
+                        </a:rPr>
+                        <a:t>Wynik kNN</a:t>
+                      </a:r>
+                      <a:endParaRPr lang="en-US" sz="1300" dirty="0"/>
+                    </a:p>
+                  </a:txBody>
+                  <a:tcPr marL="91440" marR="91440" marT="45720" marB="45720" anchor="ctr">
+                    <a:lnL w="6350" cap="flat" cmpd="sng" algn="ctr">
+                      <a:solidFill>
+                        <a:srgbClr val="C7CEDB"/>
+                      </a:solidFill>
+                      <a:prstDash val="solid"/>
+                      <a:round/>
+                      <a:headEnd type="none" w="med" len="med"/>
+                      <a:tailEnd type="none" w="med" len="med"/>
+                    </a:lnL>
+                    <a:lnR w="6350" cap="flat" cmpd="sng" algn="ctr">
+                      <a:solidFill>
+                        <a:srgbClr val="C7CEDB"/>
+                      </a:solidFill>
+                      <a:prstDash val="solid"/>
+                      <a:round/>
+                      <a:headEnd type="none" w="med" len="med"/>
+                      <a:tailEnd type="none" w="med" len="med"/>
+                    </a:lnR>
+                    <a:lnT w="6350" cap="flat" cmpd="sng" algn="ctr">
+                      <a:solidFill>
+                        <a:srgbClr val="C7CEDB"/>
+                      </a:solidFill>
+                      <a:prstDash val="solid"/>
+                      <a:round/>
+                      <a:headEnd type="none" w="med" len="med"/>
+                      <a:tailEnd type="none" w="med" len="med"/>
+                    </a:lnT>
+                    <a:lnB w="6350" cap="flat" cmpd="sng" algn="ctr">
+                      <a:solidFill>
+                        <a:srgbClr val="C7CEDB"/>
+                      </a:solidFill>
+                      <a:prstDash val="solid"/>
+                      <a:round/>
+                      <a:headEnd type="none" w="med" len="med"/>
+                      <a:tailEnd type="none" w="med" len="med"/>
+                    </a:lnB>
+                    <a:solidFill>
+                      <a:srgbClr val="F1F3F6"/>
+                    </a:solidFill>
+                  </a:tcPr>
+                </a:tc>
+              </a:tr>
+              <a:tr h="502920">
+                <a:tc>
+                  <a:txBody>
+                    <a:bodyPr/>
+                    <a:lstStyle/>
+                    <a:p>
+                      <a:pPr indent="0" marL="0">
+                        <a:buNone/>
+                      </a:pPr>
+                      <a:r>
+                        <a:rPr lang="en-US" sz="1300" dirty="0">
+                          <a:solidFill>
+                            <a:srgbClr val="1B1F2A"/>
+                          </a:solidFill>
+                        </a:rPr>
+                        <a:t>Stolica Francji</a:t>
+                      </a:r>
+                      <a:endParaRPr lang="en-US" sz="1300" dirty="0"/>
+                    </a:p>
+                  </a:txBody>
+                  <a:tcPr marL="91440" marR="91440" marT="45720" marB="45720" anchor="ctr">
+                    <a:lnL w="6350" cap="flat" cmpd="sng" algn="ctr">
+                      <a:solidFill>
+                        <a:srgbClr val="C7CEDB"/>
+                      </a:solidFill>
+                      <a:prstDash val="solid"/>
+                      <a:round/>
+                      <a:headEnd type="none" w="med" len="med"/>
+                      <a:tailEnd type="none" w="med" len="med"/>
+                    </a:lnL>
+                    <a:lnR w="6350" cap="flat" cmpd="sng" algn="ctr">
+                      <a:solidFill>
+                        <a:srgbClr val="C7CEDB"/>
+                      </a:solidFill>
+                      <a:prstDash val="solid"/>
+                      <a:round/>
+                      <a:headEnd type="none" w="med" len="med"/>
+                      <a:tailEnd type="none" w="med" len="med"/>
+                    </a:lnR>
+                    <a:lnT w="6350" cap="flat" cmpd="sng" algn="ctr">
+                      <a:solidFill>
+                        <a:srgbClr val="C7CEDB"/>
+                      </a:solidFill>
+                      <a:prstDash val="solid"/>
+                      <a:round/>
+                      <a:headEnd type="none" w="med" len="med"/>
+                      <a:tailEnd type="none" w="med" len="med"/>
+                    </a:lnT>
+                    <a:lnB w="6350" cap="flat" cmpd="sng" algn="ctr">
+                      <a:solidFill>
+                        <a:srgbClr val="C7CEDB"/>
+                      </a:solidFill>
+                      <a:prstDash val="solid"/>
+                      <a:round/>
+                      <a:headEnd type="none" w="med" len="med"/>
+                      <a:tailEnd type="none" w="med" len="med"/>
+                    </a:lnB>
+                  </a:tcPr>
+                </a:tc>
+                <a:tc>
+                  <a:txBody>
+                    <a:bodyPr/>
+                    <a:lstStyle/>
+                    <a:p>
+                      <a:pPr indent="0" marL="0">
+                        <a:buNone/>
+                      </a:pPr>
+                      <a:r>
+                        <a:rPr lang="en-US" sz="1300" dirty="0">
+                          <a:solidFill>
+                            <a:srgbClr val="1B1F2A"/>
+                          </a:solidFill>
+                        </a:rPr>
+                        <a:t>kNN</a:t>
+                      </a:r>
+                      <a:endParaRPr lang="en-US" sz="1300" dirty="0"/>
+                    </a:p>
+                  </a:txBody>
+                  <a:tcPr marL="91440" marR="91440" marT="45720" marB="45720" anchor="ctr">
+                    <a:lnL w="6350" cap="flat" cmpd="sng" algn="ctr">
+                      <a:solidFill>
+                        <a:srgbClr val="C7CEDB"/>
+                      </a:solidFill>
+                      <a:prstDash val="solid"/>
+                      <a:round/>
+                      <a:headEnd type="none" w="med" len="med"/>
+                      <a:tailEnd type="none" w="med" len="med"/>
+                    </a:lnL>
+                    <a:lnR w="6350" cap="flat" cmpd="sng" algn="ctr">
+                      <a:solidFill>
+                        <a:srgbClr val="C7CEDB"/>
+                      </a:solidFill>
+                      <a:prstDash val="solid"/>
+                      <a:round/>
+                      <a:headEnd type="none" w="med" len="med"/>
+                      <a:tailEnd type="none" w="med" len="med"/>
+                    </a:lnR>
+                    <a:lnT w="6350" cap="flat" cmpd="sng" algn="ctr">
+                      <a:solidFill>
+                        <a:srgbClr val="C7CEDB"/>
+                      </a:solidFill>
+                      <a:prstDash val="solid"/>
+                      <a:round/>
+                      <a:headEnd type="none" w="med" len="med"/>
+                      <a:tailEnd type="none" w="med" len="med"/>
+                    </a:lnT>
+                    <a:lnB w="6350" cap="flat" cmpd="sng" algn="ctr">
+                      <a:solidFill>
+                        <a:srgbClr val="C7CEDB"/>
+                      </a:solidFill>
+                      <a:prstDash val="solid"/>
+                      <a:round/>
+                      <a:headEnd type="none" w="med" len="med"/>
+                      <a:tailEnd type="none" w="med" len="med"/>
+                    </a:lnB>
+                  </a:tcPr>
+                </a:tc>
+                <a:tc>
+                  <a:txBody>
+                    <a:bodyPr/>
+                    <a:lstStyle/>
+                    <a:p>
+                      <a:pPr indent="0" marL="0">
+                        <a:buNone/>
+                      </a:pPr>
+                      <a:r>
+                        <a:rPr lang="en-US" sz="1300" dirty="0">
+                          <a:solidFill>
+                            <a:srgbClr val="1B1F2A"/>
+                          </a:solidFill>
+                        </a:rPr>
+                        <a:t>mały</a:t>
+                      </a:r>
+                      <a:endParaRPr lang="en-US" sz="1300" dirty="0"/>
+                    </a:p>
+                  </a:txBody>
+                  <a:tcPr marL="91440" marR="91440" marT="45720" marB="45720" anchor="ctr">
+                    <a:lnL w="6350" cap="flat" cmpd="sng" algn="ctr">
+                      <a:solidFill>
+                        <a:srgbClr val="C7CEDB"/>
+                      </a:solidFill>
+                      <a:prstDash val="solid"/>
+                      <a:round/>
+                      <a:headEnd type="none" w="med" len="med"/>
+                      <a:tailEnd type="none" w="med" len="med"/>
+                    </a:lnL>
+                    <a:lnR w="6350" cap="flat" cmpd="sng" algn="ctr">
+                      <a:solidFill>
+                        <a:srgbClr val="C7CEDB"/>
+                      </a:solidFill>
+                      <a:prstDash val="solid"/>
+                      <a:round/>
+                      <a:headEnd type="none" w="med" len="med"/>
+                      <a:tailEnd type="none" w="med" len="med"/>
+                    </a:lnR>
+                    <a:lnT w="6350" cap="flat" cmpd="sng" algn="ctr">
+                      <a:solidFill>
+                        <a:srgbClr val="C7CEDB"/>
+                      </a:solidFill>
+                      <a:prstDash val="solid"/>
+                      <a:round/>
+                      <a:headEnd type="none" w="med" len="med"/>
+                      <a:tailEnd type="none" w="med" len="med"/>
+                    </a:lnT>
+                    <a:lnB w="6350" cap="flat" cmpd="sng" algn="ctr">
+                      <a:solidFill>
+                        <a:srgbClr val="C7CEDB"/>
+                      </a:solidFill>
+                      <a:prstDash val="solid"/>
+                      <a:round/>
+                      <a:headEnd type="none" w="med" len="med"/>
+                      <a:tailEnd type="none" w="med" len="med"/>
+                    </a:lnB>
+                  </a:tcPr>
+                </a:tc>
+                <a:tc>
+                  <a:txBody>
+                    <a:bodyPr/>
+                    <a:lstStyle/>
+                    <a:p>
+                      <a:pPr indent="0" marL="0">
+                        <a:buNone/>
+                      </a:pPr>
+                      <a:r>
+                        <a:rPr lang="en-US" sz="1300" dirty="0">
+                          <a:solidFill>
+                            <a:srgbClr val="1B1F2A"/>
+                          </a:solidFill>
+                        </a:rPr>
+                        <a:t>0,19</a:t>
+                      </a:r>
+                      <a:endParaRPr lang="en-US" sz="1300" dirty="0"/>
+                    </a:p>
+                  </a:txBody>
+                  <a:tcPr marL="91440" marR="91440" marT="45720" marB="45720" anchor="ctr">
+                    <a:lnL w="6350" cap="flat" cmpd="sng" algn="ctr">
+                      <a:solidFill>
+                        <a:srgbClr val="C7CEDB"/>
+                      </a:solidFill>
+                      <a:prstDash val="solid"/>
+                      <a:round/>
+                      <a:headEnd type="none" w="med" len="med"/>
+                      <a:tailEnd type="none" w="med" len="med"/>
+                    </a:lnL>
+                    <a:lnR w="6350" cap="flat" cmpd="sng" algn="ctr">
+                      <a:solidFill>
+                        <a:srgbClr val="C7CEDB"/>
+                      </a:solidFill>
+                      <a:prstDash val="solid"/>
+                      <a:round/>
+                      <a:headEnd type="none" w="med" len="med"/>
+                      <a:tailEnd type="none" w="med" len="med"/>
+                    </a:lnR>
+                    <a:lnT w="6350" cap="flat" cmpd="sng" algn="ctr">
+                      <a:solidFill>
+                        <a:srgbClr val="C7CEDB"/>
+                      </a:solidFill>
+                      <a:prstDash val="solid"/>
+                      <a:round/>
+                      <a:headEnd type="none" w="med" len="med"/>
+                      <a:tailEnd type="none" w="med" len="med"/>
+                    </a:lnT>
+                    <a:lnB w="6350" cap="flat" cmpd="sng" algn="ctr">
+                      <a:solidFill>
+                        <a:srgbClr val="C7CEDB"/>
+                      </a:solidFill>
+                      <a:prstDash val="solid"/>
+                      <a:round/>
+                      <a:headEnd type="none" w="med" len="med"/>
+                      <a:tailEnd type="none" w="med" len="med"/>
+                    </a:lnB>
+                  </a:tcPr>
+                </a:tc>
+              </a:tr>
+              <a:tr h="502920">
+                <a:tc>
+                  <a:txBody>
+                    <a:bodyPr/>
+                    <a:lstStyle/>
+                    <a:p>
+                      <a:pPr indent="0" marL="0">
+                        <a:buNone/>
+                      </a:pPr>
+                      <a:r>
+                        <a:rPr lang="en-US" sz="1300" dirty="0">
+                          <a:solidFill>
+                            <a:srgbClr val="1B1F2A"/>
+                          </a:solidFill>
+                        </a:rPr>
+                        <a:t>Opowiadanie: smok i rycerz</a:t>
+                      </a:r>
+                      <a:endParaRPr lang="en-US" sz="1300" dirty="0"/>
+                    </a:p>
+                  </a:txBody>
+                  <a:tcPr marL="91440" marR="91440" marT="45720" marB="45720" anchor="ctr">
+                    <a:lnL w="6350" cap="flat" cmpd="sng" algn="ctr">
+                      <a:solidFill>
+                        <a:srgbClr val="C7CEDB"/>
+                      </a:solidFill>
+                      <a:prstDash val="solid"/>
+                      <a:round/>
+                      <a:headEnd type="none" w="med" len="med"/>
+                      <a:tailEnd type="none" w="med" len="med"/>
+                    </a:lnL>
+                    <a:lnR w="6350" cap="flat" cmpd="sng" algn="ctr">
+                      <a:solidFill>
+                        <a:srgbClr val="C7CEDB"/>
+                      </a:solidFill>
+                      <a:prstDash val="solid"/>
+                      <a:round/>
+                      <a:headEnd type="none" w="med" len="med"/>
+                      <a:tailEnd type="none" w="med" len="med"/>
+                    </a:lnR>
+                    <a:lnT w="6350" cap="flat" cmpd="sng" algn="ctr">
+                      <a:solidFill>
+                        <a:srgbClr val="C7CEDB"/>
+                      </a:solidFill>
+                      <a:prstDash val="solid"/>
+                      <a:round/>
+                      <a:headEnd type="none" w="med" len="med"/>
+                      <a:tailEnd type="none" w="med" len="med"/>
+                    </a:lnT>
+                    <a:lnB w="6350" cap="flat" cmpd="sng" algn="ctr">
+                      <a:solidFill>
+                        <a:srgbClr val="C7CEDB"/>
+                      </a:solidFill>
+                      <a:prstDash val="solid"/>
+                      <a:round/>
+                      <a:headEnd type="none" w="med" len="med"/>
+                      <a:tailEnd type="none" w="med" len="med"/>
+                    </a:lnB>
+                  </a:tcPr>
+                </a:tc>
+                <a:tc>
+                  <a:txBody>
+                    <a:bodyPr/>
+                    <a:lstStyle/>
+                    <a:p>
+                      <a:pPr indent="0" marL="0">
+                        <a:buNone/>
+                      </a:pPr>
+                      <a:r>
+                        <a:rPr lang="en-US" sz="1300" dirty="0">
+                          <a:solidFill>
+                            <a:srgbClr val="1B1F2A"/>
+                          </a:solidFill>
+                        </a:rPr>
+                        <a:t>kNN</a:t>
+                      </a:r>
+                      <a:endParaRPr lang="en-US" sz="1300" dirty="0"/>
+                    </a:p>
+                  </a:txBody>
+                  <a:tcPr marL="91440" marR="91440" marT="45720" marB="45720" anchor="ctr">
+                    <a:lnL w="6350" cap="flat" cmpd="sng" algn="ctr">
+                      <a:solidFill>
+                        <a:srgbClr val="C7CEDB"/>
+                      </a:solidFill>
+                      <a:prstDash val="solid"/>
+                      <a:round/>
+                      <a:headEnd type="none" w="med" len="med"/>
+                      <a:tailEnd type="none" w="med" len="med"/>
+                    </a:lnL>
+                    <a:lnR w="6350" cap="flat" cmpd="sng" algn="ctr">
+                      <a:solidFill>
+                        <a:srgbClr val="C7CEDB"/>
+                      </a:solidFill>
+                      <a:prstDash val="solid"/>
+                      <a:round/>
+                      <a:headEnd type="none" w="med" len="med"/>
+                      <a:tailEnd type="none" w="med" len="med"/>
+                    </a:lnR>
+                    <a:lnT w="6350" cap="flat" cmpd="sng" algn="ctr">
+                      <a:solidFill>
+                        <a:srgbClr val="C7CEDB"/>
+                      </a:solidFill>
+                      <a:prstDash val="solid"/>
+                      <a:round/>
+                      <a:headEnd type="none" w="med" len="med"/>
+                      <a:tailEnd type="none" w="med" len="med"/>
+                    </a:lnT>
+                    <a:lnB w="6350" cap="flat" cmpd="sng" algn="ctr">
+                      <a:solidFill>
+                        <a:srgbClr val="C7CEDB"/>
+                      </a:solidFill>
+                      <a:prstDash val="solid"/>
+                      <a:round/>
+                      <a:headEnd type="none" w="med" len="med"/>
+                      <a:tailEnd type="none" w="med" len="med"/>
+                    </a:lnB>
+                  </a:tcPr>
+                </a:tc>
+                <a:tc>
+                  <a:txBody>
+                    <a:bodyPr/>
+                    <a:lstStyle/>
+                    <a:p>
+                      <a:pPr indent="0" marL="0">
+                        <a:buNone/>
+                      </a:pPr>
+                      <a:r>
+                        <a:rPr lang="en-US" sz="1300" dirty="0">
+                          <a:solidFill>
+                            <a:srgbClr val="1B1F2A"/>
+                          </a:solidFill>
+                        </a:rPr>
+                        <a:t>duży</a:t>
+                      </a:r>
+                      <a:endParaRPr lang="en-US" sz="1300" dirty="0"/>
+                    </a:p>
+                  </a:txBody>
+                  <a:tcPr marL="91440" marR="91440" marT="45720" marB="45720" anchor="ctr">
+                    <a:lnL w="6350" cap="flat" cmpd="sng" algn="ctr">
+                      <a:solidFill>
+                        <a:srgbClr val="C7CEDB"/>
+                      </a:solidFill>
+                      <a:prstDash val="solid"/>
+                      <a:round/>
+                      <a:headEnd type="none" w="med" len="med"/>
+                      <a:tailEnd type="none" w="med" len="med"/>
+                    </a:lnL>
+                    <a:lnR w="6350" cap="flat" cmpd="sng" algn="ctr">
+                      <a:solidFill>
+                        <a:srgbClr val="C7CEDB"/>
+                      </a:solidFill>
+                      <a:prstDash val="solid"/>
+                      <a:round/>
+                      <a:headEnd type="none" w="med" len="med"/>
+                      <a:tailEnd type="none" w="med" len="med"/>
+                    </a:lnR>
+                    <a:lnT w="6350" cap="flat" cmpd="sng" algn="ctr">
+                      <a:solidFill>
+                        <a:srgbClr val="C7CEDB"/>
+                      </a:solidFill>
+                      <a:prstDash val="solid"/>
+                      <a:round/>
+                      <a:headEnd type="none" w="med" len="med"/>
+                      <a:tailEnd type="none" w="med" len="med"/>
+                    </a:lnT>
+                    <a:lnB w="6350" cap="flat" cmpd="sng" algn="ctr">
+                      <a:solidFill>
+                        <a:srgbClr val="C7CEDB"/>
+                      </a:solidFill>
+                      <a:prstDash val="solid"/>
+                      <a:round/>
+                      <a:headEnd type="none" w="med" len="med"/>
+                      <a:tailEnd type="none" w="med" len="med"/>
+                    </a:lnB>
+                  </a:tcPr>
+                </a:tc>
+                <a:tc>
+                  <a:txBody>
+                    <a:bodyPr/>
+                    <a:lstStyle/>
+                    <a:p>
+                      <a:pPr indent="0" marL="0">
+                        <a:buNone/>
+                      </a:pPr>
+                      <a:r>
+                        <a:rPr lang="en-US" sz="1300" dirty="0">
+                          <a:solidFill>
+                            <a:srgbClr val="1B1F2A"/>
+                          </a:solidFill>
+                        </a:rPr>
+                        <a:t>0,70</a:t>
+                      </a:r>
+                      <a:endParaRPr lang="en-US" sz="1300" dirty="0"/>
+                    </a:p>
+                  </a:txBody>
+                  <a:tcPr marL="91440" marR="91440" marT="45720" marB="45720" anchor="ctr">
+                    <a:lnL w="6350" cap="flat" cmpd="sng" algn="ctr">
+                      <a:solidFill>
+                        <a:srgbClr val="C7CEDB"/>
+                      </a:solidFill>
+                      <a:prstDash val="solid"/>
+                      <a:round/>
+                      <a:headEnd type="none" w="med" len="med"/>
+                      <a:tailEnd type="none" w="med" len="med"/>
+                    </a:lnL>
+                    <a:lnR w="6350" cap="flat" cmpd="sng" algn="ctr">
+                      <a:solidFill>
+                        <a:srgbClr val="C7CEDB"/>
+                      </a:solidFill>
+                      <a:prstDash val="solid"/>
+                      <a:round/>
+                      <a:headEnd type="none" w="med" len="med"/>
+                      <a:tailEnd type="none" w="med" len="med"/>
+                    </a:lnR>
+                    <a:lnT w="6350" cap="flat" cmpd="sng" algn="ctr">
+                      <a:solidFill>
+                        <a:srgbClr val="C7CEDB"/>
+                      </a:solidFill>
+                      <a:prstDash val="solid"/>
+                      <a:round/>
+                      <a:headEnd type="none" w="med" len="med"/>
+                      <a:tailEnd type="none" w="med" len="med"/>
+                    </a:lnT>
+                    <a:lnB w="6350" cap="flat" cmpd="sng" algn="ctr">
+                      <a:solidFill>
+                        <a:srgbClr val="C7CEDB"/>
+                      </a:solidFill>
+                      <a:prstDash val="solid"/>
+                      <a:round/>
+                      <a:headEnd type="none" w="med" len="med"/>
+                      <a:tailEnd type="none" w="med" len="med"/>
+                    </a:lnB>
+                  </a:tcPr>
+                </a:tc>
+              </a:tr>
+              <a:tr h="502920">
+                <a:tc>
+                  <a:txBody>
+                    <a:bodyPr/>
+                    <a:lstStyle/>
+                    <a:p>
+                      <a:pPr indent="0" marL="0">
+                        <a:buNone/>
+                      </a:pPr>
+                      <a:r>
+                        <a:rPr lang="en-US" sz="1300" dirty="0">
+                          <a:solidFill>
+                            <a:srgbClr val="1B1F2A"/>
+                          </a:solidFill>
+                        </a:rPr>
+                        <a:t>Analizuj, porównaj, oceń kompromisy</a:t>
+                      </a:r>
+                      <a:endParaRPr lang="en-US" sz="1300" dirty="0"/>
+                    </a:p>
+                  </a:txBody>
+                  <a:tcPr marL="91440" marR="91440" marT="45720" marB="45720" anchor="ctr">
+                    <a:lnL w="6350" cap="flat" cmpd="sng" algn="ctr">
+                      <a:solidFill>
+                        <a:srgbClr val="C7CEDB"/>
+                      </a:solidFill>
+                      <a:prstDash val="solid"/>
+                      <a:round/>
+                      <a:headEnd type="none" w="med" len="med"/>
+                      <a:tailEnd type="none" w="med" len="med"/>
+                    </a:lnL>
+                    <a:lnR w="6350" cap="flat" cmpd="sng" algn="ctr">
+                      <a:solidFill>
+                        <a:srgbClr val="C7CEDB"/>
+                      </a:solidFill>
+                      <a:prstDash val="solid"/>
+                      <a:round/>
+                      <a:headEnd type="none" w="med" len="med"/>
+                      <a:tailEnd type="none" w="med" len="med"/>
+                    </a:lnR>
+                    <a:lnT w="6350" cap="flat" cmpd="sng" algn="ctr">
+                      <a:solidFill>
+                        <a:srgbClr val="C7CEDB"/>
+                      </a:solidFill>
+                      <a:prstDash val="solid"/>
+                      <a:round/>
+                      <a:headEnd type="none" w="med" len="med"/>
+                      <a:tailEnd type="none" w="med" len="med"/>
+                    </a:lnT>
+                    <a:lnB w="6350" cap="flat" cmpd="sng" algn="ctr">
+                      <a:solidFill>
+                        <a:srgbClr val="C7CEDB"/>
+                      </a:solidFill>
+                      <a:prstDash val="solid"/>
+                      <a:round/>
+                      <a:headEnd type="none" w="med" len="med"/>
+                      <a:tailEnd type="none" w="med" len="med"/>
+                    </a:lnB>
+                  </a:tcPr>
+                </a:tc>
+                <a:tc>
+                  <a:txBody>
+                    <a:bodyPr/>
+                    <a:lstStyle/>
+                    <a:p>
+                      <a:pPr indent="0" marL="0">
+                        <a:buNone/>
+                      </a:pPr>
+                      <a:r>
+                        <a:rPr lang="en-US" sz="1300" dirty="0">
+                          <a:solidFill>
+                            <a:srgbClr val="1B1F2A"/>
+                          </a:solidFill>
+                        </a:rPr>
+                        <a:t>heurystyki</a:t>
+                      </a:r>
+                      <a:endParaRPr lang="en-US" sz="1300" dirty="0"/>
+                    </a:p>
+                  </a:txBody>
+                  <a:tcPr marL="91440" marR="91440" marT="45720" marB="45720" anchor="ctr">
+                    <a:lnL w="6350" cap="flat" cmpd="sng" algn="ctr">
+                      <a:solidFill>
+                        <a:srgbClr val="C7CEDB"/>
+                      </a:solidFill>
+                      <a:prstDash val="solid"/>
+                      <a:round/>
+                      <a:headEnd type="none" w="med" len="med"/>
+                      <a:tailEnd type="none" w="med" len="med"/>
+                    </a:lnL>
+                    <a:lnR w="6350" cap="flat" cmpd="sng" algn="ctr">
+                      <a:solidFill>
+                        <a:srgbClr val="C7CEDB"/>
+                      </a:solidFill>
+                      <a:prstDash val="solid"/>
+                      <a:round/>
+                      <a:headEnd type="none" w="med" len="med"/>
+                      <a:tailEnd type="none" w="med" len="med"/>
+                    </a:lnR>
+                    <a:lnT w="6350" cap="flat" cmpd="sng" algn="ctr">
+                      <a:solidFill>
+                        <a:srgbClr val="C7CEDB"/>
+                      </a:solidFill>
+                      <a:prstDash val="solid"/>
+                      <a:round/>
+                      <a:headEnd type="none" w="med" len="med"/>
+                      <a:tailEnd type="none" w="med" len="med"/>
+                    </a:lnT>
+                    <a:lnB w="6350" cap="flat" cmpd="sng" algn="ctr">
+                      <a:solidFill>
+                        <a:srgbClr val="C7CEDB"/>
+                      </a:solidFill>
+                      <a:prstDash val="solid"/>
+                      <a:round/>
+                      <a:headEnd type="none" w="med" len="med"/>
+                      <a:tailEnd type="none" w="med" len="med"/>
+                    </a:lnB>
+                  </a:tcPr>
+                </a:tc>
+                <a:tc>
+                  <a:txBody>
+                    <a:bodyPr/>
+                    <a:lstStyle/>
+                    <a:p>
+                      <a:pPr indent="0" marL="0">
+                        <a:buNone/>
+                      </a:pPr>
+                      <a:r>
+                        <a:rPr lang="en-US" sz="1300" dirty="0">
+                          <a:solidFill>
+                            <a:srgbClr val="1B1F2A"/>
+                          </a:solidFill>
+                        </a:rPr>
+                        <a:t>duży</a:t>
+                      </a:r>
+                      <a:endParaRPr lang="en-US" sz="1300" dirty="0"/>
+                    </a:p>
+                  </a:txBody>
+                  <a:tcPr marL="91440" marR="91440" marT="45720" marB="45720" anchor="ctr">
+                    <a:lnL w="6350" cap="flat" cmpd="sng" algn="ctr">
+                      <a:solidFill>
+                        <a:srgbClr val="C7CEDB"/>
+                      </a:solidFill>
+                      <a:prstDash val="solid"/>
+                      <a:round/>
+                      <a:headEnd type="none" w="med" len="med"/>
+                      <a:tailEnd type="none" w="med" len="med"/>
+                    </a:lnL>
+                    <a:lnR w="6350" cap="flat" cmpd="sng" algn="ctr">
+                      <a:solidFill>
+                        <a:srgbClr val="C7CEDB"/>
+                      </a:solidFill>
+                      <a:prstDash val="solid"/>
+                      <a:round/>
+                      <a:headEnd type="none" w="med" len="med"/>
+                      <a:tailEnd type="none" w="med" len="med"/>
+                    </a:lnR>
+                    <a:lnT w="6350" cap="flat" cmpd="sng" algn="ctr">
+                      <a:solidFill>
+                        <a:srgbClr val="C7CEDB"/>
+                      </a:solidFill>
+                      <a:prstDash val="solid"/>
+                      <a:round/>
+                      <a:headEnd type="none" w="med" len="med"/>
+                      <a:tailEnd type="none" w="med" len="med"/>
+                    </a:lnT>
+                    <a:lnB w="6350" cap="flat" cmpd="sng" algn="ctr">
+                      <a:solidFill>
+                        <a:srgbClr val="C7CEDB"/>
+                      </a:solidFill>
+                      <a:prstDash val="solid"/>
+                      <a:round/>
+                      <a:headEnd type="none" w="med" len="med"/>
+                      <a:tailEnd type="none" w="med" len="med"/>
+                    </a:lnB>
+                  </a:tcPr>
+                </a:tc>
+                <a:tc>
+                  <a:txBody>
+                    <a:bodyPr/>
+                    <a:lstStyle/>
+                    <a:p>
+                      <a:pPr indent="0" marL="0">
+                        <a:buNone/>
+                      </a:pPr>
+                      <a:r>
+                        <a:rPr lang="en-US" sz="1300" dirty="0">
+                          <a:solidFill>
+                            <a:srgbClr val="1B1F2A"/>
+                          </a:solidFill>
+                        </a:rPr>
+                        <a:t>brak</a:t>
+                      </a:r>
+                      <a:endParaRPr lang="en-US" sz="1300" dirty="0"/>
+                    </a:p>
+                  </a:txBody>
+                  <a:tcPr marL="91440" marR="91440" marT="45720" marB="45720" anchor="ctr">
+                    <a:lnL w="6350" cap="flat" cmpd="sng" algn="ctr">
+                      <a:solidFill>
+                        <a:srgbClr val="C7CEDB"/>
+                      </a:solidFill>
+                      <a:prstDash val="solid"/>
+                      <a:round/>
+                      <a:headEnd type="none" w="med" len="med"/>
+                      <a:tailEnd type="none" w="med" len="med"/>
+                    </a:lnL>
+                    <a:lnR w="6350" cap="flat" cmpd="sng" algn="ctr">
+                      <a:solidFill>
+                        <a:srgbClr val="C7CEDB"/>
+                      </a:solidFill>
+                      <a:prstDash val="solid"/>
+                      <a:round/>
+                      <a:headEnd type="none" w="med" len="med"/>
+                      <a:tailEnd type="none" w="med" len="med"/>
+                    </a:lnR>
+                    <a:lnT w="6350" cap="flat" cmpd="sng" algn="ctr">
+                      <a:solidFill>
+                        <a:srgbClr val="C7CEDB"/>
+                      </a:solidFill>
+                      <a:prstDash val="solid"/>
+                      <a:round/>
+                      <a:headEnd type="none" w="med" len="med"/>
+                      <a:tailEnd type="none" w="med" len="med"/>
+                    </a:lnT>
+                    <a:lnB w="6350" cap="flat" cmpd="sng" algn="ctr">
+                      <a:solidFill>
+                        <a:srgbClr val="C7CEDB"/>
+                      </a:solidFill>
+                      <a:prstDash val="solid"/>
+                      <a:round/>
+                      <a:headEnd type="none" w="med" len="med"/>
+                      <a:tailEnd type="none" w="med" len="med"/>
+                    </a:lnB>
+                  </a:tcPr>
+                </a:tc>
+              </a:tr>
+              <a:tr h="502920">
+                <a:tc>
+                  <a:txBody>
+                    <a:bodyPr/>
+                    <a:lstStyle/>
+                    <a:p>
+                      <a:pPr indent="0" marL="0">
+                        <a:buNone/>
+                      </a:pPr>
+                      <a:r>
+                        <a:rPr lang="en-US" sz="1300" dirty="0">
+                          <a:solidFill>
+                            <a:srgbClr val="1B1F2A"/>
+                          </a:solidFill>
+                        </a:rPr>
+                        <a:t>Mnożenie 17·23 (strumień)</a:t>
+                      </a:r>
+                      <a:endParaRPr lang="en-US" sz="1300" dirty="0"/>
+                    </a:p>
+                  </a:txBody>
+                  <a:tcPr marL="91440" marR="91440" marT="45720" marB="45720" anchor="ctr">
+                    <a:lnL w="6350" cap="flat" cmpd="sng" algn="ctr">
+                      <a:solidFill>
+                        <a:srgbClr val="C7CEDB"/>
+                      </a:solidFill>
+                      <a:prstDash val="solid"/>
+                      <a:round/>
+                      <a:headEnd type="none" w="med" len="med"/>
+                      <a:tailEnd type="none" w="med" len="med"/>
+                    </a:lnL>
+                    <a:lnR w="6350" cap="flat" cmpd="sng" algn="ctr">
+                      <a:solidFill>
+                        <a:srgbClr val="C7CEDB"/>
+                      </a:solidFill>
+                      <a:prstDash val="solid"/>
+                      <a:round/>
+                      <a:headEnd type="none" w="med" len="med"/>
+                      <a:tailEnd type="none" w="med" len="med"/>
+                    </a:lnR>
+                    <a:lnT w="6350" cap="flat" cmpd="sng" algn="ctr">
+                      <a:solidFill>
+                        <a:srgbClr val="C7CEDB"/>
+                      </a:solidFill>
+                      <a:prstDash val="solid"/>
+                      <a:round/>
+                      <a:headEnd type="none" w="med" len="med"/>
+                      <a:tailEnd type="none" w="med" len="med"/>
+                    </a:lnT>
+                    <a:lnB w="6350" cap="flat" cmpd="sng" algn="ctr">
+                      <a:solidFill>
+                        <a:srgbClr val="C7CEDB"/>
+                      </a:solidFill>
+                      <a:prstDash val="solid"/>
+                      <a:round/>
+                      <a:headEnd type="none" w="med" len="med"/>
+                      <a:tailEnd type="none" w="med" len="med"/>
+                    </a:lnB>
+                  </a:tcPr>
+                </a:tc>
+                <a:tc>
+                  <a:txBody>
+                    <a:bodyPr/>
+                    <a:lstStyle/>
+                    <a:p>
+                      <a:pPr indent="0" marL="0">
+                        <a:buNone/>
+                      </a:pPr>
+                      <a:r>
+                        <a:rPr lang="en-US" sz="1300" dirty="0">
+                          <a:solidFill>
+                            <a:srgbClr val="1B1F2A"/>
+                          </a:solidFill>
+                        </a:rPr>
+                        <a:t>kNN</a:t>
+                      </a:r>
+                      <a:endParaRPr lang="en-US" sz="1300" dirty="0"/>
+                    </a:p>
+                  </a:txBody>
+                  <a:tcPr marL="91440" marR="91440" marT="45720" marB="45720" anchor="ctr">
+                    <a:lnL w="6350" cap="flat" cmpd="sng" algn="ctr">
+                      <a:solidFill>
+                        <a:srgbClr val="C7CEDB"/>
+                      </a:solidFill>
+                      <a:prstDash val="solid"/>
+                      <a:round/>
+                      <a:headEnd type="none" w="med" len="med"/>
+                      <a:tailEnd type="none" w="med" len="med"/>
+                    </a:lnL>
+                    <a:lnR w="6350" cap="flat" cmpd="sng" algn="ctr">
+                      <a:solidFill>
+                        <a:srgbClr val="C7CEDB"/>
+                      </a:solidFill>
+                      <a:prstDash val="solid"/>
+                      <a:round/>
+                      <a:headEnd type="none" w="med" len="med"/>
+                      <a:tailEnd type="none" w="med" len="med"/>
+                    </a:lnR>
+                    <a:lnT w="6350" cap="flat" cmpd="sng" algn="ctr">
+                      <a:solidFill>
+                        <a:srgbClr val="C7CEDB"/>
+                      </a:solidFill>
+                      <a:prstDash val="solid"/>
+                      <a:round/>
+                      <a:headEnd type="none" w="med" len="med"/>
+                      <a:tailEnd type="none" w="med" len="med"/>
+                    </a:lnT>
+                    <a:lnB w="6350" cap="flat" cmpd="sng" algn="ctr">
+                      <a:solidFill>
+                        <a:srgbClr val="C7CEDB"/>
+                      </a:solidFill>
+                      <a:prstDash val="solid"/>
+                      <a:round/>
+                      <a:headEnd type="none" w="med" len="med"/>
+                      <a:tailEnd type="none" w="med" len="med"/>
+                    </a:lnB>
+                  </a:tcPr>
+                </a:tc>
+                <a:tc>
+                  <a:txBody>
+                    <a:bodyPr/>
+                    <a:lstStyle/>
+                    <a:p>
+                      <a:pPr indent="0" marL="0">
+                        <a:buNone/>
+                      </a:pPr>
+                      <a:r>
+                        <a:rPr lang="en-US" sz="1300" dirty="0">
+                          <a:solidFill>
+                            <a:srgbClr val="1B1F2A"/>
+                          </a:solidFill>
+                        </a:rPr>
+                        <a:t>mały</a:t>
+                      </a:r>
+                      <a:endParaRPr lang="en-US" sz="1300" dirty="0"/>
+                    </a:p>
+                  </a:txBody>
+                  <a:tcPr marL="91440" marR="91440" marT="45720" marB="45720" anchor="ctr">
+                    <a:lnL w="6350" cap="flat" cmpd="sng" algn="ctr">
+                      <a:solidFill>
+                        <a:srgbClr val="C7CEDB"/>
+                      </a:solidFill>
+                      <a:prstDash val="solid"/>
+                      <a:round/>
+                      <a:headEnd type="none" w="med" len="med"/>
+                      <a:tailEnd type="none" w="med" len="med"/>
+                    </a:lnL>
+                    <a:lnR w="6350" cap="flat" cmpd="sng" algn="ctr">
+                      <a:solidFill>
+                        <a:srgbClr val="C7CEDB"/>
+                      </a:solidFill>
+                      <a:prstDash val="solid"/>
+                      <a:round/>
+                      <a:headEnd type="none" w="med" len="med"/>
+                      <a:tailEnd type="none" w="med" len="med"/>
+                    </a:lnR>
+                    <a:lnT w="6350" cap="flat" cmpd="sng" algn="ctr">
+                      <a:solidFill>
+                        <a:srgbClr val="C7CEDB"/>
+                      </a:solidFill>
+                      <a:prstDash val="solid"/>
+                      <a:round/>
+                      <a:headEnd type="none" w="med" len="med"/>
+                      <a:tailEnd type="none" w="med" len="med"/>
+                    </a:lnT>
+                    <a:lnB w="6350" cap="flat" cmpd="sng" algn="ctr">
+                      <a:solidFill>
+                        <a:srgbClr val="C7CEDB"/>
+                      </a:solidFill>
+                      <a:prstDash val="solid"/>
+                      <a:round/>
+                      <a:headEnd type="none" w="med" len="med"/>
+                      <a:tailEnd type="none" w="med" len="med"/>
+                    </a:lnB>
+                  </a:tcPr>
+                </a:tc>
+                <a:tc>
+                  <a:txBody>
+                    <a:bodyPr/>
+                    <a:lstStyle/>
+                    <a:p>
+                      <a:pPr indent="0" marL="0">
+                        <a:buNone/>
+                      </a:pPr>
+                      <a:r>
+                        <a:rPr lang="en-US" sz="1300" dirty="0">
+                          <a:solidFill>
+                            <a:srgbClr val="1B1F2A"/>
+                          </a:solidFill>
+                        </a:rPr>
+                        <a:t>0,10</a:t>
+                      </a:r>
+                      <a:endParaRPr lang="en-US" sz="1300" dirty="0"/>
+                    </a:p>
+                  </a:txBody>
+                  <a:tcPr marL="91440" marR="91440" marT="45720" marB="45720" anchor="ctr">
+                    <a:lnL w="6350" cap="flat" cmpd="sng" algn="ctr">
+                      <a:solidFill>
+                        <a:srgbClr val="C7CEDB"/>
+                      </a:solidFill>
+                      <a:prstDash val="solid"/>
+                      <a:round/>
+                      <a:headEnd type="none" w="med" len="med"/>
+                      <a:tailEnd type="none" w="med" len="med"/>
+                    </a:lnL>
+                    <a:lnR w="6350" cap="flat" cmpd="sng" algn="ctr">
+                      <a:solidFill>
+                        <a:srgbClr val="C7CEDB"/>
+                      </a:solidFill>
+                      <a:prstDash val="solid"/>
+                      <a:round/>
+                      <a:headEnd type="none" w="med" len="med"/>
+                      <a:tailEnd type="none" w="med" len="med"/>
+                    </a:lnR>
+                    <a:lnT w="6350" cap="flat" cmpd="sng" algn="ctr">
+                      <a:solidFill>
+                        <a:srgbClr val="C7CEDB"/>
+                      </a:solidFill>
+                      <a:prstDash val="solid"/>
+                      <a:round/>
+                      <a:headEnd type="none" w="med" len="med"/>
+                      <a:tailEnd type="none" w="med" len="med"/>
+                    </a:lnT>
+                    <a:lnB w="6350" cap="flat" cmpd="sng" algn="ctr">
+                      <a:solidFill>
+                        <a:srgbClr val="C7CEDB"/>
+                      </a:solidFill>
+                      <a:prstDash val="solid"/>
+                      <a:round/>
+                      <a:headEnd type="none" w="med" len="med"/>
+                      <a:tailEnd type="none" w="med" len="med"/>
+                    </a:lnB>
+                  </a:tcPr>
+                </a:tc>
+              </a:tr>
+            </a:tbl>
+          </a:graphicData>
+        </a:graphic>
+      </p:graphicFrame>
+      <p:sp>
+        <p:nvSpPr>
+          <p:cNvPr id="4" name="Co zostało"/>
+          <p:cNvSpPr txBox="1"/>
+          <p:nvPr/>
+        </p:nvSpPr>
+        <p:spPr>
+          <a:xfrm>
+            <a:off x="457200" y="3840480"/>
+            <a:ext cx="5577840" cy="640080"/>
+          </a:xfrm>
+          <a:prstGeom prst="rect">
+            <a:avLst/>
+          </a:prstGeom>
+          <a:noFill/>
+          <a:ln/>
+        </p:spPr>
+        <p:txBody>
+          <a:bodyPr wrap="square" lIns="0" tIns="0" rIns="0" bIns="0" rtlCol="0" anchor="t"/>
+          <a:lstStyle/>
+          <a:p>
+            <a:pPr indent="0" marL="0">
+              <a:buNone/>
+            </a:pPr>
+            <a:r>
+              <a:rPr lang="en-US" sz="1400" dirty="0">
+                <a:solidFill>
+                  <a:schemeClr val="tx2"/>
+                </a:solidFill>
+              </a:rPr>
+              <a:t>Zostały do sprawdzenia: przełączenie na duży model przy awarii routera i restart usługi.</a:t>
+            </a:r>
+            <a:endParaRPr lang="en-US" sz="1400" dirty="0"/>
+          </a:p>
+        </p:txBody>
+      </p:sp>
+      <p:sp>
+        <p:nvSpPr>
+          <p:cNvPr id="5" name="Narzut routera karta"/>
           <p:cNvSpPr/>
           <p:nvPr/>
         </p:nvSpPr>
         <p:spPr>
           <a:xfrm>
-            <a:off x="457200" y="1188720"/>
-            <a:ext cx="4023360" cy="3291840"/>
+            <a:off x="6309360" y="1188720"/>
+            <a:ext cx="2377440" cy="1600200"/>
           </a:xfrm>
           <a:prstGeom prst="rect">
             <a:avLst/>
@@ -4664,14 +6108,14 @@
       </p:sp>
       <p:sp>
         <p:nvSpPr>
-          <p:cNvPr id="4" name="Implementacja tytuł"/>
+          <p:cNvPr id="6" name="Narzut routera liczba"/>
           <p:cNvSpPr txBox="1"/>
           <p:nvPr/>
         </p:nvSpPr>
         <p:spPr>
           <a:xfrm>
-            <a:off x="640080" y="1280160"/>
-            <a:ext cx="3657600" cy="365760"/>
+            <a:off x="6492240" y="1261872"/>
+            <a:ext cx="2011680" cy="685800"/>
           </a:xfrm>
           <a:prstGeom prst="rect">
             <a:avLst/>
@@ -4680,34 +6124,34 @@
           <a:ln/>
         </p:spPr>
         <p:txBody>
-          <a:bodyPr wrap="square" lIns="0" tIns="0" rIns="0" bIns="0" rtlCol="0" anchor="t"/>
+          <a:bodyPr wrap="square" lIns="0" tIns="0" rIns="0" bIns="0" rtlCol="0" anchor="ctr"/>
           <a:lstStyle/>
           <a:p>
             <a:pPr indent="0" marL="0">
               <a:buNone/>
             </a:pPr>
             <a:r>
-              <a:rPr lang="en-US" sz="1800" b="1" dirty="0">
+              <a:rPr lang="en-US" sz="4400" b="1" dirty="0">
                 <a:solidFill>
                   <a:schemeClr val="accent2"/>
                 </a:solidFill>
               </a:rPr>
-              <a:t>Implementacja</a:t>
-            </a:r>
-            <a:endParaRPr lang="en-US" sz="1800" dirty="0"/>
-          </a:p>
-        </p:txBody>
-      </p:sp>
-      <p:sp>
-        <p:nvSpPr>
-          <p:cNvPr id="5" name="Implementacja lista"/>
+              <a:t>~13 ms</a:t>
+            </a:r>
+            <a:endParaRPr lang="en-US" sz="4400" dirty="0"/>
+          </a:p>
+        </p:txBody>
+      </p:sp>
+      <p:sp>
+        <p:nvSpPr>
+          <p:cNvPr id="7" name="Narzut routera opis"/>
           <p:cNvSpPr txBox="1"/>
           <p:nvPr/>
         </p:nvSpPr>
         <p:spPr>
           <a:xfrm>
-            <a:off x="640080" y="1691640"/>
-            <a:ext cx="3657600" cy="2743200"/>
+            <a:off x="6492240" y="1965960"/>
+            <a:ext cx="2011680" cy="731520"/>
           </a:xfrm>
           <a:prstGeom prst="rect">
             <a:avLst/>
@@ -4719,122 +6163,31 @@
           <a:bodyPr wrap="square" lIns="0" tIns="0" rIns="0" bIns="0" rtlCol="0" anchor="t"/>
           <a:lstStyle/>
           <a:p>
-            <a:pPr marL="342900" indent="-342900">
-              <a:spcAft>
-                <a:spcPts val="600"/>
-              </a:spcAft>
-              <a:buSzPct val="100000"/>
-              <a:buChar char="•"/>
+            <a:pPr indent="0" marL="0">
+              <a:buNone/>
             </a:pPr>
             <a:r>
               <a:rPr lang="en-US" sz="1400" dirty="0">
                 <a:solidFill>
-                  <a:schemeClr val="tx1"/>
-                </a:solidFill>
-              </a:rPr>
-              <a:t>RouterService w DeepFellow Infra v0.34.0</a:t>
+                  <a:schemeClr val="tx2"/>
+                </a:solidFill>
+              </a:rPr>
+              <a:t>narzut routera (średnio 0,376 s wobec 0,363 s bez niego)</a:t>
             </a:r>
             <a:endParaRPr lang="en-US" sz="1400" dirty="0"/>
           </a:p>
-          <a:p>
-            <a:pPr marL="342900" indent="-342900">
-              <a:spcAft>
-                <a:spcPts val="600"/>
-              </a:spcAft>
-              <a:buSzPct val="100000"/>
-              <a:buChar char="•"/>
-            </a:pPr>
-            <a:r>
-              <a:rPr lang="en-US" sz="1400" dirty="0">
-                <a:solidFill>
-                  <a:schemeClr val="tx1"/>
-                </a:solidFill>
-              </a:rPr>
-              <a:t>57 nowych testów, cały zestaw (5157) zielony</a:t>
-            </a:r>
-            <a:endParaRPr lang="en-US" sz="1400" dirty="0"/>
-          </a:p>
-          <a:p>
-            <a:pPr marL="342900" indent="-342900">
-              <a:spcAft>
-                <a:spcPts val="600"/>
-              </a:spcAft>
-              <a:buSzPct val="100000"/>
-              <a:buChar char="•"/>
-            </a:pPr>
-            <a:r>
-              <a:rPr lang="en-US" sz="1400" dirty="0">
-                <a:solidFill>
-                  <a:schemeClr val="tx1"/>
-                </a:solidFill>
-              </a:rPr>
-              <a:t>Test end-to-end z modelami Gemini: routing, nagłówki, streaming, fallback</a:t>
-            </a:r>
-            <a:endParaRPr lang="en-US" sz="1400" dirty="0"/>
-          </a:p>
-          <a:p>
-            <a:pPr marL="342900" indent="-342900">
-              <a:spcAft>
-                <a:spcPts val="600"/>
-              </a:spcAft>
-              <a:buSzPct val="100000"/>
-              <a:buChar char="•"/>
-            </a:pPr>
-            <a:r>
-              <a:rPr lang="en-US" sz="1400" dirty="0">
-                <a:solidFill>
-                  <a:schemeClr val="tx1"/>
-                </a:solidFill>
-              </a:rPr>
-              <a:t>Opóźnienie warstw 1+2: mediana 20,6 ms</a:t>
-            </a:r>
-            <a:endParaRPr lang="en-US" sz="1400" dirty="0"/>
-          </a:p>
-          <a:p>
-            <a:pPr marL="342900" indent="-342900">
-              <a:spcAft>
-                <a:spcPts val="600"/>
-              </a:spcAft>
-              <a:buSzPct val="100000"/>
-              <a:buChar char="•"/>
-            </a:pPr>
-            <a:r>
-              <a:rPr lang="en-US" sz="1400" dirty="0">
-                <a:solidFill>
-                  <a:schemeClr val="tx1"/>
-                </a:solidFill>
-              </a:rPr>
-              <a:t>Zmiana decyzji po literówkach i parafrazach: 6–10% pytań</a:t>
-            </a:r>
-            <a:endParaRPr lang="en-US" sz="1400" dirty="0"/>
-          </a:p>
-          <a:p>
-            <a:pPr marL="342900" indent="-342900">
-              <a:buSzPct val="100000"/>
-              <a:buChar char="•"/>
-            </a:pPr>
-            <a:r>
-              <a:rPr lang="en-US" sz="1400" dirty="0">
-                <a:solidFill>
-                  <a:schemeClr val="tx1"/>
-                </a:solidFill>
-              </a:rPr>
-              <a:t>Jeszcze nie z Qwenem 8B/27B</a:t>
-            </a:r>
-            <a:endParaRPr lang="en-US" sz="1400" dirty="0"/>
-          </a:p>
-        </p:txBody>
-      </p:sp>
-      <p:sp>
-        <p:nvSpPr>
-          <p:cNvPr id="6" name="Ograniczenia karta"/>
+        </p:txBody>
+      </p:sp>
+      <p:sp>
+        <p:nvSpPr>
+          <p:cNvPr id="8" name="Cel opóźnienia karta"/>
           <p:cNvSpPr/>
           <p:nvPr/>
         </p:nvSpPr>
         <p:spPr>
           <a:xfrm>
-            <a:off x="4663440" y="1188720"/>
-            <a:ext cx="4023360" cy="3291840"/>
+            <a:off x="6309360" y="2926080"/>
+            <a:ext cx="2377440" cy="1463040"/>
           </a:xfrm>
           <a:prstGeom prst="rect">
             <a:avLst/>
@@ -4852,14 +6205,14 @@
       </p:sp>
       <p:sp>
         <p:nvSpPr>
-          <p:cNvPr id="7" name="Ograniczenia tytuł"/>
+          <p:cNvPr id="9" name="Cel opóźnienia liczba"/>
           <p:cNvSpPr txBox="1"/>
           <p:nvPr/>
         </p:nvSpPr>
         <p:spPr>
           <a:xfrm>
-            <a:off x="4846320" y="1280160"/>
-            <a:ext cx="3657600" cy="365760"/>
+            <a:off x="6492240" y="2999232"/>
+            <a:ext cx="2011680" cy="685800"/>
           </a:xfrm>
           <a:prstGeom prst="rect">
             <a:avLst/>
@@ -4868,34 +6221,34 @@
           <a:ln/>
         </p:spPr>
         <p:txBody>
-          <a:bodyPr wrap="square" lIns="0" tIns="0" rIns="0" bIns="0" rtlCol="0" anchor="t"/>
+          <a:bodyPr wrap="square" lIns="0" tIns="0" rIns="0" bIns="0" rtlCol="0" anchor="ctr"/>
           <a:lstStyle/>
           <a:p>
             <a:pPr indent="0" marL="0">
               <a:buNone/>
             </a:pPr>
             <a:r>
-              <a:rPr lang="en-US" sz="1800" b="1" dirty="0">
-                <a:solidFill>
-                  <a:schemeClr val="accent1"/>
-                </a:solidFill>
-              </a:rPr>
-              <a:t>Ograniczenia</a:t>
-            </a:r>
-            <a:endParaRPr lang="en-US" sz="1800" dirty="0"/>
-          </a:p>
-        </p:txBody>
-      </p:sp>
-      <p:sp>
-        <p:nvSpPr>
-          <p:cNvPr id="8" name="Ograniczenia lista"/>
+              <a:rPr lang="en-US" sz="4400" b="1" dirty="0">
+                <a:solidFill>
+                  <a:schemeClr val="tx1"/>
+                </a:solidFill>
+              </a:rPr>
+              <a:t>&lt;50 ms</a:t>
+            </a:r>
+            <a:endParaRPr lang="en-US" sz="4400" dirty="0"/>
+          </a:p>
+        </p:txBody>
+      </p:sp>
+      <p:sp>
+        <p:nvSpPr>
+          <p:cNvPr id="10" name="Cel opóźnienia opis"/>
           <p:cNvSpPr txBox="1"/>
           <p:nvPr/>
         </p:nvSpPr>
         <p:spPr>
           <a:xfrm>
-            <a:off x="4846320" y="1691640"/>
-            <a:ext cx="3657600" cy="2743200"/>
+            <a:off x="6492240" y="3703320"/>
+            <a:ext cx="2011680" cy="594360"/>
           </a:xfrm>
           <a:prstGeom prst="rect">
             <a:avLst/>
@@ -4907,71 +6260,16 @@
           <a:bodyPr wrap="square" lIns="0" tIns="0" rIns="0" bIns="0" rtlCol="0" anchor="t"/>
           <a:lstStyle/>
           <a:p>
-            <a:pPr marL="342900" indent="-342900">
-              <a:spcAft>
-                <a:spcPts val="600"/>
-              </a:spcAft>
-              <a:buSzPct val="100000"/>
-              <a:buChar char="•"/>
+            <a:pPr indent="0" marL="0">
+              <a:buNone/>
             </a:pPr>
             <a:r>
               <a:rPr lang="en-US" sz="1400" dirty="0">
                 <a:solidFill>
-                  <a:schemeClr val="tx1"/>
-                </a:solidFill>
-              </a:rPr>
-              <a:t>Jedna para modeli i jeden sędzia</a:t>
-            </a:r>
-            <a:endParaRPr lang="en-US" sz="1400" dirty="0"/>
-          </a:p>
-          <a:p>
-            <a:pPr marL="342900" indent="-342900">
-              <a:spcAft>
-                <a:spcPts val="600"/>
-              </a:spcAft>
-              <a:buSzPct val="100000"/>
-              <a:buChar char="•"/>
-            </a:pPr>
-            <a:r>
-              <a:rPr lang="en-US" sz="1400" dirty="0">
-                <a:solidFill>
-                  <a:schemeClr val="tx1"/>
-                </a:solidFill>
-              </a:rPr>
-              <a:t>Dane mało „firmowe”: 63% to czaty (Arena, WildChat)</a:t>
-            </a:r>
-            <a:endParaRPr lang="en-US" sz="1400" dirty="0"/>
-          </a:p>
-          <a:p>
-            <a:pPr marL="342900" indent="-342900">
-              <a:spcAft>
-                <a:spcPts val="600"/>
-              </a:spcAft>
-              <a:buSzPct val="100000"/>
-              <a:buChar char="•"/>
-            </a:pPr>
-            <a:r>
-              <a:rPr lang="en-US" sz="1400" dirty="0">
-                <a:solidFill>
-                  <a:schemeClr val="tx1"/>
-                </a:solidFill>
-              </a:rPr>
-              <a:t>Duży model ma jedną próbkę na pytanie</a:t>
-            </a:r>
-            <a:endParaRPr lang="en-US" sz="1400" dirty="0"/>
-          </a:p>
-          <a:p>
-            <a:pPr marL="342900" indent="-342900">
-              <a:buSzPct val="100000"/>
-              <a:buChar char="•"/>
-            </a:pPr>
-            <a:r>
-              <a:rPr lang="en-US" sz="1400" dirty="0">
-                <a:solidFill>
-                  <a:schemeClr val="tx1"/>
-                </a:solidFill>
-              </a:rPr>
-              <a:t>Wiedza i kod słabo wykrywane</a:t>
+                  <a:schemeClr val="tx2"/>
+                </a:solidFill>
+              </a:rPr>
+              <a:t>cel z planu pracy, spełniony</a:t>
             </a:r>
             <a:endParaRPr lang="en-US" sz="1400" dirty="0"/>
           </a:p>
@@ -5079,6 +6377,454 @@
                   <a:srgbClr val="1B1F2A"/>
                 </a:solidFill>
               </a:rPr>
+              <a:t>Implementacja i ograniczenia</a:t>
+            </a:r>
+            <a:endParaRPr lang="en-US" sz="3200" dirty="0"/>
+          </a:p>
+        </p:txBody>
+      </p:sp>
+      <p:sp>
+        <p:nvSpPr>
+          <p:cNvPr id="3" name="Implementacja karta"/>
+          <p:cNvSpPr/>
+          <p:nvPr/>
+        </p:nvSpPr>
+        <p:spPr>
+          <a:xfrm>
+            <a:off x="457200" y="1188720"/>
+            <a:ext cx="4023360" cy="3291840"/>
+          </a:xfrm>
+          <a:prstGeom prst="rect">
+            <a:avLst/>
+          </a:prstGeom>
+          <a:solidFill>
+            <a:schemeClr val="bg2"/>
+          </a:solidFill>
+          <a:ln w="12700">
+            <a:solidFill>
+              <a:schemeClr val="bg2"/>
+            </a:solidFill>
+            <a:prstDash val="solid"/>
+          </a:ln>
+        </p:spPr>
+      </p:sp>
+      <p:sp>
+        <p:nvSpPr>
+          <p:cNvPr id="4" name="Implementacja tytuł"/>
+          <p:cNvSpPr txBox="1"/>
+          <p:nvPr/>
+        </p:nvSpPr>
+        <p:spPr>
+          <a:xfrm>
+            <a:off x="640080" y="1280160"/>
+            <a:ext cx="3657600" cy="365760"/>
+          </a:xfrm>
+          <a:prstGeom prst="rect">
+            <a:avLst/>
+          </a:prstGeom>
+          <a:noFill/>
+          <a:ln/>
+        </p:spPr>
+        <p:txBody>
+          <a:bodyPr wrap="square" lIns="0" tIns="0" rIns="0" bIns="0" rtlCol="0" anchor="t"/>
+          <a:lstStyle/>
+          <a:p>
+            <a:pPr indent="0" marL="0">
+              <a:buNone/>
+            </a:pPr>
+            <a:r>
+              <a:rPr lang="en-US" sz="1800" b="1" dirty="0">
+                <a:solidFill>
+                  <a:schemeClr val="accent2"/>
+                </a:solidFill>
+              </a:rPr>
+              <a:t>Implementacja</a:t>
+            </a:r>
+            <a:endParaRPr lang="en-US" sz="1800" dirty="0"/>
+          </a:p>
+        </p:txBody>
+      </p:sp>
+      <p:sp>
+        <p:nvSpPr>
+          <p:cNvPr id="5" name="Implementacja lista"/>
+          <p:cNvSpPr txBox="1"/>
+          <p:nvPr/>
+        </p:nvSpPr>
+        <p:spPr>
+          <a:xfrm>
+            <a:off x="640080" y="1691640"/>
+            <a:ext cx="3657600" cy="2743200"/>
+          </a:xfrm>
+          <a:prstGeom prst="rect">
+            <a:avLst/>
+          </a:prstGeom>
+          <a:noFill/>
+          <a:ln/>
+        </p:spPr>
+        <p:txBody>
+          <a:bodyPr wrap="square" lIns="0" tIns="0" rIns="0" bIns="0" rtlCol="0" anchor="t"/>
+          <a:lstStyle/>
+          <a:p>
+            <a:pPr marL="342900" indent="-342900">
+              <a:spcAft>
+                <a:spcPts val="400"/>
+              </a:spcAft>
+              <a:buSzPct val="100000"/>
+              <a:buChar char="•"/>
+            </a:pPr>
+            <a:r>
+              <a:rPr lang="en-US" sz="1400" dirty="0">
+                <a:solidFill>
+                  <a:schemeClr val="tx1"/>
+                </a:solidFill>
+              </a:rPr>
+              <a:t>RouterService w DeepFellow Infra v0.34.0</a:t>
+            </a:r>
+            <a:endParaRPr lang="en-US" sz="1400" dirty="0"/>
+          </a:p>
+          <a:p>
+            <a:pPr marL="342900" indent="-342900">
+              <a:spcAft>
+                <a:spcPts val="400"/>
+              </a:spcAft>
+              <a:buSzPct val="100000"/>
+              <a:buChar char="•"/>
+            </a:pPr>
+            <a:r>
+              <a:rPr lang="en-US" sz="1400" dirty="0">
+                <a:solidFill>
+                  <a:schemeClr val="tx1"/>
+                </a:solidFill>
+              </a:rPr>
+              <a:t>57 nowych testów, cały zestaw (5157) zielony</a:t>
+            </a:r>
+            <a:endParaRPr lang="en-US" sz="1400" dirty="0"/>
+          </a:p>
+          <a:p>
+            <a:pPr marL="342900" indent="-342900">
+              <a:spcAft>
+                <a:spcPts val="400"/>
+              </a:spcAft>
+              <a:buSzPct val="100000"/>
+              <a:buChar char="•"/>
+            </a:pPr>
+            <a:r>
+              <a:rPr lang="en-US" sz="1400" dirty="0">
+                <a:solidFill>
+                  <a:schemeClr val="tx1"/>
+                </a:solidFill>
+              </a:rPr>
+              <a:t>Test end-to-end z modelami Gemini: routing, nagłówki, streaming, fallback</a:t>
+            </a:r>
+            <a:endParaRPr lang="en-US" sz="1400" dirty="0"/>
+          </a:p>
+          <a:p>
+            <a:pPr marL="342900" indent="-342900">
+              <a:spcAft>
+                <a:spcPts val="400"/>
+              </a:spcAft>
+              <a:buSzPct val="100000"/>
+              <a:buChar char="•"/>
+            </a:pPr>
+            <a:r>
+              <a:rPr lang="en-US" sz="1400" dirty="0">
+                <a:solidFill>
+                  <a:schemeClr val="tx1"/>
+                </a:solidFill>
+              </a:rPr>
+              <a:t>Opóźnienie warstw 1+2: mediana 20,6 ms</a:t>
+            </a:r>
+            <a:endParaRPr lang="en-US" sz="1400" dirty="0"/>
+          </a:p>
+          <a:p>
+            <a:pPr marL="342900" indent="-342900">
+              <a:spcAft>
+                <a:spcPts val="400"/>
+              </a:spcAft>
+              <a:buSzPct val="100000"/>
+              <a:buChar char="•"/>
+            </a:pPr>
+            <a:r>
+              <a:rPr lang="en-US" sz="1400" dirty="0">
+                <a:solidFill>
+                  <a:schemeClr val="tx1"/>
+                </a:solidFill>
+              </a:rPr>
+              <a:t>Zmiana decyzji po literówkach i parafrazach: 6–10% pytań</a:t>
+            </a:r>
+            <a:endParaRPr lang="en-US" sz="1400" dirty="0"/>
+          </a:p>
+          <a:p>
+            <a:pPr marL="342900" indent="-342900">
+              <a:buSzPct val="100000"/>
+              <a:buChar char="•"/>
+            </a:pPr>
+            <a:r>
+              <a:rPr lang="en-US" sz="1400" dirty="0">
+                <a:solidFill>
+                  <a:schemeClr val="tx1"/>
+                </a:solidFill>
+              </a:rPr>
+              <a:t>Z Qwenem 8B/27B: pierwszy test udany, brakuje awarii i restartu</a:t>
+            </a:r>
+            <a:endParaRPr lang="en-US" sz="1400" dirty="0"/>
+          </a:p>
+        </p:txBody>
+      </p:sp>
+      <p:sp>
+        <p:nvSpPr>
+          <p:cNvPr id="6" name="Ograniczenia karta"/>
+          <p:cNvSpPr/>
+          <p:nvPr/>
+        </p:nvSpPr>
+        <p:spPr>
+          <a:xfrm>
+            <a:off x="4663440" y="1188720"/>
+            <a:ext cx="4023360" cy="3291840"/>
+          </a:xfrm>
+          <a:prstGeom prst="rect">
+            <a:avLst/>
+          </a:prstGeom>
+          <a:solidFill>
+            <a:schemeClr val="bg2"/>
+          </a:solidFill>
+          <a:ln w="12700">
+            <a:solidFill>
+              <a:schemeClr val="bg2"/>
+            </a:solidFill>
+            <a:prstDash val="solid"/>
+          </a:ln>
+        </p:spPr>
+      </p:sp>
+      <p:sp>
+        <p:nvSpPr>
+          <p:cNvPr id="7" name="Ograniczenia tytuł"/>
+          <p:cNvSpPr txBox="1"/>
+          <p:nvPr/>
+        </p:nvSpPr>
+        <p:spPr>
+          <a:xfrm>
+            <a:off x="4846320" y="1280160"/>
+            <a:ext cx="3657600" cy="365760"/>
+          </a:xfrm>
+          <a:prstGeom prst="rect">
+            <a:avLst/>
+          </a:prstGeom>
+          <a:noFill/>
+          <a:ln/>
+        </p:spPr>
+        <p:txBody>
+          <a:bodyPr wrap="square" lIns="0" tIns="0" rIns="0" bIns="0" rtlCol="0" anchor="t"/>
+          <a:lstStyle/>
+          <a:p>
+            <a:pPr indent="0" marL="0">
+              <a:buNone/>
+            </a:pPr>
+            <a:r>
+              <a:rPr lang="en-US" sz="1800" b="1" dirty="0">
+                <a:solidFill>
+                  <a:schemeClr val="accent1"/>
+                </a:solidFill>
+              </a:rPr>
+              <a:t>Ograniczenia</a:t>
+            </a:r>
+            <a:endParaRPr lang="en-US" sz="1800" dirty="0"/>
+          </a:p>
+        </p:txBody>
+      </p:sp>
+      <p:sp>
+        <p:nvSpPr>
+          <p:cNvPr id="8" name="Ograniczenia lista"/>
+          <p:cNvSpPr txBox="1"/>
+          <p:nvPr/>
+        </p:nvSpPr>
+        <p:spPr>
+          <a:xfrm>
+            <a:off x="4846320" y="1691640"/>
+            <a:ext cx="3657600" cy="2743200"/>
+          </a:xfrm>
+          <a:prstGeom prst="rect">
+            <a:avLst/>
+          </a:prstGeom>
+          <a:noFill/>
+          <a:ln/>
+        </p:spPr>
+        <p:txBody>
+          <a:bodyPr wrap="square" lIns="0" tIns="0" rIns="0" bIns="0" rtlCol="0" anchor="t"/>
+          <a:lstStyle/>
+          <a:p>
+            <a:pPr marL="342900" indent="-342900">
+              <a:spcAft>
+                <a:spcPts val="600"/>
+              </a:spcAft>
+              <a:buSzPct val="100000"/>
+              <a:buChar char="•"/>
+            </a:pPr>
+            <a:r>
+              <a:rPr lang="en-US" sz="1400" dirty="0">
+                <a:solidFill>
+                  <a:schemeClr val="tx1"/>
+                </a:solidFill>
+              </a:rPr>
+              <a:t>Jedna para modeli i jeden sędzia</a:t>
+            </a:r>
+            <a:endParaRPr lang="en-US" sz="1400" dirty="0"/>
+          </a:p>
+          <a:p>
+            <a:pPr marL="342900" indent="-342900">
+              <a:spcAft>
+                <a:spcPts val="600"/>
+              </a:spcAft>
+              <a:buSzPct val="100000"/>
+              <a:buChar char="•"/>
+            </a:pPr>
+            <a:r>
+              <a:rPr lang="en-US" sz="1400" dirty="0">
+                <a:solidFill>
+                  <a:schemeClr val="tx1"/>
+                </a:solidFill>
+              </a:rPr>
+              <a:t>Dane mało „firmowe”: 63% to czaty (Arena, WildChat)</a:t>
+            </a:r>
+            <a:endParaRPr lang="en-US" sz="1400" dirty="0"/>
+          </a:p>
+          <a:p>
+            <a:pPr marL="342900" indent="-342900">
+              <a:spcAft>
+                <a:spcPts val="600"/>
+              </a:spcAft>
+              <a:buSzPct val="100000"/>
+              <a:buChar char="•"/>
+            </a:pPr>
+            <a:r>
+              <a:rPr lang="en-US" sz="1400" dirty="0">
+                <a:solidFill>
+                  <a:schemeClr val="tx1"/>
+                </a:solidFill>
+              </a:rPr>
+              <a:t>Duży model ma jedną próbkę na pytanie</a:t>
+            </a:r>
+            <a:endParaRPr lang="en-US" sz="1400" dirty="0"/>
+          </a:p>
+          <a:p>
+            <a:pPr marL="342900" indent="-342900">
+              <a:buSzPct val="100000"/>
+              <a:buChar char="•"/>
+            </a:pPr>
+            <a:r>
+              <a:rPr lang="en-US" sz="1400" dirty="0">
+                <a:solidFill>
+                  <a:schemeClr val="tx1"/>
+                </a:solidFill>
+              </a:rPr>
+              <a:t>Wiedza i kod słabo wykrywane</a:t>
+            </a:r>
+            <a:endParaRPr lang="en-US" sz="1400" dirty="0"/>
+          </a:p>
+        </p:txBody>
+      </p:sp>
+      <p:sp>
+        <p:nvSpPr>
+          <p:cNvPr id="25" name="Slide Number Placeholder 0"/>
+          <p:cNvSpPr>
+            <a:spLocks noGrp="1"/>
+          </p:cNvSpPr>
+          <p:nvPr>
+            <p:ph type="sldNum" sz="quarter" idx="4294967295"/>
+          </p:nvPr>
+        </p:nvSpPr>
+        <p:spPr>
+          <a:xfrm>
+            <a:off x="8321040" y="4754880"/>
+            <a:ext cx="457200" cy="274320"/>
+          </a:xfrm>
+          <a:prstGeom prst="rect">
+            <a:avLst/>
+          </a:prstGeom>
+          <a:extLst>
+            <a:ext uri="{C572A759-6A51-4108-AA02-DFA0A04FC94B}">
+              <ma14:wrappingTextBoxFlag xmlns:ma14="http://schemas.microsoft.com/office/mac/drawingml/2011/main" val="0"/>
+            </a:ext>
+          </a:extLst>
+        </p:spPr>
+        <p:txBody>
+          <a:bodyPr/>
+          <a:lstStyle>
+            <a:lvl1pPr>
+              <a:defRPr sz="1000">
+                <a:solidFill>
+                  <a:srgbClr val="8C9BB5"/>
+                </a:solidFill>
+              </a:defRPr>
+            </a:lvl1pPr>
+          </a:lstStyle>
+          <a:p>
+            <a:pPr algn="r"/>
+            <a:fld id="{F7021451-1387-4CA6-816F-3879F97B5CBC}" type="slidenum">
+              <a:rPr b="0" lang="en-US"/>
+              <a:t>14</a:t>
+            </a:fld>
+            <a:endParaRPr lang="en-US"/>
+          </a:p>
+        </p:txBody>
+      </p:sp>
+    </p:spTree>
+  </p:cSld>
+  <p:clrMapOvr>
+    <a:masterClrMapping/>
+  </p:clrMapOvr>
+</p:sld>
+</file>
+
+<file path=ppt/slides/slide15.xml><?xml version="1.0" encoding="utf-8"?>
+<p:sld xmlns:a="http://schemas.openxmlformats.org/drawingml/2006/main" xmlns:r="http://schemas.openxmlformats.org/officeDocument/2006/relationships" xmlns:p="http://schemas.openxmlformats.org/presentationml/2006/main">
+  <p:cSld name="Slide 15">
+    <p:spTree>
+      <p:nvGrpSpPr>
+        <p:cNvPr id="1" name=""/>
+        <p:cNvGrpSpPr/>
+        <p:nvPr/>
+      </p:nvGrpSpPr>
+      <p:grpSpPr>
+        <a:xfrm>
+          <a:off x="0" y="0"/>
+          <a:ext cx="0" cy="0"/>
+          <a:chOff x="0" y="0"/>
+          <a:chExt cx="0" cy="0"/>
+        </a:xfrm>
+      </p:grpSpPr>
+      <p:sp>
+        <p:nvSpPr>
+          <p:cNvPr id="2" name="Text 0"/>
+          <p:cNvSpPr/>
+          <p:nvPr>
+            <p:ph idx="100" type="title" hasCustomPrompt="1"/>
+          </p:nvPr>
+        </p:nvSpPr>
+        <p:spPr>
+          <a:xfrm>
+            <a:off x="457200" y="274320"/>
+            <a:ext cx="8229600" cy="731520"/>
+          </a:xfrm>
+          <a:prstGeom prst="rect">
+            <a:avLst/>
+          </a:prstGeom>
+          <a:noFill/>
+          <a:ln/>
+        </p:spPr>
+        <p:txBody>
+          <a:bodyPr wrap="square" lIns="0" tIns="0" rIns="0" bIns="0" rtlCol="0" anchor="ctr"/>
+          <a:lstStyle/>
+          <a:p>
+            <a:pPr algn="l" indent="0" marL="0">
+              <a:buNone/>
+            </a:pPr>
+            <a:r>
+              <a:rPr lang="en-US" sz="3200" b="1" dirty="0">
+                <a:solidFill>
+                  <a:srgbClr val="1B1F2A"/>
+                </a:solidFill>
+              </a:rPr>
               <a:t>Plan i prośba</a:t>
             </a:r>
             <a:endParaRPr lang="en-US" sz="3200" dirty="0"/>
@@ -5176,7 +6922,7 @@
                   <a:schemeClr val="tx1"/>
                 </a:solidFill>
               </a:rPr>
-              <a:t>Uruchomienie z Qwen 8B/27B na komputerze służbowym</a:t>
+              <a:t>Dokończenie testu z Qwen 8B/27B (awaria, restart)</a:t>
             </a:r>
             <a:endParaRPr lang="en-US" sz="1600" dirty="0"/>
           </a:p>
@@ -5273,7 +7019,7 @@
                   <a:schemeClr val="tx1"/>
                 </a:solidFill>
               </a:rPr>
-              <a:t>Test warstwy 3 (go/no-go)</a:t>
+              <a:t>Test warstwy 3 (go/no-go) w strefie niepewności</a:t>
             </a:r>
             <a:endParaRPr lang="en-US" sz="1600" dirty="0"/>
           </a:p>
@@ -5609,7 +7355,7 @@
             <a:pPr algn="r"/>
             <a:fld id="{F7021451-1387-4CA6-816F-3879F97B5CBC}" type="slidenum">
               <a:rPr b="0" lang="en-US"/>
-              <a:t>14</a:t>
+              <a:t>15</a:t>
             </a:fld>
             <a:endParaRPr lang="en-US"/>
           </a:p>
@@ -9212,7 +10958,7 @@
                   <a:schemeClr val="tx2"/>
                 </a:solidFill>
               </a:rPr>
-              <a:t>Po teście go/no-go. Jeszcze nie w rdzeniu.</a:t>
+              <a:t>Tylko w strefie niepewności warstwy 2, po teście go/no-go. Jeszcze nie w rdzeniu.</a:t>
             </a:r>
             <a:endParaRPr lang="en-US" sz="1400" dirty="0"/>
           </a:p>

</xml_diff>

<commit_message>
docs: slajd o dodatkowych danych z licencjami, dziennik 71-72, prezentacja 16 slajdów
Co-Authored-By: Claude Sonnet 5.5 <noreply@anthropic.com>
Claude-Session: https://claude.ai/code/session_01V1631aLqopE3GM2inWjbQ8
</commit_message>
<xml_diff>
--- a/docs/prezentacja_postepy.pptx
+++ b/docs/prezentacja_postepy.pptx
@@ -20,9 +20,10 @@
     <p:sldId id="268" r:id="rId14"/>
     <p:sldId id="269" r:id="rId15"/>
     <p:sldId id="270" r:id="rId16"/>
+    <p:sldId id="271" r:id="rId17"/>
   </p:sldIdLst>
   <p:notesMasterIdLst>
-    <p:notesMasterId r:id="rId17"/>
+    <p:notesMasterId r:id="rId18"/>
   </p:notesMasterIdLst>
   <p:sldSz cx="9144000" cy="5143500"/>
   <p:notesSz cx="5143500" cy="9144000"/>
@@ -121,7 +122,7 @@
   <p:extLst>
     <p:ext uri="{521415D9-36F7-43E2-AB2F-B90AF26B5E84}">
       <p14:sectionLst xmlns:p14="http://schemas.microsoft.com/office/powerpoint/2010/main">
-        <p14:section name="Wprowadzenie" id="{9f792a53-830f-8634-4c6b-eb0cd7be41d9}">
+        <p14:section name="Wprowadzenie" id="{4e2955fb-ccac-7eca-65c4-1924764c3b78}">
           <p14:sldIdLst>
             <p14:sldId id="256"/>
             <p14:sldId id="257"/>
@@ -129,20 +130,20 @@
             <p14:sldId id="259"/>
           </p14:sldIdLst>
         </p14:section>
-        <p14:section name="Dane i etykiety" id="{c3531a53-bccc-b061-5d30-1e0ffb342f79}">
+        <p14:section name="Dane i etykiety" id="{7c2798c1-0730-d7ce-d2cf-247483282989}">
           <p14:sldIdLst>
             <p14:sldId id="260"/>
             <p14:sldId id="261"/>
             <p14:sldId id="262"/>
           </p14:sldIdLst>
         </p14:section>
-        <p14:section name="Router" id="{6d8d1785-5f62-84ca-7ac3-1ea253b93b1d}">
+        <p14:section name="Router" id="{58a86839-b555-6820-284d-c5bdd9dbf563}">
           <p14:sldIdLst>
             <p14:sldId id="263"/>
             <p14:sldId id="264"/>
           </p14:sldIdLst>
         </p14:section>
-        <p14:section name="Wyniki" id="{186936ac-1291-99a7-c4b4-8d6c00aaad95}">
+        <p14:section name="Wyniki" id="{4298aecd-365f-0ba3-c327-3fdec03fbef0}">
           <p14:sldIdLst>
             <p14:sldId id="265"/>
             <p14:sldId id="266"/>
@@ -150,10 +151,11 @@
             <p14:sldId id="268"/>
           </p14:sldIdLst>
         </p14:section>
-        <p14:section name="Dalej" id="{c7214c98-ff16-45ce-0887-2f39a54d43d4}">
+        <p14:section name="Dalej" id="{4c63d7b5-3605-8206-8c38-8a2d8dc7f34d}">
           <p14:sldIdLst>
             <p14:sldId id="269"/>
             <p14:sldId id="270"/>
+            <p14:sldId id="271"/>
           </p14:sldIdLst>
         </p14:section>
       </p14:sectionLst>
@@ -591,7 +593,7 @@
           <a:p>
             <a:r>
               <a:rPr lang="pl-PL" sz="1400"/>
-              <a:t>Całość zajmie ok. 20 minut.</a:t>
+              <a:t>Całość zajmie ok. 20–25 minut.</a:t>
             </a:r>
           </a:p>
         </p:txBody>
@@ -1585,7 +1587,7 @@
           <a:p>
             <a:r>
               <a:rPr lang="pl-PL" sz="1400"/>
-              <a:t>Co dalej. Po pierwsze, dokończyć test z modelami Qwen 8B i 27B na komputerze służbowym: awaria i restart usługi, a opóźnienie zmierzyć dokładniej, na większej liczbie pomiarów. Po drugie, sprawdzić warstwę 3 (test go/no-go): czy mały model oceniający pytanie poprawia wynik routera, i to tylko w strefie niepewności, czyli tam, gdzie warstwa 2 nie jest pewna. Granice strefy dobiorę tak, żeby jakość nie spadła poniżej ustalonego poziomu, który jeszcze trzeba ustalić. Po trzecie, dodać dane bliższe wdrożeniu, np. własne zapytania, zadania SQL, polecenia biurowe. To wymaga ponownego pomiaru, ale pozwoli też sprawdzić, czy heurystyki warstwy 1 działają lepiej na takich danych. Po czwarte, otworzyć zbiór testowy raz i zrobić ocenę końcową.
+              <a:t>Najsłabsza strona moich danych jest taka, że niewiele przypominają zwykłe użycie w firmie. 63% to publiczne czaty z Areny i WildChat, w dużej części zabawa i fikcja literacka. Reszta to znane testy. Brakuje poleceń biurowych, zadań z bazami danych i prawdziwego kodu pisanego przez programistów. Przez to router słabo wykrywa trudny kod, a heurystyki z warstwy 1 mogły wypaść gorzej, niż wypadną na danych z firmy. To jest hipoteza do sprawdzenia, a nie wynik.
 </a:t>
             </a:r>
           </a:p>
@@ -1595,7 +1597,7 @@
           <a:p>
             <a:r>
               <a:rPr lang="pl-PL" sz="1400"/>
-              <a:t>Prośba. Proszę o zatwierdzenie celów liczbowych przed otwarciem testu. Po otwarciu nie będę ich zmieniał, a wyniki podam niezależnie od tego, czy cele są spełnione. To zabezpiecza przed dopasowaniem wymagań do wyniku.
+              <a:t>Dlatego po prezentacji chcę dołożyć dane z innych publicznych zbiorów. Pokazuję cztery kandydatki. Licencje sprawdziłem na kartach zbiorów: Dolly ma CC BY-SA 3.0, CodeChat ODC-By, Spider CC BY-SA 4.0, a Arena 140k CC BY 4.0 dla promptów. Dwie z nich, Dolly i Spider, to licencje typu ShareAlike, czyli z warunkiem zachowania tej samej licencji. Opiszę to w pracy. Używam tylko promptów, a odpowiedzi generują moje modele, więc warunki dotyczące odpowiedzi modeli w Arenie mnie nie obejmują. Ostateczny wybór zrobię przed pomiarem.
 </a:t>
             </a:r>
           </a:p>
@@ -1605,49 +1607,7 @@
           <a:p>
             <a:r>
               <a:rPr lang="pl-PL" sz="1400"/>
-              <a:t>Moja propozycja celów:
-</a:t>
-            </a:r>
-          </a:p>
-          <a:p>
-            <a:r>
-              <a:rPr lang="pl-PL" sz="1400"/>
-              <a:t>• router lepszy od „samego źródła” w sposób istotny statystycznie,
-</a:t>
-            </a:r>
-          </a:p>
-          <a:p>
-            <a:r>
-              <a:rPr lang="pl-PL" sz="1400"/>
-              <a:t>• AUROC co najmniej 0,64 (w badaniach 0,68),
-</a:t>
-            </a:r>
-          </a:p>
-          <a:p>
-            <a:r>
-              <a:rPr lang="pl-PL" sz="1400"/>
-              <a:t>• żeby odzyskać 80% możliwego zysku jakości, wysyłam do dużego nie więcej niż 72% pytań (losowo byłoby 80%),
-</a:t>
-            </a:r>
-          </a:p>
-          <a:p>
-            <a:r>
-              <a:rPr lang="pl-PL" sz="1400"/>
-              <a:t>• po literówkach i parafrazach decyzja zmienia się w najwyżej 15% pytań,
-</a:t>
-            </a:r>
-          </a:p>
-          <a:p>
-            <a:r>
-              <a:rPr lang="pl-PL" sz="1400"/>
-              <a:t>• mediana czasu decyzji poniżej 50 ms,
-</a:t>
-            </a:r>
-          </a:p>
-          <a:p>
-            <a:r>
-              <a:rPr lang="pl-PL" sz="1400"/>
-              <a:t>• pytania spoza dziedziny (MMLU, MT-Bench) tylko raportuję, bez progu.
+              <a:t>Pierwsza to Dolly, około 15 tysięcy poleceń napisanych przez pracowników firmy Databricks: streszczanie tekstu, wyciąganie informacji, pytania zamknięte, burza mózgów. To najbliższe temu, o co ktoś mógłby pytać asystenta w firmie. Część poleceń ma dołączone fragmenty Wikipedii, z których usunę numery przypisów.
 </a:t>
             </a:r>
           </a:p>
@@ -1657,7 +1617,99 @@
           <a:p>
             <a:r>
               <a:rPr lang="pl-PL" sz="1400"/>
-              <a:t>Podsumowanie. Etykiety mierzę z prawdziwych odpowiedzi modeli. Router oparty na podobieństwie pytań daje realny, ale umiarkowany zysk, jest szybki i stabilny. Nie przewidzi tylko tego, czy mały model zna konkretny fakt.</a:t>
+              <a:t>Druga to CodeChat, około 83 tysięcy prawdziwych rozmów programistów z modelami językowymi, w ponad dwudziestu językach programowania. Dałaby dużo więcej prawdziwego kodu niż dzisiejsze zadania z jednego zbioru, HumanEval. To część zbioru WildChat, który już mam, więc najpierw usunę powtórzenia.
+</a:t>
+            </a:r>
+          </a:p>
+          <a:p>
+            <a:endParaRPr lang="pl-PL" sz="1400"/>
+          </a:p>
+          <a:p>
+            <a:r>
+              <a:rPr lang="pl-PL" sz="1400"/>
+              <a:t>Trzecia to Spider, około 8 tysięcy pytań zadawanych bazom danych po angielsku, do których trzeba napisać zapytanie w języku SQL. SQL to język, którym pyta się bazy danych. To nowy rodzaj zadań, typowy dla firm. Pytania napisało 11 studentów uniwersytetu Yale, więc nie są to zapytania prawdziwych użytkowników. Jest najdroższy w ocenie, bo żeby sprawdzić wynik automatem, trzeba uruchamiać zapytania na bazach.
+</a:t>
+            </a:r>
+          </a:p>
+          <a:p>
+            <a:endParaRPr lang="pl-PL" sz="1400"/>
+          </a:p>
+          <a:p>
+            <a:r>
+              <a:rPr lang="pl-PL" sz="1400"/>
+              <a:t>Czwarta to Arena 140k, około 135 tysięcy prawdziwych rozmów z Areny, na wielu tematach i w wielu językach, ze znacznikiem, które dotyczą kodu. Daje więcej różnych pytań. Część pytań z Areny już mam, więc też sprawdzę powtórzenia.
+</a:t>
+            </a:r>
+          </a:p>
+          <a:p>
+            <a:endParaRPr lang="pl-PL" sz="1400"/>
+          </a:p>
+          <a:p>
+            <a:r>
+              <a:rPr lang="pl-PL" sz="1400"/>
+              <a:t>Co trzeba zrobić z każdym zbiorem: tak jak z poprzednimi, wysłać pytania do obu modeli (mały trzy razy, duży raz), ocenić odpowiedzi sędzią i policzyć różnicę Δ. Dopiero wtedy pytania dostają etykiety. Zbiór testowy zostaje zamknięty, nowe dane trafią tylko do części do nauki i dostrajania. Koszt sędziego to moje oszacowanie: ok. 1 dolar na 500 pytań, na podstawie dotychczasowych ok. 8 dolarów za całość. Płatne wywołania zrobię dopiero za zgodą na konkretną kwotę.
+</a:t>
+            </a:r>
+          </a:p>
+          <a:p>
+            <a:endParaRPr lang="pl-PL" sz="1400"/>
+          </a:p>
+          <a:p>
+            <a:r>
+              <a:rPr lang="pl-PL" sz="1400" b="1"/>
+              <a:t>UWAGA
+</a:t>
+            </a:r>
+          </a:p>
+          <a:p>
+            <a:r>
+              <a:rPr lang="pl-PL" sz="1400"/>
+              <a:t>To jest plan, nic z tego jeszcze nie zrobiłem. Nie wiem, czy nowe dane poprawią router. Wiem tylko, że obecne nie pokazują zwykłego użycia w firmie, więc ich uzupełnienie jest uzasadnione.
+</a:t>
+            </a:r>
+          </a:p>
+          <a:p>
+            <a:endParaRPr lang="pl-PL" sz="1400"/>
+          </a:p>
+          <a:p>
+            <a:r>
+              <a:rPr lang="pl-PL" sz="1400" b="1"/>
+              <a:t>JEŚLI ZAPYTAJĄ
+</a:t>
+            </a:r>
+          </a:p>
+          <a:p>
+            <a:r>
+              <a:rPr lang="pl-PL" sz="1400"/>
+              <a:t>Czy jest zbiór prawdziwych zapytań firmowych? Nie znalazłem go w otwartych zbiorach. Najbliższy jest Dolly, pisany przez pracowników firmy.
+</a:t>
+            </a:r>
+          </a:p>
+          <a:p>
+            <a:r>
+              <a:rPr lang="pl-PL" sz="1400"/>
+              <a:t>Dlaczego nie Bitext, czyli zbiór pytań do obsługi klienta? Jest syntetyczny i szablonowy, więc pewnie prawie same pytania łatwe i bardzo do siebie podobne. Nic by nie powiedział o prawdziwym ruchu.
+</a:t>
+            </a:r>
+          </a:p>
+          <a:p>
+            <a:r>
+              <a:rPr lang="pl-PL" sz="1400"/>
+              <a:t>Dlaczego nie LMSYS-Chat-1M? Wymaga zgody na dostęp. Odrzuciłem go wcześniej.
+</a:t>
+            </a:r>
+          </a:p>
+          <a:p>
+            <a:r>
+              <a:rPr lang="pl-PL" sz="1400"/>
+              <a:t>Dlaczego nie RouterBench, zbiór do badań nad routingiem? Na jego karcie nie ma licencji, a pytania pochodzą ze znanych testów, więc nie dodałby nowych rodzajów pytań.
+</a:t>
+            </a:r>
+          </a:p>
+          <a:p>
+            <a:r>
+              <a:rPr lang="pl-PL" sz="1400"/>
+              <a:t>A licencje? Sprawdziłem je na kartach zbiorów: Dolly CC BY-SA 3.0, CodeChat ODC-By, Spider CC BY-SA 4.0, Arena 140k CC BY 4.0 dla promptów. Dolly i Spider mają ShareAlike, co opiszę w pracy. Prawnej interpretacji nie robiłem, karty podają same licencje. Nie sprawdziłem oficjalnej strony Spider poza kartą.</a:t>
             </a:r>
           </a:p>
         </p:txBody>
@@ -1680,6 +1732,172 @@
             <a:fld id="{F7021451-1387-4CA6-816F-3879F97B5CBC}" type="slidenum">
               <a:rPr lang="en-US"/>
               <a:t>15</a:t>
+            </a:fld>
+            <a:endParaRPr lang="en-US"/>
+          </a:p>
+        </p:txBody>
+      </p:sp>
+    </p:spTree>
+    <p:extLst>
+      <p:ext uri="{BB962C8B-B14F-4D97-AF65-F5344CB8AC3E}">
+        <p14:creationId xmlns:p14="http://schemas.microsoft.com/office/powerpoint/2010/main" val="1024086991"/>
+      </p:ext>
+    </p:extLst>
+  </p:cSld>
+  <p:clrMapOvr>
+    <a:masterClrMapping/>
+  </p:clrMapOvr>
+</p:notes>
+</file>
+
+<file path=ppt/notesSlides/notesSlide16.xml><?xml version="1.0" encoding="utf-8"?>
+<p:notes xmlns:a="http://schemas.openxmlformats.org/drawingml/2006/main" xmlns:r="http://schemas.openxmlformats.org/officeDocument/2006/relationships" xmlns:p="http://schemas.openxmlformats.org/presentationml/2006/main">
+  <p:cSld>
+    <p:spTree>
+      <p:nvGrpSpPr>
+        <p:cNvPr id="1" name=""/>
+        <p:cNvGrpSpPr/>
+        <p:nvPr/>
+      </p:nvGrpSpPr>
+      <p:grpSpPr>
+        <a:xfrm>
+          <a:off x="0" y="0"/>
+          <a:ext cx="0" cy="0"/>
+          <a:chOff x="0" y="0"/>
+          <a:chExt cx="0" cy="0"/>
+        </a:xfrm>
+      </p:grpSpPr>
+      <p:sp>
+        <p:nvSpPr>
+          <p:cNvPr id="2" name="Slide Image Placeholder 1"/>
+          <p:cNvSpPr>
+            <a:spLocks noGrp="1" noRot="1" noChangeAspect="1"/>
+          </p:cNvSpPr>
+          <p:nvPr>
+            <p:ph type="sldImg"/>
+          </p:nvPr>
+        </p:nvSpPr>
+        <p:spPr/>
+      </p:sp>
+      <p:sp>
+        <p:nvSpPr>
+          <p:cNvPr id="3" name="Notes Placeholder 2"/>
+          <p:cNvSpPr>
+            <a:spLocks noGrp="1"/>
+          </p:cNvSpPr>
+          <p:nvPr>
+            <p:ph type="body" idx="1"/>
+          </p:nvPr>
+        </p:nvSpPr>
+        <p:spPr/>
+        <p:txBody>
+          <a:bodyPr/>
+          <a:lstStyle/>
+          <a:p>
+            <a:r>
+              <a:rPr lang="pl-PL" sz="1400" b="1"/>
+              <a:t>MÓW
+</a:t>
+            </a:r>
+          </a:p>
+          <a:p>
+            <a:r>
+              <a:rPr lang="pl-PL" sz="1400"/>
+              <a:t>Co dalej. Po pierwsze, dokończyć test z modelami Qwen 8B i 27B na komputerze służbowym: awaria i restart usługi, a opóźnienie zmierzyć dokładniej, na większej liczbie pomiarów. Po drugie, sprawdzić warstwę 3 (test go/no-go): czy mały model oceniający pytanie poprawia wynik routera, i to tylko w strefie niepewności, czyli tam, gdzie warstwa 2 nie jest pewna. Granice strefy dobiorę tak, żeby jakość nie spadła poniżej ustalonego poziomu, który jeszcze trzeba ustalić. Po trzecie, dodać dane bliższe wdrożeniu, czyli te zbiory, które pokazałem na poprzednim slajdzie: polecenia biurowe, prawdziwy kod i zadania SQL. To wymaga ponownego pomiaru, ale pozwoli też sprawdzić, czy heurystyki warstwy 1 działają lepiej na takich danych. Po czwarte, otworzyć zbiór testowy raz i zrobić ocenę końcową.
+</a:t>
+            </a:r>
+          </a:p>
+          <a:p>
+            <a:endParaRPr lang="pl-PL" sz="1400"/>
+          </a:p>
+          <a:p>
+            <a:r>
+              <a:rPr lang="pl-PL" sz="1400"/>
+              <a:t>Prośba. Proszę o zatwierdzenie celów liczbowych przed otwarciem testu. Po otwarciu nie będę ich zmieniał, a wyniki podam niezależnie od tego, czy cele są spełnione. To zabezpiecza przed dopasowaniem wymagań do wyniku.
+</a:t>
+            </a:r>
+          </a:p>
+          <a:p>
+            <a:endParaRPr lang="pl-PL" sz="1400"/>
+          </a:p>
+          <a:p>
+            <a:r>
+              <a:rPr lang="pl-PL" sz="1400"/>
+              <a:t>Moja propozycja celów:
+</a:t>
+            </a:r>
+          </a:p>
+          <a:p>
+            <a:r>
+              <a:rPr lang="pl-PL" sz="1400"/>
+              <a:t>• router lepszy od „samego źródła” w sposób istotny statystycznie,
+</a:t>
+            </a:r>
+          </a:p>
+          <a:p>
+            <a:r>
+              <a:rPr lang="pl-PL" sz="1400"/>
+              <a:t>• AUROC co najmniej 0,64 (w badaniach 0,68),
+</a:t>
+            </a:r>
+          </a:p>
+          <a:p>
+            <a:r>
+              <a:rPr lang="pl-PL" sz="1400"/>
+              <a:t>• żeby odzyskać 80% możliwego zysku jakości, wysyłam do dużego nie więcej niż 72% pytań (losowo byłoby 80%),
+</a:t>
+            </a:r>
+          </a:p>
+          <a:p>
+            <a:r>
+              <a:rPr lang="pl-PL" sz="1400"/>
+              <a:t>• po literówkach i parafrazach decyzja zmienia się w najwyżej 15% pytań,
+</a:t>
+            </a:r>
+          </a:p>
+          <a:p>
+            <a:r>
+              <a:rPr lang="pl-PL" sz="1400"/>
+              <a:t>• mediana czasu decyzji poniżej 50 ms,
+</a:t>
+            </a:r>
+          </a:p>
+          <a:p>
+            <a:r>
+              <a:rPr lang="pl-PL" sz="1400"/>
+              <a:t>• pytania spoza dziedziny (MMLU, MT-Bench) tylko raportuję, bez progu.
+</a:t>
+            </a:r>
+          </a:p>
+          <a:p>
+            <a:endParaRPr lang="pl-PL" sz="1400"/>
+          </a:p>
+          <a:p>
+            <a:r>
+              <a:rPr lang="pl-PL" sz="1400"/>
+              <a:t>Podsumowanie. Etykiety mierzę z prawdziwych odpowiedzi modeli. Router oparty na podobieństwie pytań daje realny, ale umiarkowany zysk, jest szybki i stabilny. Nie przewidzi tylko tego, czy mały model zna konkretny fakt.</a:t>
+            </a:r>
+          </a:p>
+        </p:txBody>
+      </p:sp>
+      <p:sp>
+        <p:nvSpPr>
+          <p:cNvPr id="4" name="Slide Number Placeholder 3"/>
+          <p:cNvSpPr>
+            <a:spLocks noGrp="1"/>
+          </p:cNvSpPr>
+          <p:nvPr>
+            <p:ph type="sldNum" sz="quarter" idx="10"/>
+          </p:nvPr>
+        </p:nvSpPr>
+        <p:spPr/>
+        <p:txBody>
+          <a:bodyPr/>
+          <a:lstStyle/>
+          <a:p>
+            <a:fld id="{F7021451-1387-4CA6-816F-3879F97B5CBC}" type="slidenum">
+              <a:rPr lang="en-US"/>
+              <a:t>16</a:t>
             </a:fld>
             <a:endParaRPr lang="en-US"/>
           </a:p>
@@ -6825,6 +7043,1364 @@
                   <a:srgbClr val="1B1F2A"/>
                 </a:solidFill>
               </a:rPr>
+              <a:t>Dodatkowe dane: plan</a:t>
+            </a:r>
+            <a:endParaRPr lang="en-US" sz="3200" dirty="0"/>
+          </a:p>
+        </p:txBody>
+      </p:sp>
+      <p:graphicFrame>
+        <p:nvGraphicFramePr>
+          <p:cNvPr id="16" name="Tabela zbiorów"/>
+          <p:cNvGraphicFramePr>
+            <a:graphicFrameLocks noGrp="1"/>
+          </p:cNvGraphicFramePr>
+          <p:nvPr>
+            <p:extLst>
+              <p:ext uri="{D42A27DB-BD31-4B8C-83A1-F6EECF244321}">
+                <p14:modId xmlns:p14="http://schemas.microsoft.com/office/powerpoint/2010/main" val="1579011935"/>
+              </p:ext>
+            </p:extLst>
+          </p:nvPr>
+        </p:nvGraphicFramePr>
+        <p:xfrm>
+          <a:off x="457200" y="1188720"/>
+          <a:ext cx="8229600" cy="914400"/>
+        </p:xfrm>
+        <a:graphic>
+          <a:graphicData uri="http://schemas.openxmlformats.org/drawingml/2006/table">
+            <a:tbl>
+              <a:tblPr/>
+              <a:tblGrid>
+                <a:gridCol w="1371600"/>
+                <a:gridCol w="3200400"/>
+                <a:gridCol w="2103120"/>
+                <a:gridCol w="1554480"/>
+              </a:tblGrid>
+              <a:tr h="566928">
+                <a:tc>
+                  <a:txBody>
+                    <a:bodyPr/>
+                    <a:lstStyle/>
+                    <a:p>
+                      <a:pPr indent="0" marL="0">
+                        <a:buNone/>
+                      </a:pPr>
+                      <a:r>
+                        <a:rPr lang="en-US" sz="1300" b="1" dirty="0">
+                          <a:solidFill>
+                            <a:srgbClr val="1B1F2A"/>
+                          </a:solidFill>
+                        </a:rPr>
+                        <a:t>Zbiór</a:t>
+                      </a:r>
+                      <a:endParaRPr lang="en-US" sz="1300" dirty="0"/>
+                    </a:p>
+                  </a:txBody>
+                  <a:tcPr marL="91440" marR="91440" marT="45720" marB="45720" anchor="ctr">
+                    <a:lnL w="6350" cap="flat" cmpd="sng" algn="ctr">
+                      <a:solidFill>
+                        <a:srgbClr val="C7CEDB"/>
+                      </a:solidFill>
+                      <a:prstDash val="solid"/>
+                      <a:round/>
+                      <a:headEnd type="none" w="med" len="med"/>
+                      <a:tailEnd type="none" w="med" len="med"/>
+                    </a:lnL>
+                    <a:lnR w="6350" cap="flat" cmpd="sng" algn="ctr">
+                      <a:solidFill>
+                        <a:srgbClr val="C7CEDB"/>
+                      </a:solidFill>
+                      <a:prstDash val="solid"/>
+                      <a:round/>
+                      <a:headEnd type="none" w="med" len="med"/>
+                      <a:tailEnd type="none" w="med" len="med"/>
+                    </a:lnR>
+                    <a:lnT w="6350" cap="flat" cmpd="sng" algn="ctr">
+                      <a:solidFill>
+                        <a:srgbClr val="C7CEDB"/>
+                      </a:solidFill>
+                      <a:prstDash val="solid"/>
+                      <a:round/>
+                      <a:headEnd type="none" w="med" len="med"/>
+                      <a:tailEnd type="none" w="med" len="med"/>
+                    </a:lnT>
+                    <a:lnB w="6350" cap="flat" cmpd="sng" algn="ctr">
+                      <a:solidFill>
+                        <a:srgbClr val="C7CEDB"/>
+                      </a:solidFill>
+                      <a:prstDash val="solid"/>
+                      <a:round/>
+                      <a:headEnd type="none" w="med" len="med"/>
+                      <a:tailEnd type="none" w="med" len="med"/>
+                    </a:lnB>
+                    <a:solidFill>
+                      <a:srgbClr val="F1F3F6"/>
+                    </a:solidFill>
+                  </a:tcPr>
+                </a:tc>
+                <a:tc>
+                  <a:txBody>
+                    <a:bodyPr/>
+                    <a:lstStyle/>
+                    <a:p>
+                      <a:pPr indent="0" marL="0">
+                        <a:buNone/>
+                      </a:pPr>
+                      <a:r>
+                        <a:rPr lang="en-US" sz="1300" b="1" dirty="0">
+                          <a:solidFill>
+                            <a:srgbClr val="1B1F2A"/>
+                          </a:solidFill>
+                        </a:rPr>
+                        <a:t>Rodzaj pytań</a:t>
+                      </a:r>
+                      <a:endParaRPr lang="en-US" sz="1300" dirty="0"/>
+                    </a:p>
+                  </a:txBody>
+                  <a:tcPr marL="91440" marR="91440" marT="45720" marB="45720" anchor="ctr">
+                    <a:lnL w="6350" cap="flat" cmpd="sng" algn="ctr">
+                      <a:solidFill>
+                        <a:srgbClr val="C7CEDB"/>
+                      </a:solidFill>
+                      <a:prstDash val="solid"/>
+                      <a:round/>
+                      <a:headEnd type="none" w="med" len="med"/>
+                      <a:tailEnd type="none" w="med" len="med"/>
+                    </a:lnL>
+                    <a:lnR w="6350" cap="flat" cmpd="sng" algn="ctr">
+                      <a:solidFill>
+                        <a:srgbClr val="C7CEDB"/>
+                      </a:solidFill>
+                      <a:prstDash val="solid"/>
+                      <a:round/>
+                      <a:headEnd type="none" w="med" len="med"/>
+                      <a:tailEnd type="none" w="med" len="med"/>
+                    </a:lnR>
+                    <a:lnT w="6350" cap="flat" cmpd="sng" algn="ctr">
+                      <a:solidFill>
+                        <a:srgbClr val="C7CEDB"/>
+                      </a:solidFill>
+                      <a:prstDash val="solid"/>
+                      <a:round/>
+                      <a:headEnd type="none" w="med" len="med"/>
+                      <a:tailEnd type="none" w="med" len="med"/>
+                    </a:lnT>
+                    <a:lnB w="6350" cap="flat" cmpd="sng" algn="ctr">
+                      <a:solidFill>
+                        <a:srgbClr val="C7CEDB"/>
+                      </a:solidFill>
+                      <a:prstDash val="solid"/>
+                      <a:round/>
+                      <a:headEnd type="none" w="med" len="med"/>
+                      <a:tailEnd type="none" w="med" len="med"/>
+                    </a:lnB>
+                    <a:solidFill>
+                      <a:srgbClr val="F1F3F6"/>
+                    </a:solidFill>
+                  </a:tcPr>
+                </a:tc>
+                <a:tc>
+                  <a:txBody>
+                    <a:bodyPr/>
+                    <a:lstStyle/>
+                    <a:p>
+                      <a:pPr indent="0" marL="0">
+                        <a:buNone/>
+                      </a:pPr>
+                      <a:r>
+                        <a:rPr lang="en-US" sz="1300" b="1" dirty="0">
+                          <a:solidFill>
+                            <a:srgbClr val="1B1F2A"/>
+                          </a:solidFill>
+                        </a:rPr>
+                        <a:t>Po co</a:t>
+                      </a:r>
+                      <a:endParaRPr lang="en-US" sz="1300" dirty="0"/>
+                    </a:p>
+                  </a:txBody>
+                  <a:tcPr marL="91440" marR="91440" marT="45720" marB="45720" anchor="ctr">
+                    <a:lnL w="6350" cap="flat" cmpd="sng" algn="ctr">
+                      <a:solidFill>
+                        <a:srgbClr val="C7CEDB"/>
+                      </a:solidFill>
+                      <a:prstDash val="solid"/>
+                      <a:round/>
+                      <a:headEnd type="none" w="med" len="med"/>
+                      <a:tailEnd type="none" w="med" len="med"/>
+                    </a:lnL>
+                    <a:lnR w="6350" cap="flat" cmpd="sng" algn="ctr">
+                      <a:solidFill>
+                        <a:srgbClr val="C7CEDB"/>
+                      </a:solidFill>
+                      <a:prstDash val="solid"/>
+                      <a:round/>
+                      <a:headEnd type="none" w="med" len="med"/>
+                      <a:tailEnd type="none" w="med" len="med"/>
+                    </a:lnR>
+                    <a:lnT w="6350" cap="flat" cmpd="sng" algn="ctr">
+                      <a:solidFill>
+                        <a:srgbClr val="C7CEDB"/>
+                      </a:solidFill>
+                      <a:prstDash val="solid"/>
+                      <a:round/>
+                      <a:headEnd type="none" w="med" len="med"/>
+                      <a:tailEnd type="none" w="med" len="med"/>
+                    </a:lnT>
+                    <a:lnB w="6350" cap="flat" cmpd="sng" algn="ctr">
+                      <a:solidFill>
+                        <a:srgbClr val="C7CEDB"/>
+                      </a:solidFill>
+                      <a:prstDash val="solid"/>
+                      <a:round/>
+                      <a:headEnd type="none" w="med" len="med"/>
+                      <a:tailEnd type="none" w="med" len="med"/>
+                    </a:lnB>
+                    <a:solidFill>
+                      <a:srgbClr val="F1F3F6"/>
+                    </a:solidFill>
+                  </a:tcPr>
+                </a:tc>
+                <a:tc>
+                  <a:txBody>
+                    <a:bodyPr/>
+                    <a:lstStyle/>
+                    <a:p>
+                      <a:pPr indent="0" marL="0">
+                        <a:buNone/>
+                      </a:pPr>
+                      <a:r>
+                        <a:rPr lang="en-US" sz="1300" b="1" dirty="0">
+                          <a:solidFill>
+                            <a:srgbClr val="1B1F2A"/>
+                          </a:solidFill>
+                        </a:rPr>
+                        <a:t>Licencja</a:t>
+                      </a:r>
+                      <a:endParaRPr lang="en-US" sz="1300" dirty="0"/>
+                    </a:p>
+                  </a:txBody>
+                  <a:tcPr marL="91440" marR="91440" marT="45720" marB="45720" anchor="ctr">
+                    <a:lnL w="6350" cap="flat" cmpd="sng" algn="ctr">
+                      <a:solidFill>
+                        <a:srgbClr val="C7CEDB"/>
+                      </a:solidFill>
+                      <a:prstDash val="solid"/>
+                      <a:round/>
+                      <a:headEnd type="none" w="med" len="med"/>
+                      <a:tailEnd type="none" w="med" len="med"/>
+                    </a:lnL>
+                    <a:lnR w="6350" cap="flat" cmpd="sng" algn="ctr">
+                      <a:solidFill>
+                        <a:srgbClr val="C7CEDB"/>
+                      </a:solidFill>
+                      <a:prstDash val="solid"/>
+                      <a:round/>
+                      <a:headEnd type="none" w="med" len="med"/>
+                      <a:tailEnd type="none" w="med" len="med"/>
+                    </a:lnR>
+                    <a:lnT w="6350" cap="flat" cmpd="sng" algn="ctr">
+                      <a:solidFill>
+                        <a:srgbClr val="C7CEDB"/>
+                      </a:solidFill>
+                      <a:prstDash val="solid"/>
+                      <a:round/>
+                      <a:headEnd type="none" w="med" len="med"/>
+                      <a:tailEnd type="none" w="med" len="med"/>
+                    </a:lnT>
+                    <a:lnB w="6350" cap="flat" cmpd="sng" algn="ctr">
+                      <a:solidFill>
+                        <a:srgbClr val="C7CEDB"/>
+                      </a:solidFill>
+                      <a:prstDash val="solid"/>
+                      <a:round/>
+                      <a:headEnd type="none" w="med" len="med"/>
+                      <a:tailEnd type="none" w="med" len="med"/>
+                    </a:lnB>
+                    <a:solidFill>
+                      <a:srgbClr val="F1F3F6"/>
+                    </a:solidFill>
+                  </a:tcPr>
+                </a:tc>
+              </a:tr>
+              <a:tr h="566928">
+                <a:tc>
+                  <a:txBody>
+                    <a:bodyPr/>
+                    <a:lstStyle/>
+                    <a:p>
+                      <a:pPr indent="0" marL="0">
+                        <a:buNone/>
+                      </a:pPr>
+                      <a:r>
+                        <a:rPr lang="en-US" sz="1300" dirty="0">
+                          <a:solidFill>
+                            <a:srgbClr val="1B1F2A"/>
+                          </a:solidFill>
+                        </a:rPr>
+                        <a:t>Dolly 15k</a:t>
+                      </a:r>
+                      <a:endParaRPr lang="en-US" sz="1300" dirty="0"/>
+                    </a:p>
+                  </a:txBody>
+                  <a:tcPr marL="91440" marR="91440" marT="45720" marB="45720" anchor="ctr">
+                    <a:lnL w="6350" cap="flat" cmpd="sng" algn="ctr">
+                      <a:solidFill>
+                        <a:srgbClr val="C7CEDB"/>
+                      </a:solidFill>
+                      <a:prstDash val="solid"/>
+                      <a:round/>
+                      <a:headEnd type="none" w="med" len="med"/>
+                      <a:tailEnd type="none" w="med" len="med"/>
+                    </a:lnL>
+                    <a:lnR w="6350" cap="flat" cmpd="sng" algn="ctr">
+                      <a:solidFill>
+                        <a:srgbClr val="C7CEDB"/>
+                      </a:solidFill>
+                      <a:prstDash val="solid"/>
+                      <a:round/>
+                      <a:headEnd type="none" w="med" len="med"/>
+                      <a:tailEnd type="none" w="med" len="med"/>
+                    </a:lnR>
+                    <a:lnT w="6350" cap="flat" cmpd="sng" algn="ctr">
+                      <a:solidFill>
+                        <a:srgbClr val="C7CEDB"/>
+                      </a:solidFill>
+                      <a:prstDash val="solid"/>
+                      <a:round/>
+                      <a:headEnd type="none" w="med" len="med"/>
+                      <a:tailEnd type="none" w="med" len="med"/>
+                    </a:lnT>
+                    <a:lnB w="6350" cap="flat" cmpd="sng" algn="ctr">
+                      <a:solidFill>
+                        <a:srgbClr val="C7CEDB"/>
+                      </a:solidFill>
+                      <a:prstDash val="solid"/>
+                      <a:round/>
+                      <a:headEnd type="none" w="med" len="med"/>
+                      <a:tailEnd type="none" w="med" len="med"/>
+                    </a:lnB>
+                  </a:tcPr>
+                </a:tc>
+                <a:tc>
+                  <a:txBody>
+                    <a:bodyPr/>
+                    <a:lstStyle/>
+                    <a:p>
+                      <a:pPr indent="0" marL="0">
+                        <a:buNone/>
+                      </a:pPr>
+                      <a:r>
+                        <a:rPr lang="en-US" sz="1300" dirty="0">
+                          <a:solidFill>
+                            <a:srgbClr val="1B1F2A"/>
+                          </a:solidFill>
+                        </a:rPr>
+                        <a:t>Polecenia biurowe: streszczanie, wyciąganie informacji</a:t>
+                      </a:r>
+                      <a:endParaRPr lang="en-US" sz="1300" dirty="0"/>
+                    </a:p>
+                  </a:txBody>
+                  <a:tcPr marL="91440" marR="91440" marT="45720" marB="45720" anchor="ctr">
+                    <a:lnL w="6350" cap="flat" cmpd="sng" algn="ctr">
+                      <a:solidFill>
+                        <a:srgbClr val="C7CEDB"/>
+                      </a:solidFill>
+                      <a:prstDash val="solid"/>
+                      <a:round/>
+                      <a:headEnd type="none" w="med" len="med"/>
+                      <a:tailEnd type="none" w="med" len="med"/>
+                    </a:lnL>
+                    <a:lnR w="6350" cap="flat" cmpd="sng" algn="ctr">
+                      <a:solidFill>
+                        <a:srgbClr val="C7CEDB"/>
+                      </a:solidFill>
+                      <a:prstDash val="solid"/>
+                      <a:round/>
+                      <a:headEnd type="none" w="med" len="med"/>
+                      <a:tailEnd type="none" w="med" len="med"/>
+                    </a:lnR>
+                    <a:lnT w="6350" cap="flat" cmpd="sng" algn="ctr">
+                      <a:solidFill>
+                        <a:srgbClr val="C7CEDB"/>
+                      </a:solidFill>
+                      <a:prstDash val="solid"/>
+                      <a:round/>
+                      <a:headEnd type="none" w="med" len="med"/>
+                      <a:tailEnd type="none" w="med" len="med"/>
+                    </a:lnT>
+                    <a:lnB w="6350" cap="flat" cmpd="sng" algn="ctr">
+                      <a:solidFill>
+                        <a:srgbClr val="C7CEDB"/>
+                      </a:solidFill>
+                      <a:prstDash val="solid"/>
+                      <a:round/>
+                      <a:headEnd type="none" w="med" len="med"/>
+                      <a:tailEnd type="none" w="med" len="med"/>
+                    </a:lnB>
+                  </a:tcPr>
+                </a:tc>
+                <a:tc>
+                  <a:txBody>
+                    <a:bodyPr/>
+                    <a:lstStyle/>
+                    <a:p>
+                      <a:pPr indent="0" marL="0">
+                        <a:buNone/>
+                      </a:pPr>
+                      <a:r>
+                        <a:rPr lang="en-US" sz="1300" dirty="0">
+                          <a:solidFill>
+                            <a:srgbClr val="1B1F2A"/>
+                          </a:solidFill>
+                        </a:rPr>
+                        <a:t>Użycie bliższe firmie</a:t>
+                      </a:r>
+                      <a:endParaRPr lang="en-US" sz="1300" dirty="0"/>
+                    </a:p>
+                  </a:txBody>
+                  <a:tcPr marL="91440" marR="91440" marT="45720" marB="45720" anchor="ctr">
+                    <a:lnL w="6350" cap="flat" cmpd="sng" algn="ctr">
+                      <a:solidFill>
+                        <a:srgbClr val="C7CEDB"/>
+                      </a:solidFill>
+                      <a:prstDash val="solid"/>
+                      <a:round/>
+                      <a:headEnd type="none" w="med" len="med"/>
+                      <a:tailEnd type="none" w="med" len="med"/>
+                    </a:lnL>
+                    <a:lnR w="6350" cap="flat" cmpd="sng" algn="ctr">
+                      <a:solidFill>
+                        <a:srgbClr val="C7CEDB"/>
+                      </a:solidFill>
+                      <a:prstDash val="solid"/>
+                      <a:round/>
+                      <a:headEnd type="none" w="med" len="med"/>
+                      <a:tailEnd type="none" w="med" len="med"/>
+                    </a:lnR>
+                    <a:lnT w="6350" cap="flat" cmpd="sng" algn="ctr">
+                      <a:solidFill>
+                        <a:srgbClr val="C7CEDB"/>
+                      </a:solidFill>
+                      <a:prstDash val="solid"/>
+                      <a:round/>
+                      <a:headEnd type="none" w="med" len="med"/>
+                      <a:tailEnd type="none" w="med" len="med"/>
+                    </a:lnT>
+                    <a:lnB w="6350" cap="flat" cmpd="sng" algn="ctr">
+                      <a:solidFill>
+                        <a:srgbClr val="C7CEDB"/>
+                      </a:solidFill>
+                      <a:prstDash val="solid"/>
+                      <a:round/>
+                      <a:headEnd type="none" w="med" len="med"/>
+                      <a:tailEnd type="none" w="med" len="med"/>
+                    </a:lnB>
+                  </a:tcPr>
+                </a:tc>
+                <a:tc>
+                  <a:txBody>
+                    <a:bodyPr/>
+                    <a:lstStyle/>
+                    <a:p>
+                      <a:pPr indent="0" marL="0">
+                        <a:buNone/>
+                      </a:pPr>
+                      <a:r>
+                        <a:rPr lang="en-US" sz="1300" dirty="0">
+                          <a:solidFill>
+                            <a:srgbClr val="1B1F2A"/>
+                          </a:solidFill>
+                        </a:rPr>
+                        <a:t>CC BY-SA 3.0</a:t>
+                      </a:r>
+                      <a:endParaRPr lang="en-US" sz="1300" dirty="0"/>
+                    </a:p>
+                  </a:txBody>
+                  <a:tcPr marL="91440" marR="91440" marT="45720" marB="45720" anchor="ctr">
+                    <a:lnL w="6350" cap="flat" cmpd="sng" algn="ctr">
+                      <a:solidFill>
+                        <a:srgbClr val="C7CEDB"/>
+                      </a:solidFill>
+                      <a:prstDash val="solid"/>
+                      <a:round/>
+                      <a:headEnd type="none" w="med" len="med"/>
+                      <a:tailEnd type="none" w="med" len="med"/>
+                    </a:lnL>
+                    <a:lnR w="6350" cap="flat" cmpd="sng" algn="ctr">
+                      <a:solidFill>
+                        <a:srgbClr val="C7CEDB"/>
+                      </a:solidFill>
+                      <a:prstDash val="solid"/>
+                      <a:round/>
+                      <a:headEnd type="none" w="med" len="med"/>
+                      <a:tailEnd type="none" w="med" len="med"/>
+                    </a:lnR>
+                    <a:lnT w="6350" cap="flat" cmpd="sng" algn="ctr">
+                      <a:solidFill>
+                        <a:srgbClr val="C7CEDB"/>
+                      </a:solidFill>
+                      <a:prstDash val="solid"/>
+                      <a:round/>
+                      <a:headEnd type="none" w="med" len="med"/>
+                      <a:tailEnd type="none" w="med" len="med"/>
+                    </a:lnT>
+                    <a:lnB w="6350" cap="flat" cmpd="sng" algn="ctr">
+                      <a:solidFill>
+                        <a:srgbClr val="C7CEDB"/>
+                      </a:solidFill>
+                      <a:prstDash val="solid"/>
+                      <a:round/>
+                      <a:headEnd type="none" w="med" len="med"/>
+                      <a:tailEnd type="none" w="med" len="med"/>
+                    </a:lnB>
+                  </a:tcPr>
+                </a:tc>
+              </a:tr>
+              <a:tr h="566928">
+                <a:tc>
+                  <a:txBody>
+                    <a:bodyPr/>
+                    <a:lstStyle/>
+                    <a:p>
+                      <a:pPr indent="0" marL="0">
+                        <a:buNone/>
+                      </a:pPr>
+                      <a:r>
+                        <a:rPr lang="en-US" sz="1300" dirty="0">
+                          <a:solidFill>
+                            <a:srgbClr val="1B1F2A"/>
+                          </a:solidFill>
+                        </a:rPr>
+                        <a:t>CodeChat</a:t>
+                      </a:r>
+                      <a:endParaRPr lang="en-US" sz="1300" dirty="0"/>
+                    </a:p>
+                  </a:txBody>
+                  <a:tcPr marL="91440" marR="91440" marT="45720" marB="45720" anchor="ctr">
+                    <a:lnL w="6350" cap="flat" cmpd="sng" algn="ctr">
+                      <a:solidFill>
+                        <a:srgbClr val="C7CEDB"/>
+                      </a:solidFill>
+                      <a:prstDash val="solid"/>
+                      <a:round/>
+                      <a:headEnd type="none" w="med" len="med"/>
+                      <a:tailEnd type="none" w="med" len="med"/>
+                    </a:lnL>
+                    <a:lnR w="6350" cap="flat" cmpd="sng" algn="ctr">
+                      <a:solidFill>
+                        <a:srgbClr val="C7CEDB"/>
+                      </a:solidFill>
+                      <a:prstDash val="solid"/>
+                      <a:round/>
+                      <a:headEnd type="none" w="med" len="med"/>
+                      <a:tailEnd type="none" w="med" len="med"/>
+                    </a:lnR>
+                    <a:lnT w="6350" cap="flat" cmpd="sng" algn="ctr">
+                      <a:solidFill>
+                        <a:srgbClr val="C7CEDB"/>
+                      </a:solidFill>
+                      <a:prstDash val="solid"/>
+                      <a:round/>
+                      <a:headEnd type="none" w="med" len="med"/>
+                      <a:tailEnd type="none" w="med" len="med"/>
+                    </a:lnT>
+                    <a:lnB w="6350" cap="flat" cmpd="sng" algn="ctr">
+                      <a:solidFill>
+                        <a:srgbClr val="C7CEDB"/>
+                      </a:solidFill>
+                      <a:prstDash val="solid"/>
+                      <a:round/>
+                      <a:headEnd type="none" w="med" len="med"/>
+                      <a:tailEnd type="none" w="med" len="med"/>
+                    </a:lnB>
+                  </a:tcPr>
+                </a:tc>
+                <a:tc>
+                  <a:txBody>
+                    <a:bodyPr/>
+                    <a:lstStyle/>
+                    <a:p>
+                      <a:pPr indent="0" marL="0">
+                        <a:buNone/>
+                      </a:pPr>
+                      <a:r>
+                        <a:rPr lang="en-US" sz="1300" dirty="0">
+                          <a:solidFill>
+                            <a:srgbClr val="1B1F2A"/>
+                          </a:solidFill>
+                        </a:rPr>
+                        <a:t>Prawdziwe rozmowy programistów z modelami</a:t>
+                      </a:r>
+                      <a:endParaRPr lang="en-US" sz="1300" dirty="0"/>
+                    </a:p>
+                  </a:txBody>
+                  <a:tcPr marL="91440" marR="91440" marT="45720" marB="45720" anchor="ctr">
+                    <a:lnL w="6350" cap="flat" cmpd="sng" algn="ctr">
+                      <a:solidFill>
+                        <a:srgbClr val="C7CEDB"/>
+                      </a:solidFill>
+                      <a:prstDash val="solid"/>
+                      <a:round/>
+                      <a:headEnd type="none" w="med" len="med"/>
+                      <a:tailEnd type="none" w="med" len="med"/>
+                    </a:lnL>
+                    <a:lnR w="6350" cap="flat" cmpd="sng" algn="ctr">
+                      <a:solidFill>
+                        <a:srgbClr val="C7CEDB"/>
+                      </a:solidFill>
+                      <a:prstDash val="solid"/>
+                      <a:round/>
+                      <a:headEnd type="none" w="med" len="med"/>
+                      <a:tailEnd type="none" w="med" len="med"/>
+                    </a:lnR>
+                    <a:lnT w="6350" cap="flat" cmpd="sng" algn="ctr">
+                      <a:solidFill>
+                        <a:srgbClr val="C7CEDB"/>
+                      </a:solidFill>
+                      <a:prstDash val="solid"/>
+                      <a:round/>
+                      <a:headEnd type="none" w="med" len="med"/>
+                      <a:tailEnd type="none" w="med" len="med"/>
+                    </a:lnT>
+                    <a:lnB w="6350" cap="flat" cmpd="sng" algn="ctr">
+                      <a:solidFill>
+                        <a:srgbClr val="C7CEDB"/>
+                      </a:solidFill>
+                      <a:prstDash val="solid"/>
+                      <a:round/>
+                      <a:headEnd type="none" w="med" len="med"/>
+                      <a:tailEnd type="none" w="med" len="med"/>
+                    </a:lnB>
+                  </a:tcPr>
+                </a:tc>
+                <a:tc>
+                  <a:txBody>
+                    <a:bodyPr/>
+                    <a:lstStyle/>
+                    <a:p>
+                      <a:pPr indent="0" marL="0">
+                        <a:buNone/>
+                      </a:pPr>
+                      <a:r>
+                        <a:rPr lang="en-US" sz="1300" dirty="0">
+                          <a:solidFill>
+                            <a:srgbClr val="1B1F2A"/>
+                          </a:solidFill>
+                        </a:rPr>
+                        <a:t>Więcej prawdziwego kodu</a:t>
+                      </a:r>
+                      <a:endParaRPr lang="en-US" sz="1300" dirty="0"/>
+                    </a:p>
+                  </a:txBody>
+                  <a:tcPr marL="91440" marR="91440" marT="45720" marB="45720" anchor="ctr">
+                    <a:lnL w="6350" cap="flat" cmpd="sng" algn="ctr">
+                      <a:solidFill>
+                        <a:srgbClr val="C7CEDB"/>
+                      </a:solidFill>
+                      <a:prstDash val="solid"/>
+                      <a:round/>
+                      <a:headEnd type="none" w="med" len="med"/>
+                      <a:tailEnd type="none" w="med" len="med"/>
+                    </a:lnL>
+                    <a:lnR w="6350" cap="flat" cmpd="sng" algn="ctr">
+                      <a:solidFill>
+                        <a:srgbClr val="C7CEDB"/>
+                      </a:solidFill>
+                      <a:prstDash val="solid"/>
+                      <a:round/>
+                      <a:headEnd type="none" w="med" len="med"/>
+                      <a:tailEnd type="none" w="med" len="med"/>
+                    </a:lnR>
+                    <a:lnT w="6350" cap="flat" cmpd="sng" algn="ctr">
+                      <a:solidFill>
+                        <a:srgbClr val="C7CEDB"/>
+                      </a:solidFill>
+                      <a:prstDash val="solid"/>
+                      <a:round/>
+                      <a:headEnd type="none" w="med" len="med"/>
+                      <a:tailEnd type="none" w="med" len="med"/>
+                    </a:lnT>
+                    <a:lnB w="6350" cap="flat" cmpd="sng" algn="ctr">
+                      <a:solidFill>
+                        <a:srgbClr val="C7CEDB"/>
+                      </a:solidFill>
+                      <a:prstDash val="solid"/>
+                      <a:round/>
+                      <a:headEnd type="none" w="med" len="med"/>
+                      <a:tailEnd type="none" w="med" len="med"/>
+                    </a:lnB>
+                  </a:tcPr>
+                </a:tc>
+                <a:tc>
+                  <a:txBody>
+                    <a:bodyPr/>
+                    <a:lstStyle/>
+                    <a:p>
+                      <a:pPr indent="0" marL="0">
+                        <a:buNone/>
+                      </a:pPr>
+                      <a:r>
+                        <a:rPr lang="en-US" sz="1300" dirty="0">
+                          <a:solidFill>
+                            <a:srgbClr val="1B1F2A"/>
+                          </a:solidFill>
+                        </a:rPr>
+                        <a:t>ODC-By</a:t>
+                      </a:r>
+                      <a:endParaRPr lang="en-US" sz="1300" dirty="0"/>
+                    </a:p>
+                  </a:txBody>
+                  <a:tcPr marL="91440" marR="91440" marT="45720" marB="45720" anchor="ctr">
+                    <a:lnL w="6350" cap="flat" cmpd="sng" algn="ctr">
+                      <a:solidFill>
+                        <a:srgbClr val="C7CEDB"/>
+                      </a:solidFill>
+                      <a:prstDash val="solid"/>
+                      <a:round/>
+                      <a:headEnd type="none" w="med" len="med"/>
+                      <a:tailEnd type="none" w="med" len="med"/>
+                    </a:lnL>
+                    <a:lnR w="6350" cap="flat" cmpd="sng" algn="ctr">
+                      <a:solidFill>
+                        <a:srgbClr val="C7CEDB"/>
+                      </a:solidFill>
+                      <a:prstDash val="solid"/>
+                      <a:round/>
+                      <a:headEnd type="none" w="med" len="med"/>
+                      <a:tailEnd type="none" w="med" len="med"/>
+                    </a:lnR>
+                    <a:lnT w="6350" cap="flat" cmpd="sng" algn="ctr">
+                      <a:solidFill>
+                        <a:srgbClr val="C7CEDB"/>
+                      </a:solidFill>
+                      <a:prstDash val="solid"/>
+                      <a:round/>
+                      <a:headEnd type="none" w="med" len="med"/>
+                      <a:tailEnd type="none" w="med" len="med"/>
+                    </a:lnT>
+                    <a:lnB w="6350" cap="flat" cmpd="sng" algn="ctr">
+                      <a:solidFill>
+                        <a:srgbClr val="C7CEDB"/>
+                      </a:solidFill>
+                      <a:prstDash val="solid"/>
+                      <a:round/>
+                      <a:headEnd type="none" w="med" len="med"/>
+                      <a:tailEnd type="none" w="med" len="med"/>
+                    </a:lnB>
+                  </a:tcPr>
+                </a:tc>
+              </a:tr>
+              <a:tr h="566928">
+                <a:tc>
+                  <a:txBody>
+                    <a:bodyPr/>
+                    <a:lstStyle/>
+                    <a:p>
+                      <a:pPr indent="0" marL="0">
+                        <a:buNone/>
+                      </a:pPr>
+                      <a:r>
+                        <a:rPr lang="en-US" sz="1300" dirty="0">
+                          <a:solidFill>
+                            <a:srgbClr val="1B1F2A"/>
+                          </a:solidFill>
+                        </a:rPr>
+                        <a:t>Spider</a:t>
+                      </a:r>
+                      <a:endParaRPr lang="en-US" sz="1300" dirty="0"/>
+                    </a:p>
+                  </a:txBody>
+                  <a:tcPr marL="91440" marR="91440" marT="45720" marB="45720" anchor="ctr">
+                    <a:lnL w="6350" cap="flat" cmpd="sng" algn="ctr">
+                      <a:solidFill>
+                        <a:srgbClr val="C7CEDB"/>
+                      </a:solidFill>
+                      <a:prstDash val="solid"/>
+                      <a:round/>
+                      <a:headEnd type="none" w="med" len="med"/>
+                      <a:tailEnd type="none" w="med" len="med"/>
+                    </a:lnL>
+                    <a:lnR w="6350" cap="flat" cmpd="sng" algn="ctr">
+                      <a:solidFill>
+                        <a:srgbClr val="C7CEDB"/>
+                      </a:solidFill>
+                      <a:prstDash val="solid"/>
+                      <a:round/>
+                      <a:headEnd type="none" w="med" len="med"/>
+                      <a:tailEnd type="none" w="med" len="med"/>
+                    </a:lnR>
+                    <a:lnT w="6350" cap="flat" cmpd="sng" algn="ctr">
+                      <a:solidFill>
+                        <a:srgbClr val="C7CEDB"/>
+                      </a:solidFill>
+                      <a:prstDash val="solid"/>
+                      <a:round/>
+                      <a:headEnd type="none" w="med" len="med"/>
+                      <a:tailEnd type="none" w="med" len="med"/>
+                    </a:lnT>
+                    <a:lnB w="6350" cap="flat" cmpd="sng" algn="ctr">
+                      <a:solidFill>
+                        <a:srgbClr val="C7CEDB"/>
+                      </a:solidFill>
+                      <a:prstDash val="solid"/>
+                      <a:round/>
+                      <a:headEnd type="none" w="med" len="med"/>
+                      <a:tailEnd type="none" w="med" len="med"/>
+                    </a:lnB>
+                  </a:tcPr>
+                </a:tc>
+                <a:tc>
+                  <a:txBody>
+                    <a:bodyPr/>
+                    <a:lstStyle/>
+                    <a:p>
+                      <a:pPr indent="0" marL="0">
+                        <a:buNone/>
+                      </a:pPr>
+                      <a:r>
+                        <a:rPr lang="en-US" sz="1300" dirty="0">
+                          <a:solidFill>
+                            <a:srgbClr val="1B1F2A"/>
+                          </a:solidFill>
+                        </a:rPr>
+                        <a:t>Pytania do baz danych, odpowiedź w języku SQL</a:t>
+                      </a:r>
+                      <a:endParaRPr lang="en-US" sz="1300" dirty="0"/>
+                    </a:p>
+                  </a:txBody>
+                  <a:tcPr marL="91440" marR="91440" marT="45720" marB="45720" anchor="ctr">
+                    <a:lnL w="6350" cap="flat" cmpd="sng" algn="ctr">
+                      <a:solidFill>
+                        <a:srgbClr val="C7CEDB"/>
+                      </a:solidFill>
+                      <a:prstDash val="solid"/>
+                      <a:round/>
+                      <a:headEnd type="none" w="med" len="med"/>
+                      <a:tailEnd type="none" w="med" len="med"/>
+                    </a:lnL>
+                    <a:lnR w="6350" cap="flat" cmpd="sng" algn="ctr">
+                      <a:solidFill>
+                        <a:srgbClr val="C7CEDB"/>
+                      </a:solidFill>
+                      <a:prstDash val="solid"/>
+                      <a:round/>
+                      <a:headEnd type="none" w="med" len="med"/>
+                      <a:tailEnd type="none" w="med" len="med"/>
+                    </a:lnR>
+                    <a:lnT w="6350" cap="flat" cmpd="sng" algn="ctr">
+                      <a:solidFill>
+                        <a:srgbClr val="C7CEDB"/>
+                      </a:solidFill>
+                      <a:prstDash val="solid"/>
+                      <a:round/>
+                      <a:headEnd type="none" w="med" len="med"/>
+                      <a:tailEnd type="none" w="med" len="med"/>
+                    </a:lnT>
+                    <a:lnB w="6350" cap="flat" cmpd="sng" algn="ctr">
+                      <a:solidFill>
+                        <a:srgbClr val="C7CEDB"/>
+                      </a:solidFill>
+                      <a:prstDash val="solid"/>
+                      <a:round/>
+                      <a:headEnd type="none" w="med" len="med"/>
+                      <a:tailEnd type="none" w="med" len="med"/>
+                    </a:lnB>
+                  </a:tcPr>
+                </a:tc>
+                <a:tc>
+                  <a:txBody>
+                    <a:bodyPr/>
+                    <a:lstStyle/>
+                    <a:p>
+                      <a:pPr indent="0" marL="0">
+                        <a:buNone/>
+                      </a:pPr>
+                      <a:r>
+                        <a:rPr lang="en-US" sz="1300" dirty="0">
+                          <a:solidFill>
+                            <a:srgbClr val="1B1F2A"/>
+                          </a:solidFill>
+                        </a:rPr>
+                        <a:t>Nowy rodzaj zadań: SQL</a:t>
+                      </a:r>
+                      <a:endParaRPr lang="en-US" sz="1300" dirty="0"/>
+                    </a:p>
+                  </a:txBody>
+                  <a:tcPr marL="91440" marR="91440" marT="45720" marB="45720" anchor="ctr">
+                    <a:lnL w="6350" cap="flat" cmpd="sng" algn="ctr">
+                      <a:solidFill>
+                        <a:srgbClr val="C7CEDB"/>
+                      </a:solidFill>
+                      <a:prstDash val="solid"/>
+                      <a:round/>
+                      <a:headEnd type="none" w="med" len="med"/>
+                      <a:tailEnd type="none" w="med" len="med"/>
+                    </a:lnL>
+                    <a:lnR w="6350" cap="flat" cmpd="sng" algn="ctr">
+                      <a:solidFill>
+                        <a:srgbClr val="C7CEDB"/>
+                      </a:solidFill>
+                      <a:prstDash val="solid"/>
+                      <a:round/>
+                      <a:headEnd type="none" w="med" len="med"/>
+                      <a:tailEnd type="none" w="med" len="med"/>
+                    </a:lnR>
+                    <a:lnT w="6350" cap="flat" cmpd="sng" algn="ctr">
+                      <a:solidFill>
+                        <a:srgbClr val="C7CEDB"/>
+                      </a:solidFill>
+                      <a:prstDash val="solid"/>
+                      <a:round/>
+                      <a:headEnd type="none" w="med" len="med"/>
+                      <a:tailEnd type="none" w="med" len="med"/>
+                    </a:lnT>
+                    <a:lnB w="6350" cap="flat" cmpd="sng" algn="ctr">
+                      <a:solidFill>
+                        <a:srgbClr val="C7CEDB"/>
+                      </a:solidFill>
+                      <a:prstDash val="solid"/>
+                      <a:round/>
+                      <a:headEnd type="none" w="med" len="med"/>
+                      <a:tailEnd type="none" w="med" len="med"/>
+                    </a:lnB>
+                  </a:tcPr>
+                </a:tc>
+                <a:tc>
+                  <a:txBody>
+                    <a:bodyPr/>
+                    <a:lstStyle/>
+                    <a:p>
+                      <a:pPr indent="0" marL="0">
+                        <a:buNone/>
+                      </a:pPr>
+                      <a:r>
+                        <a:rPr lang="en-US" sz="1300" dirty="0">
+                          <a:solidFill>
+                            <a:srgbClr val="1B1F2A"/>
+                          </a:solidFill>
+                        </a:rPr>
+                        <a:t>CC BY-SA 4.0</a:t>
+                      </a:r>
+                      <a:endParaRPr lang="en-US" sz="1300" dirty="0"/>
+                    </a:p>
+                  </a:txBody>
+                  <a:tcPr marL="91440" marR="91440" marT="45720" marB="45720" anchor="ctr">
+                    <a:lnL w="6350" cap="flat" cmpd="sng" algn="ctr">
+                      <a:solidFill>
+                        <a:srgbClr val="C7CEDB"/>
+                      </a:solidFill>
+                      <a:prstDash val="solid"/>
+                      <a:round/>
+                      <a:headEnd type="none" w="med" len="med"/>
+                      <a:tailEnd type="none" w="med" len="med"/>
+                    </a:lnL>
+                    <a:lnR w="6350" cap="flat" cmpd="sng" algn="ctr">
+                      <a:solidFill>
+                        <a:srgbClr val="C7CEDB"/>
+                      </a:solidFill>
+                      <a:prstDash val="solid"/>
+                      <a:round/>
+                      <a:headEnd type="none" w="med" len="med"/>
+                      <a:tailEnd type="none" w="med" len="med"/>
+                    </a:lnR>
+                    <a:lnT w="6350" cap="flat" cmpd="sng" algn="ctr">
+                      <a:solidFill>
+                        <a:srgbClr val="C7CEDB"/>
+                      </a:solidFill>
+                      <a:prstDash val="solid"/>
+                      <a:round/>
+                      <a:headEnd type="none" w="med" len="med"/>
+                      <a:tailEnd type="none" w="med" len="med"/>
+                    </a:lnT>
+                    <a:lnB w="6350" cap="flat" cmpd="sng" algn="ctr">
+                      <a:solidFill>
+                        <a:srgbClr val="C7CEDB"/>
+                      </a:solidFill>
+                      <a:prstDash val="solid"/>
+                      <a:round/>
+                      <a:headEnd type="none" w="med" len="med"/>
+                      <a:tailEnd type="none" w="med" len="med"/>
+                    </a:lnB>
+                  </a:tcPr>
+                </a:tc>
+              </a:tr>
+              <a:tr h="566928">
+                <a:tc>
+                  <a:txBody>
+                    <a:bodyPr/>
+                    <a:lstStyle/>
+                    <a:p>
+                      <a:pPr indent="0" marL="0">
+                        <a:buNone/>
+                      </a:pPr>
+                      <a:r>
+                        <a:rPr lang="en-US" sz="1300" dirty="0">
+                          <a:solidFill>
+                            <a:srgbClr val="1B1F2A"/>
+                          </a:solidFill>
+                        </a:rPr>
+                        <a:t>Arena 140k</a:t>
+                      </a:r>
+                      <a:endParaRPr lang="en-US" sz="1300" dirty="0"/>
+                    </a:p>
+                  </a:txBody>
+                  <a:tcPr marL="91440" marR="91440" marT="45720" marB="45720" anchor="ctr">
+                    <a:lnL w="6350" cap="flat" cmpd="sng" algn="ctr">
+                      <a:solidFill>
+                        <a:srgbClr val="C7CEDB"/>
+                      </a:solidFill>
+                      <a:prstDash val="solid"/>
+                      <a:round/>
+                      <a:headEnd type="none" w="med" len="med"/>
+                      <a:tailEnd type="none" w="med" len="med"/>
+                    </a:lnL>
+                    <a:lnR w="6350" cap="flat" cmpd="sng" algn="ctr">
+                      <a:solidFill>
+                        <a:srgbClr val="C7CEDB"/>
+                      </a:solidFill>
+                      <a:prstDash val="solid"/>
+                      <a:round/>
+                      <a:headEnd type="none" w="med" len="med"/>
+                      <a:tailEnd type="none" w="med" len="med"/>
+                    </a:lnR>
+                    <a:lnT w="6350" cap="flat" cmpd="sng" algn="ctr">
+                      <a:solidFill>
+                        <a:srgbClr val="C7CEDB"/>
+                      </a:solidFill>
+                      <a:prstDash val="solid"/>
+                      <a:round/>
+                      <a:headEnd type="none" w="med" len="med"/>
+                      <a:tailEnd type="none" w="med" len="med"/>
+                    </a:lnT>
+                    <a:lnB w="6350" cap="flat" cmpd="sng" algn="ctr">
+                      <a:solidFill>
+                        <a:srgbClr val="C7CEDB"/>
+                      </a:solidFill>
+                      <a:prstDash val="solid"/>
+                      <a:round/>
+                      <a:headEnd type="none" w="med" len="med"/>
+                      <a:tailEnd type="none" w="med" len="med"/>
+                    </a:lnB>
+                  </a:tcPr>
+                </a:tc>
+                <a:tc>
+                  <a:txBody>
+                    <a:bodyPr/>
+                    <a:lstStyle/>
+                    <a:p>
+                      <a:pPr indent="0" marL="0">
+                        <a:buNone/>
+                      </a:pPr>
+                      <a:r>
+                        <a:rPr lang="en-US" sz="1300" dirty="0">
+                          <a:solidFill>
+                            <a:srgbClr val="1B1F2A"/>
+                          </a:solidFill>
+                        </a:rPr>
+                        <a:t>Ok. 135 tys. prawdziwych rozmów, część o kodzie</a:t>
+                      </a:r>
+                      <a:endParaRPr lang="en-US" sz="1300" dirty="0"/>
+                    </a:p>
+                  </a:txBody>
+                  <a:tcPr marL="91440" marR="91440" marT="45720" marB="45720" anchor="ctr">
+                    <a:lnL w="6350" cap="flat" cmpd="sng" algn="ctr">
+                      <a:solidFill>
+                        <a:srgbClr val="C7CEDB"/>
+                      </a:solidFill>
+                      <a:prstDash val="solid"/>
+                      <a:round/>
+                      <a:headEnd type="none" w="med" len="med"/>
+                      <a:tailEnd type="none" w="med" len="med"/>
+                    </a:lnL>
+                    <a:lnR w="6350" cap="flat" cmpd="sng" algn="ctr">
+                      <a:solidFill>
+                        <a:srgbClr val="C7CEDB"/>
+                      </a:solidFill>
+                      <a:prstDash val="solid"/>
+                      <a:round/>
+                      <a:headEnd type="none" w="med" len="med"/>
+                      <a:tailEnd type="none" w="med" len="med"/>
+                    </a:lnR>
+                    <a:lnT w="6350" cap="flat" cmpd="sng" algn="ctr">
+                      <a:solidFill>
+                        <a:srgbClr val="C7CEDB"/>
+                      </a:solidFill>
+                      <a:prstDash val="solid"/>
+                      <a:round/>
+                      <a:headEnd type="none" w="med" len="med"/>
+                      <a:tailEnd type="none" w="med" len="med"/>
+                    </a:lnT>
+                    <a:lnB w="6350" cap="flat" cmpd="sng" algn="ctr">
+                      <a:solidFill>
+                        <a:srgbClr val="C7CEDB"/>
+                      </a:solidFill>
+                      <a:prstDash val="solid"/>
+                      <a:round/>
+                      <a:headEnd type="none" w="med" len="med"/>
+                      <a:tailEnd type="none" w="med" len="med"/>
+                    </a:lnB>
+                  </a:tcPr>
+                </a:tc>
+                <a:tc>
+                  <a:txBody>
+                    <a:bodyPr/>
+                    <a:lstStyle/>
+                    <a:p>
+                      <a:pPr indent="0" marL="0">
+                        <a:buNone/>
+                      </a:pPr>
+                      <a:r>
+                        <a:rPr lang="en-US" sz="1300" dirty="0">
+                          <a:solidFill>
+                            <a:srgbClr val="1B1F2A"/>
+                          </a:solidFill>
+                        </a:rPr>
+                        <a:t>Więcej różnych pytań</a:t>
+                      </a:r>
+                      <a:endParaRPr lang="en-US" sz="1300" dirty="0"/>
+                    </a:p>
+                  </a:txBody>
+                  <a:tcPr marL="91440" marR="91440" marT="45720" marB="45720" anchor="ctr">
+                    <a:lnL w="6350" cap="flat" cmpd="sng" algn="ctr">
+                      <a:solidFill>
+                        <a:srgbClr val="C7CEDB"/>
+                      </a:solidFill>
+                      <a:prstDash val="solid"/>
+                      <a:round/>
+                      <a:headEnd type="none" w="med" len="med"/>
+                      <a:tailEnd type="none" w="med" len="med"/>
+                    </a:lnL>
+                    <a:lnR w="6350" cap="flat" cmpd="sng" algn="ctr">
+                      <a:solidFill>
+                        <a:srgbClr val="C7CEDB"/>
+                      </a:solidFill>
+                      <a:prstDash val="solid"/>
+                      <a:round/>
+                      <a:headEnd type="none" w="med" len="med"/>
+                      <a:tailEnd type="none" w="med" len="med"/>
+                    </a:lnR>
+                    <a:lnT w="6350" cap="flat" cmpd="sng" algn="ctr">
+                      <a:solidFill>
+                        <a:srgbClr val="C7CEDB"/>
+                      </a:solidFill>
+                      <a:prstDash val="solid"/>
+                      <a:round/>
+                      <a:headEnd type="none" w="med" len="med"/>
+                      <a:tailEnd type="none" w="med" len="med"/>
+                    </a:lnT>
+                    <a:lnB w="6350" cap="flat" cmpd="sng" algn="ctr">
+                      <a:solidFill>
+                        <a:srgbClr val="C7CEDB"/>
+                      </a:solidFill>
+                      <a:prstDash val="solid"/>
+                      <a:round/>
+                      <a:headEnd type="none" w="med" len="med"/>
+                      <a:tailEnd type="none" w="med" len="med"/>
+                    </a:lnB>
+                  </a:tcPr>
+                </a:tc>
+                <a:tc>
+                  <a:txBody>
+                    <a:bodyPr/>
+                    <a:lstStyle/>
+                    <a:p>
+                      <a:pPr indent="0" marL="0">
+                        <a:buNone/>
+                      </a:pPr>
+                      <a:r>
+                        <a:rPr lang="en-US" sz="1300" dirty="0">
+                          <a:solidFill>
+                            <a:srgbClr val="1B1F2A"/>
+                          </a:solidFill>
+                        </a:rPr>
+                        <a:t>CC BY 4.0</a:t>
+                      </a:r>
+                      <a:endParaRPr lang="en-US" sz="1300" dirty="0"/>
+                    </a:p>
+                  </a:txBody>
+                  <a:tcPr marL="91440" marR="91440" marT="45720" marB="45720" anchor="ctr">
+                    <a:lnL w="6350" cap="flat" cmpd="sng" algn="ctr">
+                      <a:solidFill>
+                        <a:srgbClr val="C7CEDB"/>
+                      </a:solidFill>
+                      <a:prstDash val="solid"/>
+                      <a:round/>
+                      <a:headEnd type="none" w="med" len="med"/>
+                      <a:tailEnd type="none" w="med" len="med"/>
+                    </a:lnL>
+                    <a:lnR w="6350" cap="flat" cmpd="sng" algn="ctr">
+                      <a:solidFill>
+                        <a:srgbClr val="C7CEDB"/>
+                      </a:solidFill>
+                      <a:prstDash val="solid"/>
+                      <a:round/>
+                      <a:headEnd type="none" w="med" len="med"/>
+                      <a:tailEnd type="none" w="med" len="med"/>
+                    </a:lnR>
+                    <a:lnT w="6350" cap="flat" cmpd="sng" algn="ctr">
+                      <a:solidFill>
+                        <a:srgbClr val="C7CEDB"/>
+                      </a:solidFill>
+                      <a:prstDash val="solid"/>
+                      <a:round/>
+                      <a:headEnd type="none" w="med" len="med"/>
+                      <a:tailEnd type="none" w="med" len="med"/>
+                    </a:lnT>
+                    <a:lnB w="6350" cap="flat" cmpd="sng" algn="ctr">
+                      <a:solidFill>
+                        <a:srgbClr val="C7CEDB"/>
+                      </a:solidFill>
+                      <a:prstDash val="solid"/>
+                      <a:round/>
+                      <a:headEnd type="none" w="med" len="med"/>
+                      <a:tailEnd type="none" w="med" len="med"/>
+                    </a:lnB>
+                  </a:tcPr>
+                </a:tc>
+              </a:tr>
+            </a:tbl>
+          </a:graphicData>
+        </a:graphic>
+      </p:graphicFrame>
+      <p:sp>
+        <p:nvSpPr>
+          <p:cNvPr id="4" name="Uwaga o pomiarze"/>
+          <p:cNvSpPr txBox="1"/>
+          <p:nvPr/>
+        </p:nvSpPr>
+        <p:spPr>
+          <a:xfrm>
+            <a:off x="457200" y="4160520"/>
+            <a:ext cx="8229600" cy="548640"/>
+          </a:xfrm>
+          <a:prstGeom prst="rect">
+            <a:avLst/>
+          </a:prstGeom>
+          <a:noFill/>
+          <a:ln/>
+        </p:spPr>
+        <p:txBody>
+          <a:bodyPr wrap="square" lIns="0" tIns="0" rIns="0" bIns="0" rtlCol="0" anchor="t"/>
+          <a:lstStyle/>
+          <a:p>
+            <a:pPr indent="0" marL="0">
+              <a:buNone/>
+            </a:pPr>
+            <a:r>
+              <a:rPr lang="en-US" sz="1400" dirty="0">
+                <a:solidFill>
+                  <a:schemeClr val="tx2"/>
+                </a:solidFill>
+              </a:rPr>
+              <a:t>Każdy zbiór trzeba zmierzyć od zera: odpowiedzi obu modeli i sędzia. Zbiór testowy zostaje zamknięty. Licencje sprawdzone na kartach zbiorów.</a:t>
+            </a:r>
+            <a:endParaRPr lang="en-US" sz="1400" dirty="0"/>
+          </a:p>
+        </p:txBody>
+      </p:sp>
+      <p:sp>
+        <p:nvSpPr>
+          <p:cNvPr id="25" name="Slide Number Placeholder 0"/>
+          <p:cNvSpPr>
+            <a:spLocks noGrp="1"/>
+          </p:cNvSpPr>
+          <p:nvPr>
+            <p:ph type="sldNum" sz="quarter" idx="4294967295"/>
+          </p:nvPr>
+        </p:nvSpPr>
+        <p:spPr>
+          <a:xfrm>
+            <a:off x="8321040" y="4754880"/>
+            <a:ext cx="457200" cy="274320"/>
+          </a:xfrm>
+          <a:prstGeom prst="rect">
+            <a:avLst/>
+          </a:prstGeom>
+          <a:extLst>
+            <a:ext uri="{C572A759-6A51-4108-AA02-DFA0A04FC94B}">
+              <ma14:wrappingTextBoxFlag xmlns:ma14="http://schemas.microsoft.com/office/mac/drawingml/2011/main" val="0"/>
+            </a:ext>
+          </a:extLst>
+        </p:spPr>
+        <p:txBody>
+          <a:bodyPr/>
+          <a:lstStyle>
+            <a:lvl1pPr>
+              <a:defRPr sz="1000">
+                <a:solidFill>
+                  <a:srgbClr val="8C9BB5"/>
+                </a:solidFill>
+              </a:defRPr>
+            </a:lvl1pPr>
+          </a:lstStyle>
+          <a:p>
+            <a:pPr algn="r"/>
+            <a:fld id="{F7021451-1387-4CA6-816F-3879F97B5CBC}" type="slidenum">
+              <a:rPr b="0" lang="en-US"/>
+              <a:t>15</a:t>
+            </a:fld>
+            <a:endParaRPr lang="en-US"/>
+          </a:p>
+        </p:txBody>
+      </p:sp>
+    </p:spTree>
+  </p:cSld>
+  <p:clrMapOvr>
+    <a:masterClrMapping/>
+  </p:clrMapOvr>
+</p:sld>
+</file>
+
+<file path=ppt/slides/slide16.xml><?xml version="1.0" encoding="utf-8"?>
+<p:sld xmlns:a="http://schemas.openxmlformats.org/drawingml/2006/main" xmlns:r="http://schemas.openxmlformats.org/officeDocument/2006/relationships" xmlns:p="http://schemas.openxmlformats.org/presentationml/2006/main">
+  <p:cSld name="Slide 16">
+    <p:spTree>
+      <p:nvGrpSpPr>
+        <p:cNvPr id="1" name=""/>
+        <p:cNvGrpSpPr/>
+        <p:nvPr/>
+      </p:nvGrpSpPr>
+      <p:grpSpPr>
+        <a:xfrm>
+          <a:off x="0" y="0"/>
+          <a:ext cx="0" cy="0"/>
+          <a:chOff x="0" y="0"/>
+          <a:chExt cx="0" cy="0"/>
+        </a:xfrm>
+      </p:grpSpPr>
+      <p:sp>
+        <p:nvSpPr>
+          <p:cNvPr id="2" name="Text 0"/>
+          <p:cNvSpPr/>
+          <p:nvPr>
+            <p:ph idx="100" type="title" hasCustomPrompt="1"/>
+          </p:nvPr>
+        </p:nvSpPr>
+        <p:spPr>
+          <a:xfrm>
+            <a:off x="457200" y="274320"/>
+            <a:ext cx="8229600" cy="731520"/>
+          </a:xfrm>
+          <a:prstGeom prst="rect">
+            <a:avLst/>
+          </a:prstGeom>
+          <a:noFill/>
+          <a:ln/>
+        </p:spPr>
+        <p:txBody>
+          <a:bodyPr wrap="square" lIns="0" tIns="0" rIns="0" bIns="0" rtlCol="0" anchor="ctr"/>
+          <a:lstStyle/>
+          <a:p>
+            <a:pPr algn="l" indent="0" marL="0">
+              <a:buNone/>
+            </a:pPr>
+            <a:r>
+              <a:rPr lang="en-US" sz="3200" b="1" dirty="0">
+                <a:solidFill>
+                  <a:srgbClr val="1B1F2A"/>
+                </a:solidFill>
+              </a:rPr>
               <a:t>Plan i prośba</a:t>
             </a:r>
             <a:endParaRPr lang="en-US" sz="3200" dirty="0"/>
@@ -7116,7 +8692,7 @@
                   <a:schemeClr val="tx1"/>
                 </a:solidFill>
               </a:rPr>
-              <a:t>Dodatkowe dane bliższe wdrożeniu</a:t>
+              <a:t>Dodatkowe dane bliższe wdrożeniu (poprzedni slajd)</a:t>
             </a:r>
             <a:endParaRPr lang="en-US" sz="1600" dirty="0"/>
           </a:p>
@@ -7355,7 +8931,7 @@
             <a:pPr algn="r"/>
             <a:fld id="{F7021451-1387-4CA6-816F-3879F97B5CBC}" type="slidenum">
               <a:rPr b="0" lang="en-US"/>
-              <a:t>15</a:t>
+              <a:t>16</a:t>
             </a:fld>
             <a:endParaRPr lang="en-US"/>
           </a:p>

</xml_diff>

<commit_message>
docs: notatki prezentacji w punktach z definicjami metryk, korekta idealnego APGR 0,89, dziennik 74
Co-Authored-By: Claude Sonnet 5.5 <noreply@anthropic.com>
Claude-Session: https://claude.ai/code/session_01V1631aLqopE3GM2inWjbQ8
</commit_message>
<xml_diff>
--- a/docs/prezentacja_postepy.pptx
+++ b/docs/prezentacja_postepy.pptx
@@ -122,7 +122,7 @@
   <p:extLst>
     <p:ext uri="{521415D9-36F7-43E2-AB2F-B90AF26B5E84}">
       <p14:sectionLst xmlns:p14="http://schemas.microsoft.com/office/powerpoint/2010/main">
-        <p14:section name="Wprowadzenie" id="{4e2955fb-ccac-7eca-65c4-1924764c3b78}">
+        <p14:section name="Wprowadzenie" id="{91045f2e-d137-0002-8ac4-d38dac496bd9}">
           <p14:sldIdLst>
             <p14:sldId id="256"/>
             <p14:sldId id="257"/>
@@ -130,20 +130,20 @@
             <p14:sldId id="259"/>
           </p14:sldIdLst>
         </p14:section>
-        <p14:section name="Dane i etykiety" id="{7c2798c1-0730-d7ce-d2cf-247483282989}">
+        <p14:section name="Dane i etykiety" id="{be12647c-82e7-3fd6-21e7-be019198e679}">
           <p14:sldIdLst>
             <p14:sldId id="260"/>
             <p14:sldId id="261"/>
             <p14:sldId id="262"/>
           </p14:sldIdLst>
         </p14:section>
-        <p14:section name="Router" id="{58a86839-b555-6820-284d-c5bdd9dbf563}">
+        <p14:section name="Router" id="{75274fd7-894e-e005-cbd4-ceda5af014f7}">
           <p14:sldIdLst>
             <p14:sldId id="263"/>
             <p14:sldId id="264"/>
           </p14:sldIdLst>
         </p14:section>
-        <p14:section name="Wyniki" id="{4298aecd-365f-0ba3-c327-3fdec03fbef0}">
+        <p14:section name="Wyniki" id="{6ff365cf-e978-3026-a24a-718b2da327f4}">
           <p14:sldIdLst>
             <p14:sldId id="265"/>
             <p14:sldId id="266"/>
@@ -151,7 +151,7 @@
             <p14:sldId id="268"/>
           </p14:sldIdLst>
         </p14:section>
-        <p14:section name="Dalej" id="{4c63d7b5-3605-8206-8c38-8a2d8dc7f34d}">
+        <p14:section name="Dalej" id="{bf00fa7a-410f-e662-5111-73da65727c6b}">
           <p14:sldIdLst>
             <p14:sldId id="269"/>
             <p14:sldId id="270"/>
@@ -542,27 +542,28 @@
           <a:p>
             <a:r>
               <a:rPr lang="pl-PL" sz="1400"/>
-              <a:t>Dzień dobry. Temat mojej pracy to routing zapytań do modeli językowych według ich trudności.
-</a:t>
-            </a:r>
-          </a:p>
-          <a:p>
-            <a:endParaRPr lang="pl-PL" sz="1400"/>
-          </a:p>
-          <a:p>
-            <a:r>
-              <a:rPr lang="pl-PL" sz="1400"/>
-              <a:t>Najprościej: mam dwa modele, mały i duży. Duży odpowiada lepiej, ale kosztuje więcej czasu i mocy obliczeniowej. Zbudowałem system, który czyta pytanie i, zanim ktokolwiek odpowie, wybiera, do którego modelu je wysłać. Działa jako nowa usługa w DeepFellow Infra.
-</a:t>
-            </a:r>
-          </a:p>
-          <a:p>
-            <a:endParaRPr lang="pl-PL" sz="1400"/>
-          </a:p>
-          <a:p>
-            <a:r>
-              <a:rPr lang="pl-PL" sz="1400"/>
-              <a:t>Najpierw powiem, jaki jest problem i jak zmieniłem podejście do pracy. Potem pokażę, jak sprawdzam, czy pytanie jest trudne, jak działa system i jakie ma wyniki. Na końcu ograniczenia i jedna prośba o decyzję.
+              <a:t>• Temat: routing zapytań do modeli językowych według ich trudności.
+</a:t>
+            </a:r>
+          </a:p>
+          <a:p>
+            <a:r>
+              <a:rPr lang="pl-PL" sz="1400"/>
+              <a:t>• Mam dwa modele: mały (qwen3:8b) i duży (Qwen3.8-27B). Duży odpowiada lepiej, ale kosztuje więcej czasu i mocy.
+</a:t>
+            </a:r>
+          </a:p>
+          <a:p>
+            <a:r>
+              <a:rPr lang="pl-PL" sz="1400"/>
+              <a:t>• System czyta pytanie i zanim ktokolwiek odpowie, wybiera model. Działa jako nowa usługa w DeepFellow Infra.
+</a:t>
+            </a:r>
+          </a:p>
+          <a:p>
+            <a:r>
+              <a:rPr lang="pl-PL" sz="1400"/>
+              <a:t>• Plan: problem i zmiana podejścia, jak mierzę trudność, jak działa router, wyniki, ograniczenia i prośba o decyzję.
 </a:t>
             </a:r>
           </a:p>
@@ -579,21 +580,21 @@
           <a:p>
             <a:r>
               <a:rPr lang="pl-PL" sz="1400"/>
-              <a:t>Mały model to qwen3:8b, duży to Qwen3.8-27B. Liczby 8 i 27 to miliardy parametrów, czyli rozmiar modelu.
-</a:t>
-            </a:r>
-          </a:p>
-          <a:p>
-            <a:r>
-              <a:rPr lang="pl-PL" sz="1400"/>
-              <a:t>W całej prezentacji „pytanie trudne” znaczy: duży model odpowiada na nie wyraźnie lepiej niż mały. „Pytanie łatwe” znaczy: mały wystarcza.
-</a:t>
-            </a:r>
-          </a:p>
-          <a:p>
-            <a:r>
-              <a:rPr lang="pl-PL" sz="1400"/>
-              <a:t>Całość zajmie ok. 20–25 minut.</a:t>
+              <a:t>• 8 i 27 to miliardy parametrów, czyli rozmiar modelu.
+</a:t>
+            </a:r>
+          </a:p>
+          <a:p>
+            <a:r>
+              <a:rPr lang="pl-PL" sz="1400"/>
+              <a:t>• „Pytanie trudne” = duży model odpowiada na nie wyraźnie lepiej niż mały. „Łatwe” = mały wystarcza.
+</a:t>
+            </a:r>
+          </a:p>
+          <a:p>
+            <a:r>
+              <a:rPr lang="pl-PL" sz="1400"/>
+              <a:t>• Czas: ok. 20–25 minut.</a:t>
             </a:r>
           </a:p>
         </p:txBody>
@@ -680,6 +681,69 @@
           <a:p>
             <a:r>
               <a:rPr lang="pl-PL" sz="1400" b="1"/>
+              <a:t>DEFINICJE
+</a:t>
+            </a:r>
+          </a:p>
+          <a:p>
+            <a:r>
+              <a:rPr lang="pl-PL" sz="1400"/>
+              <a:t>AUROC (ze slajdu 4): odsetek par (trudne, łatwe), w których router dał trudnemu wyższy wynik. Remis = 0,5. 0,5 to losowo, 1,0 to bezbłędny router. Nie zależy od progu.
+</a:t>
+            </a:r>
+          </a:p>
+          <a:p>
+            <a:r>
+              <a:rPr lang="pl-PL" sz="1400"/>
+              <a:t>• Wynik routera to liczba 0–1 ze slajdu 9: im wyższa, tym bardziej pytanie wygląda na trudne.
+</a:t>
+            </a:r>
+          </a:p>
+          <a:p>
+            <a:r>
+              <a:rPr lang="pl-PL" sz="1400"/>
+              <a:t>• Przykład pary: trudne dostało 0,70, łatwe 0,40, więc para = 1. U nas ok. 1130 trudnych i 1880 łatwych pytań, czyli ponad 2 miliony par.
+</a:t>
+            </a:r>
+          </a:p>
+          <a:p>
+            <a:r>
+              <a:rPr lang="pl-PL" sz="1400" b="1"/>
+              <a:t>JAKOŚĆ: </a:t>
+            </a:r>
+            <a:r>
+              <a:rPr lang="pl-PL" sz="1400"/>
+              <a:t>średnia ocena odpowiedzi w skali 0–1 (dla każdego pytania ocena modelu, do którego poszło). Wszystko do małego 0,625, wszystko do dużego 0,846. Luka 0,221.
+</a:t>
+            </a:r>
+          </a:p>
+          <a:p>
+            <a:r>
+              <a:rPr lang="pl-PL" sz="1400"/>
+              <a:t>APGR (średni odzyskany zysk): dla jednego progu odzyskany zysk = (jakość routera − 0,625) / 0,221. Np. jakość 0,777 daje 0,152 / 0,221 = 0,69.
+</a:t>
+            </a:r>
+          </a:p>
+          <a:p>
+            <a:r>
+              <a:rPr lang="pl-PL" sz="1400"/>
+              <a:t>• APGR to średnia z tego po wszystkich progach, czyli jedna liczba opisująca cały router. Wykres na następnym slajdzie.
+</a:t>
+            </a:r>
+          </a:p>
+          <a:p>
+            <a:r>
+              <a:rPr lang="pl-PL" sz="1400"/>
+              <a:t>• Losowe wysyłanie daje APGR 0,5, idealny router 0,89 (dla 3010 pytań). Mój ma 0,605.
+</a:t>
+            </a:r>
+          </a:p>
+          <a:p>
+            <a:endParaRPr lang="pl-PL" sz="1400"/>
+          </a:p>
+          <a:p>
+            <a:r>
+              <a:rPr lang="pl-PL" sz="1400" b="1"/>
               <a:t>MÓW
 </a:t>
             </a:r>
@@ -687,7 +751,28 @@
           <a:p>
             <a:r>
               <a:rPr lang="pl-PL" sz="1400"/>
-              <a:t>Teraz wyniki routera. Używam dwóch miar.
+              <a:t>• Mój router ma AUROC 0,682, czyli w 68 parach na 100 ustawia pytania dobrze.
+</a:t>
+            </a:r>
+          </a:p>
+          <a:p>
+            <a:r>
+              <a:rPr lang="pl-PL" sz="1400"/>
+              <a:t>• Słupki na wykresie to AUROC: losowy 0,5, sama długość pytania 0,525 (prawie nic nie mówi), „samo źródło” 0,631, router 0,682.
+</a:t>
+            </a:r>
+          </a:p>
+          <a:p>
+            <a:r>
+              <a:rPr lang="pl-PL" sz="1400"/>
+              <a:t>• „Samo źródło”: router, który nie czyta pytania, tylko wie, z jakiego zbioru pochodzi, i daje wynik równy odsetkowi trudnych w tym zbiorze (matematyka 4%, WildChat 48%). W praktyce źródła nie znamy, to tylko poprzeczka.
+</a:t>
+            </a:r>
+          </a:p>
+          <a:p>
+            <a:r>
+              <a:rPr lang="pl-PL" sz="1400"/>
+              <a:t>• Router wie coś więcej niż rodzaj pytania, ale niewiele: różnica 0,05 w AUROC i 0,023 w APGR (0,605 wobec 0,582), istotna statystycznie.
 </a:t>
             </a:r>
           </a:p>
@@ -696,52 +781,22 @@
           </a:p>
           <a:p>
             <a:r>
-              <a:rPr lang="pl-PL" sz="1400"/>
-              <a:t>Pierwsza to AUROC, znany już ze slajdu 4: dla losowej pary pytań, jedno trudne i jedno łatwe, odsetek par, w których router dał trudnemu wyższy wynik. Wynik routera to ta liczba od 0 do 1 ze slajdu 9: im wyższa, tym bardziej router uważa pytanie za trudne (np. 0,7, gdy 14 z 20 podobnych pytań było trudnych). 0,5 to zgadywanie, 1,0 to bezbłędny router. Mój router ma 0,682, czyli w 68 parach na 100 ustawia je dobrze. AUROC nie zależy od progu: ocenia sam wynik routera.
-</a:t>
-            </a:r>
-          </a:p>
-          <a:p>
-            <a:r>
-              <a:rPr lang="pl-PL" sz="1400"/>
-              <a:t>Jak liczy się jedną parę: jeśli trudne pytanie dostało wyższy wynik niż łatwe, para daje 1. Jeśli niższy, 0. Jeśli wyniki są równe, 0,5. Np. trudne dostało 0,70, a łatwe 0,40: wynik pary to 1. AUROC to średnia z wyników wszystkich takich par. U nas jest ok. 1130 trudnych i 1880 łatwych pytań, czyli ponad 2 miliony par.
-</a:t>
-            </a:r>
-          </a:p>
-          <a:p>
-            <a:endParaRPr lang="pl-PL" sz="1400"/>
-          </a:p>
-          <a:p>
-            <a:r>
-              <a:rPr lang="pl-PL" sz="1400"/>
-              <a:t>Druga to APGR. Najpierw „jakość”: to średnia ocena odpowiedzi w skali od 0 do 1. Gdy wszystko idzie do małego, jakość to 0,625, a gdy wszystko do dużego, 0,846. Cały możliwy zysk to więc 0,221. Router, który przy pewnym progu daje jakość 0,777, odzyskuje 0,152 z 0,221, czyli 0,69. To odzyskana część zysku dla jednego progu. Takich punktów jest wiele, po jednym dla każdego progu. APGR to średnia z nich wszystkich, czyli jedna liczba opisująca cały router. Zobaczysz te punkty jako wykres na następnym slajdzie. Losowe wysyłanie daje APGR 0,5, a idealny router 0,91. Mój ma 0,605.
-</a:t>
-            </a:r>
-          </a:p>
-          <a:p>
-            <a:endParaRPr lang="pl-PL" sz="1400"/>
-          </a:p>
-          <a:p>
-            <a:r>
-              <a:rPr lang="pl-PL" sz="1400"/>
-              <a:t>Uwaga, co dokładnie mierzą te liczby: to wynik warstwy 2 (kNN), bo tylko ona daje liczbę od 0 do 1 dla każdego pytania. Warstwę 1 sprawdziłem osobno (ok. 0,55) oraz razem z kNN: kaskada nie zmienia jakości. Warstwy 3 jeszcze nie ma, więc nie ma czego mierzyć. Cały router, ze wszystkimi warstwami, ocenię na zbiorze testowym.
-</a:t>
-            </a:r>
-          </a:p>
-          <a:p>
-            <a:r>
-              <a:rPr lang="pl-PL" sz="1400"/>
-              <a:t>Słupki na wykresie to AUROC. Losowy: 0,5. Sama długość pytania: 0,525, czyli prawie nic nie mówi. „Samo źródło”: 0,631. To router, który w ogóle nie czyta pytania, tylko wie, z jakiego zbioru pochodzi, i daje każdemu pytaniu wynik równy odsetkowi trudnych pytań w tym zbiorze (4% dla zadań matematycznych, 48% dla WildChat). W praktyce źródła nie znamy, więc to tylko poprzeczka. Pytam: czy router wie coś więcej niż rodzaj pytania? Wie, ale niewiele więcej: różnica to 0,05 w AUROC i 0,023 w APGR (0,605 wobec 0,582), istotna statystycznie.
-</a:t>
-            </a:r>
-          </a:p>
-          <a:p>
-            <a:endParaRPr lang="pl-PL" sz="1400"/>
-          </a:p>
-          <a:p>
-            <a:r>
-              <a:rPr lang="pl-PL" sz="1400"/>
-              <a:t>Uczciwie: dużą część skuteczności daje samo rozpoznanie rodzaju pytania. Wewnątrz jednego źródła wynik jest słabszy: dla Areny 0,60, a dla pytań o wiedzę (TriviaQA) ok. 0,50, czyli nic. Heurystyki z warstwy 1 dają same ok. 0,55, więc nie poprawiają kNN.
+              <a:rPr lang="pl-PL" sz="1400" b="1"/>
+              <a:t>UWAGA
+</a:t>
+            </a:r>
+          </a:p>
+          <a:p>
+            <a:r>
+              <a:rPr lang="pl-PL" sz="1400"/>
+              <a:t>• Liczby dotyczą warstwy 2 (kNN), bo tylko ona daje wynik 0–1 dla każdego pytania. Warstwa 1 osobno ok. 0,55, w kaskadzie z kNN jakość się nie zmienia. Warstwy 3 jeszcze nie ma. Cały router ocenię na zbiorze testowym.
+</a:t>
+            </a:r>
+          </a:p>
+          <a:p>
+            <a:r>
+              <a:rPr lang="pl-PL" sz="1400"/>
+              <a:t>• Uczciwie: dużą część skuteczności daje samo rozpoznanie rodzaju pytania. Wewnątrz jednego źródła jest słabiej: Arena 0,60, TriviaQA ok. 0,50.
 </a:t>
             </a:r>
           </a:p>
@@ -758,7 +813,7 @@
           <a:p>
             <a:r>
               <a:rPr lang="pl-PL" sz="1400"/>
-              <a:t>Czy da się lepiej? Z samego tekstu raczej nie: różne metody dają podobny wynik. Potrzebny byłby inny sygnał, np. warstwa 3.</a:t>
+              <a:t>• Czy da się lepiej? Z samego tekstu raczej nie, różne metody dają podobny wynik. Potrzebny byłby inny sygnał, np. warstwa 3.</a:t>
             </a:r>
           </a:p>
         </p:txBody>
@@ -852,7 +907,7 @@
           <a:p>
             <a:r>
               <a:rPr lang="pl-PL" sz="1400"/>
-              <a:t>Ten slajd pokazuje dwie różne rzeczy: po lewej wykres, po prawej tabelę. Wyjaśniam je po kolei, a na końcu, jak się do siebie mają.
+              <a:t>• Ten slajd pokazuje dwie różne rzeczy: po lewej wykres (obraz APGR), po prawej tabelę (ryzyko poważnych błędów).
 </a:t>
             </a:r>
           </a:p>
@@ -862,39 +917,42 @@
           <a:p>
             <a:r>
               <a:rPr lang="pl-PL" sz="1400" b="1"/>
-              <a:t>LEWA STRONA: </a:t>
-            </a:r>
-            <a:r>
-              <a:rPr lang="pl-PL" sz="1400"/>
-              <a:t>WYKRES (to jest obraz APGR)
-</a:t>
-            </a:r>
-          </a:p>
-          <a:p>
-            <a:r>
-              <a:rPr lang="pl-PL" sz="1400"/>
-              <a:t>Oś pozioma to odsetek pytań, które wysyłam do dużego modelu, od 0% do 100%. Oś pionowa to jakość, czyli średnia ocena odpowiedzi w skali 0–1. Liczę ją tak: dla każdego pytania biorę ocenę modelu, do którego poszło, i uśredniam po wszystkich pytaniach.
-</a:t>
-            </a:r>
-          </a:p>
-          <a:p>
-            <a:r>
-              <a:rPr lang="pl-PL" sz="1400"/>
-              <a:t>Wszystko do małego daje 0,625, a wszystko do dużego 0,846. Szara linia to wysyłanie losowe: jakość rośnie po prostu proporcjonalnie do udziału dużego. Pomarańczowa linia to router. Jest wyżej, czyli przy tym samym udziale dużego modelu daje lepszą jakość.
-</a:t>
-            </a:r>
-          </a:p>
-          <a:p>
-            <a:r>
-              <a:rPr lang="pl-PL" sz="1400"/>
-              <a:t>Ten wykres to właśnie te punkty, z których APGR jest średnią. Przy 54% do dużego jakość routera to 0,777, czyli odzyskuję 0,69 luki między 0,625 a 0,846, a przy wysyłaniu losowym byłoby to 0,54. APGR (0,605 wobec 0,5 losowo) mierzy odstęp między liniami.
-</a:t>
-            </a:r>
-          </a:p>
-          <a:p>
-            <a:r>
-              <a:rPr lang="pl-PL" sz="1400"/>
-              <a:t>Jeden punkt jako przykład, próg 0,3: do dużego idzie 54% pytań, jakość to 0,777. To ok. 46% mniej wywołań dużego modelu (100% minus 54%) za ok. 8% niższą jakość (0,846 spada do 0,777). Uwaga: te dwie liczby, 46% i 8%, to odczyt z jednego punktu wykresu, a nie APGR. APGR jest jedną liczbą opisującą całą linię.
+              <a:t>WYKRES (LEWA STRONA)
+</a:t>
+            </a:r>
+          </a:p>
+          <a:p>
+            <a:r>
+              <a:rPr lang="pl-PL" sz="1400"/>
+              <a:t>• Oś pozioma: odsetek pytań wysyłanych do dużego modelu (0–100%). Oś pionowa: jakość, czyli średnia ocena odpowiedzi (0–1).
+</a:t>
+            </a:r>
+          </a:p>
+          <a:p>
+            <a:r>
+              <a:rPr lang="pl-PL" sz="1400"/>
+              <a:t>• Wszystko do małego daje 0,625, wszystko do dużego 0,846. Szara linia to wysyłanie losowe. Pomarańczowa to router: wyżej = lepsza jakość przy tym samym udziale dużego.
+</a:t>
+            </a:r>
+          </a:p>
+          <a:p>
+            <a:r>
+              <a:rPr lang="pl-PL" sz="1400"/>
+              <a:t>• Punkty tej linii to te, z których APGR jest średnią. APGR (0,605 wobec 0,5 losowo) mierzy odstęp między liniami.
+</a:t>
+            </a:r>
+          </a:p>
+          <a:p>
+            <a:r>
+              <a:rPr lang="pl-PL" sz="1400"/>
+              <a:t>• Przykład, próg 0,3: do dużego idzie 54% pytań, jakość 0,777. Odzyskuję 0,69 luki między 0,625 a 0,846 (losowo byłoby 0,54).
+</a:t>
+            </a:r>
+          </a:p>
+          <a:p>
+            <a:r>
+              <a:rPr lang="pl-PL" sz="1400"/>
+              <a:t>• To ok. 46% mniej wywołań dużego modelu za ok. 8% niższą jakość (0,846 spada do 0,777). Uwaga: to odczyt z jednego punktu, nie APGR.
 </a:t>
             </a:r>
           </a:p>
@@ -904,25 +962,18 @@
           <a:p>
             <a:r>
               <a:rPr lang="pl-PL" sz="1400" b="1"/>
-              <a:t>PRAWA STRONA: </a:t>
-            </a:r>
-            <a:r>
-              <a:rPr lang="pl-PL" sz="1400"/>
-              <a:t>TABELA (to jest inna miara, nie APGR)
-</a:t>
-            </a:r>
-          </a:p>
-          <a:p>
-            <a:r>
-              <a:rPr lang="pl-PL" sz="1400"/>
-              <a:t>Średnia jakość nie pokazuje najgorszych przypadków. Pytanie poważnie błędne to takie, na które duży model odpowiedziałby wyraźnie lepiej (o ponad 2 punkty w skali 1–5), a które poszło do małego. Takich pytań jest 15,9% wszystkich.
-</a:t>
-            </a:r>
-          </a:p>
-          <a:p>
-            <a:r>
-              <a:rPr lang="pl-PL" sz="1400"/>
-              <a:t>Tabela mówi: jeśli akceptuję do 12% poważnych błędów wśród pytań wysłanych do małego, to do małego idzie 47% pytań. Przy 10% idzie 22%, przy 15% aż 90%. Poniżej ok. 8% żaden próg nie daje gwarancji z 95% pewnością.
+              <a:t>DEFINICJE
+</a:t>
+            </a:r>
+          </a:p>
+          <a:p>
+            <a:r>
+              <a:rPr lang="pl-PL" sz="1400" b="1"/>
+              <a:t>POWAŻNY BŁĄD: </a:t>
+            </a:r>
+            <a:r>
+              <a:rPr lang="pl-PL" sz="1400"/>
+              <a:t>pytanie, na które duży model odpowiedziałby wyraźnie lepiej (o ponad 2 punkty w skali 1–5, czyli Δ &gt; 0,5), a które poszło do małego. Takich pytań jest 15,9%.
 </a:t>
             </a:r>
           </a:p>
@@ -932,21 +983,52 @@
           <a:p>
             <a:r>
               <a:rPr lang="pl-PL" sz="1400" b="1"/>
-              <a:t>JAK SIĘ TE DWA OBRAZY DO SIEBIE MAJĄ
-</a:t>
-            </a:r>
-          </a:p>
-          <a:p>
-            <a:r>
-              <a:rPr lang="pl-PL" sz="1400"/>
-              <a:t>To ten sam router i te same progi, oglądane z dwóch stron. Wykres odpowiada na pytanie „ile średnio stracę na jakości”, tabela na pytanie „jak często popełnię poważny błąd”. Np. próg 0,3: z wykresu 54% do dużego i jakość 0,777, z tabeli do małego idzie ok. 47% pytań, a wśród nich ok. 11% to poważne błędy.
-</a:t>
-            </a:r>
-          </a:p>
-          <a:p>
-            <a:r>
-              <a:rPr lang="pl-PL" sz="1400"/>
-              <a:t>Do oceny routera służą AUROC i APGR (nie zależą od progu). Wykres i tabela pomagają administratorowi wybrać jeden próg: albo patrząc na koszt (wykres), albo na ryzyko (tabela).
+              <a:t>TABELA (PRAWA STRONA)
+</a:t>
+            </a:r>
+          </a:p>
+          <a:p>
+            <a:r>
+              <a:rPr lang="pl-PL" sz="1400"/>
+              <a:t>• To inna miara niż APGR. Jeśli akceptuję do 12% poważnych błędów wśród pytań wysłanych do małego, do małego idzie 47% pytań.
+</a:t>
+            </a:r>
+          </a:p>
+          <a:p>
+            <a:r>
+              <a:rPr lang="pl-PL" sz="1400"/>
+              <a:t>• Przy 10% idzie 22% pytań, przy 15% aż 90%. Poniżej ok. 8% żaden próg nie daje gwarancji z 95% pewnością.
+</a:t>
+            </a:r>
+          </a:p>
+          <a:p>
+            <a:endParaRPr lang="pl-PL" sz="1400"/>
+          </a:p>
+          <a:p>
+            <a:r>
+              <a:rPr lang="pl-PL" sz="1400" b="1"/>
+              <a:t>JAK SIĘ MAJĄ DO SIEBIE
+</a:t>
+            </a:r>
+          </a:p>
+          <a:p>
+            <a:r>
+              <a:rPr lang="pl-PL" sz="1400"/>
+              <a:t>• To ten sam router i te same progi, oglądane z dwóch stron. Wykres: ile średnio stracę na jakości. Tabela: jak często popełnię poważny błąd.
+</a:t>
+            </a:r>
+          </a:p>
+          <a:p>
+            <a:r>
+              <a:rPr lang="pl-PL" sz="1400"/>
+              <a:t>• Np. próg 0,3: z wykresu 54% do dużego i jakość 0,777. Z tabeli: do małego idzie ok. 47% pytań, wśród nich ok. 11% to poważne błędy.
+</a:t>
+            </a:r>
+          </a:p>
+          <a:p>
+            <a:r>
+              <a:rPr lang="pl-PL" sz="1400"/>
+              <a:t>• Do oceny routera służą AUROC i APGR (nie zależą od progu). Wykres i tabela pomagają wybrać jeden próg: wg kosztu (wykres) albo wg ryzyka (tabela).
 </a:t>
             </a:r>
           </a:p>
@@ -963,14 +1045,14 @@
           <a:p>
             <a:r>
               <a:rPr lang="pl-PL" sz="1400"/>
-              <a:t>Jak liczona jest tabela? Próg wyznaczam na jednej części danych, a sprawdzam na drugiej. Pewność 95% liczę metodą Clopper–Pearsona.
-</a:t>
-            </a:r>
-          </a:p>
-          <a:p>
-            <a:r>
-              <a:rPr lang="pl-PL" sz="1400"/>
-              <a:t>Czy 46% oszczędności jest warte 8% jakości? To zależy od administratora, dlatego to on wybiera próg.</a:t>
+              <a:t>• Jak liczona jest tabela? Próg wyznaczam na jednej części danych, sprawdzam na drugiej. Pewność 95% liczę metodą Clopper–Pearsona.
+</a:t>
+            </a:r>
+          </a:p>
+          <a:p>
+            <a:r>
+              <a:rPr lang="pl-PL" sz="1400"/>
+              <a:t>• Czy 46% oszczędności jest warte 8% jakości? To zależy od administratora, dlatego to on wybiera próg.</a:t>
             </a:r>
           </a:p>
         </p:txBody>
@@ -1064,89 +1146,49 @@
           <a:p>
             <a:r>
               <a:rPr lang="pl-PL" sz="1400"/>
-              <a:t>Na poprzednim slajdzie pokazałem, że router czasem popełnia poważny błąd: wysyła do małego modelu pytanie, na które duży odpowiedziałby wyraźnie lepiej (o ponad 2 punkty w skali 1–5). Takich pytań jest 15,9% wszystkich.
-</a:t>
-            </a:r>
-          </a:p>
-          <a:p>
-            <a:endParaRPr lang="pl-PL" sz="1400"/>
-          </a:p>
-          <a:p>
-            <a:r>
-              <a:rPr lang="pl-PL" sz="1400"/>
-              <a:t>Wyobraź sobie 100 takich pytań. Przy progu 0,3 router wysyła do dużego modelu 70 z nich i to jest dobrze. Pozostałe 30 trafia do małego, więc użytkownik dostaje gorszą odpowiedź, niż mógł dostać. Stąd 30%. Gdyby router niczego nie umiał i losowo kierował do małego tyle samo pytań co teraz (ok. 46% wszystkich), do małego trafiłoby 46 z tych 100. Router jest więc lepszy od losowania, ale nie bezbłędny.
-</a:t>
-            </a:r>
-          </a:p>
-          <a:p>
-            <a:endParaRPr lang="pl-PL" sz="1400"/>
-          </a:p>
-          <a:p>
-            <a:r>
-              <a:rPr lang="pl-PL" sz="1400"/>
-              <a:t>Wykres pokazuje to osobno dla każdego źródła. Biorę 100 pytań trudnych z danego źródła i liczę, ile z nich router wysłał do małego, czyli w ilu przypadkach się pomylił:
-</a:t>
-            </a:r>
-          </a:p>
-          <a:p>
-            <a:r>
-              <a:rPr lang="pl-PL" sz="1400"/>
-              <a:t>• Arena: 25 ze 100.
-</a:t>
-            </a:r>
-          </a:p>
-          <a:p>
-            <a:r>
-              <a:rPr lang="pl-PL" sz="1400"/>
-              <a:t>• WildChat: 17 ze 100.
-</a:t>
-            </a:r>
-          </a:p>
-          <a:p>
-            <a:r>
-              <a:rPr lang="pl-PL" sz="1400"/>
-              <a:t>• TriviaQA, pytania o fakty: 81 ze 100.
-</a:t>
-            </a:r>
-          </a:p>
-          <a:p>
-            <a:r>
-              <a:rPr lang="pl-PL" sz="1400"/>
-              <a:t>• HumanEval, zadania programistyczne: 84 ze 100.
-</a:t>
-            </a:r>
-          </a:p>
-          <a:p>
-            <a:r>
-              <a:rPr lang="pl-PL" sz="1400"/>
-              <a:t>Przy pytaniach otwartych router myli się więc rzadziej, a przy faktach i programowaniu myli się prawie za każdym razem, gdy pytanie jest trudne.
-</a:t>
-            </a:r>
-          </a:p>
-          <a:p>
-            <a:endParaRPr lang="pl-PL" sz="1400"/>
-          </a:p>
-          <a:p>
-            <a:r>
-              <a:rPr lang="pl-PL" sz="1400"/>
-              <a:t>Dlaczego tak jest? Router widzi tylko tekst pytania, a nie to, co wie mały model. Dwa pytania o fakty wyglądają podobnie, ale mały model może znać odpowiedź na jedno i nie znać drugiej. W tekście tego nie widać.
-</a:t>
-            </a:r>
-          </a:p>
-          <a:p>
-            <a:r>
-              <a:rPr lang="pl-PL" sz="1400"/>
-              <a:t>Przy programowaniu tylko 18% zadań jest trudnych. Sąsiedzi nowego zadania są więc zwykle łatwi, wynik jest niski i zadanie idzie do małego. Te trudne wyglądają tak samo jak łatwe.
-</a:t>
-            </a:r>
-          </a:p>
-          <a:p>
-            <a:endParaRPr lang="pl-PL" sz="1400"/>
-          </a:p>
-          <a:p>
-            <a:r>
-              <a:rPr lang="pl-PL" sz="1400"/>
-              <a:t>To nie jest błąd metody, tylko brak informacji w samym tekście. Dlatego rozważam warstwę 3: może sam mały model „czuje”, czy da radę. To hipoteza do sprawdzenia, a nie obietnica.
+              <a:t>• Poważny błąd (slajd 11): pytanie trudne wysłane do małego. Takich pytań jest 15,9%.
+</a:t>
+            </a:r>
+          </a:p>
+          <a:p>
+            <a:r>
+              <a:rPr lang="pl-PL" sz="1400"/>
+              <a:t>• Przykład: 100 takich pytań. Przy progu 0,3 router wysyła 70 do dużego (dobrze) i 30 do małego (gorsza odpowiedź niż mogła być). Losowo, przy tym samym udziale pytań do małego (ok. 46% wszystkich), do małego trafiłoby 46. Router jest lepszy od losowania, ale nie bezbłędny.
+</a:t>
+            </a:r>
+          </a:p>
+          <a:p>
+            <a:r>
+              <a:rPr lang="pl-PL" sz="1400"/>
+              <a:t>• Wykres: ile ze 100 trudnych pytań z danego źródła router wysłał do małego. Arena 25, WildChat 17, TriviaQA (fakty) 81, HumanEval (programowanie) 84.
+</a:t>
+            </a:r>
+          </a:p>
+          <a:p>
+            <a:r>
+              <a:rPr lang="pl-PL" sz="1400"/>
+              <a:t>• Przy pytaniach otwartych router myli się rzadziej, przy faktach i kodzie prawie za każdym razem, gdy pytanie jest trudne.
+</a:t>
+            </a:r>
+          </a:p>
+          <a:p>
+            <a:r>
+              <a:rPr lang="pl-PL" sz="1400"/>
+              <a:t>• Dlaczego: router widzi tylko tekst, a nie to, co wie mały model. Dwa pytania o fakty wyglądają podobnie, a mały zna odpowiedź na jedno i nie zna drugiej.
+</a:t>
+            </a:r>
+          </a:p>
+          <a:p>
+            <a:r>
+              <a:rPr lang="pl-PL" sz="1400"/>
+              <a:t>• Kod: tylko 18% zadań jest trudnych, więc sąsiedzi nowego zadania są zwykle łatwi, wynik jest niski i zadanie idzie do małego. Trudne wyglądają jak łatwe.
+</a:t>
+            </a:r>
+          </a:p>
+          <a:p>
+            <a:r>
+              <a:rPr lang="pl-PL" sz="1400"/>
+              <a:t>• To brak informacji w samym tekście, a nie błąd metody. Dlatego rozważam warstwę 3 (mały model może „czuć”, czy da radę). To hipoteza do sprawdzenia, nie obietnica.
 </a:t>
             </a:r>
           </a:p>
@@ -1163,7 +1205,7 @@
           <a:p>
             <a:r>
               <a:rPr lang="pl-PL" sz="1400"/>
-              <a:t>Próbki są małe: 42 pytania trudne z TriviaQA i 19 z HumanEval. Wnioski ostrożnie.
+              <a:t>• Próbki są małe: 42 pytania trudne z TriviaQA i 19 z HumanEval. Wnioski ostrożnie.
 </a:t>
             </a:r>
           </a:p>
@@ -1180,7 +1222,7 @@
           <a:p>
             <a:r>
               <a:rPr lang="pl-PL" sz="1400"/>
-              <a:t>Czemu zadania z kodu nie są częściej trudne? Mały model rozwiązuje 83% zadań, duży 94%. Różnica jest niewielka.</a:t>
+              <a:t>• Czemu zadania z kodu rzadko są trudne? Mały model rozwiązuje 83% zadań, duży 94%. Różnica jest niewielka.</a:t>
             </a:r>
           </a:p>
         </p:txBody>
@@ -1274,47 +1316,56 @@
           <a:p>
             <a:r>
               <a:rPr lang="pl-PL" sz="1400"/>
-              <a:t>Do tej pory wszystkie wyniki liczyłem na zapisanych danych. Teraz pokazuję pierwsze uruchomienie całego systemu na prawdziwych modelach: małym qwen3:8b, uruchomionym w programie Ollama, i dużym Qwen 27B, uruchomionym przez vLLM. Oba podłączone przez DeepFellow. Zrobiłem to 20 października na komputerze służbowym i wysłałem do modelu o nazwie router cztery pytania.
-</a:t>
-            </a:r>
-          </a:p>
-          <a:p>
-            <a:endParaRPr lang="pl-PL" sz="1400"/>
-          </a:p>
-          <a:p>
-            <a:r>
-              <a:rPr lang="pl-PL" sz="1400"/>
-              <a:t>Router dopisuje do każdej odpowiedzi trzy nagłówki: który model odpowiedział, która warstwa podjęła decyzję i jaki był wynik kNN, czyli ta liczba od 0 do 1 ze slajdu 9. Dzięki temu decyzję widać bez zaglądania do logów.
-</a:t>
-            </a:r>
-          </a:p>
-          <a:p>
-            <a:endParaRPr lang="pl-PL" sz="1400"/>
-          </a:p>
-          <a:p>
-            <a:r>
-              <a:rPr lang="pl-PL" sz="1400"/>
-              <a:t>Pierwsze pytanie, o stolicę Francji: wynik 0,19, poniżej progu 0,3, więc odpowiada mały model. Drugie, prośba o opowiadanie o smoku i rycerzu: wynik 0,70, powyżej progu, więc odpowiada duży i pisze całe opowiadanie. Trzecie to polecenie „przeanalizuj i porównaj dwa projekty, oceń kompromisy krok po kroku”. Zawiera pięć fraz z listy zadań trudnych, czyli pięć punktów heurystyk przy progu dwóch. Decyduje więc warstwa 1: pytanie idzie od razu do dużego i nawet nie liczę embeddingu, dlatego nie ma wyniku kNN. Przy opowiadaniu heurystyki dały tylko jeden punkt, więc decyzja przeszła do warstwy 2. Czwarte to mnożenie 17 razy 23 wysłane w trybie strumieniowym, czyli odpowiedź przychodzi kawałkami: wynik 0,10, odpowiada mały, a nagłówki z decyzją dochodzą przed pierwszym kawałkiem odpowiedzi.
-</a:t>
-            </a:r>
-          </a:p>
-          <a:p>
-            <a:endParaRPr lang="pl-PL" sz="1400"/>
-          </a:p>
-          <a:p>
-            <a:r>
-              <a:rPr lang="pl-PL" sz="1400"/>
-              <a:t>Potem zmierzyłem, ile czasu dokłada sam router. To samo proste pytanie wysłałem pięć razy przez router i pięć razy bezpośrednio do małego modelu. Średni czas to 0,376 s wobec 0,363 s, czyli router dodaje ok. 13 ms. Cel z planu to mniej niż 50 ms.
-</a:t>
-            </a:r>
-          </a:p>
-          <a:p>
-            <a:endParaRPr lang="pl-PL" sz="1400"/>
-          </a:p>
-          <a:p>
-            <a:r>
-              <a:rPr lang="pl-PL" sz="1400"/>
-              <a:t>Czego jeszcze nie sprawdziłem: przełączenia na duży model, gdy router ulegnie awarii, oraz tego, że po restarcie DeepFellow usługa wraca sama. To zrobię w następnej kolejności.
+              <a:t>• Pierwsze uruchomienie całego systemu na prawdziwych modelach: qwen3:8b (Ollama) i Qwen 27B (vLLM), oba przez DeepFellow. 20 października, komputer służbowy, 4 pytania do modelu router.
+</a:t>
+            </a:r>
+          </a:p>
+          <a:p>
+            <a:r>
+              <a:rPr lang="pl-PL" sz="1400"/>
+              <a:t>• Router dopisuje do odpowiedzi nagłówki: który model, która warstwa, wynik kNN (liczba 0–1 ze slajdu 9).
+</a:t>
+            </a:r>
+          </a:p>
+          <a:p>
+            <a:r>
+              <a:rPr lang="pl-PL" sz="1400"/>
+              <a:t>• Stolica Francji: wynik 0,19, poniżej progu 0,3, więc mały.
+</a:t>
+            </a:r>
+          </a:p>
+          <a:p>
+            <a:r>
+              <a:rPr lang="pl-PL" sz="1400"/>
+              <a:t>• Opowiadanie o smoku i rycerzu: wynik 0,70, więc duży. Heurystyki dały tylko 1 punkt, więc decyzja przeszła do warstwy 2.
+</a:t>
+            </a:r>
+          </a:p>
+          <a:p>
+            <a:r>
+              <a:rPr lang="pl-PL" sz="1400"/>
+              <a:t>• „Przeanalizuj i porównaj dwa projekty, oceń kompromisy krok po kroku”: 5 fraz z listy trudnych = 5 punktów przy progu 2. Decyduje warstwa 1, od razu duży, bez embeddingu, więc bez wyniku kNN.
+</a:t>
+            </a:r>
+          </a:p>
+          <a:p>
+            <a:r>
+              <a:rPr lang="pl-PL" sz="1400"/>
+              <a:t>• Mnożenie 17 razy 23 w trybie strumieniowym (odpowiedź przychodzi kawałkami): wynik 0,10, mały. Nagłówki dochodzą przed pierwszym kawałkiem odpowiedzi.
+</a:t>
+            </a:r>
+          </a:p>
+          <a:p>
+            <a:r>
+              <a:rPr lang="pl-PL" sz="1400"/>
+              <a:t>• Narzut routera: to samo proste pytanie 5 razy przez router i 5 razy bezpośrednio do małego. Średnio 0,376 s wobec 0,363 s, czyli ok. 13 ms. Cel z planu: poniżej 50 ms.
+</a:t>
+            </a:r>
+          </a:p>
+          <a:p>
+            <a:r>
+              <a:rPr lang="pl-PL" sz="1400"/>
+              <a:t>• Jeszcze nie sprawdzone: przełączenie na duży model przy awarii routera i to, czy po restarcie DeepFellow usługa wraca sama.
 </a:t>
             </a:r>
           </a:p>
@@ -1331,14 +1382,14 @@
           <a:p>
             <a:r>
               <a:rPr lang="pl-PL" sz="1400"/>
-              <a:t>Pięć pomiarów to mało, a czasy bezpośrednie wahają się o ok. 27 ms, czyli więcej niż sama różnica. Wniosek brzmi więc: narzut to kilka do kilkunastu milisekund i na pewno poniżej 50, a nie dokładnie 13.
-</a:t>
-            </a:r>
-          </a:p>
-          <a:p>
-            <a:r>
-              <a:rPr lang="pl-PL" sz="1400"/>
-              <a:t>Cztery pytania pokazują, że mechanizm działa. Nie mówią, jak dobrze router wybiera. Jakość wyboru pokazują wyniki na zbiorze danych z wcześniejszych slajdów.
+              <a:t>• 5 pomiarów to mało, a czasy bezpośrednie wahają się o ok. 27 ms, więcej niż sama różnica. Wniosek: narzut to kilka do kilkunastu ms i na pewno poniżej 50, a nie dokładnie 13.
+</a:t>
+            </a:r>
+          </a:p>
+          <a:p>
+            <a:r>
+              <a:rPr lang="pl-PL" sz="1400"/>
+              <a:t>• Cztery pytania pokazują, że mechanizm działa, a nie jak dobrze router wybiera. Jakość wyboru pokazują wyniki na zbiorze danych.
 </a:t>
             </a:r>
           </a:p>
@@ -1355,14 +1406,14 @@
           <a:p>
             <a:r>
               <a:rPr lang="pl-PL" sz="1400"/>
-              <a:t>Czemu to nie jest to samo co 20,6 ms z następnego slajdu? To dwa różne pomiary: tamten dotyczył samej decyzji routera na moim komputerze, bez DeepFellow, a ten całej drogi przez DeepFellow na komputerze służbowym, jako różnica czasów. Obie liczby są poniżej 50 ms.
-</a:t>
-            </a:r>
-          </a:p>
-          <a:p>
-            <a:r>
-              <a:rPr lang="pl-PL" sz="1400"/>
-              <a:t>Jak rozumieć wynik 0,19? Jako w przybliżeniu odsetek trudnych pytań wśród 20 podobnych z bazy, z większą wagą dla bardziej podobnych.</a:t>
+              <a:t>• Czemu to nie to samo co 20,6 ms z następnego slajdu? To dwa pomiary: tamten dotyczył samej decyzji routera na moim komputerze, bez DeepFellow. Ten całej drogi przez DeepFellow na komputerze służbowym, jako różnica czasów. Obie liczby są poniżej 50 ms.
+</a:t>
+            </a:r>
+          </a:p>
+          <a:p>
+            <a:r>
+              <a:rPr lang="pl-PL" sz="1400"/>
+              <a:t>• Jak rozumieć wynik 0,19? Mniej więcej jako odsetek trudnych wśród 20 podobnych pytań z bazy, z większą wagą dla bardziej podobnych.</a:t>
             </a:r>
           </a:p>
         </p:txBody>
@@ -1456,7 +1507,35 @@
           <a:p>
             <a:r>
               <a:rPr lang="pl-PL" sz="1400"/>
-              <a:t>Implementacja. Usługa RouterService działa w DeepFellow Infra w wersji 0.34. Napisałem 57 nowych testów, a cały zestaw testów (5157) przechodzi. Sprawdziłem ją od początku do końca na osobnej instancji z modelami Gemini: wybór modelu, nagłówki z decyzją, strumieniowanie i przełączenie na duży model przy błędzie (po angielsku fallback). Test wykrył błąd: wycofany model zwracał 404 jako zwykłą odpowiedź i omijał to przełączenie. Naprawiłem. Z modelami Qwen 8B i 27B uruchomiłem ją już na komputerze służbowym i pokazałem to na poprzednim slajdzie. Zostały dwa sprawdzenia: przełączenie na duży model przy awarii i restart usługi.
+              <a:t>• RouterService działa w DeepFellow Infra v0.34. 57 nowych testów, cały zestaw (5157) przechodzi.
+</a:t>
+            </a:r>
+          </a:p>
+          <a:p>
+            <a:r>
+              <a:rPr lang="pl-PL" sz="1400"/>
+              <a:t>• Sprawdziłem go od początku do końca na osobnej instancji z modelami Gemini: wybór modelu, nagłówki, strumieniowanie i przełączenie na duży model przy błędzie (po angielsku fallback). Test wykrył błąd: wycofany model zwracał 404 jako zwykłą odpowiedź i omijał przełączenie. Naprawiłem.
+</a:t>
+            </a:r>
+          </a:p>
+          <a:p>
+            <a:r>
+              <a:rPr lang="pl-PL" sz="1400"/>
+              <a:t>• Z modelami Qwen 8B i 27B uruchomiłem go już na komputerze służbowym (poprzedni slajd). Zostały awaria i restart.
+</a:t>
+            </a:r>
+          </a:p>
+          <a:p>
+            <a:r>
+              <a:rPr lang="pl-PL" sz="1400"/>
+              <a:t>• Czas: mediana 20,6 ms, 90% zapytań poniżej 65 ms (cel poniżej 50 ms spełniony dla mediany).
+</a:t>
+            </a:r>
+          </a:p>
+          <a:p>
+            <a:r>
+              <a:rPr lang="pl-PL" sz="1400"/>
+              <a:t>• Odporność: po literówkach, parafrazach i synonimach decyzja zmienia się tylko w 6–10% pytań (losowo byłoby 42–48%).
 </a:t>
             </a:r>
           </a:p>
@@ -1465,18 +1544,43 @@
           </a:p>
           <a:p>
             <a:r>
-              <a:rPr lang="pl-PL" sz="1400"/>
-              <a:t>Sprawdziłem też dwie rzeczy. Czas: mediana 20,6 ms, a 90% zapytań w mniej niż 65 ms (cel poniżej 50 ms spełniony dla mediany). Odporność: po literówkach, parafrazach i zamianie na synonimy decyzja zmienia się tylko w 6–10% pytań. Losowo byłoby 42–48%. Router nie jest więc wrażliwy na drobne zmiany sformułowania.
-</a:t>
-            </a:r>
-          </a:p>
-          <a:p>
-            <a:endParaRPr lang="pl-PL" sz="1400"/>
-          </a:p>
-          <a:p>
-            <a:r>
-              <a:rPr lang="pl-PL" sz="1400"/>
-              <a:t>Ograniczenia, które nazywam wprost. Jedna para modeli. Jeden sędzia, a zgodność z człowiekiem jest umiarkowana. Duży model ma jedną próbkę na pytanie. Dane są mało „firmowe”: 63% to publiczne czaty. Wiedza i kod są słabo wykrywane. Warstwa 1 (heurystyki) jest na naszych danych słaba (AUROC ok. 0,55), dlatego jest opcjonalna. Możliwe, że na danych firmowych wypadnie lepiej, ale to hipoteza do sprawdzenia.
+              <a:rPr lang="pl-PL" sz="1400" b="1"/>
+              <a:t>OGRANICZENIA
+</a:t>
+            </a:r>
+          </a:p>
+          <a:p>
+            <a:r>
+              <a:rPr lang="pl-PL" sz="1400"/>
+              <a:t>• Jedna para modeli i jeden sędzia (zgodność z człowiekiem umiarkowana).
+</a:t>
+            </a:r>
+          </a:p>
+          <a:p>
+            <a:r>
+              <a:rPr lang="pl-PL" sz="1400"/>
+              <a:t>• Duży model ma jedną próbkę na pytanie.
+</a:t>
+            </a:r>
+          </a:p>
+          <a:p>
+            <a:r>
+              <a:rPr lang="pl-PL" sz="1400"/>
+              <a:t>• Dane mało „firmowe”: 63% to publiczne czaty.
+</a:t>
+            </a:r>
+          </a:p>
+          <a:p>
+            <a:r>
+              <a:rPr lang="pl-PL" sz="1400"/>
+              <a:t>• Wiedza i kod są słabo wykrywane.
+</a:t>
+            </a:r>
+          </a:p>
+          <a:p>
+            <a:r>
+              <a:rPr lang="pl-PL" sz="1400"/>
+              <a:t>• Warstwa 1 jest na naszych danych słaba (AUROC ok. 0,55), dlatego opcjonalna. Na danych firmowych może wypaść lepiej, ale to hipoteza do sprawdzenia.
 </a:t>
             </a:r>
           </a:p>
@@ -1493,7 +1597,7 @@
           <a:p>
             <a:r>
               <a:rPr lang="pl-PL" sz="1400"/>
-              <a:t>Czy zadziała na innych modelach? Router tak, ale etykiety trzeba zmierzyć od nowa: ok. 1,5 doby generowania i ok. 8 USD za sędziego.</a:t>
+              <a:t>• Czy zadziała na innych modelach? Router tak, ale etykiety trzeba zmierzyć od nowa: ok. 1,5 doby generowania i ok. 8 USD za sędziego.</a:t>
             </a:r>
           </a:p>
         </p:txBody>
@@ -1587,7 +1691,21 @@
           <a:p>
             <a:r>
               <a:rPr lang="pl-PL" sz="1400"/>
-              <a:t>Najsłabsza strona moich danych jest taka, że niewiele przypominają zwykłe użycie w firmie. 63% to publiczne czaty z Areny i WildChat, w dużej części zabawa i fikcja literacka. Reszta to znane testy. Brakuje poleceń biurowych, zadań z bazami danych i prawdziwego kodu pisanego przez programistów. Przez to router słabo wykrywa trudny kod, a heurystyki z warstwy 1 mogły wypaść gorzej, niż wypadną na danych z firmy. To jest hipoteza do sprawdzenia, a nie wynik.
+              <a:t>• Najsłabsza strona danych: niewiele przypominają użycie w firmie. 63% to publiczne czaty (Arena, WildChat), w dużej części zabawa i fikcja. Reszta to znane testy. Brakuje poleceń biurowych, SQL i prawdziwego kodu.
+</a:t>
+            </a:r>
+          </a:p>
+          <a:p>
+            <a:r>
+              <a:rPr lang="pl-PL" sz="1400"/>
+              <a:t>• Hipoteza, nie wynik: przez to router słabo wykrywa trudny kod, a heurystyki mogły wypaść gorzej niż na danych z firmy.
+</a:t>
+            </a:r>
+          </a:p>
+          <a:p>
+            <a:r>
+              <a:rPr lang="pl-PL" sz="1400"/>
+              <a:t>• Po prezentacji dołożę dane z publicznych zbiorów. Cztery kandydatki, ostateczny wybór przed pomiarem.
 </a:t>
             </a:r>
           </a:p>
@@ -1596,8 +1714,36 @@
           </a:p>
           <a:p>
             <a:r>
-              <a:rPr lang="pl-PL" sz="1400"/>
-              <a:t>Dlatego po prezentacji chcę dołożyć dane z innych publicznych zbiorów. Pokazuję cztery kandydatki. Licencje sprawdziłem na kartach zbiorów: Dolly ma CC BY-SA 3.0, CodeChat ODC-By, Spider CC BY-SA 4.0, a Arena 140k CC BY 4.0 dla promptów. Dwie z nich, Dolly i Spider, to licencje typu ShareAlike, czyli z warunkiem zachowania tej samej licencji. Opiszę to w pracy. Używam tylko promptów, a odpowiedzi generują moje modele, więc warunki dotyczące odpowiedzi modeli w Arenie mnie nie obejmują. Ostateczny wybór zrobię przed pomiarem.
+              <a:rPr lang="pl-PL" sz="1400" b="1"/>
+              <a:t>ZBIORY (LICENCJE SPRAWDZONE NA KARTACH)
+</a:t>
+            </a:r>
+          </a:p>
+          <a:p>
+            <a:r>
+              <a:rPr lang="pl-PL" sz="1400"/>
+              <a:t>• Dolly (CC BY-SA 3.0): ok. 15 tys. poleceń napisanych przez pracowników Databricks (streszczanie, wyciąganie informacji, pytania zamknięte). Najbliższe użyciu w firmie. Część ma fragmenty Wikipedii, usunę z nich numery przypisów.
+</a:t>
+            </a:r>
+          </a:p>
+          <a:p>
+            <a:r>
+              <a:rPr lang="pl-PL" sz="1400"/>
+              <a:t>• CodeChat (ODC-By): ok. 83 tys. prawdziwych rozmów programistów z modelami, ponad 20 języków programowania. To część WildChat, więc usunę powtórzenia.
+</a:t>
+            </a:r>
+          </a:p>
+          <a:p>
+            <a:r>
+              <a:rPr lang="pl-PL" sz="1400"/>
+              <a:t>• Spider (CC BY-SA 4.0): ok. 8 tys. pytań do baz danych z odpowiedzią w SQL (język zapytań do baz). Nowy rodzaj zadań. Pytania napisało 11 studentów Yale, nie prawdziwi użytkownicy. Najdroższy w ocenie, bo trzeba uruchamiać zapytania na bazach.
+</a:t>
+            </a:r>
+          </a:p>
+          <a:p>
+            <a:r>
+              <a:rPr lang="pl-PL" sz="1400"/>
+              <a:t>• Arena 140k (CC BY 4.0 dla promptów): ok. 135 tys. prawdziwych rozmów na wielu tematach i w wielu językach, ze znacznikiem „kod”. Część pytań z Areny już mam, więc sprawdzę powtórzenia.
 </a:t>
             </a:r>
           </a:p>
@@ -1606,48 +1752,29 @@
           </a:p>
           <a:p>
             <a:r>
-              <a:rPr lang="pl-PL" sz="1400"/>
-              <a:t>Pierwsza to Dolly, około 15 tysięcy poleceń napisanych przez pracowników firmy Databricks: streszczanie tekstu, wyciąganie informacji, pytania zamknięte, burza mózgów. To najbliższe temu, o co ktoś mógłby pytać asystenta w firmie. Część poleceń ma dołączone fragmenty Wikipedii, z których usunę numery przypisów.
-</a:t>
-            </a:r>
-          </a:p>
-          <a:p>
-            <a:endParaRPr lang="pl-PL" sz="1400"/>
-          </a:p>
-          <a:p>
-            <a:r>
-              <a:rPr lang="pl-PL" sz="1400"/>
-              <a:t>Druga to CodeChat, około 83 tysięcy prawdziwych rozmów programistów z modelami językowymi, w ponad dwudziestu językach programowania. Dałaby dużo więcej prawdziwego kodu niż dzisiejsze zadania z jednego zbioru, HumanEval. To część zbioru WildChat, który już mam, więc najpierw usunę powtórzenia.
-</a:t>
-            </a:r>
-          </a:p>
-          <a:p>
-            <a:endParaRPr lang="pl-PL" sz="1400"/>
-          </a:p>
-          <a:p>
-            <a:r>
-              <a:rPr lang="pl-PL" sz="1400"/>
-              <a:t>Trzecia to Spider, około 8 tysięcy pytań zadawanych bazom danych po angielsku, do których trzeba napisać zapytanie w języku SQL. SQL to język, którym pyta się bazy danych. To nowy rodzaj zadań, typowy dla firm. Pytania napisało 11 studentów uniwersytetu Yale, więc nie są to zapytania prawdziwych użytkowników. Jest najdroższy w ocenie, bo żeby sprawdzić wynik automatem, trzeba uruchamiać zapytania na bazach.
-</a:t>
-            </a:r>
-          </a:p>
-          <a:p>
-            <a:endParaRPr lang="pl-PL" sz="1400"/>
-          </a:p>
-          <a:p>
-            <a:r>
-              <a:rPr lang="pl-PL" sz="1400"/>
-              <a:t>Czwarta to Arena 140k, około 135 tysięcy prawdziwych rozmów z Areny, na wielu tematach i w wielu językach, ze znacznikiem, które dotyczą kodu. Daje więcej różnych pytań. Część pytań z Areny już mam, więc też sprawdzę powtórzenia.
-</a:t>
-            </a:r>
-          </a:p>
-          <a:p>
-            <a:endParaRPr lang="pl-PL" sz="1400"/>
-          </a:p>
-          <a:p>
-            <a:r>
-              <a:rPr lang="pl-PL" sz="1400"/>
-              <a:t>Co trzeba zrobić z każdym zbiorem: tak jak z poprzednimi, wysłać pytania do obu modeli (mały trzy razy, duży raz), ocenić odpowiedzi sędzią i policzyć różnicę Δ. Dopiero wtedy pytania dostają etykiety. Zbiór testowy zostaje zamknięty, nowe dane trafią tylko do części do nauki i dostrajania. Koszt sędziego to moje oszacowanie: ok. 1 dolar na 500 pytań, na podstawie dotychczasowych ok. 8 dolarów za całość. Płatne wywołania zrobię dopiero za zgodą na konkretną kwotę.
+              <a:rPr lang="pl-PL" sz="1400" b="1"/>
+              <a:t>CO Z KAŻDYM ZBIOREM
+</a:t>
+            </a:r>
+          </a:p>
+          <a:p>
+            <a:r>
+              <a:rPr lang="pl-PL" sz="1400"/>
+              <a:t>• Tak jak z poprzednimi: odpowiedzi obu modeli (mały 3 razy, duży raz), sędzia, Δ. Zbiór testowy zostaje zamknięty, nowe dane trafią tylko do nauki i dostrajania.
+</a:t>
+            </a:r>
+          </a:p>
+          <a:p>
+            <a:r>
+              <a:rPr lang="pl-PL" sz="1400"/>
+              <a:t>• Koszt sędziego (moje oszacowanie): ok. 1 USD na 500 pytań, z ok. 8 USD za całość. Płatne wywołania dopiero za zgodą na konkretną kwotę.
+</a:t>
+            </a:r>
+          </a:p>
+          <a:p>
+            <a:r>
+              <a:rPr lang="pl-PL" sz="1400"/>
+              <a:t>• Licencje ShareAlike (Dolly, Spider) wymagają zachowania tej samej licencji, opiszę to w pracy. Używam tylko promptów, więc warunki dotyczące odpowiedzi modeli (Arena) mnie nie obejmują.
 </a:t>
             </a:r>
           </a:p>
@@ -1664,7 +1791,7 @@
           <a:p>
             <a:r>
               <a:rPr lang="pl-PL" sz="1400"/>
-              <a:t>To jest plan, nic z tego jeszcze nie zrobiłem. Nie wiem, czy nowe dane poprawią router. Wiem tylko, że obecne nie pokazują zwykłego użycia w firmie, więc ich uzupełnienie jest uzasadnione.
+              <a:t>• To plan, nic z tego jeszcze nie zrobiłem. Nie wiem, czy nowe dane poprawią router.
 </a:t>
             </a:r>
           </a:p>
@@ -1681,35 +1808,35 @@
           <a:p>
             <a:r>
               <a:rPr lang="pl-PL" sz="1400"/>
-              <a:t>Czy jest zbiór prawdziwych zapytań firmowych? Nie znalazłem go w otwartych zbiorach. Najbliższy jest Dolly, pisany przez pracowników firmy.
-</a:t>
-            </a:r>
-          </a:p>
-          <a:p>
-            <a:r>
-              <a:rPr lang="pl-PL" sz="1400"/>
-              <a:t>Dlaczego nie Bitext, czyli zbiór pytań do obsługi klienta? Jest syntetyczny i szablonowy, więc pewnie prawie same pytania łatwe i bardzo do siebie podobne. Nic by nie powiedział o prawdziwym ruchu.
-</a:t>
-            </a:r>
-          </a:p>
-          <a:p>
-            <a:r>
-              <a:rPr lang="pl-PL" sz="1400"/>
-              <a:t>Dlaczego nie LMSYS-Chat-1M? Wymaga zgody na dostęp. Odrzuciłem go wcześniej.
-</a:t>
-            </a:r>
-          </a:p>
-          <a:p>
-            <a:r>
-              <a:rPr lang="pl-PL" sz="1400"/>
-              <a:t>Dlaczego nie RouterBench, zbiór do badań nad routingiem? Na jego karcie nie ma licencji, a pytania pochodzą ze znanych testów, więc nie dodałby nowych rodzajów pytań.
-</a:t>
-            </a:r>
-          </a:p>
-          <a:p>
-            <a:r>
-              <a:rPr lang="pl-PL" sz="1400"/>
-              <a:t>A licencje? Sprawdziłem je na kartach zbiorów: Dolly CC BY-SA 3.0, CodeChat ODC-By, Spider CC BY-SA 4.0, Arena 140k CC BY 4.0 dla promptów. Dolly i Spider mają ShareAlike, co opiszę w pracy. Prawnej interpretacji nie robiłem, karty podają same licencje. Nie sprawdziłem oficjalnej strony Spider poza kartą.</a:t>
+              <a:t>• Czy jest zbiór prawdziwych zapytań firmowych? Nie znalazłem w otwartych zbiorach. Najbliższy jest Dolly.
+</a:t>
+            </a:r>
+          </a:p>
+          <a:p>
+            <a:r>
+              <a:rPr lang="pl-PL" sz="1400"/>
+              <a:t>• Dlaczego nie Bitext (obsługa klienta)? Jest syntetyczny i szablonowy, pewnie prawie same pytania łatwe i bardzo podobne.
+</a:t>
+            </a:r>
+          </a:p>
+          <a:p>
+            <a:r>
+              <a:rPr lang="pl-PL" sz="1400"/>
+              <a:t>• Dlaczego nie LMSYS-Chat-1M? Wymaga zgody na dostęp. Odrzuciłem go wcześniej.
+</a:t>
+            </a:r>
+          </a:p>
+          <a:p>
+            <a:r>
+              <a:rPr lang="pl-PL" sz="1400"/>
+              <a:t>• Dlaczego nie RouterBench? Na jego karcie nie ma licencji, a pytania pochodzą ze znanych testów, więc nie dodaje nowych rodzajów.
+</a:t>
+            </a:r>
+          </a:p>
+          <a:p>
+            <a:r>
+              <a:rPr lang="pl-PL" sz="1400"/>
+              <a:t>• Licencje: interpretacji prawnej nie robiłem, karty podają same licencje. Oficjalnej strony Spider poza kartą nie sprawdzałem.</a:t>
             </a:r>
           </a:p>
         </p:txBody>
@@ -1796,14 +1923,35 @@
           <a:p>
             <a:r>
               <a:rPr lang="pl-PL" sz="1400" b="1"/>
-              <a:t>MÓW
-</a:t>
-            </a:r>
-          </a:p>
-          <a:p>
-            <a:r>
-              <a:rPr lang="pl-PL" sz="1400"/>
-              <a:t>Co dalej. Po pierwsze, dokończyć test z modelami Qwen 8B i 27B na komputerze służbowym: awaria i restart usługi, a opóźnienie zmierzyć dokładniej, na większej liczbie pomiarów. Po drugie, sprawdzić warstwę 3 (test go/no-go): czy mały model oceniający pytanie poprawia wynik routera, i to tylko w strefie niepewności, czyli tam, gdzie warstwa 2 nie jest pewna. Granice strefy dobiorę tak, żeby jakość nie spadła poniżej ustalonego poziomu, który jeszcze trzeba ustalić. Po trzecie, dodać dane bliższe wdrożeniu, czyli te zbiory, które pokazałem na poprzednim slajdzie: polecenia biurowe, prawdziwy kod i zadania SQL. To wymaga ponownego pomiaru, ale pozwoli też sprawdzić, czy heurystyki warstwy 1 działają lepiej na takich danych. Po czwarte, otworzyć zbiór testowy raz i zrobić ocenę końcową.
+              <a:t>PLAN
+</a:t>
+            </a:r>
+          </a:p>
+          <a:p>
+            <a:r>
+              <a:rPr lang="pl-PL" sz="1400"/>
+              <a:t>• 1. Dokończyć test z modelami Qwen 8B i 27B na komputerze służbowym: awaria i restart usługi, a opóźnienie zmierzyć dokładniej, na większej liczbie pomiarów.
+</a:t>
+            </a:r>
+          </a:p>
+          <a:p>
+            <a:r>
+              <a:rPr lang="pl-PL" sz="1400"/>
+              <a:t>• 2. Sprawdzić warstwę 3 (test go/no-go): czy mały model oceniający pytanie poprawia router, i to tylko w strefie niepewności, czyli tam, gdzie warstwa 2 nie jest pewna. Granice strefy dobiorę tak, by jakość nie spadła poniżej ustalonego poziomu (jeszcze do ustalenia).
+</a:t>
+            </a:r>
+          </a:p>
+          <a:p>
+            <a:r>
+              <a:rPr lang="pl-PL" sz="1400"/>
+              <a:t>• 3. Dodać dane bliższe wdrożeniu z poprzedniego slajdu (polecenia biurowe, kod, SQL). Wymaga to ponownego pomiaru, ale pozwoli też sprawdzić, czy heurystyki działają lepiej na takich danych.
+</a:t>
+            </a:r>
+          </a:p>
+          <a:p>
+            <a:r>
+              <a:rPr lang="pl-PL" sz="1400"/>
+              <a:t>• 4. Otworzyć zbiór testowy raz i zrobić ocenę końcową.
 </a:t>
             </a:r>
           </a:p>
@@ -1812,8 +1960,15 @@
           </a:p>
           <a:p>
             <a:r>
-              <a:rPr lang="pl-PL" sz="1400"/>
-              <a:t>Prośba. Proszę o zatwierdzenie celów liczbowych przed otwarciem testu. Po otwarciu nie będę ich zmieniał, a wyniki podam niezależnie od tego, czy cele są spełnione. To zabezpiecza przed dopasowaniem wymagań do wyniku.
+              <a:rPr lang="pl-PL" sz="1400" b="1"/>
+              <a:t>PROŚBA
+</a:t>
+            </a:r>
+          </a:p>
+          <a:p>
+            <a:r>
+              <a:rPr lang="pl-PL" sz="1400"/>
+              <a:t>• Proszę o zatwierdzenie celów liczbowych przed otwarciem testu. Po otwarciu ich nie zmieniam, a wyniki podam niezależnie od tego, czy cele są spełnione. To zabezpiecza przed dopasowaniem wymagań do wyniku.
 </a:t>
             </a:r>
           </a:p>
@@ -1822,50 +1977,50 @@
           </a:p>
           <a:p>
             <a:r>
-              <a:rPr lang="pl-PL" sz="1400"/>
-              <a:t>Moja propozycja celów:
-</a:t>
-            </a:r>
-          </a:p>
-          <a:p>
-            <a:r>
-              <a:rPr lang="pl-PL" sz="1400"/>
-              <a:t>• router lepszy od „samego źródła” w sposób istotny statystycznie,
-</a:t>
-            </a:r>
-          </a:p>
-          <a:p>
-            <a:r>
-              <a:rPr lang="pl-PL" sz="1400"/>
-              <a:t>• AUROC co najmniej 0,64 (w badaniach 0,68),
-</a:t>
-            </a:r>
-          </a:p>
-          <a:p>
-            <a:r>
-              <a:rPr lang="pl-PL" sz="1400"/>
-              <a:t>• żeby odzyskać 80% możliwego zysku jakości, wysyłam do dużego nie więcej niż 72% pytań (losowo byłoby 80%),
-</a:t>
-            </a:r>
-          </a:p>
-          <a:p>
-            <a:r>
-              <a:rPr lang="pl-PL" sz="1400"/>
-              <a:t>• po literówkach i parafrazach decyzja zmienia się w najwyżej 15% pytań,
-</a:t>
-            </a:r>
-          </a:p>
-          <a:p>
-            <a:r>
-              <a:rPr lang="pl-PL" sz="1400"/>
-              <a:t>• mediana czasu decyzji poniżej 50 ms,
-</a:t>
-            </a:r>
-          </a:p>
-          <a:p>
-            <a:r>
-              <a:rPr lang="pl-PL" sz="1400"/>
-              <a:t>• pytania spoza dziedziny (MMLU, MT-Bench) tylko raportuję, bez progu.
+              <a:rPr lang="pl-PL" sz="1400" b="1"/>
+              <a:t>PROPOZYCJA CELÓW
+</a:t>
+            </a:r>
+          </a:p>
+          <a:p>
+            <a:r>
+              <a:rPr lang="pl-PL" sz="1400"/>
+              <a:t>• Router lepszy od „samego źródła” w sposób istotny statystycznie.
+</a:t>
+            </a:r>
+          </a:p>
+          <a:p>
+            <a:r>
+              <a:rPr lang="pl-PL" sz="1400"/>
+              <a:t>• AUROC co najmniej 0,64 (w badaniach 0,68).
+</a:t>
+            </a:r>
+          </a:p>
+          <a:p>
+            <a:r>
+              <a:rPr lang="pl-PL" sz="1400"/>
+              <a:t>• Żeby odzyskać 80% możliwego zysku jakości, wysyłam do dużego nie więcej niż 72% pytań (losowo byłoby 80%).
+</a:t>
+            </a:r>
+          </a:p>
+          <a:p>
+            <a:r>
+              <a:rPr lang="pl-PL" sz="1400"/>
+              <a:t>• Po literówkach i parafrazach decyzja zmienia się w najwyżej 15% pytań.
+</a:t>
+            </a:r>
+          </a:p>
+          <a:p>
+            <a:r>
+              <a:rPr lang="pl-PL" sz="1400"/>
+              <a:t>• Mediana czasu decyzji poniżej 50 ms.
+</a:t>
+            </a:r>
+          </a:p>
+          <a:p>
+            <a:r>
+              <a:rPr lang="pl-PL" sz="1400"/>
+              <a:t>• Pytania spoza dziedziny (MMLU, MT-Bench) tylko raportuję, bez progu.
 </a:t>
             </a:r>
           </a:p>
@@ -1874,8 +2029,29 @@
           </a:p>
           <a:p>
             <a:r>
-              <a:rPr lang="pl-PL" sz="1400"/>
-              <a:t>Podsumowanie. Etykiety mierzę z prawdziwych odpowiedzi modeli. Router oparty na podobieństwie pytań daje realny, ale umiarkowany zysk, jest szybki i stabilny. Nie przewidzi tylko tego, czy mały model zna konkretny fakt.</a:t>
+              <a:rPr lang="pl-PL" sz="1400" b="1"/>
+              <a:t>PODSUMOWANIE
+</a:t>
+            </a:r>
+          </a:p>
+          <a:p>
+            <a:r>
+              <a:rPr lang="pl-PL" sz="1400"/>
+              <a:t>• Etykiety mierzę z prawdziwych odpowiedzi modeli.
+</a:t>
+            </a:r>
+          </a:p>
+          <a:p>
+            <a:r>
+              <a:rPr lang="pl-PL" sz="1400"/>
+              <a:t>• Router oparty na podobieństwie pytań daje realny, ale umiarkowany zysk, jest szybki i stabilny.
+</a:t>
+            </a:r>
+          </a:p>
+          <a:p>
+            <a:r>
+              <a:rPr lang="pl-PL" sz="1400"/>
+              <a:t>• Nie przewidzi tylko tego, czy mały model zna konkretny fakt.</a:t>
             </a:r>
           </a:p>
         </p:txBody>
@@ -1969,47 +2145,35 @@
           <a:p>
             <a:r>
               <a:rPr lang="pl-PL" sz="1400"/>
-              <a:t>Duży model daje lepsze odpowiedzi, ale jest wolniejszy i potrzebuje mocniejszego sprzętu. Mały jest szybki, ale przy trudnych pytaniach bywa słaby.
-</a:t>
-            </a:r>
-          </a:p>
-          <a:p>
-            <a:endParaRPr lang="pl-PL" sz="1400"/>
-          </a:p>
-          <a:p>
-            <a:r>
-              <a:rPr lang="pl-PL" sz="1400"/>
-              <a:t>Administrator ma dziś dwa wyjścia. Wszystko do dużego modelu: drogo. Wszystko do małego: gorsza jakość tam, gdzie była potrzebna.
-</a:t>
-            </a:r>
-          </a:p>
-          <a:p>
-            <a:endParaRPr lang="pl-PL" sz="1400"/>
-          </a:p>
-          <a:p>
-            <a:r>
-              <a:rPr lang="pl-PL" sz="1400"/>
-              <a:t>Router ma wybierać osobno dla każdego pytania: proste do małego (qwen3:8b), trudne do dużego (Qwen 27B). Na rysunku pytanie wchodzi do routera i idzie w jedną z dwóch stron. Dla użytkownika nic się nie zmienia: w DeepFellow to po prostu model o nazwie router.
-</a:t>
-            </a:r>
-          </a:p>
-          <a:p>
-            <a:endParaRPr lang="pl-PL" sz="1400"/>
-          </a:p>
-          <a:p>
-            <a:r>
-              <a:rPr lang="pl-PL" sz="1400"/>
-              <a:t>Trudność jest taka: router musi zdecydować, zanim jakikolwiek model odpowie. Widzi więc tylko treść pytania. Cała praca jest o tym, ile można o trudności pytania wywnioskować z samego jego tekstu.
-</a:t>
-            </a:r>
-          </a:p>
-          <a:p>
-            <a:endParaRPr lang="pl-PL" sz="1400"/>
-          </a:p>
-          <a:p>
-            <a:r>
-              <a:rPr lang="pl-PL" sz="1400"/>
-              <a:t>Cel: jak najwięcej pytań do małego modelu przy prawie niezmienionej jakości.
+              <a:t>• Duży model: lepsze odpowiedzi, ale wolniejszy i wymaga mocniejszego sprzętu. Mały: szybki, ale słabszy przy trudnych pytaniach.
+</a:t>
+            </a:r>
+          </a:p>
+          <a:p>
+            <a:r>
+              <a:rPr lang="pl-PL" sz="1400"/>
+              <a:t>• Dziś administrator ma dwa wyjścia: wszystko do dużego (drogo) albo wszystko do małego (gorsza jakość tam, gdzie była potrzebna).
+</a:t>
+            </a:r>
+          </a:p>
+          <a:p>
+            <a:r>
+              <a:rPr lang="pl-PL" sz="1400"/>
+              <a:t>• Router wybiera osobno dla każdego pytania: proste do małego (qwen3:8b), trudne do dużego (Qwen 27B). Na rysunku pytanie wchodzi do routera i idzie w jedną z dwóch stron. Dla użytkownika to po prostu model o nazwie router.
+</a:t>
+            </a:r>
+          </a:p>
+          <a:p>
+            <a:r>
+              <a:rPr lang="pl-PL" sz="1400"/>
+              <a:t>• Trudność: router decyduje, zanim model odpowie, więc widzi tylko tekst pytania. Praca sprawdza, ile o trudności da się wywnioskować z samego tekstu.
+</a:t>
+            </a:r>
+          </a:p>
+          <a:p>
+            <a:r>
+              <a:rPr lang="pl-PL" sz="1400"/>
+              <a:t>• Cel: jak najwięcej pytań do małego modelu przy prawie niezmienionej jakości.
 </a:t>
             </a:r>
           </a:p>
@@ -2026,7 +2190,7 @@
           <a:p>
             <a:r>
               <a:rPr lang="pl-PL" sz="1400"/>
-              <a:t>Dlaczego nie zawsze duży model? Bo to najdroższe rozwiązanie. Pokażę, ile da się zaoszczędzić i jakim kosztem.</a:t>
+              <a:t>• Dlaczego nie zawsze duży? To najdroższe rozwiązanie. Pokażę, ile da się zaoszczędzić i jakim kosztem.</a:t>
             </a:r>
           </a:p>
         </p:txBody>
@@ -2120,7 +2284,28 @@
           <a:p>
             <a:r>
               <a:rPr lang="pl-PL" sz="1400"/>
-              <a:t>Zacznę od tego, jak wyglądała pierwsza wersja pracy.
+              <a:t>• Etykiety (pytanie łatwe lub trudne) brałem z gotowych danych: z głosowań w Chatbot Arena (ludzie wybierają lepszą z dwóch odpowiedzi) i z pytań wygenerowanych przez Gemini.
+</a:t>
+            </a:r>
+          </a:p>
+          <a:p>
+            <a:r>
+              <a:rPr lang="pl-PL" sz="1400"/>
+              <a:t>• Plan miał trzy warstwy (heurystyki, porównanie z podobnymi pytaniami, mały model), konfigurację w YAML, kategorie tematyczne i podział złożonych zadań na części (Map-Reduce).
+</a:t>
+            </a:r>
+          </a:p>
+          <a:p>
+            <a:r>
+              <a:rPr lang="pl-PL" sz="1400"/>
+              <a:t>• Odpowiedzi miałem oceniać m.in. miarą ROUGE.
+</a:t>
+            </a:r>
+          </a:p>
+          <a:p>
+            <a:r>
+              <a:rPr lang="pl-PL" sz="1400"/>
+              <a:t>• Plan był rozsądny, bo RouteLLM uczy się na głosach z Areny. Miał jednak jeden słaby punkt, pokazany na następnym slajdzie.
 </a:t>
             </a:r>
           </a:p>
@@ -2129,38 +2314,26 @@
           </a:p>
           <a:p>
             <a:r>
-              <a:rPr lang="pl-PL" sz="1400"/>
-              <a:t>Informację, że pytanie jest łatwe albo trudne, czyli etykietę, brałem z gotowych danych: z głosowań w Chatbot Arena, gdzie ludzie wybierają lepszą z dwóch odpowiedzi, oraz z pytań wygenerowanych przez Gemini.
-</a:t>
-            </a:r>
-          </a:p>
-          <a:p>
-            <a:endParaRPr lang="pl-PL" sz="1400"/>
-          </a:p>
-          <a:p>
-            <a:r>
-              <a:rPr lang="pl-PL" sz="1400"/>
-              <a:t>Plan miał też trzy warstwy rozpoznawania trudności: proste heurystyki, porównanie z podobnymi pytaniami i mały model. Do tego konfigurację w pliku YAML, kategorie tematyczne i podział złożonych zadań na części (Map-Reduce). Odpowiedzi miałem oceniać między innymi miarą ROUGE.
-</a:t>
-            </a:r>
-          </a:p>
-          <a:p>
-            <a:endParaRPr lang="pl-PL" sz="1400"/>
-          </a:p>
-          <a:p>
-            <a:r>
-              <a:rPr lang="pl-PL" sz="1400"/>
-              <a:t>ROUGE liczy, ile słów wspólnych ma odpowiedź modelu z odpowiedzią wzorcową. Zrezygnowałem z niej, bo zbieżność słów nie mówi, czy odpowiedź jest poprawna: dobra odpowiedź może być napisana innymi słowami, a zła może mieć wiele wspólnych.
-</a:t>
-            </a:r>
-          </a:p>
-          <a:p>
-            <a:endParaRPr lang="pl-PL" sz="1400"/>
-          </a:p>
-          <a:p>
-            <a:r>
-              <a:rPr lang="pl-PL" sz="1400"/>
-              <a:t>To był rozsądny plan, bo opierał się na literaturze: znany system RouteLLM uczy się właśnie na głosach z Areny. Miał jednak jeden słaby punkt. Pokazuję go na następnym slajdzie.</a:t>
+              <a:rPr lang="pl-PL" sz="1400" b="1"/>
+              <a:t>DEFINICJE
+</a:t>
+            </a:r>
+          </a:p>
+          <a:p>
+            <a:r>
+              <a:rPr lang="pl-PL" sz="1400" b="1"/>
+              <a:t>ROUGE: </a:t>
+            </a:r>
+            <a:r>
+              <a:rPr lang="pl-PL" sz="1400"/>
+              <a:t>liczy, ile słów wspólnych ma odpowiedź modelu z odpowiedzią wzorcową.
+</a:t>
+            </a:r>
+          </a:p>
+          <a:p>
+            <a:r>
+              <a:rPr lang="pl-PL" sz="1400"/>
+              <a:t>• Zrezygnowałem z niej, bo zbieżność słów nie mówi o poprawności: dobra odpowiedź może być napisana innymi słowami, a zła może mieć wiele wspólnych.</a:t>
             </a:r>
           </a:p>
         </p:txBody>
@@ -2254,7 +2427,42 @@
           <a:p>
             <a:r>
               <a:rPr lang="pl-PL" sz="1400"/>
-              <a:t>Sprawdziłem, czy etykiety z Areny pasują do moich dwóch modeli.
+              <a:t>• Sprawdziłem, czy stare etykiety z Areny pasują do moich dwóch modeli.
+</a:t>
+            </a:r>
+          </a:p>
+          <a:p>
+            <a:r>
+              <a:rPr lang="pl-PL" sz="1400"/>
+              <a:t>• Stara etykieta: pytanie jest „trudne”, jeśli w głosowaniu wygrał mocniejszy model.
+</a:t>
+            </a:r>
+          </a:p>
+          <a:p>
+            <a:r>
+              <a:rPr lang="pl-PL" sz="1400"/>
+              <a:t>• Dla moich dwóch modeli zmierzyłem osobno, o ile duży jest lepszy od małego na każdym pytaniu (jak dokładnie, na następnym slajdzie).
+</a:t>
+            </a:r>
+          </a:p>
+          <a:p>
+            <a:r>
+              <a:rPr lang="pl-PL" sz="1400"/>
+              <a:t>• Porównanie dla 1723 pytań: AUROC = 0,55, czyli prawie rzut monetą (0,5).
+</a:t>
+            </a:r>
+          </a:p>
+          <a:p>
+            <a:r>
+              <a:rPr lang="pl-PL" sz="1400"/>
+              <a:t>• Dlaczego: Arena porównywała inne modele z innej epoki. Gdy gpt-4 wygrywa ze słabym modelem, to bez względu na pytanie. Stara etykieta mówi więcej o różnicy między modelami niż o trudności pytania.
+</a:t>
+            </a:r>
+          </a:p>
+          <a:p>
+            <a:r>
+              <a:rPr lang="pl-PL" sz="1400"/>
+              <a:t>• Wniosek: trudność zależy od konkretnej pary modeli, więc mierzę ją sam.
 </a:t>
             </a:r>
           </a:p>
@@ -2263,38 +2471,54 @@
           </a:p>
           <a:p>
             <a:r>
-              <a:rPr lang="pl-PL" sz="1400"/>
-              <a:t>Z Areny mam stare etykiety: pytanie jest „trudne”, jeśli w głosowaniu wygrał mocniejszy model. Dla moich dwóch modeli zmierzyłem osobno, o ile duży jest lepszy od małego na każdym pytaniu.
-</a:t>
-            </a:r>
-          </a:p>
-          <a:p>
-            <a:endParaRPr lang="pl-PL" sz="1400"/>
-          </a:p>
-          <a:p>
-            <a:r>
-              <a:rPr lang="pl-PL" sz="1400"/>
-              <a:t>Porównałem jedno z drugim dla 1723 pytań. Wynik to 0,55. Mierzę to miarą o nazwie AUROC. Wyobraź sobie losowo wybraną parę pytań: jedno trudne według Areny, drugie nie. Para liczy się jako 1, gdy to pierwsze ma większą zmierzoną przewagę dużego modelu, jako 0, gdy mniejszą, i jako 0,5 przy remisie. AUROC to średnia z takich wyników po wszystkich parach, czyli w praktyce odsetek par ustawionych dobrze. Wynik 0,55 znaczy: w 55 parach na 100. Przy zwykłym rzucie monetą byłoby 50 na 100, a przy pełnej zgodności 100 na 100. Czyli zgodności prawie nie ma. Tej samej miary użyję później do oceny routera.
-</a:t>
-            </a:r>
-          </a:p>
-          <a:p>
-            <a:endParaRPr lang="pl-PL" sz="1400"/>
-          </a:p>
-          <a:p>
-            <a:r>
-              <a:rPr lang="pl-PL" sz="1400"/>
-              <a:t>Dlaczego tak wyszło? Arena porównywała inne modele, z innej epoki. Gdy gpt-4 wygrywa ze słabym modelem, to zwykle bez względu na pytanie. Stara etykieta mówi więc więcej o różnicy między modelami niż o trudności pytania.
-</a:t>
-            </a:r>
-          </a:p>
-          <a:p>
-            <a:endParaRPr lang="pl-PL" sz="1400"/>
-          </a:p>
-          <a:p>
-            <a:r>
-              <a:rPr lang="pl-PL" sz="1400"/>
-              <a:t>Wniosek: trudność zależy od konkretnej pary modeli. Dlatego sam ją mierzę na swoich dwóch modelach. Zaraz pokażę jak.
+              <a:rPr lang="pl-PL" sz="1400" b="1"/>
+              <a:t>DEFINICJE
+</a:t>
+            </a:r>
+          </a:p>
+          <a:p>
+            <a:r>
+              <a:rPr lang="pl-PL" sz="1400" b="1"/>
+              <a:t>AUROC: </a:t>
+            </a:r>
+            <a:r>
+              <a:rPr lang="pl-PL" sz="1400"/>
+              <a:t>miara zgodności rankingu z prawdą, od 0 do 1.
+</a:t>
+            </a:r>
+          </a:p>
+          <a:p>
+            <a:r>
+              <a:rPr lang="pl-PL" sz="1400"/>
+              <a:t>• Biorę losową parę pytań: jedno trudne, jedno łatwe.
+</a:t>
+            </a:r>
+          </a:p>
+          <a:p>
+            <a:r>
+              <a:rPr lang="pl-PL" sz="1400"/>
+              <a:t>• Para = 1, gdy trudne dostało wyższy wynik niż łatwe. 0, gdy niższy. 0,5 przy dokładnie równym wyniku (remis). Żaden próg nie jest potrzebny.
+</a:t>
+            </a:r>
+          </a:p>
+          <a:p>
+            <a:r>
+              <a:rPr lang="pl-PL" sz="1400"/>
+              <a:t>• AUROC to średnia z takich wyników po wszystkich parach, czyli odsetek par ułożonych dobrze.
+</a:t>
+            </a:r>
+          </a:p>
+          <a:p>
+            <a:r>
+              <a:rPr lang="pl-PL" sz="1400"/>
+              <a:t>• 0,5 = losowo (50 par na 100 ułożonych dobrze), 1,0 = idealnie (100 na 100). Nasze 0,55 to 55 na 100.
+</a:t>
+            </a:r>
+          </a:p>
+          <a:p>
+            <a:r>
+              <a:rPr lang="pl-PL" sz="1400"/>
+              <a:t>• Tu „wynik” to zmierzona przewaga dużego modelu, a „trudne” to stare trudne wg Areny. Później w ten sam sposób ocenię router.
 </a:t>
             </a:r>
           </a:p>
@@ -2311,7 +2535,7 @@
           <a:p>
             <a:r>
               <a:rPr lang="pl-PL" sz="1400"/>
-              <a:t>To jest analiza, a nie dowód, że moje etykiety są lepsze. Pokazuje tylko, że stare nie pasują do tych modeli.
+              <a:t>• To analiza, a nie dowód, że moje etykiety są lepsze. Pokazuje tylko, że stare nie pasują do tych modeli.
 </a:t>
             </a:r>
           </a:p>
@@ -2328,7 +2552,21 @@
           <a:p>
             <a:r>
               <a:rPr lang="pl-PL" sz="1400"/>
-              <a:t>Czy 0,55 to nie przypadek? Było 1723 pytań, a 0,55 jest bardzo blisko 0,5, więc wniosek jest ostrożny: stara etykieta słabo przewiduje wyniki naszych modeli.</a:t>
+              <a:t>• Czy 0,55 to przypadek? Pytań było 1723, a wynik jest blisko 0,5, więc wniosek jest ostrożny: stara etykieta słabo przewiduje wyniki naszych modeli.
+</a:t>
+            </a:r>
+          </a:p>
+          <a:p>
+            <a:r>
+              <a:rPr lang="pl-PL" sz="1400"/>
+              <a:t>• Ile jest remisów? Ok. 10% par (9,7%).
+</a:t>
+            </a:r>
+          </a:p>
+          <a:p>
+            <a:r>
+              <a:rPr lang="pl-PL" sz="1400"/>
+              <a:t>• Dlaczego nie zwykły odsetek zgodności? Stara etykieta ma dwie wartości, a moja miara jest liczbą. Porównanie par nie wymaga wybierania progu.</a:t>
             </a:r>
           </a:p>
         </p:txBody>
@@ -2422,7 +2660,42 @@
           <a:p>
             <a:r>
               <a:rPr lang="pl-PL" sz="1400"/>
-              <a:t>Każde pytanie przechodzi cztery kroki.
+              <a:t>• Mam 4313 pytań z ośmiu źródeł. Każde przechodzi cztery kroki.
+</a:t>
+            </a:r>
+          </a:p>
+          <a:p>
+            <a:r>
+              <a:rPr lang="pl-PL" sz="1400"/>
+              <a:t>• Krok 1: wysyłam pytanie do obu modeli, do małego 3 razy, do dużego raz. Odpowiedzi są losowe, więc jedna próbka małego byłaby za mało pewna.
+</a:t>
+            </a:r>
+          </a:p>
+          <a:p>
+            <a:r>
+              <a:rPr lang="pl-PL" sz="1400"/>
+              <a:t>• Krok 2: ocena. Gdy znana jest poprawna odpowiedź (np. wynik zadania), sprawdza automat. W pozostałych przypadkach ocenia Gemini w skali 1–5, dostając pytanie i odpowiedzi w losowej kolejności i bez nazw modeli.
+</a:t>
+            </a:r>
+          </a:p>
+          <a:p>
+            <a:r>
+              <a:rPr lang="pl-PL" sz="1400"/>
+              <a:t>• Krok 3: liczę różnicę Δ = ocena dużego minus średnia ocena małego.
+</a:t>
+            </a:r>
+          </a:p>
+          <a:p>
+            <a:r>
+              <a:rPr lang="pl-PL" sz="1400"/>
+              <a:t>• Krok 4: Δ &gt; 0,25 (czyli ponad 1 punkt w skali 1–5) = TRUDNE (COMPLEX). W przeciwnym razie ŁATWE (SIMPLE).
+</a:t>
+            </a:r>
+          </a:p>
+          <a:p>
+            <a:r>
+              <a:rPr lang="pl-PL" sz="1400"/>
+              <a:t>• Gdy oba modele odpowiedziały źle, pytanie zostaje łatwe, bo duży nic by nie dał.
 </a:t>
             </a:r>
           </a:p>
@@ -2431,8 +2704,26 @@
           </a:p>
           <a:p>
             <a:r>
-              <a:rPr lang="pl-PL" sz="1400"/>
-              <a:t>Mam 4313 pytań z ośmiu źródeł. Krok 1. Wysyłam każde do obu modeli: do małego trzy razy, do dużego raz. Odpowiedzi modeli są losowe, więc jedna próbka małego modelu byłaby za mało pewna.
+              <a:rPr lang="pl-PL" sz="1400" b="1"/>
+              <a:t>DEFINICJE
+</a:t>
+            </a:r>
+          </a:p>
+          <a:p>
+            <a:r>
+              <a:rPr lang="pl-PL" sz="1400"/>
+              <a:t>Δ (delta): przewaga dużego modelu = ocena dużego minus średnia ocena małego, w skali 0–1 (oceny przeliczone wzorem (ocena − 1) / 4).
+</a:t>
+            </a:r>
+          </a:p>
+          <a:p>
+            <a:r>
+              <a:rPr lang="pl-PL" sz="1400" b="1"/>
+              <a:t>PRÓG TRUDNOŚCI: </a:t>
+            </a:r>
+            <a:r>
+              <a:rPr lang="pl-PL" sz="1400"/>
+              <a:t>Δ &gt; 0,25, czyli 1 punkt w skali 1–5. Nie mylić z progiem routera, o którym będzie dalej.
 </a:t>
             </a:r>
           </a:p>
@@ -2441,48 +2732,15 @@
           </a:p>
           <a:p>
             <a:r>
-              <a:rPr lang="pl-PL" sz="1400"/>
-              <a:t>Krok 2. Oceniam odpowiedzi. Gdy znana jest poprawna odpowiedź, np. wynik zadania, sprawdza automat. W pozostałych przypadkach ocenia drugi model, Gemini, w skali od 1 do 5. Dostaje pytanie i wszystkie odpowiedzi w losowej kolejności i bez nazw modeli, żeby nikogo nie faworyzował.
-</a:t>
-            </a:r>
-          </a:p>
-          <a:p>
-            <a:endParaRPr lang="pl-PL" sz="1400"/>
-          </a:p>
-          <a:p>
-            <a:r>
-              <a:rPr lang="pl-PL" sz="1400"/>
-              <a:t>Krok 3. Liczę różnicę, oznaczoną Δ (delta): ocena dużego minus średnia ocena małego.
-</a:t>
-            </a:r>
-          </a:p>
-          <a:p>
-            <a:endParaRPr lang="pl-PL" sz="1400"/>
-          </a:p>
-          <a:p>
-            <a:r>
-              <a:rPr lang="pl-PL" sz="1400"/>
-              <a:t>Krok 4. Jeśli różnica jest większa niż jeden punkt w skali 1–5, pytanie jest TRUDNE (COMPLEX), czyli duży jest wyraźnie lepszy. W przeciwnym razie jest ŁATWE (SIMPLE).
-</a:t>
-            </a:r>
-          </a:p>
-          <a:p>
-            <a:endParaRPr lang="pl-PL" sz="1400"/>
-          </a:p>
-          <a:p>
-            <a:r>
-              <a:rPr lang="pl-PL" sz="1400"/>
-              <a:t>Przykład z rysunku. Duży dostał 5, mały 3, 3 i 4, średnio 3,3. Różnica to 1,7 punktu, więcej niż 1, więc pytanie jest trudne. Na slajdzie te oceny są przeliczone na skalę 0–1 (wzorem (ocena − 1) / 4): duży dostał 1,00, mały średnio 0,58, więc Δ = 0,42. Granica Δ &gt; 0,25 odpowiada więc jednemu punktowi. Nazywam ją progiem trudności, żeby nie mylić jej z progiem routera, o którym będzie mowa dalej.
-</a:t>
-            </a:r>
-          </a:p>
-          <a:p>
-            <a:endParaRPr lang="pl-PL" sz="1400"/>
-          </a:p>
-          <a:p>
-            <a:r>
-              <a:rPr lang="pl-PL" sz="1400"/>
-              <a:t>Jeśli oba modele odpowiedziały źle, pytanie zostaje łatwe, bo duży model nic by nie dał.
+              <a:rPr lang="pl-PL" sz="1400" b="1"/>
+              <a:t>PRZYKŁAD Z RYSUNKU
+</a:t>
+            </a:r>
+          </a:p>
+          <a:p>
+            <a:r>
+              <a:rPr lang="pl-PL" sz="1400"/>
+              <a:t>• Duży dostał 5 (1,00), mały 3, 3 i 4 (średnio 0,58). Δ = 0,42, więc pytanie jest trudne.
 </a:t>
             </a:r>
           </a:p>
@@ -2499,14 +2757,14 @@
           <a:p>
             <a:r>
               <a:rPr lang="pl-PL" sz="1400"/>
-              <a:t>Dlaczego trzy próbki małego? Sprawdziłem, że jedna próbka dałaby tę samą klasę co wszystkie trzy tylko w 74% pytań otwartych. Średnia z trzech zmniejsza ten szum.
-</a:t>
-            </a:r>
-          </a:p>
-          <a:p>
-            <a:r>
-              <a:rPr lang="pl-PL" sz="1400"/>
-              <a:t>Skąd próg jeden punkt? To mój wybór. Sprawdziłem też łagodniejszy i ostrzejszy (odsetek trudnych pytań: 51,5%, 35,4% i 27,6%). Wnioski o routerze są te same.</a:t>
+              <a:t>• Dlaczego 3 próbki małego? Jedna próbka dałaby tę samą klasę co trzy tylko w 74% pytań otwartych. Średnia z trzech zmniejsza szum.
+</a:t>
+            </a:r>
+          </a:p>
+          <a:p>
+            <a:r>
+              <a:rPr lang="pl-PL" sz="1400"/>
+              <a:t>• Skąd próg 1 punkt? To mój wybór. Sprawdziłem też łagodniejszy i ostrzejszy (odsetek trudnych: 51,5%, 35,4% i 27,6%). Wnioski o routerze są te same.</a:t>
             </a:r>
           </a:p>
         </p:txBody>
@@ -2600,37 +2858,35 @@
           <a:p>
             <a:r>
               <a:rPr lang="pl-PL" sz="1400"/>
-              <a:t>Mam 4313 pytań z ośmiu źródeł i 17 252 odpowiedzi obu modeli. Dwa źródła to zbiory prawdziwych rozmów z chatbotami: Arena i WildChat. Dalej pytania wygenerowane przez Gemini i zbiory z matematyki, wiedzy i programowania. Dzięki temu są i pytania otwarte, i takie ze znaną poprawną odpowiedzią.
-</a:t>
-            </a:r>
-          </a:p>
-          <a:p>
-            <a:endParaRPr lang="pl-PL" sz="1400"/>
-          </a:p>
-          <a:p>
-            <a:r>
-              <a:rPr lang="pl-PL" sz="1400"/>
-              <a:t>Podzieliłem je na trzy części: 50% do nauki routera, 20% do dostrajania i 30% do końcowego testu. Test jest zamknięty: otworzę go raz, na końcu, żeby nie dopasować routera do testu.
-</a:t>
-            </a:r>
-          </a:p>
-          <a:p>
-            <a:endParaRPr lang="pl-PL" sz="1400"/>
-          </a:p>
-          <a:p>
-            <a:r>
-              <a:rPr lang="pl-PL" sz="1400"/>
-              <a:t>Bardzo podobne pytania trafiają zawsze do jednej części. Inaczej router „znałby” pytania z testu, a wynik byłby zawyżony.
-</a:t>
-            </a:r>
-          </a:p>
-          <a:p>
-            <a:endParaRPr lang="pl-PL" sz="1400"/>
-          </a:p>
-          <a:p>
-            <a:r>
-              <a:rPr lang="pl-PL" sz="1400"/>
-              <a:t>Wynik pomiaru: 35,4% pytań jest trudnych. Ale bardzo różnie zależnie od źródła: w zadaniach matematycznych 4%, w rozmowach z WildChat 48%. Mały model dobrze liczy, a rozmowy otwarte są dla niego trudniejsze. Czyli „trudne” nie zawsze znaczy to, co podpowiada intuicja.
+              <a:t>• 4313 pytań z ośmiu źródeł i 17 252 odpowiedzi obu modeli.
+</a:t>
+            </a:r>
+          </a:p>
+          <a:p>
+            <a:r>
+              <a:rPr lang="pl-PL" sz="1400"/>
+              <a:t>• Źródła: prawdziwe rozmowy (Arena, WildChat), pytania wygenerowane przez Gemini, zbiory z matematyki, wiedzy i programowania. Są pytania otwarte i takie ze znaną poprawną odpowiedzią.
+</a:t>
+            </a:r>
+          </a:p>
+          <a:p>
+            <a:r>
+              <a:rPr lang="pl-PL" sz="1400"/>
+              <a:t>• Podział: 50% do nauki routera, 20% do dostrajania, 30% do testu końcowego. Test jest zamknięty: otworzę go raz, na końcu.
+</a:t>
+            </a:r>
+          </a:p>
+          <a:p>
+            <a:r>
+              <a:rPr lang="pl-PL" sz="1400"/>
+              <a:t>• Bardzo podobne pytania trafiają zawsze do jednej części. Inaczej router „znałby” pytania z testu, a wynik byłby zawyżony.
+</a:t>
+            </a:r>
+          </a:p>
+          <a:p>
+            <a:r>
+              <a:rPr lang="pl-PL" sz="1400"/>
+              <a:t>• Wynik pomiaru: 35,4% pytań jest trudnych, ale zależnie od źródła: matematyka 4%, WildChat 48%. Mały model dobrze liczy, a rozmowy otwarte są dla niego trudniejsze.
 </a:t>
             </a:r>
           </a:p>
@@ -2647,14 +2903,14 @@
           <a:p>
             <a:r>
               <a:rPr lang="pl-PL" sz="1400"/>
-              <a:t>Skąd te źródła? Chciałem mieszankę: prawdziwe, niejednoznaczne rozmowy oraz zadania, w których poprawność da się sprawdzić automatem.
-</a:t>
-            </a:r>
-          </a:p>
-          <a:p>
-            <a:r>
-              <a:rPr lang="pl-PL" sz="1400"/>
-              <a:t>Ograniczenie: to głównie publiczne czaty, więc brakuje zapytań z typowego użycia w firmie. Wracam do tego na końcu.</a:t>
+              <a:t>• Skąd te źródła? Chciałem mieszankę prawdziwych, niejednoznacznych rozmów i zadań, w których poprawność da się sprawdzić automatem.
+</a:t>
+            </a:r>
+          </a:p>
+          <a:p>
+            <a:r>
+              <a:rPr lang="pl-PL" sz="1400"/>
+              <a:t>• Ograniczenie: to głównie publiczne czaty, brakuje zapytań z typowego użycia w firmie. Wracam do tego na końcu.</a:t>
             </a:r>
           </a:p>
         </p:txBody>
@@ -2748,57 +3004,42 @@
           <a:p>
             <a:r>
               <a:rPr lang="pl-PL" sz="1400"/>
-              <a:t>Etykiety ocenia model, więc sprawdziłem, ile można im ufać.
-</a:t>
-            </a:r>
-          </a:p>
-          <a:p>
-            <a:endParaRPr lang="pl-PL" sz="1400"/>
-          </a:p>
-          <a:p>
-            <a:r>
-              <a:rPr lang="pl-PL" sz="1400"/>
-              <a:t>Pierwsza liczba: 90%. Gdy zmienię kolejność odpowiedzi, ten sam sędzia daje tę samą klasę (trudne albo łatwe) w 90% pytań. Jest więc w miarę stabilny.
-</a:t>
-            </a:r>
-          </a:p>
-          <a:p>
-            <a:endParaRPr lang="pl-PL" sz="1400"/>
-          </a:p>
-          <a:p>
-            <a:r>
-              <a:rPr lang="pl-PL" sz="1400"/>
-              <a:t>Druga: 79%. Drugi, mocniejszy sędzia zgadza się z pierwszym co do klasy w 79% pytań.
-</a:t>
-            </a:r>
-          </a:p>
-          <a:p>
-            <a:endParaRPr lang="pl-PL" sz="1400"/>
-          </a:p>
-          <a:p>
-            <a:r>
-              <a:rPr lang="pl-PL" sz="1400"/>
-              <a:t>Trzecia: sam oceniłem 100 odpowiedzi, nie wiedząc, który model je napisał. Z sędzią zgadzam się umiarkowanie. Korelacja wynosi 0,59 (1 oznaczałaby identyczne uporządkowanie ocen, a 0 brak związku). Dodatkowo identyczną ocenę dałem w 43% przypadków, a różnicę nie większą niż jeden punkt w 77%.
-</a:t>
-            </a:r>
-          </a:p>
-          <a:p>
-            <a:endParaRPr lang="pl-PL" sz="1400"/>
-          </a:p>
-          <a:p>
-            <a:r>
-              <a:rPr lang="pl-PL" sz="1400"/>
-              <a:t>Czwarta: sędzia jest surowszy ode mnie średnio o 0,4 punktu (jego średnia ocena to 3,00, a moja 3,40).
-</a:t>
-            </a:r>
-          </a:p>
-          <a:p>
-            <a:endParaRPr lang="pl-PL" sz="1400"/>
-          </a:p>
-          <a:p>
-            <a:r>
-              <a:rPr lang="pl-PL" sz="1400"/>
-              <a:t>Wniosek: etykiety są użyteczne, ale nie idealne, i tak je opisuję w pracy. To nie przekreśla wyników, bo etykieta opiera się na różnicy ocen dwóch modeli, więc stała surowość sędziego się znosi.
+              <a:t>• Etykiety ocenia model, więc sprawdziłem, ile można im ufać.
+</a:t>
+            </a:r>
+          </a:p>
+          <a:p>
+            <a:r>
+              <a:rPr lang="pl-PL" sz="1400"/>
+              <a:t>• 90%: po zmianie kolejności odpowiedzi ten sam sędzia daje tę samą klasę (trudne lub łatwe) w 90% pytań.
+</a:t>
+            </a:r>
+          </a:p>
+          <a:p>
+            <a:r>
+              <a:rPr lang="pl-PL" sz="1400"/>
+              <a:t>• 79%: drugi, mocniejszy sędzia (Gemini Pro) zgadza się z pierwszym co do klasy w 79% pytań.
+</a:t>
+            </a:r>
+          </a:p>
+          <a:p>
+            <a:r>
+              <a:rPr lang="pl-PL" sz="1400"/>
+              <a:t>• Sam oceniłem 100 odpowiedzi, nie wiedząc, który model je napisał. Korelacja z sędzią 0,59 (1 = identyczne uporządkowanie ocen, 0 = brak związku). Identyczna ocena w 43% przypadków, różnica nie większa niż 1 punkt w 77%.
+</a:t>
+            </a:r>
+          </a:p>
+          <a:p>
+            <a:r>
+              <a:rPr lang="pl-PL" sz="1400"/>
+              <a:t>• Sędzia jest surowszy ode mnie o 0,4 punktu (średnio 3,00 wobec 3,40).
+</a:t>
+            </a:r>
+          </a:p>
+          <a:p>
+            <a:r>
+              <a:rPr lang="pl-PL" sz="1400"/>
+              <a:t>• Wniosek: etykiety są użyteczne, ale nie idealne. Stała surowość sędziego się znosi, bo etykieta to różnica ocen dwóch modeli.
 </a:t>
             </a:r>
           </a:p>
@@ -2815,14 +3056,14 @@
           <a:p>
             <a:r>
               <a:rPr lang="pl-PL" sz="1400"/>
-              <a:t>Czy sędzia nie faworyzuje długich odpowiedzi? Sprawdziłem: korelacja z długością to 0,06, czyli prawie żadna.
-</a:t>
-            </a:r>
-          </a:p>
-          <a:p>
-            <a:r>
-              <a:rPr lang="pl-PL" sz="1400"/>
-              <a:t>Który sędzia jest lepszy? Nie rozstrzygam. Używam tańszego, a drugi dostał tylko część pytań.</a:t>
+              <a:t>• Czy sędzia faworyzuje długie odpowiedzi? Korelacja z długością to 0,06, czyli prawie żadna.
+</a:t>
+            </a:r>
+          </a:p>
+          <a:p>
+            <a:r>
+              <a:rPr lang="pl-PL" sz="1400"/>
+              <a:t>• Który sędzia jest lepszy? Nie rozstrzygam. Używam tańszego, drugi dostał tylko część pytań.</a:t>
             </a:r>
           </a:p>
         </p:txBody>
@@ -2916,7 +3157,56 @@
           <a:p>
             <a:r>
               <a:rPr lang="pl-PL" sz="1400"/>
-              <a:t>Router ma trzy warstwy, od najtańszej do najdroższej. Zasada: warstwa zostaje tylko wtedy, gdy pokaże zysk.
+              <a:t>• Router ma trzy warstwy, od najtańszej do najdroższej. Warstwa zostaje tylko wtedy, gdy pokaże zysk.
+</a:t>
+            </a:r>
+          </a:p>
+          <a:p>
+            <a:r>
+              <a:rPr lang="pl-PL" sz="1400"/>
+              <a:t>• Warstwa 1, heurystyki: punkty za cechy tekstu. +1 za frazę z listy zadań trudnych, −1 za frazę z listy łatwych, +1 za długość powyżej 400 znaków, +1 powyżej 1500, −1 gdy ponad 10% znaków to cyfry, +1 za adres internetowy. Administrator może zmienić punkty.
+</a:t>
+            </a:r>
+          </a:p>
+          <a:p>
+            <a:r>
+              <a:rPr lang="pl-PL" sz="1400"/>
+              <a:t>• Frazy pochodzą z literatury, nie z moich danych, żeby ich nie dopasować do wyników. Taksonomia Blooma (Anderson i Krathwohl, 2001): „analyze”, „compare”, „design” to zadania trudniejsze, „what is”, „define” łatwiejsze. Lista z AgentBus, praktycznego systemu routingu: np. „debug”, „refactor”, „step by step”.
+</a:t>
+            </a:r>
+          </a:p>
+          <a:p>
+            <a:r>
+              <a:rPr lang="pl-PL" sz="1400"/>
+              <a:t>• Suma punktów od progu (domyślnie 2) = pytanie idzie od razu do dużego, bez dalszych warstw. Tylko w tę stronę, bo pomyłka w stronę dużego kosztuje pieniądze, a nie jakość. Warstwa jest opcjonalna: bez pliku z parametrami jest wyłączona.
+</a:t>
+            </a:r>
+          </a:p>
+          <a:p>
+            <a:r>
+              <a:rPr lang="pl-PL" sz="1400"/>
+              <a:t>• U nas próg 2 obejmuje 6% pytań, z których 52% jest naprawdę trudnych (wśród wszystkich 37%). Lepsze od zgadywania, ale obejmuje niewiele ruchu.
+</a:t>
+            </a:r>
+          </a:p>
+          <a:p>
+            <a:r>
+              <a:rPr lang="pl-PL" sz="1400"/>
+              <a:t>• Warstwa 2: porównanie z podobnymi pytaniami (kNN) na embeddingach. Główna część rozwiązania, następny slajd.
+</a:t>
+            </a:r>
+          </a:p>
+          <a:p>
+            <a:r>
+              <a:rPr lang="pl-PL" sz="1400"/>
+              <a:t>• Warstwa 3: mały model sam ocenia, czy pytanie jest trudne. Jeszcze jej nie ma. Wejdzie, jeśli test go/no-go pokaże zysk: jeśli pomaga, budujemy, jeśli nie, rezygnujemy. Wywołanie małego modelu trwa sekundy, więc tylko dla pytań, przy których warstwa 2 jest niepewna.
+</a:t>
+            </a:r>
+          </a:p>
+          <a:p>
+            <a:r>
+              <a:rPr lang="pl-PL" sz="1400"/>
+              <a:t>• Na końcu router zwraca wynik od 0 do 1: im wyższy, tym bardziej pytanie wygląda na trudne. Administrator ustawia próg: powyżej idzie do dużego, poniżej do małego. Gdy cokolwiek zawiedzie, idzie do dużego, bo to bezpieczniejsze.
 </a:t>
             </a:r>
           </a:p>
@@ -2925,62 +3215,26 @@
           </a:p>
           <a:p>
             <a:r>
-              <a:rPr lang="pl-PL" sz="1400"/>
-              <a:t>Warstwa 1: heurystyki, czyli punkty za proste cechy tekstu pytania. Pytanie dostaje plus jeden punkt za każdą frazę z listy zadań trudnych i minus jeden za każdą frazę z listy łatwych. Do tego plus jeden punkt, gdy jest dłuższe niż 400 znaków, kolejny plus jeden powyżej 1500, minus jeden, gdy ponad 10% znaków to cyfry, i plus jeden za adres internetowy. Administrator może zmienić wszystkie te punkty.
-</a:t>
-            </a:r>
-          </a:p>
-          <a:p>
-            <a:r>
-              <a:rPr lang="pl-PL" sz="1400"/>
-              <a:t>Słowa pochodzą z literatury, a nie z moich danych, żeby ich nie dopasować do wyników. Pierwsze źródło to taksonomia Blooma (Anderson i Krathwohl, 2001), czyli hierarchia poziomów myślenia od zapamiętywania do tworzenia: słowa jak „analyze”, „compare”, „design” wskazują zadania trudniejsze, a „what is”, „define” łatwiejsze. Drugie źródło to lista fraz z AgentBus, praktycznego systemu routingu modeli: np. „debug”, „refactor”, „step by step”.
-</a:t>
-            </a:r>
-          </a:p>
-          <a:p>
-            <a:r>
-              <a:rPr lang="pl-PL" sz="1400"/>
-              <a:t>Gdy suma punktów dojdzie do progu (domyślnie 2), pytanie idzie od razu do dużego modelu, bez dalszych warstw. Ta warstwa kieruje tylko do dużego, bo pomyłka w tę stronę kosztuje tylko pieniądze, a nie jakość. Jest opcjonalna: bez pliku z parametrami jest wyłączona. U nas próg 2 punkty obejmuje 6% pytań, z których 52% jest naprawdę trudnych (wśród wszystkich pytań 37%), więc heurystyki są lepsze od zgadywania o kilkanaście punktów procentowych i obejmują niewiele ruchu. W pomiarze nie zmieniają jakości całego routera.
-</a:t>
-            </a:r>
-          </a:p>
-          <a:p>
-            <a:endParaRPr lang="pl-PL" sz="1400"/>
-          </a:p>
-          <a:p>
-            <a:r>
-              <a:rPr lang="pl-PL" sz="1400"/>
-              <a:t>Warstwa 2: porównanie z podobnymi pytaniami (metoda kNN) na embeddingach, czyli na liczbowym opisie pytania. To główna część rozwiązania i wyjaśniam ją na następnym slajdzie.
-</a:t>
-            </a:r>
-          </a:p>
-          <a:p>
-            <a:endParaRPr lang="pl-PL" sz="1400"/>
-          </a:p>
-          <a:p>
-            <a:r>
-              <a:rPr lang="pl-PL" sz="1400"/>
-              <a:t>Warstwa 3: mały model sam ocenia, czy pytanie jest trudne. Jeszcze jej nie ma. Wejdzie, jeśli krótki test pokaże zysk. Ten test nazywa się go/no-go: jeśli pomaga, budujemy, jeśli nie, rezygnujemy. Nie chcę jej wywoływać dla każdego pytania, bo to wywołanie małego modelu i trwa sekundy. Będzie dotyczyć tylko pytań, przy których warstwa 2 jest niepewna. Wyjaśniam to niżej, po omówieniu wyniku routera.
-</a:t>
-            </a:r>
-          </a:p>
-          <a:p>
-            <a:endParaRPr lang="pl-PL" sz="1400"/>
-          </a:p>
-          <a:p>
-            <a:r>
-              <a:rPr lang="pl-PL" sz="1400"/>
-              <a:t>Na końcu router zwraca liczbę od 0 do 1. To jego wynik dla pytania: im wyższy, tym bardziej router uważa pytanie za trudne, czyli tym większa szansa, że duży model odpowie wyraźnie lepiej. Administrator ustawia próg: wynik powyżej idzie do dużego modelu, poniżej do małego. Gdy cokolwiek zawiedzie, pytanie idzie do dużego, bo to bezpieczniejsze.
-</a:t>
-            </a:r>
-          </a:p>
-          <a:p>
-            <a:endParaRPr lang="pl-PL" sz="1400"/>
-          </a:p>
-          <a:p>
-            <a:r>
-              <a:rPr lang="pl-PL" sz="1400"/>
-              <a:t>Teraz warstwa 3. Niepewna znaczy: wynik warstwy 2 jest w środku skali, między dwoma progami, a nie przy jej końcach. Przykład: poniżej 0,2 pytanie idzie do małego, powyżej 0,45 do dużego, a pomiędzy decyduje warstwa 3. W naszych danych to mniej więcej połowa pytań. Pozostałe, tak czy inaczej rozstrzyga sama warstwa 2. Granice dobiorę na danych do dostrajania tak, żeby jakość nie spadła poniżej ustalonego poziomu. Tego poziomu jeszcze nie ustaliłem.
+              <a:rPr lang="pl-PL" sz="1400" b="1"/>
+              <a:t>DEFINICJE
+</a:t>
+            </a:r>
+          </a:p>
+          <a:p>
+            <a:r>
+              <a:rPr lang="pl-PL" sz="1400" b="1"/>
+              <a:t>STREFA NIEPEWNOŚCI: </a:t>
+            </a:r>
+            <a:r>
+              <a:rPr lang="pl-PL" sz="1400"/>
+              <a:t>wynik warstwy 2 w środku skali, między dwoma progami. Np. poniżej 0,2 do małego, powyżej 0,45 do dużego, pomiędzy decyduje warstwa 3. W naszych danych to ok. połowa pytań.
+</a:t>
+            </a:r>
+          </a:p>
+          <a:p>
+            <a:r>
+              <a:rPr lang="pl-PL" sz="1400"/>
+              <a:t>• Granice dobiorę na danych do dostrajania tak, by jakość nie spadła poniżej ustalonego poziomu. Tego poziomu jeszcze nie ustaliłem.
 </a:t>
             </a:r>
           </a:p>
@@ -2997,7 +3251,7 @@
           <a:p>
             <a:r>
               <a:rPr lang="pl-PL" sz="1400"/>
-              <a:t>Ile to trwa? Heurystyki ok. 0,3 ms, a warstwa 2 ok. 20 ms. Warstwa 3 byłaby wywołaniem małego modelu, czyli sekundami, dlatego jest ostatnia i tylko dla pytań w strefie niepewności.</a:t>
+              <a:t>• Ile to trwa? Heurystyki ok. 0,3 ms, warstwa 2 ok. 20 ms. Warstwa 3 to sekundy, dlatego jest ostatnia i tylko w strefie niepewności.</a:t>
             </a:r>
           </a:p>
         </p:txBody>
@@ -3091,7 +3345,35 @@
           <a:p>
             <a:r>
               <a:rPr lang="pl-PL" sz="1400"/>
-              <a:t>Router dostaje tekst pytania, a ma zwrócić liczbę od 0 do 1. Robi to w czterech krokach.
+              <a:t>• Router dostaje tekst pytania, a zwraca liczbę od 0 do 1. Cztery kroki:
+</a:t>
+            </a:r>
+          </a:p>
+          <a:p>
+            <a:r>
+              <a:rPr lang="pl-PL" sz="1400"/>
+              <a:t>• Krok 1: zamieniam pytanie na 768 liczb (embedding). Pytania o podobnym znaczeniu dostają podobne liczby, jak punkty blisko siebie na mapie.
+</a:t>
+            </a:r>
+          </a:p>
+          <a:p>
+            <a:r>
+              <a:rPr lang="pl-PL" sz="1400"/>
+              <a:t>• Krok 2: szukam 20 najbardziej podobnych pytań w bazie, czyli takich, których trudność już zmierzyłem.
+</a:t>
+            </a:r>
+          </a:p>
+          <a:p>
+            <a:r>
+              <a:rPr lang="pl-PL" sz="1400"/>
+              <a:t>• Krok 3: wynik to odsetek trudnych wśród tych 20, przy czym podobniejsze liczą się bardziej. Np. 14 z 20 trudnych = wynik wysoki = duży model.
+</a:t>
+            </a:r>
+          </a:p>
+          <a:p>
+            <a:r>
+              <a:rPr lang="pl-PL" sz="1400"/>
+              <a:t>• Krok 4: porównuję wynik z progiem administratora.
 </a:t>
             </a:r>
           </a:p>
@@ -3100,8 +3382,26 @@
           </a:p>
           <a:p>
             <a:r>
-              <a:rPr lang="pl-PL" sz="1400"/>
-              <a:t>Krok 1. Zamienia pytanie na liczby. Komputer nie potrafi porównać dwóch zdań, więc zamieniam każde na listę 768 liczb. To się nazywa embedding. Pytania o podobnym znaczeniu dostają podobne listy, jak punkty leżące blisko siebie na mapie.
+              <a:rPr lang="pl-PL" sz="1400" b="1"/>
+              <a:t>DEFINICJE
+</a:t>
+            </a:r>
+          </a:p>
+          <a:p>
+            <a:r>
+              <a:rPr lang="pl-PL" sz="1400" b="1"/>
+              <a:t>EMBEDDING: </a:t>
+            </a:r>
+            <a:r>
+              <a:rPr lang="pl-PL" sz="1400"/>
+              <a:t>lista liczb (tu 768) opisująca znaczenie tekstu. Sama nie mówi, czy pytanie jest trudne.
+</a:t>
+            </a:r>
+          </a:p>
+          <a:p>
+            <a:r>
+              <a:rPr lang="pl-PL" sz="1400"/>
+              <a:t>kNN: metoda, która z embeddingu robi wynik: ważony odsetek trudnych wśród k = 20 najbardziej podobnych pytań z bazy.
 </a:t>
             </a:r>
           </a:p>
@@ -3110,8 +3410,43 @@
           </a:p>
           <a:p>
             <a:r>
-              <a:rPr lang="pl-PL" sz="1400"/>
-              <a:t>Krok 2. Szuka 20 najbardziej podobnych pytań w mojej bazie, czyli takich, których trudność już zmierzyłem.
+              <a:rPr lang="pl-PL" sz="1400" b="1"/>
+              <a:t>DLACZEGO TAK
+</a:t>
+            </a:r>
+          </a:p>
+          <a:p>
+            <a:r>
+              <a:rPr lang="pl-PL" sz="1400"/>
+              <a:t>• Bez trenowania: baza to zapisane pytania, nowe dane to dopisanie wierszy.
+</a:t>
+            </a:r>
+          </a:p>
+          <a:p>
+            <a:r>
+              <a:rPr lang="pl-PL" sz="1400"/>
+              <a:t>• Wynik ma zrozumiałe znaczenie i można pokazać sąsiadów.
+</a:t>
+            </a:r>
+          </a:p>
+          <a:p>
+            <a:r>
+              <a:rPr lang="pl-PL" sz="1400"/>
+              <a:t>• Liczy się lokalnie w ok. 20 ms, pytania nie opuszczają serwera.
+</a:t>
+            </a:r>
+          </a:p>
+          <a:p>
+            <a:r>
+              <a:rPr lang="pl-PL" sz="1400"/>
+              <a:t>• Wzorem jest „Similarity-Weighted Ranking” z RouteLLM (Ong i in., 2024): embedding, podobieństwo do 80 tys. pytań z Areny, ważona suma głosów, bez trenowania. Inne metody z artykułu wymagają trenowania lub fine-tuningu.
+</a:t>
+            </a:r>
+          </a:p>
+          <a:p>
+            <a:r>
+              <a:rPr lang="pl-PL" sz="1400"/>
+              <a:t>• Różnice: moje etykiety są zmierzone na własnych modelach, biorę 20 najbliższych, nie całą historię. Baza ma ok. 3 tys. wektorów i ok. 1 ms (oryginał ok. 39 USD za milion zapytań).
 </a:t>
             </a:r>
           </a:p>
@@ -3120,55 +3455,29 @@
           </a:p>
           <a:p>
             <a:r>
-              <a:rPr lang="pl-PL" sz="1400"/>
-              <a:t>Krok 3. Sprawdza, ile z tych 20 było trudnych. Wynik to ten odsetek, a podobniejsze pytania liczą się bardziej. Jeśli 14 z 20 było trudnych, wynik jest wysoki i pytanie idzie do dużego modelu.
-</a:t>
-            </a:r>
-          </a:p>
-          <a:p>
-            <a:endParaRPr lang="pl-PL" sz="1400"/>
-          </a:p>
-          <a:p>
-            <a:r>
-              <a:rPr lang="pl-PL" sz="1400"/>
-              <a:t>Krok 4. Porównuje wynik z progiem administratora.
-</a:t>
-            </a:r>
-          </a:p>
-          <a:p>
-            <a:endParaRPr lang="pl-PL" sz="1400"/>
-          </a:p>
-          <a:p>
-            <a:r>
-              <a:rPr lang="pl-PL" sz="1400"/>
-              <a:t>Dlaczego tak, a nie bardziej skomplikowanie? Po pierwsze, nie trzeba niczego trenować: baza to zapisane pytania, a nowe dane to dopisanie wierszy. Po drugie, wynik ma zrozumiałe znaczenie i można pokazać, które pytania były sąsiadami. Po trzecie, liczy się lokalnie w ok. 20 ms, więc pytania nie opuszczają serwera.
-</a:t>
-            </a:r>
-          </a:p>
-          <a:p>
-            <a:endParaRPr lang="pl-PL" sz="1400"/>
-          </a:p>
-          <a:p>
-            <a:r>
-              <a:rPr lang="pl-PL" sz="1400"/>
-              <a:t>A dlaczego kNN, a nie same embeddingi? Embedding to tylko lista liczb opisująca pytanie. Sama nie mówi, czy pytanie jest trudne. Potrzebna jest metoda, która z tych liczb zrobi wynik. Najprostsza to porównanie z pytaniami, których trudność już znam, czyli właśnie kNN.
-</a:t>
-            </a:r>
-          </a:p>
-          <a:p>
-            <a:r>
-              <a:rPr lang="pl-PL" sz="1400"/>
-              <a:t>To nie jest mój wymysł. Wzorowałem się na metodzie „Similarity-Weighted Ranking” z artykułu RouteLLM (Ong i in., 2024). Tam nowe zapytanie też zamienia się na embedding, porównuje z 80 tysiącami pytań z Chatbot Arena przez podobieństwo i liczy ważoną sumę głosów ludzi. Ta metoda nie wymaga trenowania. Inne metody z tego artykułu (faktoryzacja macierzy, BERT, duży model językowy) wymagają trenowania albo fine-tuningu, którego mój plan nie przewiduje. Różnię się tym, że uśredniam etykiety zmierzone na własnych modelach, a nie głosy z Areny, i biorę tylko 20 najbliższych pytań, a nie całą historię. Wadą oryginału jest czas i koszt: przeszukuje całą bazę przy każdym zapytaniu (w ich zestawieniu ok. 39 USD za milion zapytań). U mnie baza ma ok. 3 tysięcy wektorów, a wyszukiwanie trwa ok. 1 ms.
-</a:t>
-            </a:r>
-          </a:p>
-          <a:p>
-            <a:endParaRPr lang="pl-PL" sz="1400"/>
-          </a:p>
-          <a:p>
-            <a:r>
-              <a:rPr lang="pl-PL" sz="1400"/>
-              <a:t>Co sprawdziłem. Wyniki routera liczę na pytaniach, których router nie widział w nauce (walidacja krzyżowa: dzielę dane na części, uczę na jednych, oceniam na pozostałych). Miara to AUROC, taka jak na slajdzie 4, tylko teraz pytam, czy router daje wyższy wynik pytaniom trudnym niż łatwym. Cztery modele zamieniające tekst na liczby dały AUROC od 0,679 do 0,709. Najlepszy, qwen3, jest trzy razy wolniejszy (52 ms wobec 17,6 ms) i ma niewielką przewagę, więc zostaje nomic. Dziewięć klasyfikatorów (regresja logistyczna, SVM, sieć MLP, boosting drzew i inne) dało od 0,662 do 0,691. Żaden nie jest istotnie lepszy od kNN. Wniosek: ok. 0,68–0,69 to sufit informacji, który mają w sobie embeddingi dla tych etykiet.
+              <a:rPr lang="pl-PL" sz="1400" b="1"/>
+              <a:t>CO SPRAWDZIŁEM
+</a:t>
+            </a:r>
+          </a:p>
+          <a:p>
+            <a:r>
+              <a:rPr lang="pl-PL" sz="1400"/>
+              <a:t>• Walidacja krzyżowa: uczę na jednych częściach danych, oceniam na pozostałych. Miara AUROC jak na slajdzie 4.
+</a:t>
+            </a:r>
+          </a:p>
+          <a:p>
+            <a:r>
+              <a:rPr lang="pl-PL" sz="1400"/>
+              <a:t>• 4 modele embeddingów: AUROC 0,679–0,709. Najlepszy (qwen3) jest 3× wolniejszy (52 ms wobec 17,6 ms), więc zostaje nomic.
+</a:t>
+            </a:r>
+          </a:p>
+          <a:p>
+            <a:r>
+              <a:rPr lang="pl-PL" sz="1400"/>
+              <a:t>• 9 klasyfikatorów (regresja logistyczna, SVM, sieć MLP, boosting i inne): 0,662–0,691, żaden istotnie lepszy od kNN. Sufit informacji w embeddingach to ok. 0,68–0,69.
 </a:t>
             </a:r>
           </a:p>
@@ -3185,28 +3494,28 @@
           <a:p>
             <a:r>
               <a:rPr lang="pl-PL" sz="1400"/>
-              <a:t>Dlaczego 20 sąsiadów? Przy jednym AUROC to 0,590, bo wynik jest zaszumiony, a od ok. 20 jest stabilny (0,682 przy 20, 0,689 przy 40). Więcej nie poprawia.
-</a:t>
-            </a:r>
-          </a:p>
-          <a:p>
-            <a:r>
-              <a:rPr lang="pl-PL" sz="1400"/>
-              <a:t>Czy ważenie pomaga? Tak, trochę: równe wagi dają 0,677, a ważenie podobieństwem 0,682. Ostrzejsze ważenie daje do 0,702, ale wybrałem je spośród 30 wariantów na tych samych danych, więc nie przyjmuję tego bez potwierdzenia.
-</a:t>
-            </a:r>
-          </a:p>
-          <a:p>
-            <a:r>
-              <a:rPr lang="pl-PL" sz="1400"/>
-              <a:t>Czy więcej danych pomoże? Niewiele: powyżej ok. 1200 pytań podwojenie bazy poprawia wynik o ok. 0,01.
-</a:t>
-            </a:r>
-          </a:p>
-          <a:p>
-            <a:r>
-              <a:rPr lang="pl-PL" sz="1400"/>
-              <a:t>Ograniczenie: model liczący wektory czyta do 2048 tokenów, więc dłuższe pytania liczy z samego początku.</a:t>
+              <a:t>• Dlaczego 20 sąsiadów? Przy 1: AUROC 0,590 (szum). Od ok. 20 stabilnie: 0,682 przy 20, 0,689 przy 40.
+</a:t>
+            </a:r>
+          </a:p>
+          <a:p>
+            <a:r>
+              <a:rPr lang="pl-PL" sz="1400"/>
+              <a:t>• Czy ważenie pomaga? Trochę: równe wagi 0,677, ważenie podobieństwem 0,682. Ostrzejsze do 0,702, ale wybrane z 30 wariantów na tych samych danych, więc nie przyjmuję bez potwierdzenia.
+</a:t>
+            </a:r>
+          </a:p>
+          <a:p>
+            <a:r>
+              <a:rPr lang="pl-PL" sz="1400"/>
+              <a:t>• Czy więcej danych pomoże? Niewiele: powyżej ok. 1200 pytań podwojenie bazy daje ok. +0,01.
+</a:t>
+            </a:r>
+          </a:p>
+          <a:p>
+            <a:r>
+              <a:rPr lang="pl-PL" sz="1400"/>
+              <a:t>• Ograniczenie: model liczący wektory czyta do 2048 tokenów, dłuższe pytania liczy z samego początku.</a:t>
             </a:r>
           </a:p>
         </p:txBody>

</xml_diff>

<commit_message>
docs: poprawki slajdów 3, 4, 6 i notatek, idealny APGR 0,89 w dokumentach i PDF, dziennik 75
Co-Authored-By: Claude Sonnet 5.5 <noreply@anthropic.com>
Claude-Session: https://claude.ai/code/session_01V1631aLqopE3GM2inWjbQ8
</commit_message>
<xml_diff>
--- a/docs/prezentacja_postepy.pptx
+++ b/docs/prezentacja_postepy.pptx
@@ -122,7 +122,7 @@
   <p:extLst>
     <p:ext uri="{521415D9-36F7-43E2-AB2F-B90AF26B5E84}">
       <p14:sectionLst xmlns:p14="http://schemas.microsoft.com/office/powerpoint/2010/main">
-        <p14:section name="Wprowadzenie" id="{91045f2e-d137-0002-8ac4-d38dac496bd9}">
+        <p14:section name="Wprowadzenie" id="{71b5edfb-b8a7-3cdf-0707-dd76794208da}">
           <p14:sldIdLst>
             <p14:sldId id="256"/>
             <p14:sldId id="257"/>
@@ -130,20 +130,20 @@
             <p14:sldId id="259"/>
           </p14:sldIdLst>
         </p14:section>
-        <p14:section name="Dane i etykiety" id="{be12647c-82e7-3fd6-21e7-be019198e679}">
+        <p14:section name="Dane i etykiety" id="{0c8849c6-86e7-1d94-1597-8f6408d53a85}">
           <p14:sldIdLst>
             <p14:sldId id="260"/>
             <p14:sldId id="261"/>
             <p14:sldId id="262"/>
           </p14:sldIdLst>
         </p14:section>
-        <p14:section name="Router" id="{75274fd7-894e-e005-cbd4-ceda5af014f7}">
+        <p14:section name="Router" id="{18757e91-6cf8-bb39-77e0-750d7394117e}">
           <p14:sldIdLst>
             <p14:sldId id="263"/>
             <p14:sldId id="264"/>
           </p14:sldIdLst>
         </p14:section>
-        <p14:section name="Wyniki" id="{6ff365cf-e978-3026-a24a-718b2da327f4}">
+        <p14:section name="Wyniki" id="{39b3355b-34d9-b6bd-37e1-2165aa83eb28}">
           <p14:sldIdLst>
             <p14:sldId id="265"/>
             <p14:sldId id="266"/>
@@ -151,7 +151,7 @@
             <p14:sldId id="268"/>
           </p14:sldIdLst>
         </p14:section>
-        <p14:section name="Dalej" id="{bf00fa7a-410f-e662-5111-73da65727c6b}">
+        <p14:section name="Dalej" id="{ff5239d5-0e55-c5d0-b387-9725a0564037}">
           <p14:sldIdLst>
             <p14:sldId id="269"/>
             <p14:sldId id="270"/>
@@ -2291,7 +2291,7 @@
           <a:p>
             <a:r>
               <a:rPr lang="pl-PL" sz="1400"/>
-              <a:t>• Plan miał trzy warstwy (heurystyki, porównanie z podobnymi pytaniami, mały model), konfigurację w YAML, kategorie tematyczne i podział złożonych zadań na części (Map-Reduce).
+              <a:t>• Trzy warstwy (heurystyki, porównanie z podobnymi pytaniami, mały model) zostają, opisuję je na slajdzie 8. Z rdzenia wypadły: konfiguracja w YAML, kategorie tematyczne i podział złożonych zadań na części (Map-Reduce).
 </a:t>
             </a:r>
           </a:p>
@@ -2427,7 +2427,14 @@
           <a:p>
             <a:r>
               <a:rPr lang="pl-PL" sz="1400"/>
-              <a:t>• Sprawdziłem, czy stare etykiety z Areny pasują do moich dwóch modeli.
+              <a:t>• Zmieniłem podejście: zamiast cudzych etykiet mierzę trudność sam, na swoich modelach. Dla każdego pytania liczę, o ile duży model odpowiedział lepiej niż mały. Tę przewagę oznaczam Δ (delta). Jak ją liczę, pokażę na następnym slajdzie.
+</a:t>
+            </a:r>
+          </a:p>
+          <a:p>
+            <a:r>
+              <a:rPr lang="pl-PL" sz="1400"/>
+              <a:t>• Najpierw sprawdziłem, czy stare etykiety z Areny pasują do tej zmierzonej przewagi.
 </a:t>
             </a:r>
           </a:p>
@@ -2435,13 +2442,6 @@
             <a:r>
               <a:rPr lang="pl-PL" sz="1400"/>
               <a:t>• Stara etykieta: pytanie jest „trudne”, jeśli w głosowaniu wygrał mocniejszy model.
-</a:t>
-            </a:r>
-          </a:p>
-          <a:p>
-            <a:r>
-              <a:rPr lang="pl-PL" sz="1400"/>
-              <a:t>• Dla moich dwóch modeli zmierzyłem osobno, o ile duży jest lepszy od małego na każdym pytaniu (jak dokładnie, na następnym slajdzie).
 </a:t>
             </a:r>
           </a:p>
@@ -2518,7 +2518,7 @@
           <a:p>
             <a:r>
               <a:rPr lang="pl-PL" sz="1400"/>
-              <a:t>• Tu „wynik” to zmierzona przewaga dużego modelu, a „trudne” to stare trudne wg Areny. Później w ten sam sposób ocenię router.
+              <a:t>• Tu „wynik” to zmierzona przewaga dużego modelu (Δ), a „trudne” to stare trudne wg Areny. Później w ten sam sposób ocenię router.
 </a:t>
             </a:r>
           </a:p>
@@ -2886,7 +2886,7 @@
           <a:p>
             <a:r>
               <a:rPr lang="pl-PL" sz="1400"/>
-              <a:t>• Wynik pomiaru: 35,4% pytań jest trudnych, ale zależnie od źródła: matematyka 4%, WildChat 48%. Mały model dobrze liczy, a rozmowy otwarte są dla niego trudniejsze.
+              <a:t>• Wynik pomiaru: 35,4% pytań jest trudnych (liczone dla 4304 pytań z etykietą; 9 z 4313 zablokował sędzia z powodu treści, więc są poza analizą), ale zależnie od źródła: matematyka 4%, WildChat 48%. Mały model dobrze liczy, a rozmowy otwarte są dla niego trudniejsze.
 </a:t>
             </a:r>
           </a:p>
@@ -10063,7 +10063,7 @@
                   <a:schemeClr val="tx1"/>
                 </a:solidFill>
               </a:rPr>
-              <a:t>Trzy warstwy</a:t>
+              <a:t>Trzy warstwy (zostają)</a:t>
             </a:r>
             <a:endParaRPr lang="en-US" sz="1800" dirty="0"/>
           </a:p>
@@ -10099,7 +10099,7 @@
                   <a:schemeClr val="tx2"/>
                 </a:solidFill>
               </a:rPr>
-              <a:t>heurystyki, porównanie z podobnymi pytaniami, mały model</a:t>
+              <a:t>heurystyki, podobne pytania, mały model; opis dalej</a:t>
             </a:r>
             <a:endParaRPr lang="en-US" sz="1400" dirty="0"/>
           </a:p>
@@ -10660,7 +10660,7 @@
                   <a:schemeClr val="tx1"/>
                 </a:solidFill>
               </a:rPr>
-              <a:t>Nowe podejście: mierzę trudność z prawdziwych odpowiedzi małego i dużego modelu</a:t>
+              <a:t>Nowe podejście: mierzę trudność sam, z prawdziwych odpowiedzi obu modeli (Δ = przewaga dużego, następny slajd)</a:t>
             </a:r>
             <a:endParaRPr lang="en-US" sz="1800" dirty="0"/>
           </a:p>

</xml_diff>

<commit_message>
docs: opis taksonomii Blooma na slajdzie 8, rozdzielenie AUROC i APGR (slajdy 10 i 11), dziennik 76-77
Co-Authored-By: Claude Sonnet 5.5 <noreply@anthropic.com>
Claude-Session: https://claude.ai/code/session_01V1631aLqopE3GM2inWjbQ8
</commit_message>
<xml_diff>
--- a/docs/prezentacja_postepy.pptx
+++ b/docs/prezentacja_postepy.pptx
@@ -122,7 +122,7 @@
   <p:extLst>
     <p:ext uri="{521415D9-36F7-43E2-AB2F-B90AF26B5E84}">
       <p14:sectionLst xmlns:p14="http://schemas.microsoft.com/office/powerpoint/2010/main">
-        <p14:section name="Wprowadzenie" id="{71b5edfb-b8a7-3cdf-0707-dd76794208da}">
+        <p14:section name="Wprowadzenie" id="{5b73faa2-94d1-ff0d-ed4a-e4eaf61b8ec3}">
           <p14:sldIdLst>
             <p14:sldId id="256"/>
             <p14:sldId id="257"/>
@@ -130,20 +130,20 @@
             <p14:sldId id="259"/>
           </p14:sldIdLst>
         </p14:section>
-        <p14:section name="Dane i etykiety" id="{0c8849c6-86e7-1d94-1597-8f6408d53a85}">
+        <p14:section name="Dane i etykiety" id="{5fbde4c6-2486-1199-59a4-4731b2107ca7}">
           <p14:sldIdLst>
             <p14:sldId id="260"/>
             <p14:sldId id="261"/>
             <p14:sldId id="262"/>
           </p14:sldIdLst>
         </p14:section>
-        <p14:section name="Router" id="{18757e91-6cf8-bb39-77e0-750d7394117e}">
+        <p14:section name="Router" id="{27d8018a-ce91-d467-4477-4e170f760aaa}">
           <p14:sldIdLst>
             <p14:sldId id="263"/>
             <p14:sldId id="264"/>
           </p14:sldIdLst>
         </p14:section>
-        <p14:section name="Wyniki" id="{39b3355b-34d9-b6bd-37e1-2165aa83eb28}">
+        <p14:section name="Wyniki" id="{94ebdcf2-c325-e5b8-eebc-5f205868baa4}">
           <p14:sldIdLst>
             <p14:sldId id="265"/>
             <p14:sldId id="266"/>
@@ -151,7 +151,7 @@
             <p14:sldId id="268"/>
           </p14:sldIdLst>
         </p14:section>
-        <p14:section name="Dalej" id="{ff5239d5-0e55-c5d0-b387-9725a0564037}">
+        <p14:section name="Dalej" id="{953df87f-aa75-c0c6-ef0c-27f6aa9855cf}">
           <p14:sldIdLst>
             <p14:sldId id="269"/>
             <p14:sldId id="270"/>
@@ -708,33 +708,8 @@
           </a:p>
           <a:p>
             <a:r>
-              <a:rPr lang="pl-PL" sz="1400" b="1"/>
-              <a:t>JAKOŚĆ: </a:t>
-            </a:r>
-            <a:r>
-              <a:rPr lang="pl-PL" sz="1400"/>
-              <a:t>średnia ocena odpowiedzi w skali 0–1 (dla każdego pytania ocena modelu, do którego poszło). Wszystko do małego 0,625, wszystko do dużego 0,846. Luka 0,221.
-</a:t>
-            </a:r>
-          </a:p>
-          <a:p>
-            <a:r>
-              <a:rPr lang="pl-PL" sz="1400"/>
-              <a:t>APGR (średni odzyskany zysk): dla jednego progu odzyskany zysk = (jakość routera − 0,625) / 0,221. Np. jakość 0,777 daje 0,152 / 0,221 = 0,69.
-</a:t>
-            </a:r>
-          </a:p>
-          <a:p>
-            <a:r>
-              <a:rPr lang="pl-PL" sz="1400"/>
-              <a:t>• APGR to średnia z tego po wszystkich progach, czyli jedna liczba opisująca cały router. Wykres na następnym slajdzie.
-</a:t>
-            </a:r>
-          </a:p>
-          <a:p>
-            <a:r>
-              <a:rPr lang="pl-PL" sz="1400"/>
-              <a:t>• Losowe wysyłanie daje APGR 0,5, idealny router 0,89 (dla 3010 pytań). Mój ma 0,605.
+              <a:rPr lang="pl-PL" sz="1400"/>
+              <a:t>• AUROC ocenia sam wynik routera, bez wybierania progu. Drugą miarę, APGR, która pokazuje jakość odpowiedzi przy danym udziale dużego modelu, omawiam na następnym slajdzie.
 </a:t>
             </a:r>
           </a:p>
@@ -772,7 +747,7 @@
           <a:p>
             <a:r>
               <a:rPr lang="pl-PL" sz="1400"/>
-              <a:t>• Router wie coś więcej niż rodzaj pytania, ale niewiele: różnica 0,05 w AUROC i 0,023 w APGR (0,605 wobec 0,582), istotna statystycznie.
+              <a:t>• Router wie coś więcej niż rodzaj pytania, ale niewiele: różnica 0,05 w AUROC (0,682 wobec 0,631).
 </a:t>
             </a:r>
           </a:p>
@@ -907,7 +882,60 @@
           <a:p>
             <a:r>
               <a:rPr lang="pl-PL" sz="1400"/>
-              <a:t>• Ten slajd pokazuje dwie różne rzeczy: po lewej wykres (obraz APGR), po prawej tabelę (ryzyko poważnych błędów).
+              <a:t>• Ten slajd pokazuje drugą miarę. Po lewej APGR (wykres), po prawej ryzyko poważnych błędów (tabela). To dwa różne spojrzenia na ten sam router.
+</a:t>
+            </a:r>
+          </a:p>
+          <a:p>
+            <a:endParaRPr lang="pl-PL" sz="1400"/>
+          </a:p>
+          <a:p>
+            <a:r>
+              <a:rPr lang="pl-PL" sz="1400" b="1"/>
+              <a:t>DEFINICJE
+</a:t>
+            </a:r>
+          </a:p>
+          <a:p>
+            <a:r>
+              <a:rPr lang="pl-PL" sz="1400" b="1"/>
+              <a:t>JAKOŚĆ: </a:t>
+            </a:r>
+            <a:r>
+              <a:rPr lang="pl-PL" sz="1400"/>
+              <a:t>średnia ocena odpowiedzi w skali 0–1 (dla każdego pytania ocena modelu, do którego poszło). Wszystko do małego 0,625, wszystko do dużego 0,846. Luka 0,221.
+</a:t>
+            </a:r>
+          </a:p>
+          <a:p>
+            <a:r>
+              <a:rPr lang="pl-PL" sz="1400"/>
+              <a:t>APGR (średni odzyskany zysk): dla jednego progu odzyskany zysk = (jakość routera − 0,625) / 0,221. Np. jakość 0,777 daje 0,152 / 0,221 = 0,69.
+</a:t>
+            </a:r>
+          </a:p>
+          <a:p>
+            <a:r>
+              <a:rPr lang="pl-PL" sz="1400"/>
+              <a:t>• APGR to średnia z tego po wszystkich progach, czyli jedna liczba opisująca cały router.
+</a:t>
+            </a:r>
+          </a:p>
+          <a:p>
+            <a:r>
+              <a:rPr lang="pl-PL" sz="1400"/>
+              <a:t>• Losowe wysyłanie daje APGR 0,5, idealny router 0,89 (dla 3010 pytań). Mój router ma 0,605, a „samo źródło” 0,582 (różnica 0,023, istotna statystycznie).
+</a:t>
+            </a:r>
+          </a:p>
+          <a:p>
+            <a:r>
+              <a:rPr lang="pl-PL" sz="1400" b="1"/>
+              <a:t>POWAŻNY BŁĄD: </a:t>
+            </a:r>
+            <a:r>
+              <a:rPr lang="pl-PL" sz="1400"/>
+              <a:t>pytanie, na które duży model odpowiedziałby wyraźnie lepiej (o ponad 2 punkty w skali 1–5, czyli Δ &gt; 0,5), a które poszło do małego. Takich pytań jest 15,9%.
 </a:t>
             </a:r>
           </a:p>
@@ -924,14 +952,14 @@
           <a:p>
             <a:r>
               <a:rPr lang="pl-PL" sz="1400"/>
-              <a:t>• Oś pozioma: odsetek pytań wysyłanych do dużego modelu (0–100%). Oś pionowa: jakość, czyli średnia ocena odpowiedzi (0–1).
-</a:t>
-            </a:r>
-          </a:p>
-          <a:p>
-            <a:r>
-              <a:rPr lang="pl-PL" sz="1400"/>
-              <a:t>• Wszystko do małego daje 0,625, wszystko do dużego 0,846. Szara linia to wysyłanie losowe. Pomarańczowa to router: wyżej = lepsza jakość przy tym samym udziale dużego.
+              <a:t>• Oś pozioma: odsetek pytań wysyłanych do dużego modelu (0–100%). Oś pionowa: jakość.
+</a:t>
+            </a:r>
+          </a:p>
+          <a:p>
+            <a:r>
+              <a:rPr lang="pl-PL" sz="1400"/>
+              <a:t>• Szara linia to wysyłanie losowe. Pomarańczowa to router: wyżej = lepsza jakość przy tym samym udziale dużego.
 </a:t>
             </a:r>
           </a:p>
@@ -953,27 +981,6 @@
             <a:r>
               <a:rPr lang="pl-PL" sz="1400"/>
               <a:t>• To ok. 46% mniej wywołań dużego modelu za ok. 8% niższą jakość (0,846 spada do 0,777). Uwaga: to odczyt z jednego punktu, nie APGR.
-</a:t>
-            </a:r>
-          </a:p>
-          <a:p>
-            <a:endParaRPr lang="pl-PL" sz="1400"/>
-          </a:p>
-          <a:p>
-            <a:r>
-              <a:rPr lang="pl-PL" sz="1400" b="1"/>
-              <a:t>DEFINICJE
-</a:t>
-            </a:r>
-          </a:p>
-          <a:p>
-            <a:r>
-              <a:rPr lang="pl-PL" sz="1400" b="1"/>
-              <a:t>POWAŻNY BŁĄD: </a:t>
-            </a:r>
-            <a:r>
-              <a:rPr lang="pl-PL" sz="1400"/>
-              <a:t>pytanie, na które duży model odpowiedziałby wyraźnie lepiej (o ponad 2 punkty w skali 1–5, czyli Δ &gt; 0,5), a które poszło do małego. Takich pytań jest 15,9%.
 </a:t>
             </a:r>
           </a:p>
@@ -3171,7 +3178,7 @@
           <a:p>
             <a:r>
               <a:rPr lang="pl-PL" sz="1400"/>
-              <a:t>• Frazy pochodzą z literatury, nie z moich danych, żeby ich nie dopasować do wyników. Taksonomia Blooma (Anderson i Krathwohl, 2001): „analyze”, „compare”, „design” to zadania trudniejsze, „what is”, „define” łatwiejsze. Lista z AgentBus, praktycznego systemu routingu: np. „debug”, „refactor”, „step by step”.
+              <a:t>• Frazy pochodzą z literatury, nie z moich danych, żeby ich nie dopasować do wyników. Taksonomia Blooma (Anderson i Krathwohl, 2001, definicja niżej): „analyze”, „compare”, „design” to zadania trudniejsze, „what is”, „define” łatwiejsze. Lista z AgentBus, praktycznego systemu routingu: np. „debug”, „refactor”, „step by step”.
 </a:t>
             </a:r>
           </a:p>
@@ -3217,6 +3224,45 @@
             <a:r>
               <a:rPr lang="pl-PL" sz="1400" b="1"/>
               <a:t>DEFINICJE
+</a:t>
+            </a:r>
+          </a:p>
+          <a:p>
+            <a:r>
+              <a:rPr lang="pl-PL" sz="1400" b="1"/>
+              <a:t>TAKSONOMIA BLOOMA: </a:t>
+            </a:r>
+            <a:r>
+              <a:rPr lang="pl-PL" sz="1400"/>
+              <a:t>podział celów uczenia na sześć poziomów myślenia, od najprostszego do najtrudniejszego. Używam wersji poprawionej (Anderson i Krathwohl, 2001).
+</a:t>
+            </a:r>
+          </a:p>
+          <a:p>
+            <a:r>
+              <a:rPr lang="pl-PL" sz="1400"/>
+              <a:t>• Poziomy: zapamiętać (remember), zrozumieć (understand), zastosować (apply), analizować (analyze), oceniać (evaluate), tworzyć (create).
+</a:t>
+            </a:r>
+          </a:p>
+          <a:p>
+            <a:r>
+              <a:rPr lang="pl-PL" sz="1400"/>
+              <a:t>• Do każdego poziomu pasują czasowniki, którymi zadaje się polecenia. Zapamiętać: „define”, „name”, „recall”, „what is”. Zrozumieć: „summarize”, „translate”, „paraphrase”. Zastosować: „solve”, „calculate”, „implement”. Analizować: „analyze”, „compare”, „contrast”. Oceniać: „evaluate”, „critique”, „justify”. Tworzyć: „design”, „compose”, „invent”.
+</a:t>
+            </a:r>
+          </a:p>
+          <a:p>
+            <a:r>
+              <a:rPr lang="pl-PL" sz="1400"/>
+              <a:t>• Jak użyłem: czasowniki z czterech wyższych poziomów (zastosować, analizować, oceniać, tworzyć) to lista fraz TRUDNYCH (+1 punkt). Z dwóch niższych (zapamiętać, zrozumieć) to lista fraz ŁATWYCH (−1 punkt). Do listy trudnych doszły frazy z AgentBus, np. „debug”, „refactor”, „step by step”.
+</a:t>
+            </a:r>
+          </a:p>
+          <a:p>
+            <a:r>
+              <a:rPr lang="pl-PL" sz="1400"/>
+              <a:t>• Założenie z literatury: polecenie, które wymaga wyższego poziomu myślenia, jest trudniejsze. U nas sama warstwa 1 wypada słabo (AUROC ok. 0,55), więc to założenie tylko częściowo pasuje do pary naszych modeli. Prawdopodobnie dlatego, że o trudności dla modelu decyduje też to, czy zna fakt, a tego z czasownika nie widać (hipoteza, niesprawdzona).
 </a:t>
             </a:r>
           </a:p>
@@ -4382,7 +4428,7 @@
                   <a:schemeClr val="tx1"/>
                 </a:solidFill>
               </a:rPr>
-              <a:t>Od samego źródła tylko skromnie: APGR 0,605 wobec 0,582 (+0,023, istotnie)</a:t>
+              <a:t>Od samego źródła tylko skromnie: AUROC 0,682 wobec 0,631</a:t>
             </a:r>
             <a:endParaRPr lang="en-US" sz="1600" dirty="0"/>
           </a:p>
@@ -12527,7 +12573,7 @@
                   <a:schemeClr val="tx2"/>
                 </a:solidFill>
               </a:rPr>
-              <a:t>Punkty za frazy z list z literatury i cechy tekstu. Po przekroczeniu progu: duży model.</a:t>
+              <a:t>Punkty za frazy z taksonomii Blooma (poziomy myślenia od zapamiętania do tworzenia) i cechy tekstu. Próg: duży model.</a:t>
             </a:r>
             <a:endParaRPr lang="en-US" sz="1400" dirty="0"/>
           </a:p>

</xml_diff>